<commit_message>
AI Agent workflow v2: richer native flow page and HTML-dashboard page
</commit_message>
<xml_diff>
--- a/benchmarks/manual_tasks/ai-agent-workflow/output/ai_agent_workflow.pptx
+++ b/benchmarks/manual_tasks/ai-agent-workflow/output/ai_agent_workflow.pptx
@@ -106,446 +106,6 @@
     </a:lvl9pPr>
   </p:defaultTextStyle>
 </p:presentation>
-</file>
-
-<file path=ppt/notesMasters/notesMaster1.xml><?xml version="1.0" encoding="utf-8"?>
-<p:notesMaster xmlns:a="http://schemas.openxmlformats.org/drawingml/2006/main" xmlns:p="http://schemas.openxmlformats.org/presentationml/2006/main" xmlns:r="http://schemas.openxmlformats.org/officeDocument/2006/relationships">
-  <p:cSld>
-    <p:bg>
-      <p:bgRef idx="1001">
-        <a:schemeClr val="bg1"/>
-      </p:bgRef>
-    </p:bg>
-    <p:spTree>
-      <p:nvGrpSpPr>
-        <p:cNvPr id="1" name=""/>
-        <p:cNvGrpSpPr/>
-        <p:nvPr/>
-      </p:nvGrpSpPr>
-      <p:grpSpPr>
-        <a:xfrm>
-          <a:off x="0" y="0"/>
-          <a:ext cx="0" cy="0"/>
-          <a:chOff x="0" y="0"/>
-          <a:chExt cx="0" cy="0"/>
-        </a:xfrm>
-      </p:grpSpPr>
-      <p:sp>
-        <p:nvSpPr>
-          <p:cNvPr id="2" name="Header Placeholder 1"/>
-          <p:cNvSpPr>
-            <a:spLocks noGrp="1"/>
-          </p:cNvSpPr>
-          <p:nvPr>
-            <p:ph type="hdr" sz="quarter"/>
-          </p:nvPr>
-        </p:nvSpPr>
-        <p:spPr>
-          <a:xfrm>
-            <a:off x="0" y="0"/>
-            <a:ext cx="2971800" cy="457200"/>
-          </a:xfrm>
-          <a:prstGeom prst="rect">
-            <a:avLst/>
-          </a:prstGeom>
-        </p:spPr>
-        <p:txBody>
-          <a:bodyPr vert="horz" lIns="91440" tIns="45720" rIns="91440" bIns="45720" rtlCol="0"/>
-          <a:lstStyle>
-            <a:lvl1pPr algn="l">
-              <a:defRPr sz="1200"/>
-            </a:lvl1pPr>
-          </a:lstStyle>
-          <a:p>
-            <a:endParaRPr lang="en-US"/>
-          </a:p>
-        </p:txBody>
-      </p:sp>
-      <p:sp>
-        <p:nvSpPr>
-          <p:cNvPr id="3" name="Date Placeholder 2"/>
-          <p:cNvSpPr>
-            <a:spLocks noGrp="1"/>
-          </p:cNvSpPr>
-          <p:nvPr>
-            <p:ph type="dt" idx="1"/>
-          </p:nvPr>
-        </p:nvSpPr>
-        <p:spPr>
-          <a:xfrm>
-            <a:off x="3884613" y="0"/>
-            <a:ext cx="2971800" cy="457200"/>
-          </a:xfrm>
-          <a:prstGeom prst="rect">
-            <a:avLst/>
-          </a:prstGeom>
-        </p:spPr>
-        <p:txBody>
-          <a:bodyPr vert="horz" lIns="91440" tIns="45720" rIns="91440" bIns="45720" rtlCol="0"/>
-          <a:lstStyle>
-            <a:lvl1pPr algn="r">
-              <a:defRPr sz="1200"/>
-            </a:lvl1pPr>
-          </a:lstStyle>
-          <a:p>
-            <a:fld id="{0F89C1C7-3DCD-1040-A9CF-14679D8B5DDD}" type="datetimeFigureOut">
-              <a:rPr lang="en-US" smtClean="0"/>
-              <a:t>10/17/16</a:t>
-            </a:fld>
-            <a:endParaRPr lang="en-US"/>
-          </a:p>
-        </p:txBody>
-      </p:sp>
-      <p:sp>
-        <p:nvSpPr>
-          <p:cNvPr id="4" name="Slide Image Placeholder 3"/>
-          <p:cNvSpPr>
-            <a:spLocks noGrp="1" noRot="1" noChangeAspect="1"/>
-          </p:cNvSpPr>
-          <p:nvPr>
-            <p:ph type="sldImg" idx="2"/>
-          </p:nvPr>
-        </p:nvSpPr>
-        <p:spPr>
-          <a:xfrm>
-            <a:off x="1143000" y="685800"/>
-            <a:ext cx="4572000" cy="3429000"/>
-          </a:xfrm>
-          <a:prstGeom prst="rect">
-            <a:avLst/>
-          </a:prstGeom>
-          <a:noFill/>
-          <a:ln w="12700">
-            <a:solidFill>
-              <a:prstClr val="black"/>
-            </a:solidFill>
-          </a:ln>
-        </p:spPr>
-        <p:txBody>
-          <a:bodyPr vert="horz" lIns="91440" tIns="45720" rIns="91440" bIns="45720" rtlCol="0" anchor="ctr"/>
-          <a:lstStyle/>
-          <a:p>
-            <a:endParaRPr lang="en-US"/>
-          </a:p>
-        </p:txBody>
-      </p:sp>
-      <p:sp>
-        <p:nvSpPr>
-          <p:cNvPr id="5" name="Notes Placeholder 4"/>
-          <p:cNvSpPr>
-            <a:spLocks noGrp="1"/>
-          </p:cNvSpPr>
-          <p:nvPr>
-            <p:ph type="body" sz="quarter" idx="3"/>
-          </p:nvPr>
-        </p:nvSpPr>
-        <p:spPr>
-          <a:xfrm>
-            <a:off x="685800" y="4343400"/>
-            <a:ext cx="5486400" cy="4114800"/>
-          </a:xfrm>
-          <a:prstGeom prst="rect">
-            <a:avLst/>
-          </a:prstGeom>
-        </p:spPr>
-        <p:txBody>
-          <a:bodyPr vert="horz" lIns="91440" tIns="45720" rIns="91440" bIns="45720" rtlCol="0"/>
-          <a:lstStyle/>
-          <a:p>
-            <a:pPr lvl="0"/>
-            <a:r>
-              <a:rPr lang="en-US" smtClean="0"/>
-              <a:t>Click to edit Master text styles</a:t>
-            </a:r>
-          </a:p>
-          <a:p>
-            <a:pPr lvl="1"/>
-            <a:r>
-              <a:rPr lang="en-US" smtClean="0"/>
-              <a:t>Second level</a:t>
-            </a:r>
-          </a:p>
-          <a:p>
-            <a:pPr lvl="2"/>
-            <a:r>
-              <a:rPr lang="en-US" smtClean="0"/>
-              <a:t>Third level</a:t>
-            </a:r>
-          </a:p>
-          <a:p>
-            <a:pPr lvl="3"/>
-            <a:r>
-              <a:rPr lang="en-US" smtClean="0"/>
-              <a:t>Fourth level</a:t>
-            </a:r>
-          </a:p>
-          <a:p>
-            <a:pPr lvl="4"/>
-            <a:r>
-              <a:rPr lang="en-US" smtClean="0"/>
-              <a:t>Fifth level</a:t>
-            </a:r>
-            <a:endParaRPr lang="en-US"/>
-          </a:p>
-        </p:txBody>
-      </p:sp>
-      <p:sp>
-        <p:nvSpPr>
-          <p:cNvPr id="6" name="Footer Placeholder 5"/>
-          <p:cNvSpPr>
-            <a:spLocks noGrp="1"/>
-          </p:cNvSpPr>
-          <p:nvPr>
-            <p:ph type="ftr" sz="quarter" idx="4"/>
-          </p:nvPr>
-        </p:nvSpPr>
-        <p:spPr>
-          <a:xfrm>
-            <a:off x="0" y="8685213"/>
-            <a:ext cx="2971800" cy="457200"/>
-          </a:xfrm>
-          <a:prstGeom prst="rect">
-            <a:avLst/>
-          </a:prstGeom>
-        </p:spPr>
-        <p:txBody>
-          <a:bodyPr vert="horz" lIns="91440" tIns="45720" rIns="91440" bIns="45720" rtlCol="0" anchor="b"/>
-          <a:lstStyle>
-            <a:lvl1pPr algn="l">
-              <a:defRPr sz="1200"/>
-            </a:lvl1pPr>
-          </a:lstStyle>
-          <a:p>
-            <a:endParaRPr lang="en-US"/>
-          </a:p>
-        </p:txBody>
-      </p:sp>
-      <p:sp>
-        <p:nvSpPr>
-          <p:cNvPr id="7" name="Slide Number Placeholder 6"/>
-          <p:cNvSpPr>
-            <a:spLocks noGrp="1"/>
-          </p:cNvSpPr>
-          <p:nvPr>
-            <p:ph type="sldNum" sz="quarter" idx="5"/>
-          </p:nvPr>
-        </p:nvSpPr>
-        <p:spPr>
-          <a:xfrm>
-            <a:off x="3884613" y="8685213"/>
-            <a:ext cx="2971800" cy="457200"/>
-          </a:xfrm>
-          <a:prstGeom prst="rect">
-            <a:avLst/>
-          </a:prstGeom>
-        </p:spPr>
-        <p:txBody>
-          <a:bodyPr vert="horz" lIns="91440" tIns="45720" rIns="91440" bIns="45720" rtlCol="0" anchor="b"/>
-          <a:lstStyle>
-            <a:lvl1pPr algn="r">
-              <a:defRPr sz="1200"/>
-            </a:lvl1pPr>
-          </a:lstStyle>
-          <a:p>
-            <a:fld id="{BB5E49A5-4136-284D-997B-48E1D791AD67}" type="slidenum">
-              <a:rPr lang="en-US" smtClean="0"/>
-              <a:t>‹#›</a:t>
-            </a:fld>
-            <a:endParaRPr lang="en-US"/>
-          </a:p>
-        </p:txBody>
-      </p:sp>
-    </p:spTree>
-    <p:extLst>
-      <p:ext uri="{BB962C8B-B14F-4D97-AF65-F5344CB8AC3E}">
-        <p14:creationId xmlns:p14="http://schemas.microsoft.com/office/powerpoint/2010/main" val="2623252185"/>
-      </p:ext>
-    </p:extLst>
-  </p:cSld>
-  <p:clrMap bg1="lt1" tx1="dk1" bg2="lt2" tx2="dk2" accent1="accent1" accent2="accent2" accent3="accent3" accent4="accent4" accent5="accent5" accent6="accent6" hlink="hlink" folHlink="folHlink"/>
-  <p:notesStyle>
-    <a:lvl1pPr marL="0" algn="l" defTabSz="457200" rtl="0" eaLnBrk="1" latinLnBrk="0" hangingPunct="1">
-      <a:defRPr sz="1200" kern="1200">
-        <a:solidFill>
-          <a:schemeClr val="tx1"/>
-        </a:solidFill>
-        <a:latin typeface="+mn-lt"/>
-        <a:ea typeface="+mn-ea"/>
-        <a:cs typeface="+mn-cs"/>
-      </a:defRPr>
-    </a:lvl1pPr>
-    <a:lvl2pPr marL="457200" algn="l" defTabSz="457200" rtl="0" eaLnBrk="1" latinLnBrk="0" hangingPunct="1">
-      <a:defRPr sz="1200" kern="1200">
-        <a:solidFill>
-          <a:schemeClr val="tx1"/>
-        </a:solidFill>
-        <a:latin typeface="+mn-lt"/>
-        <a:ea typeface="+mn-ea"/>
-        <a:cs typeface="+mn-cs"/>
-      </a:defRPr>
-    </a:lvl2pPr>
-    <a:lvl3pPr marL="914400" algn="l" defTabSz="457200" rtl="0" eaLnBrk="1" latinLnBrk="0" hangingPunct="1">
-      <a:defRPr sz="1200" kern="1200">
-        <a:solidFill>
-          <a:schemeClr val="tx1"/>
-        </a:solidFill>
-        <a:latin typeface="+mn-lt"/>
-        <a:ea typeface="+mn-ea"/>
-        <a:cs typeface="+mn-cs"/>
-      </a:defRPr>
-    </a:lvl3pPr>
-    <a:lvl4pPr marL="1371600" algn="l" defTabSz="457200" rtl="0" eaLnBrk="1" latinLnBrk="0" hangingPunct="1">
-      <a:defRPr sz="1200" kern="1200">
-        <a:solidFill>
-          <a:schemeClr val="tx1"/>
-        </a:solidFill>
-        <a:latin typeface="+mn-lt"/>
-        <a:ea typeface="+mn-ea"/>
-        <a:cs typeface="+mn-cs"/>
-      </a:defRPr>
-    </a:lvl4pPr>
-    <a:lvl5pPr marL="1828800" algn="l" defTabSz="457200" rtl="0" eaLnBrk="1" latinLnBrk="0" hangingPunct="1">
-      <a:defRPr sz="1200" kern="1200">
-        <a:solidFill>
-          <a:schemeClr val="tx1"/>
-        </a:solidFill>
-        <a:latin typeface="+mn-lt"/>
-        <a:ea typeface="+mn-ea"/>
-        <a:cs typeface="+mn-cs"/>
-      </a:defRPr>
-    </a:lvl5pPr>
-    <a:lvl6pPr marL="2286000" algn="l" defTabSz="457200" rtl="0" eaLnBrk="1" latinLnBrk="0" hangingPunct="1">
-      <a:defRPr sz="1200" kern="1200">
-        <a:solidFill>
-          <a:schemeClr val="tx1"/>
-        </a:solidFill>
-        <a:latin typeface="+mn-lt"/>
-        <a:ea typeface="+mn-ea"/>
-        <a:cs typeface="+mn-cs"/>
-      </a:defRPr>
-    </a:lvl6pPr>
-    <a:lvl7pPr marL="2743200" algn="l" defTabSz="457200" rtl="0" eaLnBrk="1" latinLnBrk="0" hangingPunct="1">
-      <a:defRPr sz="1200" kern="1200">
-        <a:solidFill>
-          <a:schemeClr val="tx1"/>
-        </a:solidFill>
-        <a:latin typeface="+mn-lt"/>
-        <a:ea typeface="+mn-ea"/>
-        <a:cs typeface="+mn-cs"/>
-      </a:defRPr>
-    </a:lvl7pPr>
-    <a:lvl8pPr marL="3200400" algn="l" defTabSz="457200" rtl="0" eaLnBrk="1" latinLnBrk="0" hangingPunct="1">
-      <a:defRPr sz="1200" kern="1200">
-        <a:solidFill>
-          <a:schemeClr val="tx1"/>
-        </a:solidFill>
-        <a:latin typeface="+mn-lt"/>
-        <a:ea typeface="+mn-ea"/>
-        <a:cs typeface="+mn-cs"/>
-      </a:defRPr>
-    </a:lvl8pPr>
-    <a:lvl9pPr marL="3657600" algn="l" defTabSz="457200" rtl="0" eaLnBrk="1" latinLnBrk="0" hangingPunct="1">
-      <a:defRPr sz="1200" kern="1200">
-        <a:solidFill>
-          <a:schemeClr val="tx1"/>
-        </a:solidFill>
-        <a:latin typeface="+mn-lt"/>
-        <a:ea typeface="+mn-ea"/>
-        <a:cs typeface="+mn-cs"/>
-      </a:defRPr>
-    </a:lvl9pPr>
-  </p:notesStyle>
-</p:notesMaster>
-</file>
-
-<file path=ppt/notesSlides/notesSlide1.xml><?xml version="1.0" encoding="utf-8"?>
-<p:notes xmlns:a="http://schemas.openxmlformats.org/drawingml/2006/main" xmlns:p="http://schemas.openxmlformats.org/presentationml/2006/main" xmlns:r="http://schemas.openxmlformats.org/officeDocument/2006/relationships">
-  <p:cSld>
-    <p:spTree>
-      <p:nvGrpSpPr>
-        <p:cNvPr id="1" name=""/>
-        <p:cNvGrpSpPr/>
-        <p:nvPr/>
-      </p:nvGrpSpPr>
-      <p:grpSpPr>
-        <a:xfrm>
-          <a:off x="0" y="0"/>
-          <a:ext cx="0" cy="0"/>
-          <a:chOff x="0" y="0"/>
-          <a:chExt cx="0" cy="0"/>
-        </a:xfrm>
-      </p:grpSpPr>
-      <p:sp>
-        <p:nvSpPr>
-          <p:cNvPr id="2" name="Slide Image Placeholder 1"/>
-          <p:cNvSpPr>
-            <a:spLocks noGrp="1"/>
-          </p:cNvSpPr>
-          <p:nvPr>
-            <p:ph type="sldImg" idx="2"/>
-          </p:nvPr>
-        </p:nvSpPr>
-        <p:spPr/>
-      </p:sp>
-      <p:sp>
-        <p:nvSpPr>
-          <p:cNvPr id="3" name="Notes Placeholder 2"/>
-          <p:cNvSpPr>
-            <a:spLocks noGrp="1"/>
-          </p:cNvSpPr>
-          <p:nvPr>
-            <p:ph type="body" idx="3" sz="quarter"/>
-          </p:nvPr>
-        </p:nvSpPr>
-        <p:spPr/>
-        <p:txBody>
-          <a:bodyPr/>
-          <a:lstStyle/>
-          <a:p>
-            <a:r>
-              <a:t>[Sources]</a:t>
-            </a:r>
-          </a:p>
-          <a:p>
-            <a:r>
-              <a:t>Q1: 流程起点</a:t>
-            </a:r>
-          </a:p>
-          <a:p>
-            <a:r>
-              <a:t>Q2: 规划阶段</a:t>
-            </a:r>
-          </a:p>
-          <a:p>
-            <a:r>
-              <a:t>Q3: 行动阶段</a:t>
-            </a:r>
-          </a:p>
-          <a:p>
-            <a:r>
-              <a:t>Q4: 收尾阶段</a:t>
-            </a:r>
-          </a:p>
-        </p:txBody>
-      </p:sp>
-      <p:sp>
-        <p:nvSpPr>
-          <p:cNvPr id="4" name="Slide Number Placeholder 3"/>
-          <p:cNvSpPr>
-            <a:spLocks noGrp="1"/>
-          </p:cNvSpPr>
-          <p:nvPr>
-            <p:ph type="sldNum" idx="5" sz="quarter"/>
-          </p:nvPr>
-        </p:nvSpPr>
-        <p:spPr/>
-      </p:sp>
-    </p:spTree>
-  </p:cSld>
-  <p:clrMapOvr>
-    <a:masterClrMapping/>
-  </p:clrMapOvr>
-</p:notes>
 </file>
 
 <file path=ppt/slideLayouts/slideLayout1.xml><?xml version="1.0" encoding="utf-8"?>
@@ -3544,7 +3104,7 @@
             <a:avLst/>
           </a:prstGeom>
           <a:solidFill>
-            <a:srgbClr val="FBFAF7"/>
+            <a:srgbClr val="101B2D"/>
           </a:solidFill>
           <a:ln>
             <a:noFill/>
@@ -3582,13 +3142,13 @@
         <p:spPr>
           <a:xfrm>
             <a:off x="0" y="0"/>
-            <a:ext cx="12191695" cy="1005840"/>
+            <a:ext cx="12191695" cy="91440"/>
           </a:xfrm>
           <a:prstGeom prst="rect">
             <a:avLst/>
           </a:prstGeom>
           <a:solidFill>
-            <a:srgbClr val="25477C"/>
+            <a:srgbClr val="F5B341"/>
           </a:solidFill>
           <a:ln>
             <a:noFill/>
@@ -3619,20 +3179,187 @@
       </p:sp>
       <p:sp>
         <p:nvSpPr>
-          <p:cNvPr id="4" name="Rectangle 3"/>
-          <p:cNvSpPr/>
-          <p:nvPr/>
-        </p:nvSpPr>
-        <p:spPr>
-          <a:xfrm>
-            <a:off x="0" y="1005840"/>
-            <a:ext cx="12191695" cy="64008"/>
+          <p:cNvPr id="4" name="TextBox 3"/>
+          <p:cNvSpPr txBox="1"/>
+          <p:nvPr/>
+        </p:nvSpPr>
+        <p:spPr>
+          <a:xfrm>
+            <a:off x="822960" y="502920"/>
+            <a:ext cx="10515600" cy="365760"/>
           </a:xfrm>
           <a:prstGeom prst="rect">
             <a:avLst/>
           </a:prstGeom>
+          <a:noFill/>
+        </p:spPr>
+        <p:txBody>
+          <a:bodyPr wrap="square" anchor="t">
+            <a:spAutoFit/>
+          </a:bodyPr>
+          <a:lstStyle/>
+          <a:p>
+            <a:pPr algn="l">
+              <a:lnSpc>
+                <a:spcPct val="100000"/>
+              </a:lnSpc>
+            </a:pPr>
+            <a:r>
+              <a:rPr sz="1200" b="1">
+                <a:solidFill>
+                  <a:srgbClr val="F5B341"/>
+                </a:solidFill>
+                <a:latin typeface="Microsoft YaHei"/>
+              </a:rPr>
+              <a:t>AI AGENT · WORKFLOW OVERVIEW</a:t>
+            </a:r>
+          </a:p>
+        </p:txBody>
+      </p:sp>
+      <p:sp>
+        <p:nvSpPr>
+          <p:cNvPr id="5" name="TextBox 4"/>
+          <p:cNvSpPr txBox="1"/>
+          <p:nvPr/>
+        </p:nvSpPr>
+        <p:spPr>
+          <a:xfrm>
+            <a:off x="822960" y="868680"/>
+            <a:ext cx="10515600" cy="1005840"/>
+          </a:xfrm>
+          <a:prstGeom prst="rect">
+            <a:avLst/>
+          </a:prstGeom>
+          <a:noFill/>
+        </p:spPr>
+        <p:txBody>
+          <a:bodyPr wrap="square" anchor="t">
+            <a:spAutoFit/>
+          </a:bodyPr>
+          <a:lstStyle/>
+          <a:p>
+            <a:pPr algn="l">
+              <a:lnSpc>
+                <a:spcPct val="100000"/>
+              </a:lnSpc>
+            </a:pPr>
+            <a:r>
+              <a:rPr sz="4200" b="1">
+                <a:solidFill>
+                  <a:srgbClr val="FFFFFF"/>
+                </a:solidFill>
+                <a:latin typeface="Microsoft YaHei"/>
+              </a:rPr>
+              <a:t>AI Agent 工作流程</a:t>
+            </a:r>
+          </a:p>
+        </p:txBody>
+      </p:sp>
+      <p:sp>
+        <p:nvSpPr>
+          <p:cNvPr id="6" name="TextBox 5"/>
+          <p:cNvSpPr txBox="1"/>
+          <p:nvPr/>
+        </p:nvSpPr>
+        <p:spPr>
+          <a:xfrm>
+            <a:off x="822960" y="1874519"/>
+            <a:ext cx="10515600" cy="548640"/>
+          </a:xfrm>
+          <a:prstGeom prst="rect">
+            <a:avLst/>
+          </a:prstGeom>
+          <a:noFill/>
+        </p:spPr>
+        <p:txBody>
+          <a:bodyPr wrap="square" anchor="t">
+            <a:spAutoFit/>
+          </a:bodyPr>
+          <a:lstStyle/>
+          <a:p>
+            <a:pPr algn="l">
+              <a:lnSpc>
+                <a:spcPct val="100000"/>
+              </a:lnSpc>
+            </a:pPr>
+            <a:r>
+              <a:rPr sz="1800" b="0">
+                <a:solidFill>
+                  <a:srgbClr val="B8C4D6"/>
+                </a:solidFill>
+                <a:latin typeface="Microsoft YaHei"/>
+              </a:rPr>
+              <a:t>从任务输入到可验证交付的六阶段闭环，每一步都沉淀为可审计证据</a:t>
+            </a:r>
+          </a:p>
+        </p:txBody>
+      </p:sp>
+      <p:sp>
+        <p:nvSpPr>
+          <p:cNvPr id="7" name="Rounded Rectangle 6"/>
+          <p:cNvSpPr/>
+          <p:nvPr/>
+        </p:nvSpPr>
+        <p:spPr>
+          <a:xfrm>
+            <a:off x="685800" y="3063240"/>
+            <a:ext cx="1938528" cy="2331720"/>
+          </a:xfrm>
+          <a:prstGeom prst="roundRect">
+            <a:avLst>
+              <a:gd name="adj" fmla="val 10000"/>
+            </a:avLst>
+          </a:prstGeom>
           <a:solidFill>
-            <a:srgbClr val="F09A1A"/>
+            <a:srgbClr val="182A44"/>
+          </a:solidFill>
+          <a:ln w="9525">
+            <a:solidFill>
+              <a:srgbClr val="2C3E5E"/>
+            </a:solidFill>
+          </a:ln>
+          <a:effectLst/>
+        </p:spPr>
+        <p:style>
+          <a:lnRef idx="1">
+            <a:schemeClr val="accent1"/>
+          </a:lnRef>
+          <a:fillRef idx="3">
+            <a:schemeClr val="accent1"/>
+          </a:fillRef>
+          <a:effectRef idx="2">
+            <a:schemeClr val="accent1"/>
+          </a:effectRef>
+          <a:fontRef idx="minor">
+            <a:schemeClr val="lt1"/>
+          </a:fontRef>
+        </p:style>
+        <p:txBody>
+          <a:bodyPr rtlCol="0" anchor="ctr"/>
+          <a:lstStyle/>
+          <a:p>
+            <a:pPr algn="ctr"/>
+          </a:p>
+        </p:txBody>
+      </p:sp>
+      <p:sp>
+        <p:nvSpPr>
+          <p:cNvPr id="8" name="Rounded Rectangle 7"/>
+          <p:cNvSpPr/>
+          <p:nvPr/>
+        </p:nvSpPr>
+        <p:spPr>
+          <a:xfrm>
+            <a:off x="850392" y="3227832"/>
+            <a:ext cx="475488" cy="475488"/>
+          </a:xfrm>
+          <a:prstGeom prst="roundRect">
+            <a:avLst>
+              <a:gd name="adj" fmla="val 50000"/>
+            </a:avLst>
+          </a:prstGeom>
+          <a:solidFill>
+            <a:srgbClr val="F5B341"/>
           </a:solidFill>
           <a:ln>
             <a:noFill/>
@@ -3654,23 +3381,31 @@
           </a:fontRef>
         </p:style>
         <p:txBody>
-          <a:bodyPr rtlCol="0" anchor="ctr"/>
+          <a:bodyPr rtlCol="0" anchor="ctr" wrap="none"/>
           <a:lstStyle/>
           <a:p>
             <a:pPr algn="ctr"/>
-          </a:p>
-        </p:txBody>
-      </p:sp>
-      <p:sp>
-        <p:nvSpPr>
-          <p:cNvPr id="5" name="TextBox 4"/>
+            <a:r>
+              <a:rPr sz="1300" b="1">
+                <a:solidFill>
+                  <a:srgbClr val="101B2D"/>
+                </a:solidFill>
+              </a:rPr>
+              <a:t>01</a:t>
+            </a:r>
+          </a:p>
+        </p:txBody>
+      </p:sp>
+      <p:sp>
+        <p:nvSpPr>
+          <p:cNvPr id="9" name="TextBox 8"/>
           <p:cNvSpPr txBox="1"/>
           <p:nvPr/>
         </p:nvSpPr>
         <p:spPr>
           <a:xfrm>
-            <a:off x="502920" y="109728"/>
-            <a:ext cx="11155680" cy="822960"/>
+            <a:off x="832104" y="3886200"/>
+            <a:ext cx="1645920" cy="411480"/>
           </a:xfrm>
           <a:prstGeom prst="rect">
             <a:avLst/>
@@ -3678,38 +3413,38 @@
           <a:noFill/>
         </p:spPr>
         <p:txBody>
-          <a:bodyPr wrap="square" lIns="0" tIns="0">
+          <a:bodyPr wrap="square" anchor="t">
             <a:spAutoFit/>
           </a:bodyPr>
           <a:lstStyle/>
           <a:p>
-            <a:pPr>
+            <a:pPr algn="l">
               <a:lnSpc>
-                <a:spcPct val="125000"/>
+                <a:spcPct val="100000"/>
               </a:lnSpc>
             </a:pPr>
             <a:r>
-              <a:rPr sz="2600" b="1">
+              <a:rPr sz="1500" b="1">
                 <a:solidFill>
                   <a:srgbClr val="FFFFFF"/>
                 </a:solidFill>
                 <a:latin typeface="Microsoft YaHei"/>
               </a:rPr>
-              <a:t>AI Agent 工作流程</a:t>
-            </a:r>
-          </a:p>
-        </p:txBody>
-      </p:sp>
-      <p:sp>
-        <p:nvSpPr>
-          <p:cNvPr id="6" name="TextBox 5"/>
+              <a:t>输入 Input</a:t>
+            </a:r>
+          </a:p>
+        </p:txBody>
+      </p:sp>
+      <p:sp>
+        <p:nvSpPr>
+          <p:cNvPr id="10" name="TextBox 9"/>
           <p:cNvSpPr txBox="1"/>
           <p:nvPr/>
         </p:nvSpPr>
         <p:spPr>
           <a:xfrm>
-            <a:off x="822960" y="1554480"/>
-            <a:ext cx="10515600" cy="4754880"/>
+            <a:off x="832104" y="4389120"/>
+            <a:ext cx="1645920" cy="868680"/>
           </a:xfrm>
           <a:prstGeom prst="rect">
             <a:avLst/>
@@ -3717,40 +3452,975 @@
           <a:noFill/>
         </p:spPr>
         <p:txBody>
-          <a:bodyPr wrap="square" lIns="0" tIns="0">
+          <a:bodyPr wrap="square" anchor="t">
             <a:spAutoFit/>
           </a:bodyPr>
           <a:lstStyle/>
           <a:p>
-            <a:pPr>
+            <a:pPr algn="l">
               <a:lnSpc>
-                <a:spcPct val="125000"/>
+                <a:spcPct val="105000"/>
               </a:lnSpc>
             </a:pPr>
             <a:r>
-              <a:rPr sz="1800" b="0">
-                <a:solidFill>
-                  <a:srgbClr val="2B2B2B"/>
+              <a:rPr sz="1150" b="0">
+                <a:solidFill>
+                  <a:srgbClr val="B8C4D6"/>
                 </a:solidFill>
                 <a:latin typeface="Microsoft YaHei"/>
               </a:rPr>
-              <a:t>•  输入 → 理解 → 执行 → 验证</a:t>
-            </a:r>
-          </a:p>
-          <a:p>
-            <a:pPr>
+              <a:t>接收指令、文件与上下文</a:t>
+            </a:r>
+          </a:p>
+        </p:txBody>
+      </p:sp>
+      <p:cxnSp>
+        <p:nvCxnSpPr>
+          <p:cNvPr id="11" name="Connector 10"/>
+          <p:cNvCxnSpPr/>
+          <p:nvPr/>
+        </p:nvCxnSpPr>
+        <p:spPr>
+          <a:xfrm>
+            <a:off x="2656332" y="4229100"/>
+            <a:ext cx="155448" cy="0"/>
+          </a:xfrm>
+          <a:prstGeom prst="line">
+            <a:avLst/>
+          </a:prstGeom>
+          <a:ln w="25400">
+            <a:solidFill>
+              <a:srgbClr val="F5B341"/>
+            </a:solidFill>
+            <a:headEnd type="arrow" w="med" len="med"/>
+          </a:ln>
+        </p:spPr>
+        <p:style>
+          <a:lnRef idx="2">
+            <a:schemeClr val="accent1"/>
+          </a:lnRef>
+          <a:fillRef idx="0">
+            <a:schemeClr val="accent1"/>
+          </a:fillRef>
+          <a:effectRef idx="1">
+            <a:schemeClr val="accent1"/>
+          </a:effectRef>
+          <a:fontRef idx="minor">
+            <a:schemeClr val="tx1"/>
+          </a:fontRef>
+        </p:style>
+      </p:cxnSp>
+      <p:sp>
+        <p:nvSpPr>
+          <p:cNvPr id="12" name="Rounded Rectangle 11"/>
+          <p:cNvSpPr/>
+          <p:nvPr/>
+        </p:nvSpPr>
+        <p:spPr>
+          <a:xfrm>
+            <a:off x="2843784" y="3063240"/>
+            <a:ext cx="1938528" cy="2331720"/>
+          </a:xfrm>
+          <a:prstGeom prst="roundRect">
+            <a:avLst>
+              <a:gd name="adj" fmla="val 10000"/>
+            </a:avLst>
+          </a:prstGeom>
+          <a:solidFill>
+            <a:srgbClr val="182A44"/>
+          </a:solidFill>
+          <a:ln w="9525">
+            <a:solidFill>
+              <a:srgbClr val="2C3E5E"/>
+            </a:solidFill>
+          </a:ln>
+          <a:effectLst/>
+        </p:spPr>
+        <p:style>
+          <a:lnRef idx="1">
+            <a:schemeClr val="accent1"/>
+          </a:lnRef>
+          <a:fillRef idx="3">
+            <a:schemeClr val="accent1"/>
+          </a:fillRef>
+          <a:effectRef idx="2">
+            <a:schemeClr val="accent1"/>
+          </a:effectRef>
+          <a:fontRef idx="minor">
+            <a:schemeClr val="lt1"/>
+          </a:fontRef>
+        </p:style>
+        <p:txBody>
+          <a:bodyPr rtlCol="0" anchor="ctr"/>
+          <a:lstStyle/>
+          <a:p>
+            <a:pPr algn="ctr"/>
+          </a:p>
+        </p:txBody>
+      </p:sp>
+      <p:sp>
+        <p:nvSpPr>
+          <p:cNvPr id="13" name="Rounded Rectangle 12"/>
+          <p:cNvSpPr/>
+          <p:nvPr/>
+        </p:nvSpPr>
+        <p:spPr>
+          <a:xfrm>
+            <a:off x="3008376" y="3227832"/>
+            <a:ext cx="475488" cy="475488"/>
+          </a:xfrm>
+          <a:prstGeom prst="roundRect">
+            <a:avLst>
+              <a:gd name="adj" fmla="val 50000"/>
+            </a:avLst>
+          </a:prstGeom>
+          <a:solidFill>
+            <a:srgbClr val="F5B341"/>
+          </a:solidFill>
+          <a:ln>
+            <a:noFill/>
+          </a:ln>
+          <a:effectLst/>
+        </p:spPr>
+        <p:style>
+          <a:lnRef idx="1">
+            <a:schemeClr val="accent1"/>
+          </a:lnRef>
+          <a:fillRef idx="3">
+            <a:schemeClr val="accent1"/>
+          </a:fillRef>
+          <a:effectRef idx="2">
+            <a:schemeClr val="accent1"/>
+          </a:effectRef>
+          <a:fontRef idx="minor">
+            <a:schemeClr val="lt1"/>
+          </a:fontRef>
+        </p:style>
+        <p:txBody>
+          <a:bodyPr rtlCol="0" anchor="ctr" wrap="none"/>
+          <a:lstStyle/>
+          <a:p>
+            <a:pPr algn="ctr"/>
+            <a:r>
+              <a:rPr sz="1300" b="1">
+                <a:solidFill>
+                  <a:srgbClr val="101B2D"/>
+                </a:solidFill>
+              </a:rPr>
+              <a:t>02</a:t>
+            </a:r>
+          </a:p>
+        </p:txBody>
+      </p:sp>
+      <p:sp>
+        <p:nvSpPr>
+          <p:cNvPr id="14" name="TextBox 13"/>
+          <p:cNvSpPr txBox="1"/>
+          <p:nvPr/>
+        </p:nvSpPr>
+        <p:spPr>
+          <a:xfrm>
+            <a:off x="2990088" y="3886200"/>
+            <a:ext cx="1645920" cy="411480"/>
+          </a:xfrm>
+          <a:prstGeom prst="rect">
+            <a:avLst/>
+          </a:prstGeom>
+          <a:noFill/>
+        </p:spPr>
+        <p:txBody>
+          <a:bodyPr wrap="square" anchor="t">
+            <a:spAutoFit/>
+          </a:bodyPr>
+          <a:lstStyle/>
+          <a:p>
+            <a:pPr algn="l">
               <a:lnSpc>
-                <a:spcPct val="125000"/>
+                <a:spcPct val="100000"/>
               </a:lnSpc>
             </a:pPr>
             <a:r>
-              <a:rPr sz="1800" b="0">
-                <a:solidFill>
-                  <a:srgbClr val="2B2B2B"/>
+              <a:rPr sz="1500" b="1">
+                <a:solidFill>
+                  <a:srgbClr val="FFFFFF"/>
                 </a:solidFill>
                 <a:latin typeface="Microsoft YaHei"/>
               </a:rPr>
-              <a:t>•  HTML 页面风格排版</a:t>
+              <a:t>理解 Understand</a:t>
+            </a:r>
+          </a:p>
+        </p:txBody>
+      </p:sp>
+      <p:sp>
+        <p:nvSpPr>
+          <p:cNvPr id="15" name="TextBox 14"/>
+          <p:cNvSpPr txBox="1"/>
+          <p:nvPr/>
+        </p:nvSpPr>
+        <p:spPr>
+          <a:xfrm>
+            <a:off x="2990088" y="4389120"/>
+            <a:ext cx="1645920" cy="868680"/>
+          </a:xfrm>
+          <a:prstGeom prst="rect">
+            <a:avLst/>
+          </a:prstGeom>
+          <a:noFill/>
+        </p:spPr>
+        <p:txBody>
+          <a:bodyPr wrap="square" anchor="t">
+            <a:spAutoFit/>
+          </a:bodyPr>
+          <a:lstStyle/>
+          <a:p>
+            <a:pPr algn="l">
+              <a:lnSpc>
+                <a:spcPct val="105000"/>
+              </a:lnSpc>
+            </a:pPr>
+            <a:r>
+              <a:rPr sz="1150" b="0">
+                <a:solidFill>
+                  <a:srgbClr val="B8C4D6"/>
+                </a:solidFill>
+                <a:latin typeface="Microsoft YaHei"/>
+              </a:rPr>
+              <a:t>任务分类、能力匹配与计划</a:t>
+            </a:r>
+          </a:p>
+        </p:txBody>
+      </p:sp>
+      <p:cxnSp>
+        <p:nvCxnSpPr>
+          <p:cNvPr id="16" name="Connector 15"/>
+          <p:cNvCxnSpPr/>
+          <p:nvPr/>
+        </p:nvCxnSpPr>
+        <p:spPr>
+          <a:xfrm>
+            <a:off x="4814316" y="4229100"/>
+            <a:ext cx="155448" cy="0"/>
+          </a:xfrm>
+          <a:prstGeom prst="line">
+            <a:avLst/>
+          </a:prstGeom>
+          <a:ln w="25400">
+            <a:solidFill>
+              <a:srgbClr val="F5B341"/>
+            </a:solidFill>
+            <a:headEnd type="arrow" w="med" len="med"/>
+          </a:ln>
+        </p:spPr>
+        <p:style>
+          <a:lnRef idx="2">
+            <a:schemeClr val="accent1"/>
+          </a:lnRef>
+          <a:fillRef idx="0">
+            <a:schemeClr val="accent1"/>
+          </a:fillRef>
+          <a:effectRef idx="1">
+            <a:schemeClr val="accent1"/>
+          </a:effectRef>
+          <a:fontRef idx="minor">
+            <a:schemeClr val="tx1"/>
+          </a:fontRef>
+        </p:style>
+      </p:cxnSp>
+      <p:sp>
+        <p:nvSpPr>
+          <p:cNvPr id="17" name="Rounded Rectangle 16"/>
+          <p:cNvSpPr/>
+          <p:nvPr/>
+        </p:nvSpPr>
+        <p:spPr>
+          <a:xfrm>
+            <a:off x="5001768" y="3063240"/>
+            <a:ext cx="1938528" cy="2331720"/>
+          </a:xfrm>
+          <a:prstGeom prst="roundRect">
+            <a:avLst>
+              <a:gd name="adj" fmla="val 10000"/>
+            </a:avLst>
+          </a:prstGeom>
+          <a:solidFill>
+            <a:srgbClr val="182A44"/>
+          </a:solidFill>
+          <a:ln w="9525">
+            <a:solidFill>
+              <a:srgbClr val="2C3E5E"/>
+            </a:solidFill>
+          </a:ln>
+          <a:effectLst/>
+        </p:spPr>
+        <p:style>
+          <a:lnRef idx="1">
+            <a:schemeClr val="accent1"/>
+          </a:lnRef>
+          <a:fillRef idx="3">
+            <a:schemeClr val="accent1"/>
+          </a:fillRef>
+          <a:effectRef idx="2">
+            <a:schemeClr val="accent1"/>
+          </a:effectRef>
+          <a:fontRef idx="minor">
+            <a:schemeClr val="lt1"/>
+          </a:fontRef>
+        </p:style>
+        <p:txBody>
+          <a:bodyPr rtlCol="0" anchor="ctr"/>
+          <a:lstStyle/>
+          <a:p>
+            <a:pPr algn="ctr"/>
+          </a:p>
+        </p:txBody>
+      </p:sp>
+      <p:sp>
+        <p:nvSpPr>
+          <p:cNvPr id="18" name="Rounded Rectangle 17"/>
+          <p:cNvSpPr/>
+          <p:nvPr/>
+        </p:nvSpPr>
+        <p:spPr>
+          <a:xfrm>
+            <a:off x="5166360" y="3227832"/>
+            <a:ext cx="475488" cy="475488"/>
+          </a:xfrm>
+          <a:prstGeom prst="roundRect">
+            <a:avLst>
+              <a:gd name="adj" fmla="val 50000"/>
+            </a:avLst>
+          </a:prstGeom>
+          <a:solidFill>
+            <a:srgbClr val="F5B341"/>
+          </a:solidFill>
+          <a:ln>
+            <a:noFill/>
+          </a:ln>
+          <a:effectLst/>
+        </p:spPr>
+        <p:style>
+          <a:lnRef idx="1">
+            <a:schemeClr val="accent1"/>
+          </a:lnRef>
+          <a:fillRef idx="3">
+            <a:schemeClr val="accent1"/>
+          </a:fillRef>
+          <a:effectRef idx="2">
+            <a:schemeClr val="accent1"/>
+          </a:effectRef>
+          <a:fontRef idx="minor">
+            <a:schemeClr val="lt1"/>
+          </a:fontRef>
+        </p:style>
+        <p:txBody>
+          <a:bodyPr rtlCol="0" anchor="ctr" wrap="none"/>
+          <a:lstStyle/>
+          <a:p>
+            <a:pPr algn="ctr"/>
+            <a:r>
+              <a:rPr sz="1300" b="1">
+                <a:solidFill>
+                  <a:srgbClr val="101B2D"/>
+                </a:solidFill>
+              </a:rPr>
+              <a:t>03</a:t>
+            </a:r>
+          </a:p>
+        </p:txBody>
+      </p:sp>
+      <p:sp>
+        <p:nvSpPr>
+          <p:cNvPr id="19" name="TextBox 18"/>
+          <p:cNvSpPr txBox="1"/>
+          <p:nvPr/>
+        </p:nvSpPr>
+        <p:spPr>
+          <a:xfrm>
+            <a:off x="5148072" y="3886200"/>
+            <a:ext cx="1645920" cy="411480"/>
+          </a:xfrm>
+          <a:prstGeom prst="rect">
+            <a:avLst/>
+          </a:prstGeom>
+          <a:noFill/>
+        </p:spPr>
+        <p:txBody>
+          <a:bodyPr wrap="square" anchor="t">
+            <a:spAutoFit/>
+          </a:bodyPr>
+          <a:lstStyle/>
+          <a:p>
+            <a:pPr algn="l">
+              <a:lnSpc>
+                <a:spcPct val="100000"/>
+              </a:lnSpc>
+            </a:pPr>
+            <a:r>
+              <a:rPr sz="1500" b="1">
+                <a:solidFill>
+                  <a:srgbClr val="FFFFFF"/>
+                </a:solidFill>
+                <a:latin typeface="Microsoft YaHei"/>
+              </a:rPr>
+              <a:t>规划 Plan</a:t>
+            </a:r>
+          </a:p>
+        </p:txBody>
+      </p:sp>
+      <p:sp>
+        <p:nvSpPr>
+          <p:cNvPr id="20" name="TextBox 19"/>
+          <p:cNvSpPr txBox="1"/>
+          <p:nvPr/>
+        </p:nvSpPr>
+        <p:spPr>
+          <a:xfrm>
+            <a:off x="5148072" y="4389120"/>
+            <a:ext cx="1645920" cy="868680"/>
+          </a:xfrm>
+          <a:prstGeom prst="rect">
+            <a:avLst/>
+          </a:prstGeom>
+          <a:noFill/>
+        </p:spPr>
+        <p:txBody>
+          <a:bodyPr wrap="square" anchor="t">
+            <a:spAutoFit/>
+          </a:bodyPr>
+          <a:lstStyle/>
+          <a:p>
+            <a:pPr algn="l">
+              <a:lnSpc>
+                <a:spcPct val="105000"/>
+              </a:lnSpc>
+            </a:pPr>
+            <a:r>
+              <a:rPr sz="1150" b="0">
+                <a:solidFill>
+                  <a:srgbClr val="B8C4D6"/>
+                </a:solidFill>
+                <a:latin typeface="Microsoft YaHei"/>
+              </a:rPr>
+              <a:t>生成执行合同与工具面</a:t>
+            </a:r>
+          </a:p>
+        </p:txBody>
+      </p:sp>
+      <p:cxnSp>
+        <p:nvCxnSpPr>
+          <p:cNvPr id="21" name="Connector 20"/>
+          <p:cNvCxnSpPr/>
+          <p:nvPr/>
+        </p:nvCxnSpPr>
+        <p:spPr>
+          <a:xfrm>
+            <a:off x="6972300" y="4229100"/>
+            <a:ext cx="155448" cy="0"/>
+          </a:xfrm>
+          <a:prstGeom prst="line">
+            <a:avLst/>
+          </a:prstGeom>
+          <a:ln w="25400">
+            <a:solidFill>
+              <a:srgbClr val="F5B341"/>
+            </a:solidFill>
+            <a:headEnd type="arrow" w="med" len="med"/>
+          </a:ln>
+        </p:spPr>
+        <p:style>
+          <a:lnRef idx="2">
+            <a:schemeClr val="accent1"/>
+          </a:lnRef>
+          <a:fillRef idx="0">
+            <a:schemeClr val="accent1"/>
+          </a:fillRef>
+          <a:effectRef idx="1">
+            <a:schemeClr val="accent1"/>
+          </a:effectRef>
+          <a:fontRef idx="minor">
+            <a:schemeClr val="tx1"/>
+          </a:fontRef>
+        </p:style>
+      </p:cxnSp>
+      <p:sp>
+        <p:nvSpPr>
+          <p:cNvPr id="22" name="Rounded Rectangle 21"/>
+          <p:cNvSpPr/>
+          <p:nvPr/>
+        </p:nvSpPr>
+        <p:spPr>
+          <a:xfrm>
+            <a:off x="7159752" y="3063240"/>
+            <a:ext cx="1938528" cy="2331720"/>
+          </a:xfrm>
+          <a:prstGeom prst="roundRect">
+            <a:avLst>
+              <a:gd name="adj" fmla="val 10000"/>
+            </a:avLst>
+          </a:prstGeom>
+          <a:solidFill>
+            <a:srgbClr val="182A44"/>
+          </a:solidFill>
+          <a:ln w="9525">
+            <a:solidFill>
+              <a:srgbClr val="2C3E5E"/>
+            </a:solidFill>
+          </a:ln>
+          <a:effectLst/>
+        </p:spPr>
+        <p:style>
+          <a:lnRef idx="1">
+            <a:schemeClr val="accent1"/>
+          </a:lnRef>
+          <a:fillRef idx="3">
+            <a:schemeClr val="accent1"/>
+          </a:fillRef>
+          <a:effectRef idx="2">
+            <a:schemeClr val="accent1"/>
+          </a:effectRef>
+          <a:fontRef idx="minor">
+            <a:schemeClr val="lt1"/>
+          </a:fontRef>
+        </p:style>
+        <p:txBody>
+          <a:bodyPr rtlCol="0" anchor="ctr"/>
+          <a:lstStyle/>
+          <a:p>
+            <a:pPr algn="ctr"/>
+          </a:p>
+        </p:txBody>
+      </p:sp>
+      <p:sp>
+        <p:nvSpPr>
+          <p:cNvPr id="23" name="Rounded Rectangle 22"/>
+          <p:cNvSpPr/>
+          <p:nvPr/>
+        </p:nvSpPr>
+        <p:spPr>
+          <a:xfrm>
+            <a:off x="7324344" y="3227832"/>
+            <a:ext cx="475488" cy="475488"/>
+          </a:xfrm>
+          <a:prstGeom prst="roundRect">
+            <a:avLst>
+              <a:gd name="adj" fmla="val 50000"/>
+            </a:avLst>
+          </a:prstGeom>
+          <a:solidFill>
+            <a:srgbClr val="F5B341"/>
+          </a:solidFill>
+          <a:ln>
+            <a:noFill/>
+          </a:ln>
+          <a:effectLst/>
+        </p:spPr>
+        <p:style>
+          <a:lnRef idx="1">
+            <a:schemeClr val="accent1"/>
+          </a:lnRef>
+          <a:fillRef idx="3">
+            <a:schemeClr val="accent1"/>
+          </a:fillRef>
+          <a:effectRef idx="2">
+            <a:schemeClr val="accent1"/>
+          </a:effectRef>
+          <a:fontRef idx="minor">
+            <a:schemeClr val="lt1"/>
+          </a:fontRef>
+        </p:style>
+        <p:txBody>
+          <a:bodyPr rtlCol="0" anchor="ctr" wrap="none"/>
+          <a:lstStyle/>
+          <a:p>
+            <a:pPr algn="ctr"/>
+            <a:r>
+              <a:rPr sz="1300" b="1">
+                <a:solidFill>
+                  <a:srgbClr val="101B2D"/>
+                </a:solidFill>
+              </a:rPr>
+              <a:t>04</a:t>
+            </a:r>
+          </a:p>
+        </p:txBody>
+      </p:sp>
+      <p:sp>
+        <p:nvSpPr>
+          <p:cNvPr id="24" name="TextBox 23"/>
+          <p:cNvSpPr txBox="1"/>
+          <p:nvPr/>
+        </p:nvSpPr>
+        <p:spPr>
+          <a:xfrm>
+            <a:off x="7306056" y="3886200"/>
+            <a:ext cx="1645920" cy="411480"/>
+          </a:xfrm>
+          <a:prstGeom prst="rect">
+            <a:avLst/>
+          </a:prstGeom>
+          <a:noFill/>
+        </p:spPr>
+        <p:txBody>
+          <a:bodyPr wrap="square" anchor="t">
+            <a:spAutoFit/>
+          </a:bodyPr>
+          <a:lstStyle/>
+          <a:p>
+            <a:pPr algn="l">
+              <a:lnSpc>
+                <a:spcPct val="100000"/>
+              </a:lnSpc>
+            </a:pPr>
+            <a:r>
+              <a:rPr sz="1500" b="1">
+                <a:solidFill>
+                  <a:srgbClr val="FFFFFF"/>
+                </a:solidFill>
+                <a:latin typeface="Microsoft YaHei"/>
+              </a:rPr>
+              <a:t>执行 Execute</a:t>
+            </a:r>
+          </a:p>
+        </p:txBody>
+      </p:sp>
+      <p:sp>
+        <p:nvSpPr>
+          <p:cNvPr id="25" name="TextBox 24"/>
+          <p:cNvSpPr txBox="1"/>
+          <p:nvPr/>
+        </p:nvSpPr>
+        <p:spPr>
+          <a:xfrm>
+            <a:off x="7306056" y="4389120"/>
+            <a:ext cx="1645920" cy="868680"/>
+          </a:xfrm>
+          <a:prstGeom prst="rect">
+            <a:avLst/>
+          </a:prstGeom>
+          <a:noFill/>
+        </p:spPr>
+        <p:txBody>
+          <a:bodyPr wrap="square" anchor="t">
+            <a:spAutoFit/>
+          </a:bodyPr>
+          <a:lstStyle/>
+          <a:p>
+            <a:pPr algn="l">
+              <a:lnSpc>
+                <a:spcPct val="105000"/>
+              </a:lnSpc>
+            </a:pPr>
+            <a:r>
+              <a:rPr sz="1150" b="0">
+                <a:solidFill>
+                  <a:srgbClr val="B8C4D6"/>
+                </a:solidFill>
+                <a:latin typeface="Microsoft YaHei"/>
+              </a:rPr>
+              <a:t>工具调用、事务与沙箱</a:t>
+            </a:r>
+          </a:p>
+        </p:txBody>
+      </p:sp>
+      <p:cxnSp>
+        <p:nvCxnSpPr>
+          <p:cNvPr id="26" name="Connector 25"/>
+          <p:cNvCxnSpPr/>
+          <p:nvPr/>
+        </p:nvCxnSpPr>
+        <p:spPr>
+          <a:xfrm>
+            <a:off x="9130284" y="4229100"/>
+            <a:ext cx="155448" cy="0"/>
+          </a:xfrm>
+          <a:prstGeom prst="line">
+            <a:avLst/>
+          </a:prstGeom>
+          <a:ln w="25400">
+            <a:solidFill>
+              <a:srgbClr val="F5B341"/>
+            </a:solidFill>
+            <a:headEnd type="arrow" w="med" len="med"/>
+          </a:ln>
+        </p:spPr>
+        <p:style>
+          <a:lnRef idx="2">
+            <a:schemeClr val="accent1"/>
+          </a:lnRef>
+          <a:fillRef idx="0">
+            <a:schemeClr val="accent1"/>
+          </a:fillRef>
+          <a:effectRef idx="1">
+            <a:schemeClr val="accent1"/>
+          </a:effectRef>
+          <a:fontRef idx="minor">
+            <a:schemeClr val="tx1"/>
+          </a:fontRef>
+        </p:style>
+      </p:cxnSp>
+      <p:sp>
+        <p:nvSpPr>
+          <p:cNvPr id="27" name="Rounded Rectangle 26"/>
+          <p:cNvSpPr/>
+          <p:nvPr/>
+        </p:nvSpPr>
+        <p:spPr>
+          <a:xfrm>
+            <a:off x="9317736" y="3063240"/>
+            <a:ext cx="1938528" cy="2331720"/>
+          </a:xfrm>
+          <a:prstGeom prst="roundRect">
+            <a:avLst>
+              <a:gd name="adj" fmla="val 10000"/>
+            </a:avLst>
+          </a:prstGeom>
+          <a:solidFill>
+            <a:srgbClr val="182A44"/>
+          </a:solidFill>
+          <a:ln w="9525">
+            <a:solidFill>
+              <a:srgbClr val="2C3E5E"/>
+            </a:solidFill>
+          </a:ln>
+          <a:effectLst/>
+        </p:spPr>
+        <p:style>
+          <a:lnRef idx="1">
+            <a:schemeClr val="accent1"/>
+          </a:lnRef>
+          <a:fillRef idx="3">
+            <a:schemeClr val="accent1"/>
+          </a:fillRef>
+          <a:effectRef idx="2">
+            <a:schemeClr val="accent1"/>
+          </a:effectRef>
+          <a:fontRef idx="minor">
+            <a:schemeClr val="lt1"/>
+          </a:fontRef>
+        </p:style>
+        <p:txBody>
+          <a:bodyPr rtlCol="0" anchor="ctr"/>
+          <a:lstStyle/>
+          <a:p>
+            <a:pPr algn="ctr"/>
+          </a:p>
+        </p:txBody>
+      </p:sp>
+      <p:sp>
+        <p:nvSpPr>
+          <p:cNvPr id="28" name="Rounded Rectangle 27"/>
+          <p:cNvSpPr/>
+          <p:nvPr/>
+        </p:nvSpPr>
+        <p:spPr>
+          <a:xfrm>
+            <a:off x="9482328" y="3227832"/>
+            <a:ext cx="475488" cy="475488"/>
+          </a:xfrm>
+          <a:prstGeom prst="roundRect">
+            <a:avLst>
+              <a:gd name="adj" fmla="val 50000"/>
+            </a:avLst>
+          </a:prstGeom>
+          <a:solidFill>
+            <a:srgbClr val="F5B341"/>
+          </a:solidFill>
+          <a:ln>
+            <a:noFill/>
+          </a:ln>
+          <a:effectLst/>
+        </p:spPr>
+        <p:style>
+          <a:lnRef idx="1">
+            <a:schemeClr val="accent1"/>
+          </a:lnRef>
+          <a:fillRef idx="3">
+            <a:schemeClr val="accent1"/>
+          </a:fillRef>
+          <a:effectRef idx="2">
+            <a:schemeClr val="accent1"/>
+          </a:effectRef>
+          <a:fontRef idx="minor">
+            <a:schemeClr val="lt1"/>
+          </a:fontRef>
+        </p:style>
+        <p:txBody>
+          <a:bodyPr rtlCol="0" anchor="ctr" wrap="none"/>
+          <a:lstStyle/>
+          <a:p>
+            <a:pPr algn="ctr"/>
+            <a:r>
+              <a:rPr sz="1300" b="1">
+                <a:solidFill>
+                  <a:srgbClr val="101B2D"/>
+                </a:solidFill>
+              </a:rPr>
+              <a:t>05</a:t>
+            </a:r>
+          </a:p>
+        </p:txBody>
+      </p:sp>
+      <p:sp>
+        <p:nvSpPr>
+          <p:cNvPr id="29" name="TextBox 28"/>
+          <p:cNvSpPr txBox="1"/>
+          <p:nvPr/>
+        </p:nvSpPr>
+        <p:spPr>
+          <a:xfrm>
+            <a:off x="9464040" y="3886200"/>
+            <a:ext cx="1645920" cy="411480"/>
+          </a:xfrm>
+          <a:prstGeom prst="rect">
+            <a:avLst/>
+          </a:prstGeom>
+          <a:noFill/>
+        </p:spPr>
+        <p:txBody>
+          <a:bodyPr wrap="square" anchor="t">
+            <a:spAutoFit/>
+          </a:bodyPr>
+          <a:lstStyle/>
+          <a:p>
+            <a:pPr algn="l">
+              <a:lnSpc>
+                <a:spcPct val="100000"/>
+              </a:lnSpc>
+            </a:pPr>
+            <a:r>
+              <a:rPr sz="1500" b="1">
+                <a:solidFill>
+                  <a:srgbClr val="FFFFFF"/>
+                </a:solidFill>
+                <a:latin typeface="Microsoft YaHei"/>
+              </a:rPr>
+              <a:t>验证 Verify</a:t>
+            </a:r>
+          </a:p>
+        </p:txBody>
+      </p:sp>
+      <p:sp>
+        <p:nvSpPr>
+          <p:cNvPr id="30" name="TextBox 29"/>
+          <p:cNvSpPr txBox="1"/>
+          <p:nvPr/>
+        </p:nvSpPr>
+        <p:spPr>
+          <a:xfrm>
+            <a:off x="9464040" y="4389120"/>
+            <a:ext cx="1645920" cy="868680"/>
+          </a:xfrm>
+          <a:prstGeom prst="rect">
+            <a:avLst/>
+          </a:prstGeom>
+          <a:noFill/>
+        </p:spPr>
+        <p:txBody>
+          <a:bodyPr wrap="square" anchor="t">
+            <a:spAutoFit/>
+          </a:bodyPr>
+          <a:lstStyle/>
+          <a:p>
+            <a:pPr algn="l">
+              <a:lnSpc>
+                <a:spcPct val="105000"/>
+              </a:lnSpc>
+            </a:pPr>
+            <a:r>
+              <a:rPr sz="1150" b="0">
+                <a:solidFill>
+                  <a:srgbClr val="B8C4D6"/>
+                </a:solidFill>
+                <a:latin typeface="Microsoft YaHei"/>
+              </a:rPr>
+              <a:t>结构、渲染、视觉与评估器</a:t>
+            </a:r>
+          </a:p>
+        </p:txBody>
+      </p:sp>
+      <p:sp>
+        <p:nvSpPr>
+          <p:cNvPr id="31" name="Rounded Rectangle 30"/>
+          <p:cNvSpPr/>
+          <p:nvPr/>
+        </p:nvSpPr>
+        <p:spPr>
+          <a:xfrm>
+            <a:off x="685800" y="5806440"/>
+            <a:ext cx="10817352" cy="566928"/>
+          </a:xfrm>
+          <a:prstGeom prst="roundRect">
+            <a:avLst>
+              <a:gd name="adj" fmla="val 50000"/>
+            </a:avLst>
+          </a:prstGeom>
+          <a:solidFill>
+            <a:srgbClr val="182A44"/>
+          </a:solidFill>
+          <a:ln w="9525">
+            <a:solidFill>
+              <a:srgbClr val="2C3E5E"/>
+            </a:solidFill>
+          </a:ln>
+          <a:effectLst/>
+        </p:spPr>
+        <p:style>
+          <a:lnRef idx="1">
+            <a:schemeClr val="accent1"/>
+          </a:lnRef>
+          <a:fillRef idx="3">
+            <a:schemeClr val="accent1"/>
+          </a:fillRef>
+          <a:effectRef idx="2">
+            <a:schemeClr val="accent1"/>
+          </a:effectRef>
+          <a:fontRef idx="minor">
+            <a:schemeClr val="lt1"/>
+          </a:fontRef>
+        </p:style>
+        <p:txBody>
+          <a:bodyPr rtlCol="0" anchor="ctr"/>
+          <a:lstStyle/>
+          <a:p>
+            <a:pPr algn="ctr"/>
+          </a:p>
+        </p:txBody>
+      </p:sp>
+      <p:sp>
+        <p:nvSpPr>
+          <p:cNvPr id="32" name="TextBox 31"/>
+          <p:cNvSpPr txBox="1"/>
+          <p:nvPr/>
+        </p:nvSpPr>
+        <p:spPr>
+          <a:xfrm>
+            <a:off x="868680" y="5916168"/>
+            <a:ext cx="10424160" cy="365760"/>
+          </a:xfrm>
+          <a:prstGeom prst="rect">
+            <a:avLst/>
+          </a:prstGeom>
+          <a:noFill/>
+        </p:spPr>
+        <p:txBody>
+          <a:bodyPr wrap="square" anchor="t">
+            <a:spAutoFit/>
+          </a:bodyPr>
+          <a:lstStyle/>
+          <a:p>
+            <a:pPr algn="ctr">
+              <a:lnSpc>
+                <a:spcPct val="100000"/>
+              </a:lnSpc>
+            </a:pPr>
+            <a:r>
+              <a:rPr sz="1300" b="1">
+                <a:solidFill>
+                  <a:srgbClr val="F5B341"/>
+                </a:solidFill>
+                <a:latin typeface="Microsoft YaHei"/>
+              </a:rPr>
+              <a:t>INPUT → UNDERSTAND → PLAN → EXECUTE → VERIFY → DELIVER</a:t>
             </a:r>
           </a:p>
         </p:txBody>
@@ -3788,7 +4458,7 @@
             <a:avLst/>
           </a:prstGeom>
           <a:solidFill>
-            <a:srgbClr val="FFFFFF"/>
+            <a:srgbClr val="F4F6F9"/>
           </a:solidFill>
           <a:ln>
             <a:noFill/>
@@ -3826,13 +4496,61 @@
         <p:spPr>
           <a:xfrm>
             <a:off x="0" y="0"/>
-            <a:ext cx="12191695" cy="841248"/>
+            <a:ext cx="12191695" cy="713232"/>
           </a:xfrm>
           <a:prstGeom prst="rect">
             <a:avLst/>
           </a:prstGeom>
           <a:solidFill>
-            <a:srgbClr val="121212"/>
+            <a:srgbClr val="FFFFFF"/>
+          </a:solidFill>
+          <a:ln w="9525">
+            <a:solidFill>
+              <a:srgbClr val="E3E8EE"/>
+            </a:solidFill>
+          </a:ln>
+          <a:effectLst/>
+        </p:spPr>
+        <p:style>
+          <a:lnRef idx="1">
+            <a:schemeClr val="accent1"/>
+          </a:lnRef>
+          <a:fillRef idx="3">
+            <a:schemeClr val="accent1"/>
+          </a:fillRef>
+          <a:effectRef idx="2">
+            <a:schemeClr val="accent1"/>
+          </a:effectRef>
+          <a:fontRef idx="minor">
+            <a:schemeClr val="lt1"/>
+          </a:fontRef>
+        </p:style>
+        <p:txBody>
+          <a:bodyPr rtlCol="0" anchor="ctr"/>
+          <a:lstStyle/>
+          <a:p>
+            <a:pPr algn="ctr"/>
+          </a:p>
+        </p:txBody>
+      </p:sp>
+      <p:sp>
+        <p:nvSpPr>
+          <p:cNvPr id="4" name="Rounded Rectangle 3"/>
+          <p:cNvSpPr/>
+          <p:nvPr/>
+        </p:nvSpPr>
+        <p:spPr>
+          <a:xfrm>
+            <a:off x="502920" y="182880"/>
+            <a:ext cx="347472" cy="347472"/>
+          </a:xfrm>
+          <a:prstGeom prst="roundRect">
+            <a:avLst>
+              <a:gd name="adj" fmla="val 50000"/>
+            </a:avLst>
+          </a:prstGeom>
+          <a:solidFill>
+            <a:srgbClr val="3B82F6"/>
           </a:solidFill>
           <a:ln>
             <a:noFill/>
@@ -3863,14 +4581,14 @@
       </p:sp>
       <p:sp>
         <p:nvSpPr>
-          <p:cNvPr id="4" name="TextBox 3"/>
+          <p:cNvPr id="5" name="TextBox 4"/>
           <p:cNvSpPr txBox="1"/>
           <p:nvPr/>
         </p:nvSpPr>
         <p:spPr>
           <a:xfrm>
-            <a:off x="438912" y="146304"/>
-            <a:ext cx="8961120" cy="475488"/>
+            <a:off x="1005840" y="146304"/>
+            <a:ext cx="2743200" cy="411480"/>
           </a:xfrm>
           <a:prstGeom prst="rect">
             <a:avLst/>
@@ -3878,49 +4596,88 @@
           <a:noFill/>
         </p:spPr>
         <p:txBody>
-          <a:bodyPr wrap="square" lIns="0" tIns="0">
+          <a:bodyPr wrap="square" anchor="t">
             <a:spAutoFit/>
           </a:bodyPr>
           <a:lstStyle/>
           <a:p>
-            <a:pPr>
+            <a:pPr algn="l">
               <a:lnSpc>
-                <a:spcPct val="125000"/>
+                <a:spcPct val="100000"/>
               </a:lnSpc>
             </a:pPr>
             <a:r>
-              <a:rPr sz="2500" b="1">
-                <a:solidFill>
-                  <a:srgbClr val="FFFFFF"/>
+              <a:rPr sz="1500" b="1">
+                <a:solidFill>
+                  <a:srgbClr val="222A35"/>
                 </a:solidFill>
                 <a:latin typeface="Microsoft YaHei"/>
               </a:rPr>
-              <a:t>AI Agent 工作流程</a:t>
-            </a:r>
-          </a:p>
-        </p:txBody>
-      </p:sp>
-      <p:sp>
-        <p:nvSpPr>
-          <p:cNvPr id="5" name="Rectangle 4"/>
-          <p:cNvSpPr/>
-          <p:nvPr/>
-        </p:nvSpPr>
-        <p:spPr>
-          <a:xfrm>
-            <a:off x="438912" y="1078992"/>
-            <a:ext cx="5504688" cy="2359152"/>
+              <a:t>AI Agent Console</a:t>
+            </a:r>
+          </a:p>
+        </p:txBody>
+      </p:sp>
+      <p:sp>
+        <p:nvSpPr>
+          <p:cNvPr id="6" name="TextBox 5"/>
+          <p:cNvSpPr txBox="1"/>
+          <p:nvPr/>
+        </p:nvSpPr>
+        <p:spPr>
+          <a:xfrm>
+            <a:off x="4160520" y="219456"/>
+            <a:ext cx="2011680" cy="320040"/>
           </a:xfrm>
           <a:prstGeom prst="rect">
             <a:avLst/>
           </a:prstGeom>
+          <a:noFill/>
+        </p:spPr>
+        <p:txBody>
+          <a:bodyPr wrap="square" anchor="t">
+            <a:spAutoFit/>
+          </a:bodyPr>
+          <a:lstStyle/>
+          <a:p>
+            <a:pPr algn="l">
+              <a:lnSpc>
+                <a:spcPct val="100000"/>
+              </a:lnSpc>
+            </a:pPr>
+            <a:r>
+              <a:rPr sz="1100" b="1">
+                <a:solidFill>
+                  <a:srgbClr val="10B981"/>
+                </a:solidFill>
+                <a:latin typeface="Microsoft YaHei"/>
+              </a:rPr>
+              <a:t>● 系统在线</a:t>
+            </a:r>
+          </a:p>
+        </p:txBody>
+      </p:sp>
+      <p:sp>
+        <p:nvSpPr>
+          <p:cNvPr id="7" name="Rounded Rectangle 6"/>
+          <p:cNvSpPr/>
+          <p:nvPr/>
+        </p:nvSpPr>
+        <p:spPr>
+          <a:xfrm>
+            <a:off x="9646920" y="173736"/>
+            <a:ext cx="2057400" cy="384048"/>
+          </a:xfrm>
+          <a:prstGeom prst="roundRect">
+            <a:avLst>
+              <a:gd name="adj" fmla="val 50000"/>
+            </a:avLst>
+          </a:prstGeom>
           <a:solidFill>
-            <a:srgbClr val="FFFFFF"/>
+            <a:srgbClr val="3B82F6"/>
           </a:solidFill>
-          <a:ln w="13970">
-            <a:solidFill>
-              <a:srgbClr val="C8C8C8"/>
-            </a:solidFill>
+          <a:ln>
+            <a:noFill/>
           </a:ln>
           <a:effectLst/>
         </p:spPr>
@@ -3948,20 +4705,185 @@
       </p:sp>
       <p:sp>
         <p:nvSpPr>
-          <p:cNvPr id="6" name="Rectangle 5"/>
-          <p:cNvSpPr/>
-          <p:nvPr/>
-        </p:nvSpPr>
-        <p:spPr>
-          <a:xfrm>
-            <a:off x="438912" y="1078992"/>
-            <a:ext cx="73152" cy="2359152"/>
+          <p:cNvPr id="8" name="TextBox 7"/>
+          <p:cNvSpPr txBox="1"/>
+          <p:nvPr/>
+        </p:nvSpPr>
+        <p:spPr>
+          <a:xfrm>
+            <a:off x="9646920" y="237744"/>
+            <a:ext cx="2057400" cy="274320"/>
           </a:xfrm>
           <a:prstGeom prst="rect">
             <a:avLst/>
           </a:prstGeom>
+          <a:noFill/>
+        </p:spPr>
+        <p:txBody>
+          <a:bodyPr wrap="square" anchor="t">
+            <a:spAutoFit/>
+          </a:bodyPr>
+          <a:lstStyle/>
+          <a:p>
+            <a:pPr algn="ctr">
+              <a:lnSpc>
+                <a:spcPct val="100000"/>
+              </a:lnSpc>
+            </a:pPr>
+            <a:r>
+              <a:rPr sz="1150" b="1">
+                <a:solidFill>
+                  <a:srgbClr val="FFFFFF"/>
+                </a:solidFill>
+                <a:latin typeface="Microsoft YaHei"/>
+              </a:rPr>
+              <a:t>＋ 新建任务</a:t>
+            </a:r>
+          </a:p>
+        </p:txBody>
+      </p:sp>
+      <p:sp>
+        <p:nvSpPr>
+          <p:cNvPr id="9" name="TextBox 8"/>
+          <p:cNvSpPr txBox="1"/>
+          <p:nvPr/>
+        </p:nvSpPr>
+        <p:spPr>
+          <a:xfrm>
+            <a:off x="685800" y="932688"/>
+            <a:ext cx="10789920" cy="502920"/>
+          </a:xfrm>
+          <a:prstGeom prst="rect">
+            <a:avLst/>
+          </a:prstGeom>
+          <a:noFill/>
+        </p:spPr>
+        <p:txBody>
+          <a:bodyPr wrap="square" anchor="t">
+            <a:spAutoFit/>
+          </a:bodyPr>
+          <a:lstStyle/>
+          <a:p>
+            <a:pPr algn="l">
+              <a:lnSpc>
+                <a:spcPct val="100000"/>
+              </a:lnSpc>
+            </a:pPr>
+            <a:r>
+              <a:rPr sz="2600" b="1">
+                <a:solidFill>
+                  <a:srgbClr val="222A35"/>
+                </a:solidFill>
+                <a:latin typeface="Microsoft YaHei"/>
+              </a:rPr>
+              <a:t>工作台 · 四阶段运行视图</a:t>
+            </a:r>
+          </a:p>
+        </p:txBody>
+      </p:sp>
+      <p:sp>
+        <p:nvSpPr>
+          <p:cNvPr id="10" name="TextBox 9"/>
+          <p:cNvSpPr txBox="1"/>
+          <p:nvPr/>
+        </p:nvSpPr>
+        <p:spPr>
+          <a:xfrm>
+            <a:off x="685800" y="1463040"/>
+            <a:ext cx="10789920" cy="365760"/>
+          </a:xfrm>
+          <a:prstGeom prst="rect">
+            <a:avLst/>
+          </a:prstGeom>
+          <a:noFill/>
+        </p:spPr>
+        <p:txBody>
+          <a:bodyPr wrap="square" anchor="t">
+            <a:spAutoFit/>
+          </a:bodyPr>
+          <a:lstStyle/>
+          <a:p>
+            <a:pPr algn="l">
+              <a:lnSpc>
+                <a:spcPct val="100000"/>
+              </a:lnSpc>
+            </a:pPr>
+            <a:r>
+              <a:rPr sz="1300" b="0">
+                <a:solidFill>
+                  <a:srgbClr val="6B7480"/>
+                </a:solidFill>
+                <a:latin typeface="Microsoft YaHei"/>
+              </a:rPr>
+              <a:t>将复杂任务拆解为可验证的阶段，实时跟踪每一步的状态与证据</a:t>
+            </a:r>
+          </a:p>
+        </p:txBody>
+      </p:sp>
+      <p:sp>
+        <p:nvSpPr>
+          <p:cNvPr id="11" name="Rounded Rectangle 10"/>
+          <p:cNvSpPr/>
+          <p:nvPr/>
+        </p:nvSpPr>
+        <p:spPr>
+          <a:xfrm>
+            <a:off x="685800" y="2057400"/>
+            <a:ext cx="5212080" cy="2084831"/>
+          </a:xfrm>
+          <a:prstGeom prst="roundRect">
+            <a:avLst>
+              <a:gd name="adj" fmla="val 6000"/>
+            </a:avLst>
+          </a:prstGeom>
           <a:solidFill>
-            <a:srgbClr val="F09A1A"/>
+            <a:srgbClr val="FFFFFF"/>
+          </a:solidFill>
+          <a:ln w="9525">
+            <a:solidFill>
+              <a:srgbClr val="E3E8EE"/>
+            </a:solidFill>
+          </a:ln>
+          <a:effectLst/>
+        </p:spPr>
+        <p:style>
+          <a:lnRef idx="1">
+            <a:schemeClr val="accent1"/>
+          </a:lnRef>
+          <a:fillRef idx="3">
+            <a:schemeClr val="accent1"/>
+          </a:fillRef>
+          <a:effectRef idx="2">
+            <a:schemeClr val="accent1"/>
+          </a:effectRef>
+          <a:fontRef idx="minor">
+            <a:schemeClr val="lt1"/>
+          </a:fontRef>
+        </p:style>
+        <p:txBody>
+          <a:bodyPr rtlCol="0" anchor="ctr"/>
+          <a:lstStyle/>
+          <a:p>
+            <a:pPr algn="ctr"/>
+          </a:p>
+        </p:txBody>
+      </p:sp>
+      <p:sp>
+        <p:nvSpPr>
+          <p:cNvPr id="12" name="Rectangle 11"/>
+          <p:cNvSpPr/>
+          <p:nvPr/>
+        </p:nvSpPr>
+        <p:spPr>
+          <a:xfrm>
+            <a:off x="685800" y="2057400"/>
+            <a:ext cx="82296" cy="2084831"/>
+          </a:xfrm>
+          <a:prstGeom prst="rect">
+            <a:avLst/>
+          </a:prstGeom>
+          <a:solidFill>
+            <a:srgbClr val="3B82F6"/>
           </a:solidFill>
           <a:ln>
             <a:noFill/>
@@ -3992,252 +4914,25 @@
       </p:sp>
       <p:sp>
         <p:nvSpPr>
-          <p:cNvPr id="7" name="TextBox 6"/>
-          <p:cNvSpPr txBox="1"/>
-          <p:nvPr/>
-        </p:nvSpPr>
-        <p:spPr>
-          <a:xfrm>
-            <a:off x="667512" y="1243584"/>
-            <a:ext cx="502920" cy="292608"/>
-          </a:xfrm>
-          <a:prstGeom prst="rect">
-            <a:avLst/>
-          </a:prstGeom>
-          <a:noFill/>
-        </p:spPr>
-        <p:txBody>
-          <a:bodyPr wrap="square" lIns="0" tIns="0">
-            <a:spAutoFit/>
-          </a:bodyPr>
-          <a:lstStyle/>
-          <a:p>
-            <a:pPr>
-              <a:lnSpc>
-                <a:spcPct val="125000"/>
-              </a:lnSpc>
-            </a:pPr>
-            <a:r>
-              <a:rPr sz="1100" b="1">
-                <a:solidFill>
-                  <a:srgbClr val="878787"/>
-                </a:solidFill>
-                <a:latin typeface="Microsoft YaHei"/>
-              </a:rPr>
-              <a:t>Q1</a:t>
-            </a:r>
-          </a:p>
-        </p:txBody>
-      </p:sp>
-      <p:sp>
-        <p:nvSpPr>
-          <p:cNvPr id="8" name="TextBox 7"/>
-          <p:cNvSpPr txBox="1"/>
-          <p:nvPr/>
-        </p:nvSpPr>
-        <p:spPr>
-          <a:xfrm>
-            <a:off x="1188719" y="1197864"/>
-            <a:ext cx="2697480" cy="411480"/>
-          </a:xfrm>
-          <a:prstGeom prst="rect">
-            <a:avLst/>
-          </a:prstGeom>
-          <a:noFill/>
-        </p:spPr>
-        <p:txBody>
-          <a:bodyPr wrap="square" lIns="0" tIns="0">
-            <a:spAutoFit/>
-          </a:bodyPr>
-          <a:lstStyle/>
-          <a:p>
-            <a:pPr>
-              <a:lnSpc>
-                <a:spcPct val="125000"/>
-              </a:lnSpc>
-            </a:pPr>
-            <a:r>
-              <a:rPr sz="1600" b="1">
-                <a:solidFill>
-                  <a:srgbClr val="161616"/>
-                </a:solidFill>
-                <a:latin typeface="Microsoft YaHei"/>
-              </a:rPr>
-              <a:t>输入 Input</a:t>
-            </a:r>
-          </a:p>
-        </p:txBody>
-      </p:sp>
-      <p:sp>
-        <p:nvSpPr>
-          <p:cNvPr id="9" name="TextBox 8"/>
-          <p:cNvSpPr txBox="1"/>
-          <p:nvPr/>
-        </p:nvSpPr>
-        <p:spPr>
-          <a:xfrm>
-            <a:off x="3959352" y="1170432"/>
-            <a:ext cx="1691640" cy="438912"/>
-          </a:xfrm>
-          <a:prstGeom prst="rect">
-            <a:avLst/>
-          </a:prstGeom>
-          <a:noFill/>
-        </p:spPr>
-        <p:txBody>
-          <a:bodyPr wrap="square" lIns="0" tIns="0">
-            <a:spAutoFit/>
-          </a:bodyPr>
-          <a:lstStyle/>
-          <a:p>
-            <a:pPr algn="r">
-              <a:lnSpc>
-                <a:spcPct val="125000"/>
-              </a:lnSpc>
-            </a:pPr>
-            <a:r>
-              <a:rPr sz="1800" b="1">
-                <a:solidFill>
-                  <a:srgbClr val="161616"/>
-                </a:solidFill>
-                <a:latin typeface="Microsoft YaHei"/>
-              </a:rPr>
-              <a:t>01</a:t>
-            </a:r>
-          </a:p>
-        </p:txBody>
-      </p:sp>
-      <p:sp>
-        <p:nvSpPr>
-          <p:cNvPr id="10" name="TextBox 9"/>
-          <p:cNvSpPr txBox="1"/>
-          <p:nvPr/>
-        </p:nvSpPr>
-        <p:spPr>
-          <a:xfrm>
-            <a:off x="694944" y="1737360"/>
-            <a:ext cx="4956048" cy="1298448"/>
-          </a:xfrm>
-          <a:prstGeom prst="rect">
-            <a:avLst/>
-          </a:prstGeom>
-          <a:noFill/>
-        </p:spPr>
-        <p:txBody>
-          <a:bodyPr wrap="square" lIns="0" tIns="0">
-            <a:spAutoFit/>
-          </a:bodyPr>
-          <a:lstStyle/>
-          <a:p>
-            <a:pPr>
-              <a:lnSpc>
-                <a:spcPct val="108000"/>
-              </a:lnSpc>
-            </a:pPr>
-            <a:r>
-              <a:rPr sz="1100" b="0">
-                <a:solidFill>
-                  <a:srgbClr val="2B2B2B"/>
-                </a:solidFill>
-                <a:latin typeface="Microsoft YaHei"/>
-              </a:rPr>
-              <a:t>接收用户指令与任务输入</a:t>
-            </a:r>
-          </a:p>
-          <a:p>
-            <a:pPr>
-              <a:lnSpc>
-                <a:spcPct val="108000"/>
-              </a:lnSpc>
-            </a:pPr>
-            <a:r>
-              <a:rPr sz="1100" b="0">
-                <a:solidFill>
-                  <a:srgbClr val="2B2B2B"/>
-                </a:solidFill>
-                <a:latin typeface="Microsoft YaHei"/>
-              </a:rPr>
-              <a:t>• 明确任务目标</a:t>
-            </a:r>
-          </a:p>
-          <a:p>
-            <a:pPr>
-              <a:lnSpc>
-                <a:spcPct val="108000"/>
-              </a:lnSpc>
-            </a:pPr>
-            <a:r>
-              <a:rPr sz="1100" b="0">
-                <a:solidFill>
-                  <a:srgbClr val="2B2B2B"/>
-                </a:solidFill>
-                <a:latin typeface="Microsoft YaHei"/>
-              </a:rPr>
-              <a:t>• 收集所需信息</a:t>
-            </a:r>
-          </a:p>
-        </p:txBody>
-      </p:sp>
-      <p:sp>
-        <p:nvSpPr>
-          <p:cNvPr id="11" name="Q1_provenance_流程起点"/>
-          <p:cNvSpPr txBox="1"/>
-          <p:nvPr/>
-        </p:nvSpPr>
-        <p:spPr>
-          <a:xfrm>
-            <a:off x="694944" y="3081528"/>
-            <a:ext cx="4892040" cy="201168"/>
-          </a:xfrm>
-          <a:prstGeom prst="rect">
-            <a:avLst/>
-          </a:prstGeom>
-          <a:noFill/>
-        </p:spPr>
-        <p:txBody>
-          <a:bodyPr wrap="square" lIns="0" tIns="0">
-            <a:spAutoFit/>
-          </a:bodyPr>
-          <a:lstStyle/>
-          <a:p>
-            <a:pPr>
-              <a:lnSpc>
-                <a:spcPct val="125000"/>
-              </a:lnSpc>
-            </a:pPr>
-            <a:r>
-              <a:rPr sz="800" b="0">
-                <a:solidFill>
-                  <a:srgbClr val="878787"/>
-                </a:solidFill>
-                <a:latin typeface="Microsoft YaHei"/>
-              </a:rPr>
-              <a:t>流程起点</a:t>
-            </a:r>
-          </a:p>
-        </p:txBody>
-      </p:sp>
-      <p:sp>
-        <p:nvSpPr>
-          <p:cNvPr id="12" name="Rectangle 11"/>
+          <p:cNvPr id="13" name="Rounded Rectangle 12"/>
           <p:cNvSpPr/>
           <p:nvPr/>
         </p:nvSpPr>
         <p:spPr>
           <a:xfrm>
-            <a:off x="6245352" y="1078992"/>
-            <a:ext cx="5504688" cy="2359152"/>
-          </a:xfrm>
-          <a:prstGeom prst="rect">
-            <a:avLst/>
+            <a:off x="960120" y="2258568"/>
+            <a:ext cx="566928" cy="566928"/>
+          </a:xfrm>
+          <a:prstGeom prst="roundRect">
+            <a:avLst>
+              <a:gd name="adj" fmla="val 18000"/>
+            </a:avLst>
           </a:prstGeom>
           <a:solidFill>
-            <a:srgbClr val="FFFFFF"/>
+            <a:srgbClr val="3B82F6"/>
           </a:solidFill>
-          <a:ln w="13970">
-            <a:solidFill>
-              <a:srgbClr val="C8C8C8"/>
-            </a:solidFill>
+          <a:ln>
+            <a:noFill/>
           </a:ln>
           <a:effectLst/>
         </p:spPr>
@@ -4265,20 +4960,100 @@
       </p:sp>
       <p:sp>
         <p:nvSpPr>
-          <p:cNvPr id="13" name="Rectangle 12"/>
-          <p:cNvSpPr/>
-          <p:nvPr/>
-        </p:nvSpPr>
-        <p:spPr>
-          <a:xfrm>
-            <a:off x="6245352" y="1078992"/>
-            <a:ext cx="73152" cy="2359152"/>
+          <p:cNvPr id="14" name="TextBox 13"/>
+          <p:cNvSpPr txBox="1"/>
+          <p:nvPr/>
+        </p:nvSpPr>
+        <p:spPr>
+          <a:xfrm>
+            <a:off x="960120" y="2331720"/>
+            <a:ext cx="566928" cy="411480"/>
           </a:xfrm>
           <a:prstGeom prst="rect">
             <a:avLst/>
           </a:prstGeom>
+          <a:noFill/>
+        </p:spPr>
+        <p:txBody>
+          <a:bodyPr wrap="square" anchor="t">
+            <a:spAutoFit/>
+          </a:bodyPr>
+          <a:lstStyle/>
+          <a:p>
+            <a:pPr algn="ctr">
+              <a:lnSpc>
+                <a:spcPct val="100000"/>
+              </a:lnSpc>
+            </a:pPr>
+            <a:r>
+              <a:rPr sz="1400" b="1">
+                <a:solidFill>
+                  <a:srgbClr val="FFFFFF"/>
+                </a:solidFill>
+                <a:latin typeface="Microsoft YaHei"/>
+              </a:rPr>
+              <a:t>01</a:t>
+            </a:r>
+          </a:p>
+        </p:txBody>
+      </p:sp>
+      <p:sp>
+        <p:nvSpPr>
+          <p:cNvPr id="15" name="TextBox 14"/>
+          <p:cNvSpPr txBox="1"/>
+          <p:nvPr/>
+        </p:nvSpPr>
+        <p:spPr>
+          <a:xfrm>
+            <a:off x="1691640" y="2240280"/>
+            <a:ext cx="2926080" cy="365760"/>
+          </a:xfrm>
+          <a:prstGeom prst="rect">
+            <a:avLst/>
+          </a:prstGeom>
+          <a:noFill/>
+        </p:spPr>
+        <p:txBody>
+          <a:bodyPr wrap="square" anchor="t">
+            <a:spAutoFit/>
+          </a:bodyPr>
+          <a:lstStyle/>
+          <a:p>
+            <a:pPr algn="l">
+              <a:lnSpc>
+                <a:spcPct val="100000"/>
+              </a:lnSpc>
+            </a:pPr>
+            <a:r>
+              <a:rPr sz="1700" b="1">
+                <a:solidFill>
+                  <a:srgbClr val="222A35"/>
+                </a:solidFill>
+                <a:latin typeface="Microsoft YaHei"/>
+              </a:rPr>
+              <a:t>输入 Input</a:t>
+            </a:r>
+          </a:p>
+        </p:txBody>
+      </p:sp>
+      <p:sp>
+        <p:nvSpPr>
+          <p:cNvPr id="16" name="Rounded Rectangle 15"/>
+          <p:cNvSpPr/>
+          <p:nvPr/>
+        </p:nvSpPr>
+        <p:spPr>
+          <a:xfrm>
+            <a:off x="4754880" y="2313432"/>
+            <a:ext cx="868680" cy="274320"/>
+          </a:xfrm>
+          <a:prstGeom prst="roundRect">
+            <a:avLst>
+              <a:gd name="adj" fmla="val 50000"/>
+            </a:avLst>
+          </a:prstGeom>
           <a:solidFill>
-            <a:srgbClr val="F09A1A"/>
+            <a:srgbClr val="F4F6F9"/>
           </a:solidFill>
           <a:ln>
             <a:noFill/>
@@ -4309,14 +5084,14 @@
       </p:sp>
       <p:sp>
         <p:nvSpPr>
-          <p:cNvPr id="14" name="TextBox 13"/>
+          <p:cNvPr id="17" name="TextBox 16"/>
           <p:cNvSpPr txBox="1"/>
           <p:nvPr/>
         </p:nvSpPr>
         <p:spPr>
           <a:xfrm>
-            <a:off x="6473952" y="1243584"/>
-            <a:ext cx="502920" cy="292608"/>
+            <a:off x="4754880" y="2350008"/>
+            <a:ext cx="868680" cy="201168"/>
           </a:xfrm>
           <a:prstGeom prst="rect">
             <a:avLst/>
@@ -4324,38 +5099,38 @@
           <a:noFill/>
         </p:spPr>
         <p:txBody>
-          <a:bodyPr wrap="square" lIns="0" tIns="0">
+          <a:bodyPr wrap="square" anchor="t">
             <a:spAutoFit/>
           </a:bodyPr>
           <a:lstStyle/>
           <a:p>
-            <a:pPr>
+            <a:pPr algn="ctr">
               <a:lnSpc>
-                <a:spcPct val="125000"/>
+                <a:spcPct val="100000"/>
               </a:lnSpc>
             </a:pPr>
             <a:r>
-              <a:rPr sz="1100" b="1">
-                <a:solidFill>
-                  <a:srgbClr val="878787"/>
+              <a:rPr sz="900" b="1">
+                <a:solidFill>
+                  <a:srgbClr val="3B82F6"/>
                 </a:solidFill>
                 <a:latin typeface="Microsoft YaHei"/>
               </a:rPr>
-              <a:t>Q2</a:t>
-            </a:r>
-          </a:p>
-        </p:txBody>
-      </p:sp>
-      <p:sp>
-        <p:nvSpPr>
-          <p:cNvPr id="15" name="TextBox 14"/>
+              <a:t>INPUT</a:t>
+            </a:r>
+          </a:p>
+        </p:txBody>
+      </p:sp>
+      <p:sp>
+        <p:nvSpPr>
+          <p:cNvPr id="18" name="TextBox 17"/>
           <p:cNvSpPr txBox="1"/>
           <p:nvPr/>
         </p:nvSpPr>
         <p:spPr>
           <a:xfrm>
-            <a:off x="6995160" y="1197864"/>
-            <a:ext cx="2697480" cy="411480"/>
+            <a:off x="978408" y="2916936"/>
+            <a:ext cx="4626864" cy="566928"/>
           </a:xfrm>
           <a:prstGeom prst="rect">
             <a:avLst/>
@@ -4363,38 +5138,38 @@
           <a:noFill/>
         </p:spPr>
         <p:txBody>
-          <a:bodyPr wrap="square" lIns="0" tIns="0">
+          <a:bodyPr wrap="square" anchor="t">
             <a:spAutoFit/>
           </a:bodyPr>
           <a:lstStyle/>
           <a:p>
-            <a:pPr>
+            <a:pPr algn="l">
               <a:lnSpc>
-                <a:spcPct val="125000"/>
+                <a:spcPct val="105000"/>
               </a:lnSpc>
             </a:pPr>
             <a:r>
-              <a:rPr sz="1600" b="1">
-                <a:solidFill>
-                  <a:srgbClr val="161616"/>
+              <a:rPr sz="1150" b="0">
+                <a:solidFill>
+                  <a:srgbClr val="6B7480"/>
                 </a:solidFill>
                 <a:latin typeface="Microsoft YaHei"/>
               </a:rPr>
-              <a:t>理解 Understand</a:t>
-            </a:r>
-          </a:p>
-        </p:txBody>
-      </p:sp>
-      <p:sp>
-        <p:nvSpPr>
-          <p:cNvPr id="16" name="TextBox 15"/>
+              <a:t>接收用户指令、附件与工作区上下文，完成意图澄清与队列排序。</a:t>
+            </a:r>
+          </a:p>
+        </p:txBody>
+      </p:sp>
+      <p:sp>
+        <p:nvSpPr>
+          <p:cNvPr id="19" name="TextBox 18"/>
           <p:cNvSpPr txBox="1"/>
           <p:nvPr/>
         </p:nvSpPr>
         <p:spPr>
           <a:xfrm>
-            <a:off x="9765792" y="1170432"/>
-            <a:ext cx="1691640" cy="438912"/>
+            <a:off x="978408" y="3447288"/>
+            <a:ext cx="4626864" cy="603504"/>
           </a:xfrm>
           <a:prstGeom prst="rect">
             <a:avLst/>
@@ -4402,158 +5177,82 @@
           <a:noFill/>
         </p:spPr>
         <p:txBody>
-          <a:bodyPr wrap="square" lIns="0" tIns="0">
+          <a:bodyPr wrap="square" anchor="t">
             <a:spAutoFit/>
           </a:bodyPr>
           <a:lstStyle/>
           <a:p>
-            <a:pPr algn="r">
+            <a:pPr algn="l">
               <a:lnSpc>
-                <a:spcPct val="125000"/>
+                <a:spcPct val="102000"/>
               </a:lnSpc>
             </a:pPr>
             <a:r>
-              <a:rPr sz="1800" b="1">
-                <a:solidFill>
-                  <a:srgbClr val="161616"/>
+              <a:rPr sz="1050" b="0">
+                <a:solidFill>
+                  <a:srgbClr val="222A35"/>
                 </a:solidFill>
                 <a:latin typeface="Microsoft YaHei"/>
               </a:rPr>
-              <a:t>02</a:t>
-            </a:r>
-          </a:p>
-        </p:txBody>
-      </p:sp>
-      <p:sp>
-        <p:nvSpPr>
-          <p:cNvPr id="17" name="TextBox 16"/>
-          <p:cNvSpPr txBox="1"/>
-          <p:nvPr/>
-        </p:nvSpPr>
-        <p:spPr>
-          <a:xfrm>
-            <a:off x="6501384" y="1737360"/>
-            <a:ext cx="4956048" cy="1298448"/>
-          </a:xfrm>
-          <a:prstGeom prst="rect">
-            <a:avLst/>
-          </a:prstGeom>
-          <a:noFill/>
-        </p:spPr>
-        <p:txBody>
-          <a:bodyPr wrap="square" lIns="0" tIns="0">
-            <a:spAutoFit/>
-          </a:bodyPr>
-          <a:lstStyle/>
-          <a:p>
-            <a:pPr>
+              <a:t>•  支持自然语言与多模态输入</a:t>
+            </a:r>
+          </a:p>
+          <a:p>
+            <a:pPr algn="l">
               <a:lnSpc>
-                <a:spcPct val="108000"/>
+                <a:spcPct val="102000"/>
               </a:lnSpc>
             </a:pPr>
             <a:r>
-              <a:rPr sz="1100" b="0">
-                <a:solidFill>
-                  <a:srgbClr val="2B2B2B"/>
+              <a:rPr sz="1050" b="0">
+                <a:solidFill>
+                  <a:srgbClr val="222A35"/>
                 </a:solidFill>
                 <a:latin typeface="Microsoft YaHei"/>
               </a:rPr>
-              <a:t>解析意图并制定执行计划</a:t>
-            </a:r>
-          </a:p>
-          <a:p>
-            <a:pPr>
+              <a:t>•  自动发现任务相关文件</a:t>
+            </a:r>
+          </a:p>
+          <a:p>
+            <a:pPr algn="l">
               <a:lnSpc>
-                <a:spcPct val="108000"/>
+                <a:spcPct val="102000"/>
               </a:lnSpc>
             </a:pPr>
             <a:r>
-              <a:rPr sz="1100" b="0">
-                <a:solidFill>
-                  <a:srgbClr val="2B2B2B"/>
+              <a:rPr sz="1050" b="0">
+                <a:solidFill>
+                  <a:srgbClr val="222A35"/>
                 </a:solidFill>
                 <a:latin typeface="Microsoft YaHei"/>
               </a:rPr>
-              <a:t>• 语义理解</a:t>
-            </a:r>
-          </a:p>
-          <a:p>
-            <a:pPr>
-              <a:lnSpc>
-                <a:spcPct val="108000"/>
-              </a:lnSpc>
-            </a:pPr>
-            <a:r>
-              <a:rPr sz="1100" b="0">
-                <a:solidFill>
-                  <a:srgbClr val="2B2B2B"/>
-                </a:solidFill>
-                <a:latin typeface="Microsoft YaHei"/>
-              </a:rPr>
-              <a:t>• 规划工具调用</a:t>
-            </a:r>
-          </a:p>
-        </p:txBody>
-      </p:sp>
-      <p:sp>
-        <p:nvSpPr>
-          <p:cNvPr id="18" name="Q2_provenance_规划阶段"/>
-          <p:cNvSpPr txBox="1"/>
-          <p:nvPr/>
-        </p:nvSpPr>
-        <p:spPr>
-          <a:xfrm>
-            <a:off x="6501384" y="3081528"/>
-            <a:ext cx="4892040" cy="201168"/>
-          </a:xfrm>
-          <a:prstGeom prst="rect">
-            <a:avLst/>
-          </a:prstGeom>
-          <a:noFill/>
-        </p:spPr>
-        <p:txBody>
-          <a:bodyPr wrap="square" lIns="0" tIns="0">
-            <a:spAutoFit/>
-          </a:bodyPr>
-          <a:lstStyle/>
-          <a:p>
-            <a:pPr>
-              <a:lnSpc>
-                <a:spcPct val="125000"/>
-              </a:lnSpc>
-            </a:pPr>
-            <a:r>
-              <a:rPr sz="800" b="0">
-                <a:solidFill>
-                  <a:srgbClr val="878787"/>
-                </a:solidFill>
-                <a:latin typeface="Microsoft YaHei"/>
-              </a:rPr>
-              <a:t>规划阶段</a:t>
-            </a:r>
-          </a:p>
-        </p:txBody>
-      </p:sp>
-      <p:sp>
-        <p:nvSpPr>
-          <p:cNvPr id="19" name="Rectangle 18"/>
+              <a:t>•  生成结构化任务对象</a:t>
+            </a:r>
+          </a:p>
+        </p:txBody>
+      </p:sp>
+      <p:sp>
+        <p:nvSpPr>
+          <p:cNvPr id="20" name="Rounded Rectangle 19"/>
           <p:cNvSpPr/>
           <p:nvPr/>
         </p:nvSpPr>
         <p:spPr>
           <a:xfrm>
-            <a:off x="438912" y="3767328"/>
-            <a:ext cx="5504688" cy="2359152"/>
-          </a:xfrm>
-          <a:prstGeom prst="rect">
-            <a:avLst/>
+            <a:off x="6309360" y="2057400"/>
+            <a:ext cx="5212080" cy="2084831"/>
+          </a:xfrm>
+          <a:prstGeom prst="roundRect">
+            <a:avLst>
+              <a:gd name="adj" fmla="val 6000"/>
+            </a:avLst>
           </a:prstGeom>
           <a:solidFill>
             <a:srgbClr val="FFFFFF"/>
           </a:solidFill>
-          <a:ln w="13970">
+          <a:ln w="9525">
             <a:solidFill>
-              <a:srgbClr val="C8C8C8"/>
+              <a:srgbClr val="E3E8EE"/>
             </a:solidFill>
           </a:ln>
           <a:effectLst/>
@@ -4582,20 +5281,20 @@
       </p:sp>
       <p:sp>
         <p:nvSpPr>
-          <p:cNvPr id="20" name="Rectangle 19"/>
+          <p:cNvPr id="21" name="Rectangle 20"/>
           <p:cNvSpPr/>
           <p:nvPr/>
         </p:nvSpPr>
         <p:spPr>
           <a:xfrm>
-            <a:off x="438912" y="3767328"/>
-            <a:ext cx="73152" cy="2359152"/>
+            <a:off x="6309360" y="2057400"/>
+            <a:ext cx="82296" cy="2084831"/>
           </a:xfrm>
           <a:prstGeom prst="rect">
             <a:avLst/>
           </a:prstGeom>
           <a:solidFill>
-            <a:srgbClr val="F09A1A"/>
+            <a:srgbClr val="10B981"/>
           </a:solidFill>
           <a:ln>
             <a:noFill/>
@@ -4626,252 +5325,25 @@
       </p:sp>
       <p:sp>
         <p:nvSpPr>
-          <p:cNvPr id="21" name="TextBox 20"/>
-          <p:cNvSpPr txBox="1"/>
-          <p:nvPr/>
-        </p:nvSpPr>
-        <p:spPr>
-          <a:xfrm>
-            <a:off x="667512" y="3931920"/>
-            <a:ext cx="502920" cy="292608"/>
-          </a:xfrm>
-          <a:prstGeom prst="rect">
-            <a:avLst/>
-          </a:prstGeom>
-          <a:noFill/>
-        </p:spPr>
-        <p:txBody>
-          <a:bodyPr wrap="square" lIns="0" tIns="0">
-            <a:spAutoFit/>
-          </a:bodyPr>
-          <a:lstStyle/>
-          <a:p>
-            <a:pPr>
-              <a:lnSpc>
-                <a:spcPct val="125000"/>
-              </a:lnSpc>
-            </a:pPr>
-            <a:r>
-              <a:rPr sz="1100" b="1">
-                <a:solidFill>
-                  <a:srgbClr val="878787"/>
-                </a:solidFill>
-                <a:latin typeface="Microsoft YaHei"/>
-              </a:rPr>
-              <a:t>Q3</a:t>
-            </a:r>
-          </a:p>
-        </p:txBody>
-      </p:sp>
-      <p:sp>
-        <p:nvSpPr>
-          <p:cNvPr id="22" name="TextBox 21"/>
-          <p:cNvSpPr txBox="1"/>
-          <p:nvPr/>
-        </p:nvSpPr>
-        <p:spPr>
-          <a:xfrm>
-            <a:off x="1188719" y="3886200"/>
-            <a:ext cx="2697480" cy="411480"/>
-          </a:xfrm>
-          <a:prstGeom prst="rect">
-            <a:avLst/>
-          </a:prstGeom>
-          <a:noFill/>
-        </p:spPr>
-        <p:txBody>
-          <a:bodyPr wrap="square" lIns="0" tIns="0">
-            <a:spAutoFit/>
-          </a:bodyPr>
-          <a:lstStyle/>
-          <a:p>
-            <a:pPr>
-              <a:lnSpc>
-                <a:spcPct val="125000"/>
-              </a:lnSpc>
-            </a:pPr>
-            <a:r>
-              <a:rPr sz="1600" b="1">
-                <a:solidFill>
-                  <a:srgbClr val="161616"/>
-                </a:solidFill>
-                <a:latin typeface="Microsoft YaHei"/>
-              </a:rPr>
-              <a:t>执行 Execute</a:t>
-            </a:r>
-          </a:p>
-        </p:txBody>
-      </p:sp>
-      <p:sp>
-        <p:nvSpPr>
-          <p:cNvPr id="23" name="TextBox 22"/>
-          <p:cNvSpPr txBox="1"/>
-          <p:nvPr/>
-        </p:nvSpPr>
-        <p:spPr>
-          <a:xfrm>
-            <a:off x="3959352" y="3858768"/>
-            <a:ext cx="1691640" cy="438912"/>
-          </a:xfrm>
-          <a:prstGeom prst="rect">
-            <a:avLst/>
-          </a:prstGeom>
-          <a:noFill/>
-        </p:spPr>
-        <p:txBody>
-          <a:bodyPr wrap="square" lIns="0" tIns="0">
-            <a:spAutoFit/>
-          </a:bodyPr>
-          <a:lstStyle/>
-          <a:p>
-            <a:pPr algn="r">
-              <a:lnSpc>
-                <a:spcPct val="125000"/>
-              </a:lnSpc>
-            </a:pPr>
-            <a:r>
-              <a:rPr sz="1800" b="1">
-                <a:solidFill>
-                  <a:srgbClr val="161616"/>
-                </a:solidFill>
-                <a:latin typeface="Microsoft YaHei"/>
-              </a:rPr>
-              <a:t>03</a:t>
-            </a:r>
-          </a:p>
-        </p:txBody>
-      </p:sp>
-      <p:sp>
-        <p:nvSpPr>
-          <p:cNvPr id="24" name="TextBox 23"/>
-          <p:cNvSpPr txBox="1"/>
-          <p:nvPr/>
-        </p:nvSpPr>
-        <p:spPr>
-          <a:xfrm>
-            <a:off x="694944" y="4425696"/>
-            <a:ext cx="4956048" cy="1298448"/>
-          </a:xfrm>
-          <a:prstGeom prst="rect">
-            <a:avLst/>
-          </a:prstGeom>
-          <a:noFill/>
-        </p:spPr>
-        <p:txBody>
-          <a:bodyPr wrap="square" lIns="0" tIns="0">
-            <a:spAutoFit/>
-          </a:bodyPr>
-          <a:lstStyle/>
-          <a:p>
-            <a:pPr>
-              <a:lnSpc>
-                <a:spcPct val="108000"/>
-              </a:lnSpc>
-            </a:pPr>
-            <a:r>
-              <a:rPr sz="1100" b="0">
-                <a:solidFill>
-                  <a:srgbClr val="2B2B2B"/>
-                </a:solidFill>
-                <a:latin typeface="Microsoft YaHei"/>
-              </a:rPr>
-              <a:t>调用工具完成任务动作</a:t>
-            </a:r>
-          </a:p>
-          <a:p>
-            <a:pPr>
-              <a:lnSpc>
-                <a:spcPct val="108000"/>
-              </a:lnSpc>
-            </a:pPr>
-            <a:r>
-              <a:rPr sz="1100" b="0">
-                <a:solidFill>
-                  <a:srgbClr val="2B2B2B"/>
-                </a:solidFill>
-                <a:latin typeface="Microsoft YaHei"/>
-              </a:rPr>
-              <a:t>• 执行计划</a:t>
-            </a:r>
-          </a:p>
-          <a:p>
-            <a:pPr>
-              <a:lnSpc>
-                <a:spcPct val="108000"/>
-              </a:lnSpc>
-            </a:pPr>
-            <a:r>
-              <a:rPr sz="1100" b="0">
-                <a:solidFill>
-                  <a:srgbClr val="2B2B2B"/>
-                </a:solidFill>
-                <a:latin typeface="Microsoft YaHei"/>
-              </a:rPr>
-              <a:t>• 生成输出结果</a:t>
-            </a:r>
-          </a:p>
-        </p:txBody>
-      </p:sp>
-      <p:sp>
-        <p:nvSpPr>
-          <p:cNvPr id="25" name="Q3_provenance_行动阶段"/>
-          <p:cNvSpPr txBox="1"/>
-          <p:nvPr/>
-        </p:nvSpPr>
-        <p:spPr>
-          <a:xfrm>
-            <a:off x="694944" y="5769864"/>
-            <a:ext cx="4892040" cy="201168"/>
-          </a:xfrm>
-          <a:prstGeom prst="rect">
-            <a:avLst/>
-          </a:prstGeom>
-          <a:noFill/>
-        </p:spPr>
-        <p:txBody>
-          <a:bodyPr wrap="square" lIns="0" tIns="0">
-            <a:spAutoFit/>
-          </a:bodyPr>
-          <a:lstStyle/>
-          <a:p>
-            <a:pPr>
-              <a:lnSpc>
-                <a:spcPct val="125000"/>
-              </a:lnSpc>
-            </a:pPr>
-            <a:r>
-              <a:rPr sz="800" b="0">
-                <a:solidFill>
-                  <a:srgbClr val="878787"/>
-                </a:solidFill>
-                <a:latin typeface="Microsoft YaHei"/>
-              </a:rPr>
-              <a:t>行动阶段</a:t>
-            </a:r>
-          </a:p>
-        </p:txBody>
-      </p:sp>
-      <p:sp>
-        <p:nvSpPr>
-          <p:cNvPr id="26" name="Rectangle 25"/>
+          <p:cNvPr id="22" name="Rounded Rectangle 21"/>
           <p:cNvSpPr/>
           <p:nvPr/>
         </p:nvSpPr>
         <p:spPr>
           <a:xfrm>
-            <a:off x="6245352" y="3767328"/>
-            <a:ext cx="5504688" cy="2359152"/>
-          </a:xfrm>
-          <a:prstGeom prst="rect">
-            <a:avLst/>
+            <a:off x="6583680" y="2258568"/>
+            <a:ext cx="566928" cy="566928"/>
+          </a:xfrm>
+          <a:prstGeom prst="roundRect">
+            <a:avLst>
+              <a:gd name="adj" fmla="val 18000"/>
+            </a:avLst>
           </a:prstGeom>
           <a:solidFill>
-            <a:srgbClr val="FFFFFF"/>
+            <a:srgbClr val="10B981"/>
           </a:solidFill>
-          <a:ln w="13970">
-            <a:solidFill>
-              <a:srgbClr val="C8C8C8"/>
-            </a:solidFill>
+          <a:ln>
+            <a:noFill/>
           </a:ln>
           <a:effectLst/>
         </p:spPr>
@@ -4899,20 +5371,100 @@
       </p:sp>
       <p:sp>
         <p:nvSpPr>
-          <p:cNvPr id="27" name="Rectangle 26"/>
-          <p:cNvSpPr/>
-          <p:nvPr/>
-        </p:nvSpPr>
-        <p:spPr>
-          <a:xfrm>
-            <a:off x="6245352" y="3767328"/>
-            <a:ext cx="73152" cy="2359152"/>
+          <p:cNvPr id="23" name="TextBox 22"/>
+          <p:cNvSpPr txBox="1"/>
+          <p:nvPr/>
+        </p:nvSpPr>
+        <p:spPr>
+          <a:xfrm>
+            <a:off x="6583680" y="2331720"/>
+            <a:ext cx="566928" cy="411480"/>
           </a:xfrm>
           <a:prstGeom prst="rect">
             <a:avLst/>
           </a:prstGeom>
+          <a:noFill/>
+        </p:spPr>
+        <p:txBody>
+          <a:bodyPr wrap="square" anchor="t">
+            <a:spAutoFit/>
+          </a:bodyPr>
+          <a:lstStyle/>
+          <a:p>
+            <a:pPr algn="ctr">
+              <a:lnSpc>
+                <a:spcPct val="100000"/>
+              </a:lnSpc>
+            </a:pPr>
+            <a:r>
+              <a:rPr sz="1400" b="1">
+                <a:solidFill>
+                  <a:srgbClr val="FFFFFF"/>
+                </a:solidFill>
+                <a:latin typeface="Microsoft YaHei"/>
+              </a:rPr>
+              <a:t>02</a:t>
+            </a:r>
+          </a:p>
+        </p:txBody>
+      </p:sp>
+      <p:sp>
+        <p:nvSpPr>
+          <p:cNvPr id="24" name="TextBox 23"/>
+          <p:cNvSpPr txBox="1"/>
+          <p:nvPr/>
+        </p:nvSpPr>
+        <p:spPr>
+          <a:xfrm>
+            <a:off x="7315200" y="2240280"/>
+            <a:ext cx="2926080" cy="365760"/>
+          </a:xfrm>
+          <a:prstGeom prst="rect">
+            <a:avLst/>
+          </a:prstGeom>
+          <a:noFill/>
+        </p:spPr>
+        <p:txBody>
+          <a:bodyPr wrap="square" anchor="t">
+            <a:spAutoFit/>
+          </a:bodyPr>
+          <a:lstStyle/>
+          <a:p>
+            <a:pPr algn="l">
+              <a:lnSpc>
+                <a:spcPct val="100000"/>
+              </a:lnSpc>
+            </a:pPr>
+            <a:r>
+              <a:rPr sz="1700" b="1">
+                <a:solidFill>
+                  <a:srgbClr val="222A35"/>
+                </a:solidFill>
+                <a:latin typeface="Microsoft YaHei"/>
+              </a:rPr>
+              <a:t>理解 Understand</a:t>
+            </a:r>
+          </a:p>
+        </p:txBody>
+      </p:sp>
+      <p:sp>
+        <p:nvSpPr>
+          <p:cNvPr id="25" name="Rounded Rectangle 24"/>
+          <p:cNvSpPr/>
+          <p:nvPr/>
+        </p:nvSpPr>
+        <p:spPr>
+          <a:xfrm>
+            <a:off x="10378440" y="2313432"/>
+            <a:ext cx="868680" cy="274320"/>
+          </a:xfrm>
+          <a:prstGeom prst="roundRect">
+            <a:avLst>
+              <a:gd name="adj" fmla="val 50000"/>
+            </a:avLst>
+          </a:prstGeom>
           <a:solidFill>
-            <a:srgbClr val="F09A1A"/>
+            <a:srgbClr val="F4F6F9"/>
           </a:solidFill>
           <a:ln>
             <a:noFill/>
@@ -4943,14 +5495,92 @@
       </p:sp>
       <p:sp>
         <p:nvSpPr>
+          <p:cNvPr id="26" name="TextBox 25"/>
+          <p:cNvSpPr txBox="1"/>
+          <p:nvPr/>
+        </p:nvSpPr>
+        <p:spPr>
+          <a:xfrm>
+            <a:off x="10378440" y="2350008"/>
+            <a:ext cx="868680" cy="201168"/>
+          </a:xfrm>
+          <a:prstGeom prst="rect">
+            <a:avLst/>
+          </a:prstGeom>
+          <a:noFill/>
+        </p:spPr>
+        <p:txBody>
+          <a:bodyPr wrap="square" anchor="t">
+            <a:spAutoFit/>
+          </a:bodyPr>
+          <a:lstStyle/>
+          <a:p>
+            <a:pPr algn="ctr">
+              <a:lnSpc>
+                <a:spcPct val="100000"/>
+              </a:lnSpc>
+            </a:pPr>
+            <a:r>
+              <a:rPr sz="900" b="1">
+                <a:solidFill>
+                  <a:srgbClr val="10B981"/>
+                </a:solidFill>
+                <a:latin typeface="Microsoft YaHei"/>
+              </a:rPr>
+              <a:t>UNDERSTAND</a:t>
+            </a:r>
+          </a:p>
+        </p:txBody>
+      </p:sp>
+      <p:sp>
+        <p:nvSpPr>
+          <p:cNvPr id="27" name="TextBox 26"/>
+          <p:cNvSpPr txBox="1"/>
+          <p:nvPr/>
+        </p:nvSpPr>
+        <p:spPr>
+          <a:xfrm>
+            <a:off x="6601968" y="2916936"/>
+            <a:ext cx="4626864" cy="566928"/>
+          </a:xfrm>
+          <a:prstGeom prst="rect">
+            <a:avLst/>
+          </a:prstGeom>
+          <a:noFill/>
+        </p:spPr>
+        <p:txBody>
+          <a:bodyPr wrap="square" anchor="t">
+            <a:spAutoFit/>
+          </a:bodyPr>
+          <a:lstStyle/>
+          <a:p>
+            <a:pPr algn="l">
+              <a:lnSpc>
+                <a:spcPct val="105000"/>
+              </a:lnSpc>
+            </a:pPr>
+            <a:r>
+              <a:rPr sz="1150" b="0">
+                <a:solidFill>
+                  <a:srgbClr val="6B7480"/>
+                </a:solidFill>
+                <a:latin typeface="Microsoft YaHei"/>
+              </a:rPr>
+              <a:t>解析任务语义，匹配任务类型、所需能力与执行合同。</a:t>
+            </a:r>
+          </a:p>
+        </p:txBody>
+      </p:sp>
+      <p:sp>
+        <p:nvSpPr>
           <p:cNvPr id="28" name="TextBox 27"/>
           <p:cNvSpPr txBox="1"/>
           <p:nvPr/>
         </p:nvSpPr>
         <p:spPr>
           <a:xfrm>
-            <a:off x="6473952" y="3931920"/>
-            <a:ext cx="502920" cy="292608"/>
+            <a:off x="6601968" y="3447288"/>
+            <a:ext cx="4626864" cy="603504"/>
           </a:xfrm>
           <a:prstGeom prst="rect">
             <a:avLst/>
@@ -4958,59 +5588,679 @@
           <a:noFill/>
         </p:spPr>
         <p:txBody>
-          <a:bodyPr wrap="square" lIns="0" tIns="0">
+          <a:bodyPr wrap="square" anchor="t">
             <a:spAutoFit/>
           </a:bodyPr>
           <a:lstStyle/>
           <a:p>
-            <a:pPr>
+            <a:pPr algn="l">
               <a:lnSpc>
-                <a:spcPct val="125000"/>
+                <a:spcPct val="102000"/>
               </a:lnSpc>
             </a:pPr>
             <a:r>
-              <a:rPr sz="1100" b="1">
-                <a:solidFill>
-                  <a:srgbClr val="878787"/>
+              <a:rPr sz="1050" b="0">
+                <a:solidFill>
+                  <a:srgbClr val="222A35"/>
                 </a:solidFill>
                 <a:latin typeface="Microsoft YaHei"/>
               </a:rPr>
-              <a:t>Q4</a:t>
-            </a:r>
-          </a:p>
-        </p:txBody>
-      </p:sp>
-      <p:sp>
-        <p:nvSpPr>
-          <p:cNvPr id="29" name="TextBox 28"/>
-          <p:cNvSpPr txBox="1"/>
-          <p:nvPr/>
-        </p:nvSpPr>
-        <p:spPr>
-          <a:xfrm>
-            <a:off x="6995160" y="3886200"/>
-            <a:ext cx="2697480" cy="411480"/>
+              <a:t>•  任务分类与 Skill 选择</a:t>
+            </a:r>
+          </a:p>
+          <a:p>
+            <a:pPr algn="l">
+              <a:lnSpc>
+                <a:spcPct val="102000"/>
+              </a:lnSpc>
+            </a:pPr>
+            <a:r>
+              <a:rPr sz="1050" b="0">
+                <a:solidFill>
+                  <a:srgbClr val="222A35"/>
+                </a:solidFill>
+                <a:latin typeface="Microsoft YaHei"/>
+              </a:rPr>
+              <a:t>•  能力与工具面解析</a:t>
+            </a:r>
+          </a:p>
+          <a:p>
+            <a:pPr algn="l">
+              <a:lnSpc>
+                <a:spcPct val="102000"/>
+              </a:lnSpc>
+            </a:pPr>
+            <a:r>
+              <a:rPr sz="1050" b="0">
+                <a:solidFill>
+                  <a:srgbClr val="222A35"/>
+                </a:solidFill>
+                <a:latin typeface="Microsoft YaHei"/>
+              </a:rPr>
+              <a:t>•  风险与依赖预检</a:t>
+            </a:r>
+          </a:p>
+        </p:txBody>
+      </p:sp>
+      <p:sp>
+        <p:nvSpPr>
+          <p:cNvPr id="29" name="Rounded Rectangle 28"/>
+          <p:cNvSpPr/>
+          <p:nvPr/>
+        </p:nvSpPr>
+        <p:spPr>
+          <a:xfrm>
+            <a:off x="685800" y="4279392"/>
+            <a:ext cx="5212080" cy="2084831"/>
+          </a:xfrm>
+          <a:prstGeom prst="roundRect">
+            <a:avLst>
+              <a:gd name="adj" fmla="val 6000"/>
+            </a:avLst>
+          </a:prstGeom>
+          <a:solidFill>
+            <a:srgbClr val="FFFFFF"/>
+          </a:solidFill>
+          <a:ln w="9525">
+            <a:solidFill>
+              <a:srgbClr val="E3E8EE"/>
+            </a:solidFill>
+          </a:ln>
+          <a:effectLst/>
+        </p:spPr>
+        <p:style>
+          <a:lnRef idx="1">
+            <a:schemeClr val="accent1"/>
+          </a:lnRef>
+          <a:fillRef idx="3">
+            <a:schemeClr val="accent1"/>
+          </a:fillRef>
+          <a:effectRef idx="2">
+            <a:schemeClr val="accent1"/>
+          </a:effectRef>
+          <a:fontRef idx="minor">
+            <a:schemeClr val="lt1"/>
+          </a:fontRef>
+        </p:style>
+        <p:txBody>
+          <a:bodyPr rtlCol="0" anchor="ctr"/>
+          <a:lstStyle/>
+          <a:p>
+            <a:pPr algn="ctr"/>
+          </a:p>
+        </p:txBody>
+      </p:sp>
+      <p:sp>
+        <p:nvSpPr>
+          <p:cNvPr id="30" name="Rectangle 29"/>
+          <p:cNvSpPr/>
+          <p:nvPr/>
+        </p:nvSpPr>
+        <p:spPr>
+          <a:xfrm>
+            <a:off x="685800" y="4279392"/>
+            <a:ext cx="82296" cy="2084831"/>
           </a:xfrm>
           <a:prstGeom prst="rect">
             <a:avLst/>
           </a:prstGeom>
+          <a:solidFill>
+            <a:srgbClr val="F97A2E"/>
+          </a:solidFill>
+          <a:ln>
+            <a:noFill/>
+          </a:ln>
+          <a:effectLst/>
+        </p:spPr>
+        <p:style>
+          <a:lnRef idx="1">
+            <a:schemeClr val="accent1"/>
+          </a:lnRef>
+          <a:fillRef idx="3">
+            <a:schemeClr val="accent1"/>
+          </a:fillRef>
+          <a:effectRef idx="2">
+            <a:schemeClr val="accent1"/>
+          </a:effectRef>
+          <a:fontRef idx="minor">
+            <a:schemeClr val="lt1"/>
+          </a:fontRef>
+        </p:style>
+        <p:txBody>
+          <a:bodyPr rtlCol="0" anchor="ctr"/>
+          <a:lstStyle/>
+          <a:p>
+            <a:pPr algn="ctr"/>
+          </a:p>
+        </p:txBody>
+      </p:sp>
+      <p:sp>
+        <p:nvSpPr>
+          <p:cNvPr id="31" name="Rounded Rectangle 30"/>
+          <p:cNvSpPr/>
+          <p:nvPr/>
+        </p:nvSpPr>
+        <p:spPr>
+          <a:xfrm>
+            <a:off x="960120" y="4480559"/>
+            <a:ext cx="566928" cy="566928"/>
+          </a:xfrm>
+          <a:prstGeom prst="roundRect">
+            <a:avLst>
+              <a:gd name="adj" fmla="val 18000"/>
+            </a:avLst>
+          </a:prstGeom>
+          <a:solidFill>
+            <a:srgbClr val="F97A2E"/>
+          </a:solidFill>
+          <a:ln>
+            <a:noFill/>
+          </a:ln>
+          <a:effectLst/>
+        </p:spPr>
+        <p:style>
+          <a:lnRef idx="1">
+            <a:schemeClr val="accent1"/>
+          </a:lnRef>
+          <a:fillRef idx="3">
+            <a:schemeClr val="accent1"/>
+          </a:fillRef>
+          <a:effectRef idx="2">
+            <a:schemeClr val="accent1"/>
+          </a:effectRef>
+          <a:fontRef idx="minor">
+            <a:schemeClr val="lt1"/>
+          </a:fontRef>
+        </p:style>
+        <p:txBody>
+          <a:bodyPr rtlCol="0" anchor="ctr"/>
+          <a:lstStyle/>
+          <a:p>
+            <a:pPr algn="ctr"/>
+          </a:p>
+        </p:txBody>
+      </p:sp>
+      <p:sp>
+        <p:nvSpPr>
+          <p:cNvPr id="32" name="TextBox 31"/>
+          <p:cNvSpPr txBox="1"/>
+          <p:nvPr/>
+        </p:nvSpPr>
+        <p:spPr>
+          <a:xfrm>
+            <a:off x="960120" y="4553712"/>
+            <a:ext cx="566928" cy="411480"/>
+          </a:xfrm>
+          <a:prstGeom prst="rect">
+            <a:avLst/>
+          </a:prstGeom>
           <a:noFill/>
         </p:spPr>
         <p:txBody>
-          <a:bodyPr wrap="square" lIns="0" tIns="0">
+          <a:bodyPr wrap="square" anchor="t">
             <a:spAutoFit/>
           </a:bodyPr>
           <a:lstStyle/>
           <a:p>
-            <a:pPr>
+            <a:pPr algn="ctr">
               <a:lnSpc>
-                <a:spcPct val="125000"/>
+                <a:spcPct val="100000"/>
               </a:lnSpc>
             </a:pPr>
             <a:r>
-              <a:rPr sz="1600" b="1">
-                <a:solidFill>
-                  <a:srgbClr val="161616"/>
+              <a:rPr sz="1400" b="1">
+                <a:solidFill>
+                  <a:srgbClr val="FFFFFF"/>
+                </a:solidFill>
+                <a:latin typeface="Microsoft YaHei"/>
+              </a:rPr>
+              <a:t>03</a:t>
+            </a:r>
+          </a:p>
+        </p:txBody>
+      </p:sp>
+      <p:sp>
+        <p:nvSpPr>
+          <p:cNvPr id="33" name="TextBox 32"/>
+          <p:cNvSpPr txBox="1"/>
+          <p:nvPr/>
+        </p:nvSpPr>
+        <p:spPr>
+          <a:xfrm>
+            <a:off x="1691640" y="4462272"/>
+            <a:ext cx="2926080" cy="365760"/>
+          </a:xfrm>
+          <a:prstGeom prst="rect">
+            <a:avLst/>
+          </a:prstGeom>
+          <a:noFill/>
+        </p:spPr>
+        <p:txBody>
+          <a:bodyPr wrap="square" anchor="t">
+            <a:spAutoFit/>
+          </a:bodyPr>
+          <a:lstStyle/>
+          <a:p>
+            <a:pPr algn="l">
+              <a:lnSpc>
+                <a:spcPct val="100000"/>
+              </a:lnSpc>
+            </a:pPr>
+            <a:r>
+              <a:rPr sz="1700" b="1">
+                <a:solidFill>
+                  <a:srgbClr val="222A35"/>
+                </a:solidFill>
+                <a:latin typeface="Microsoft YaHei"/>
+              </a:rPr>
+              <a:t>执行 Execute</a:t>
+            </a:r>
+          </a:p>
+        </p:txBody>
+      </p:sp>
+      <p:sp>
+        <p:nvSpPr>
+          <p:cNvPr id="34" name="Rounded Rectangle 33"/>
+          <p:cNvSpPr/>
+          <p:nvPr/>
+        </p:nvSpPr>
+        <p:spPr>
+          <a:xfrm>
+            <a:off x="4754880" y="4535424"/>
+            <a:ext cx="868680" cy="274320"/>
+          </a:xfrm>
+          <a:prstGeom prst="roundRect">
+            <a:avLst>
+              <a:gd name="adj" fmla="val 50000"/>
+            </a:avLst>
+          </a:prstGeom>
+          <a:solidFill>
+            <a:srgbClr val="F4F6F9"/>
+          </a:solidFill>
+          <a:ln>
+            <a:noFill/>
+          </a:ln>
+          <a:effectLst/>
+        </p:spPr>
+        <p:style>
+          <a:lnRef idx="1">
+            <a:schemeClr val="accent1"/>
+          </a:lnRef>
+          <a:fillRef idx="3">
+            <a:schemeClr val="accent1"/>
+          </a:fillRef>
+          <a:effectRef idx="2">
+            <a:schemeClr val="accent1"/>
+          </a:effectRef>
+          <a:fontRef idx="minor">
+            <a:schemeClr val="lt1"/>
+          </a:fontRef>
+        </p:style>
+        <p:txBody>
+          <a:bodyPr rtlCol="0" anchor="ctr"/>
+          <a:lstStyle/>
+          <a:p>
+            <a:pPr algn="ctr"/>
+          </a:p>
+        </p:txBody>
+      </p:sp>
+      <p:sp>
+        <p:nvSpPr>
+          <p:cNvPr id="35" name="TextBox 34"/>
+          <p:cNvSpPr txBox="1"/>
+          <p:nvPr/>
+        </p:nvSpPr>
+        <p:spPr>
+          <a:xfrm>
+            <a:off x="4754880" y="4572000"/>
+            <a:ext cx="868680" cy="201168"/>
+          </a:xfrm>
+          <a:prstGeom prst="rect">
+            <a:avLst/>
+          </a:prstGeom>
+          <a:noFill/>
+        </p:spPr>
+        <p:txBody>
+          <a:bodyPr wrap="square" anchor="t">
+            <a:spAutoFit/>
+          </a:bodyPr>
+          <a:lstStyle/>
+          <a:p>
+            <a:pPr algn="ctr">
+              <a:lnSpc>
+                <a:spcPct val="100000"/>
+              </a:lnSpc>
+            </a:pPr>
+            <a:r>
+              <a:rPr sz="900" b="1">
+                <a:solidFill>
+                  <a:srgbClr val="F97A2E"/>
+                </a:solidFill>
+                <a:latin typeface="Microsoft YaHei"/>
+              </a:rPr>
+              <a:t>EXECUTE</a:t>
+            </a:r>
+          </a:p>
+        </p:txBody>
+      </p:sp>
+      <p:sp>
+        <p:nvSpPr>
+          <p:cNvPr id="36" name="TextBox 35"/>
+          <p:cNvSpPr txBox="1"/>
+          <p:nvPr/>
+        </p:nvSpPr>
+        <p:spPr>
+          <a:xfrm>
+            <a:off x="978408" y="5138927"/>
+            <a:ext cx="4626864" cy="566928"/>
+          </a:xfrm>
+          <a:prstGeom prst="rect">
+            <a:avLst/>
+          </a:prstGeom>
+          <a:noFill/>
+        </p:spPr>
+        <p:txBody>
+          <a:bodyPr wrap="square" anchor="t">
+            <a:spAutoFit/>
+          </a:bodyPr>
+          <a:lstStyle/>
+          <a:p>
+            <a:pPr algn="l">
+              <a:lnSpc>
+                <a:spcPct val="105000"/>
+              </a:lnSpc>
+            </a:pPr>
+            <a:r>
+              <a:rPr sz="1150" b="0">
+                <a:solidFill>
+                  <a:srgbClr val="6B7480"/>
+                </a:solidFill>
+                <a:latin typeface="Microsoft YaHei"/>
+              </a:rPr>
+              <a:t>在阶段工具面内执行修改，所有变更走原子事务与权限审计。</a:t>
+            </a:r>
+          </a:p>
+        </p:txBody>
+      </p:sp>
+      <p:sp>
+        <p:nvSpPr>
+          <p:cNvPr id="37" name="TextBox 36"/>
+          <p:cNvSpPr txBox="1"/>
+          <p:nvPr/>
+        </p:nvSpPr>
+        <p:spPr>
+          <a:xfrm>
+            <a:off x="978408" y="5669279"/>
+            <a:ext cx="4626864" cy="603504"/>
+          </a:xfrm>
+          <a:prstGeom prst="rect">
+            <a:avLst/>
+          </a:prstGeom>
+          <a:noFill/>
+        </p:spPr>
+        <p:txBody>
+          <a:bodyPr wrap="square" anchor="t">
+            <a:spAutoFit/>
+          </a:bodyPr>
+          <a:lstStyle/>
+          <a:p>
+            <a:pPr algn="l">
+              <a:lnSpc>
+                <a:spcPct val="102000"/>
+              </a:lnSpc>
+            </a:pPr>
+            <a:r>
+              <a:rPr sz="1050" b="0">
+                <a:solidFill>
+                  <a:srgbClr val="222A35"/>
+                </a:solidFill>
+                <a:latin typeface="Microsoft YaHei"/>
+              </a:rPr>
+              <a:t>•  阶段化工具准入</a:t>
+            </a:r>
+          </a:p>
+          <a:p>
+            <a:pPr algn="l">
+              <a:lnSpc>
+                <a:spcPct val="102000"/>
+              </a:lnSpc>
+            </a:pPr>
+            <a:r>
+              <a:rPr sz="1050" b="0">
+                <a:solidFill>
+                  <a:srgbClr val="222A35"/>
+                </a:solidFill>
+                <a:latin typeface="Microsoft YaHei"/>
+              </a:rPr>
+              <a:t>•  原子批量事务</a:t>
+            </a:r>
+          </a:p>
+          <a:p>
+            <a:pPr algn="l">
+              <a:lnSpc>
+                <a:spcPct val="102000"/>
+              </a:lnSpc>
+            </a:pPr>
+            <a:r>
+              <a:rPr sz="1050" b="0">
+                <a:solidFill>
+                  <a:srgbClr val="222A35"/>
+                </a:solidFill>
+                <a:latin typeface="Microsoft YaHei"/>
+              </a:rPr>
+              <a:t>•  失败自动回滚</a:t>
+            </a:r>
+          </a:p>
+        </p:txBody>
+      </p:sp>
+      <p:sp>
+        <p:nvSpPr>
+          <p:cNvPr id="38" name="Rounded Rectangle 37"/>
+          <p:cNvSpPr/>
+          <p:nvPr/>
+        </p:nvSpPr>
+        <p:spPr>
+          <a:xfrm>
+            <a:off x="6309360" y="4279392"/>
+            <a:ext cx="5212080" cy="2084831"/>
+          </a:xfrm>
+          <a:prstGeom prst="roundRect">
+            <a:avLst>
+              <a:gd name="adj" fmla="val 6000"/>
+            </a:avLst>
+          </a:prstGeom>
+          <a:solidFill>
+            <a:srgbClr val="FFFFFF"/>
+          </a:solidFill>
+          <a:ln w="9525">
+            <a:solidFill>
+              <a:srgbClr val="E3E8EE"/>
+            </a:solidFill>
+          </a:ln>
+          <a:effectLst/>
+        </p:spPr>
+        <p:style>
+          <a:lnRef idx="1">
+            <a:schemeClr val="accent1"/>
+          </a:lnRef>
+          <a:fillRef idx="3">
+            <a:schemeClr val="accent1"/>
+          </a:fillRef>
+          <a:effectRef idx="2">
+            <a:schemeClr val="accent1"/>
+          </a:effectRef>
+          <a:fontRef idx="minor">
+            <a:schemeClr val="lt1"/>
+          </a:fontRef>
+        </p:style>
+        <p:txBody>
+          <a:bodyPr rtlCol="0" anchor="ctr"/>
+          <a:lstStyle/>
+          <a:p>
+            <a:pPr algn="ctr"/>
+          </a:p>
+        </p:txBody>
+      </p:sp>
+      <p:sp>
+        <p:nvSpPr>
+          <p:cNvPr id="39" name="Rectangle 38"/>
+          <p:cNvSpPr/>
+          <p:nvPr/>
+        </p:nvSpPr>
+        <p:spPr>
+          <a:xfrm>
+            <a:off x="6309360" y="4279392"/>
+            <a:ext cx="82296" cy="2084831"/>
+          </a:xfrm>
+          <a:prstGeom prst="rect">
+            <a:avLst/>
+          </a:prstGeom>
+          <a:solidFill>
+            <a:srgbClr val="8B5CF6"/>
+          </a:solidFill>
+          <a:ln>
+            <a:noFill/>
+          </a:ln>
+          <a:effectLst/>
+        </p:spPr>
+        <p:style>
+          <a:lnRef idx="1">
+            <a:schemeClr val="accent1"/>
+          </a:lnRef>
+          <a:fillRef idx="3">
+            <a:schemeClr val="accent1"/>
+          </a:fillRef>
+          <a:effectRef idx="2">
+            <a:schemeClr val="accent1"/>
+          </a:effectRef>
+          <a:fontRef idx="minor">
+            <a:schemeClr val="lt1"/>
+          </a:fontRef>
+        </p:style>
+        <p:txBody>
+          <a:bodyPr rtlCol="0" anchor="ctr"/>
+          <a:lstStyle/>
+          <a:p>
+            <a:pPr algn="ctr"/>
+          </a:p>
+        </p:txBody>
+      </p:sp>
+      <p:sp>
+        <p:nvSpPr>
+          <p:cNvPr id="40" name="Rounded Rectangle 39"/>
+          <p:cNvSpPr/>
+          <p:nvPr/>
+        </p:nvSpPr>
+        <p:spPr>
+          <a:xfrm>
+            <a:off x="6583680" y="4480559"/>
+            <a:ext cx="566928" cy="566928"/>
+          </a:xfrm>
+          <a:prstGeom prst="roundRect">
+            <a:avLst>
+              <a:gd name="adj" fmla="val 18000"/>
+            </a:avLst>
+          </a:prstGeom>
+          <a:solidFill>
+            <a:srgbClr val="8B5CF6"/>
+          </a:solidFill>
+          <a:ln>
+            <a:noFill/>
+          </a:ln>
+          <a:effectLst/>
+        </p:spPr>
+        <p:style>
+          <a:lnRef idx="1">
+            <a:schemeClr val="accent1"/>
+          </a:lnRef>
+          <a:fillRef idx="3">
+            <a:schemeClr val="accent1"/>
+          </a:fillRef>
+          <a:effectRef idx="2">
+            <a:schemeClr val="accent1"/>
+          </a:effectRef>
+          <a:fontRef idx="minor">
+            <a:schemeClr val="lt1"/>
+          </a:fontRef>
+        </p:style>
+        <p:txBody>
+          <a:bodyPr rtlCol="0" anchor="ctr"/>
+          <a:lstStyle/>
+          <a:p>
+            <a:pPr algn="ctr"/>
+          </a:p>
+        </p:txBody>
+      </p:sp>
+      <p:sp>
+        <p:nvSpPr>
+          <p:cNvPr id="41" name="TextBox 40"/>
+          <p:cNvSpPr txBox="1"/>
+          <p:nvPr/>
+        </p:nvSpPr>
+        <p:spPr>
+          <a:xfrm>
+            <a:off x="6583680" y="4553712"/>
+            <a:ext cx="566928" cy="411480"/>
+          </a:xfrm>
+          <a:prstGeom prst="rect">
+            <a:avLst/>
+          </a:prstGeom>
+          <a:noFill/>
+        </p:spPr>
+        <p:txBody>
+          <a:bodyPr wrap="square" anchor="t">
+            <a:spAutoFit/>
+          </a:bodyPr>
+          <a:lstStyle/>
+          <a:p>
+            <a:pPr algn="ctr">
+              <a:lnSpc>
+                <a:spcPct val="100000"/>
+              </a:lnSpc>
+            </a:pPr>
+            <a:r>
+              <a:rPr sz="1400" b="1">
+                <a:solidFill>
+                  <a:srgbClr val="FFFFFF"/>
+                </a:solidFill>
+                <a:latin typeface="Microsoft YaHei"/>
+              </a:rPr>
+              <a:t>04</a:t>
+            </a:r>
+          </a:p>
+        </p:txBody>
+      </p:sp>
+      <p:sp>
+        <p:nvSpPr>
+          <p:cNvPr id="42" name="TextBox 41"/>
+          <p:cNvSpPr txBox="1"/>
+          <p:nvPr/>
+        </p:nvSpPr>
+        <p:spPr>
+          <a:xfrm>
+            <a:off x="7315200" y="4462272"/>
+            <a:ext cx="2926080" cy="365760"/>
+          </a:xfrm>
+          <a:prstGeom prst="rect">
+            <a:avLst/>
+          </a:prstGeom>
+          <a:noFill/>
+        </p:spPr>
+        <p:txBody>
+          <a:bodyPr wrap="square" anchor="t">
+            <a:spAutoFit/>
+          </a:bodyPr>
+          <a:lstStyle/>
+          <a:p>
+            <a:pPr algn="l">
+              <a:lnSpc>
+                <a:spcPct val="100000"/>
+              </a:lnSpc>
+            </a:pPr>
+            <a:r>
+              <a:rPr sz="1700" b="1">
+                <a:solidFill>
+                  <a:srgbClr val="222A35"/>
                 </a:solidFill>
                 <a:latin typeface="Microsoft YaHei"/>
               </a:rPr>
@@ -5021,14 +6271,60 @@
       </p:sp>
       <p:sp>
         <p:nvSpPr>
-          <p:cNvPr id="30" name="TextBox 29"/>
+          <p:cNvPr id="43" name="Rounded Rectangle 42"/>
+          <p:cNvSpPr/>
+          <p:nvPr/>
+        </p:nvSpPr>
+        <p:spPr>
+          <a:xfrm>
+            <a:off x="10378440" y="4535424"/>
+            <a:ext cx="868680" cy="274320"/>
+          </a:xfrm>
+          <a:prstGeom prst="roundRect">
+            <a:avLst>
+              <a:gd name="adj" fmla="val 50000"/>
+            </a:avLst>
+          </a:prstGeom>
+          <a:solidFill>
+            <a:srgbClr val="F4F6F9"/>
+          </a:solidFill>
+          <a:ln>
+            <a:noFill/>
+          </a:ln>
+          <a:effectLst/>
+        </p:spPr>
+        <p:style>
+          <a:lnRef idx="1">
+            <a:schemeClr val="accent1"/>
+          </a:lnRef>
+          <a:fillRef idx="3">
+            <a:schemeClr val="accent1"/>
+          </a:fillRef>
+          <a:effectRef idx="2">
+            <a:schemeClr val="accent1"/>
+          </a:effectRef>
+          <a:fontRef idx="minor">
+            <a:schemeClr val="lt1"/>
+          </a:fontRef>
+        </p:style>
+        <p:txBody>
+          <a:bodyPr rtlCol="0" anchor="ctr"/>
+          <a:lstStyle/>
+          <a:p>
+            <a:pPr algn="ctr"/>
+          </a:p>
+        </p:txBody>
+      </p:sp>
+      <p:sp>
+        <p:nvSpPr>
+          <p:cNvPr id="44" name="TextBox 43"/>
           <p:cNvSpPr txBox="1"/>
           <p:nvPr/>
         </p:nvSpPr>
         <p:spPr>
           <a:xfrm>
-            <a:off x="9765792" y="3858768"/>
-            <a:ext cx="1691640" cy="438912"/>
+            <a:off x="10378440" y="4572000"/>
+            <a:ext cx="868680" cy="201168"/>
           </a:xfrm>
           <a:prstGeom prst="rect">
             <a:avLst/>
@@ -5036,38 +6332,38 @@
           <a:noFill/>
         </p:spPr>
         <p:txBody>
-          <a:bodyPr wrap="square" lIns="0" tIns="0">
+          <a:bodyPr wrap="square" anchor="t">
             <a:spAutoFit/>
           </a:bodyPr>
           <a:lstStyle/>
           <a:p>
-            <a:pPr algn="r">
+            <a:pPr algn="ctr">
               <a:lnSpc>
-                <a:spcPct val="125000"/>
+                <a:spcPct val="100000"/>
               </a:lnSpc>
             </a:pPr>
             <a:r>
-              <a:rPr sz="1800" b="1">
-                <a:solidFill>
-                  <a:srgbClr val="161616"/>
+              <a:rPr sz="900" b="1">
+                <a:solidFill>
+                  <a:srgbClr val="8B5CF6"/>
                 </a:solidFill>
                 <a:latin typeface="Microsoft YaHei"/>
               </a:rPr>
-              <a:t>04</a:t>
-            </a:r>
-          </a:p>
-        </p:txBody>
-      </p:sp>
-      <p:sp>
-        <p:nvSpPr>
-          <p:cNvPr id="31" name="TextBox 30"/>
+              <a:t>VERIFY</a:t>
+            </a:r>
+          </a:p>
+        </p:txBody>
+      </p:sp>
+      <p:sp>
+        <p:nvSpPr>
+          <p:cNvPr id="45" name="TextBox 44"/>
           <p:cNvSpPr txBox="1"/>
           <p:nvPr/>
         </p:nvSpPr>
         <p:spPr>
           <a:xfrm>
-            <a:off x="6501384" y="4425696"/>
-            <a:ext cx="4956048" cy="1298448"/>
+            <a:off x="6601968" y="5138927"/>
+            <a:ext cx="4626864" cy="566928"/>
           </a:xfrm>
           <a:prstGeom prst="rect">
             <a:avLst/>
@@ -5075,134 +6371,180 @@
           <a:noFill/>
         </p:spPr>
         <p:txBody>
-          <a:bodyPr wrap="square" lIns="0" tIns="0">
+          <a:bodyPr wrap="square" anchor="t">
             <a:spAutoFit/>
           </a:bodyPr>
           <a:lstStyle/>
           <a:p>
-            <a:pPr>
+            <a:pPr algn="l">
               <a:lnSpc>
-                <a:spcPct val="108000"/>
+                <a:spcPct val="105000"/>
               </a:lnSpc>
             </a:pPr>
             <a:r>
-              <a:rPr sz="1100" b="0">
-                <a:solidFill>
-                  <a:srgbClr val="2B2B2B"/>
+              <a:rPr sz="1150" b="0">
+                <a:solidFill>
+                  <a:srgbClr val="6B7480"/>
                 </a:solidFill>
                 <a:latin typeface="Microsoft YaHei"/>
               </a:rPr>
-              <a:t>检查结果并迭代优化</a:t>
-            </a:r>
-          </a:p>
-          <a:p>
-            <a:pPr>
+              <a:t>用结构、渲染、视觉与官方评估器四层证据确认交付质量。</a:t>
+            </a:r>
+          </a:p>
+        </p:txBody>
+      </p:sp>
+      <p:sp>
+        <p:nvSpPr>
+          <p:cNvPr id="46" name="TextBox 45"/>
+          <p:cNvSpPr txBox="1"/>
+          <p:nvPr/>
+        </p:nvSpPr>
+        <p:spPr>
+          <a:xfrm>
+            <a:off x="6601968" y="5669279"/>
+            <a:ext cx="4626864" cy="603504"/>
+          </a:xfrm>
+          <a:prstGeom prst="rect">
+            <a:avLst/>
+          </a:prstGeom>
+          <a:noFill/>
+        </p:spPr>
+        <p:txBody>
+          <a:bodyPr wrap="square" anchor="t">
+            <a:spAutoFit/>
+          </a:bodyPr>
+          <a:lstStyle/>
+          <a:p>
+            <a:pPr algn="l">
               <a:lnSpc>
-                <a:spcPct val="108000"/>
+                <a:spcPct val="102000"/>
               </a:lnSpc>
             </a:pPr>
             <a:r>
-              <a:rPr sz="1100" b="0">
-                <a:solidFill>
-                  <a:srgbClr val="2B2B2B"/>
+              <a:rPr sz="1050" b="0">
+                <a:solidFill>
+                  <a:srgbClr val="222A35"/>
                 </a:solidFill>
                 <a:latin typeface="Microsoft YaHei"/>
               </a:rPr>
-              <a:t>• 结果校验</a:t>
-            </a:r>
-          </a:p>
-          <a:p>
-            <a:pPr>
+              <a:t>•  反例定位与局部修复</a:t>
+            </a:r>
+          </a:p>
+          <a:p>
+            <a:pPr algn="l">
               <a:lnSpc>
-                <a:spcPct val="108000"/>
+                <a:spcPct val="102000"/>
               </a:lnSpc>
             </a:pPr>
             <a:r>
-              <a:rPr sz="1100" b="0">
-                <a:solidFill>
-                  <a:srgbClr val="2B2B2B"/>
+              <a:rPr sz="1050" b="0">
+                <a:solidFill>
+                  <a:srgbClr val="222A35"/>
                 </a:solidFill>
                 <a:latin typeface="Microsoft YaHei"/>
               </a:rPr>
-              <a:t>• 交付最终成果</a:t>
-            </a:r>
-          </a:p>
-        </p:txBody>
-      </p:sp>
-      <p:sp>
-        <p:nvSpPr>
-          <p:cNvPr id="32" name="Q4_provenance_收尾阶段"/>
-          <p:cNvSpPr txBox="1"/>
-          <p:nvPr/>
-        </p:nvSpPr>
-        <p:spPr>
-          <a:xfrm>
-            <a:off x="6501384" y="5769864"/>
-            <a:ext cx="4892040" cy="201168"/>
+              <a:t>•  证据新鲜度管理</a:t>
+            </a:r>
+          </a:p>
+          <a:p>
+            <a:pPr algn="l">
+              <a:lnSpc>
+                <a:spcPct val="102000"/>
+              </a:lnSpc>
+            </a:pPr>
+            <a:r>
+              <a:rPr sz="1050" b="0">
+                <a:solidFill>
+                  <a:srgbClr val="222A35"/>
+                </a:solidFill>
+                <a:latin typeface="Microsoft YaHei"/>
+              </a:rPr>
+              <a:t>•  交付前强制 gate</a:t>
+            </a:r>
+          </a:p>
+        </p:txBody>
+      </p:sp>
+      <p:sp>
+        <p:nvSpPr>
+          <p:cNvPr id="47" name="Rectangle 46"/>
+          <p:cNvSpPr/>
+          <p:nvPr/>
+        </p:nvSpPr>
+        <p:spPr>
+          <a:xfrm>
+            <a:off x="0" y="6455664"/>
+            <a:ext cx="12191695" cy="402336"/>
           </a:xfrm>
           <a:prstGeom prst="rect">
             <a:avLst/>
           </a:prstGeom>
+          <a:solidFill>
+            <a:srgbClr val="FFFFFF"/>
+          </a:solidFill>
+          <a:ln w="9525">
+            <a:solidFill>
+              <a:srgbClr val="E3E8EE"/>
+            </a:solidFill>
+          </a:ln>
+          <a:effectLst/>
+        </p:spPr>
+        <p:style>
+          <a:lnRef idx="1">
+            <a:schemeClr val="accent1"/>
+          </a:lnRef>
+          <a:fillRef idx="3">
+            <a:schemeClr val="accent1"/>
+          </a:fillRef>
+          <a:effectRef idx="2">
+            <a:schemeClr val="accent1"/>
+          </a:effectRef>
+          <a:fontRef idx="minor">
+            <a:schemeClr val="lt1"/>
+          </a:fontRef>
+        </p:style>
+        <p:txBody>
+          <a:bodyPr rtlCol="0" anchor="ctr"/>
+          <a:lstStyle/>
+          <a:p>
+            <a:pPr algn="ctr"/>
+          </a:p>
+        </p:txBody>
+      </p:sp>
+      <p:sp>
+        <p:nvSpPr>
+          <p:cNvPr id="48" name="TextBox 47"/>
+          <p:cNvSpPr txBox="1"/>
+          <p:nvPr/>
+        </p:nvSpPr>
+        <p:spPr>
+          <a:xfrm>
+            <a:off x="685800" y="6519672"/>
+            <a:ext cx="10789920" cy="274320"/>
+          </a:xfrm>
+          <a:prstGeom prst="rect">
+            <a:avLst/>
+          </a:prstGeom>
           <a:noFill/>
         </p:spPr>
         <p:txBody>
-          <a:bodyPr wrap="square" lIns="0" tIns="0">
+          <a:bodyPr wrap="square" anchor="t">
             <a:spAutoFit/>
           </a:bodyPr>
           <a:lstStyle/>
           <a:p>
-            <a:pPr>
+            <a:pPr algn="ctr">
               <a:lnSpc>
-                <a:spcPct val="125000"/>
+                <a:spcPct val="100000"/>
               </a:lnSpc>
             </a:pPr>
             <a:r>
-              <a:rPr sz="800" b="0">
-                <a:solidFill>
-                  <a:srgbClr val="878787"/>
+              <a:rPr sz="1000" b="0">
+                <a:solidFill>
+                  <a:srgbClr val="6B7480"/>
                 </a:solidFill>
                 <a:latin typeface="Microsoft YaHei"/>
               </a:rPr>
-              <a:t>收尾阶段</a:t>
-            </a:r>
-          </a:p>
-        </p:txBody>
-      </p:sp>
-      <p:sp>
-        <p:nvSpPr>
-          <p:cNvPr id="33" name="TextBox 32"/>
-          <p:cNvSpPr txBox="1"/>
-          <p:nvPr/>
-        </p:nvSpPr>
-        <p:spPr>
-          <a:xfrm>
-            <a:off x="438912" y="6355080"/>
-            <a:ext cx="11311128" cy="384048"/>
-          </a:xfrm>
-          <a:prstGeom prst="rect">
-            <a:avLst/>
-          </a:prstGeom>
-          <a:noFill/>
-        </p:spPr>
-        <p:txBody>
-          <a:bodyPr wrap="square" lIns="0" tIns="0">
-            <a:spAutoFit/>
-          </a:bodyPr>
-          <a:lstStyle/>
-          <a:p>
-            <a:pPr>
-              <a:lnSpc>
-                <a:spcPct val="125000"/>
-              </a:lnSpc>
-            </a:pPr>
-            <a:r>
-              <a:rPr sz="1800" b="0">
-                <a:solidFill>
-                  <a:srgbClr val="2B2B2B"/>
-                </a:solidFill>
-                <a:latin typeface="Microsoft YaHei"/>
-              </a:rPr>
-              <a:t>就绪 Ready  ·  四阶段串联闭环</a:t>
+              <a:t>AI Agent Console · 运行状态正常 · 所有阶段证据已归档</a:t>
             </a:r>
           </a:p>
         </p:txBody>
@@ -5533,324 +6875,4 @@
   </a:objectDefaults>
   <a:extraClrSchemeLst/>
 </a:theme>
-</file>
-
-<file path=ppt/theme/theme2.xml><?xml version="1.0" encoding="utf-8"?>
-<a:theme xmlns:a="http://schemas.openxmlformats.org/drawingml/2006/main" name="Office Theme">
-  <a:themeElements>
-    <a:clrScheme name="Office">
-      <a:dk1>
-        <a:sysClr val="windowText" lastClr="000000"/>
-      </a:dk1>
-      <a:lt1>
-        <a:sysClr val="window" lastClr="FFFFFF"/>
-      </a:lt1>
-      <a:dk2>
-        <a:srgbClr val="1F497D"/>
-      </a:dk2>
-      <a:lt2>
-        <a:srgbClr val="EEECE1"/>
-      </a:lt2>
-      <a:accent1>
-        <a:srgbClr val="4F81BD"/>
-      </a:accent1>
-      <a:accent2>
-        <a:srgbClr val="C0504D"/>
-      </a:accent2>
-      <a:accent3>
-        <a:srgbClr val="9BBB59"/>
-      </a:accent3>
-      <a:accent4>
-        <a:srgbClr val="8064A2"/>
-      </a:accent4>
-      <a:accent5>
-        <a:srgbClr val="4BACC6"/>
-      </a:accent5>
-      <a:accent6>
-        <a:srgbClr val="F79646"/>
-      </a:accent6>
-      <a:hlink>
-        <a:srgbClr val="0000FF"/>
-      </a:hlink>
-      <a:folHlink>
-        <a:srgbClr val="800080"/>
-      </a:folHlink>
-    </a:clrScheme>
-    <a:fontScheme name="Office">
-      <a:majorFont>
-        <a:latin typeface="Calibri"/>
-        <a:ea typeface=""/>
-        <a:cs typeface=""/>
-        <a:font script="Jpan" typeface="ＭＳ Ｐゴシック"/>
-        <a:font script="Hang" typeface="맑은 고딕"/>
-        <a:font script="Hans" typeface="宋体"/>
-        <a:font script="Hant" typeface="新細明體"/>
-        <a:font script="Arab" typeface="Times New Roman"/>
-        <a:font script="Hebr" typeface="Times New Roman"/>
-        <a:font script="Thai" typeface="Angsana New"/>
-        <a:font script="Ethi" typeface="Nyala"/>
-        <a:font script="Beng" typeface="Vrinda"/>
-        <a:font script="Gujr" typeface="Shruti"/>
-        <a:font script="Khmr" typeface="MoolBoran"/>
-        <a:font script="Knda" typeface="Tunga"/>
-        <a:font script="Guru" typeface="Raavi"/>
-        <a:font script="Cans" typeface="Euphemia"/>
-        <a:font script="Cher" typeface="Plantagenet Cherokee"/>
-        <a:font script="Yiii" typeface="Microsoft Yi Baiti"/>
-        <a:font script="Tibt" typeface="Microsoft Himalaya"/>
-        <a:font script="Thaa" typeface="MV Boli"/>
-        <a:font script="Deva" typeface="Mangal"/>
-        <a:font script="Telu" typeface="Gautami"/>
-        <a:font script="Taml" typeface="Latha"/>
-        <a:font script="Syrc" typeface="Estrangelo Edessa"/>
-        <a:font script="Orya" typeface="Kalinga"/>
-        <a:font script="Mlym" typeface="Kartika"/>
-        <a:font script="Laoo" typeface="DokChampa"/>
-        <a:font script="Sinh" typeface="Iskoola Pota"/>
-        <a:font script="Mong" typeface="Mongolian Baiti"/>
-        <a:font script="Viet" typeface="Times New Roman"/>
-        <a:font script="Uigh" typeface="Microsoft Uighur"/>
-        <a:font script="Geor" typeface="Sylfaen"/>
-      </a:majorFont>
-      <a:minorFont>
-        <a:latin typeface="Calibri"/>
-        <a:ea typeface=""/>
-        <a:cs typeface=""/>
-        <a:font script="Jpan" typeface="ＭＳ Ｐゴシック"/>
-        <a:font script="Hang" typeface="맑은 고딕"/>
-        <a:font script="Hans" typeface="宋体"/>
-        <a:font script="Hant" typeface="新細明體"/>
-        <a:font script="Arab" typeface="Arial"/>
-        <a:font script="Hebr" typeface="Arial"/>
-        <a:font script="Thai" typeface="Cordia New"/>
-        <a:font script="Ethi" typeface="Nyala"/>
-        <a:font script="Beng" typeface="Vrinda"/>
-        <a:font script="Gujr" typeface="Shruti"/>
-        <a:font script="Khmr" typeface="DaunPenh"/>
-        <a:font script="Knda" typeface="Tunga"/>
-        <a:font script="Guru" typeface="Raavi"/>
-        <a:font script="Cans" typeface="Euphemia"/>
-        <a:font script="Cher" typeface="Plantagenet Cherokee"/>
-        <a:font script="Yiii" typeface="Microsoft Yi Baiti"/>
-        <a:font script="Tibt" typeface="Microsoft Himalaya"/>
-        <a:font script="Thaa" typeface="MV Boli"/>
-        <a:font script="Deva" typeface="Mangal"/>
-        <a:font script="Telu" typeface="Gautami"/>
-        <a:font script="Taml" typeface="Latha"/>
-        <a:font script="Syrc" typeface="Estrangelo Edessa"/>
-        <a:font script="Orya" typeface="Kalinga"/>
-        <a:font script="Mlym" typeface="Kartika"/>
-        <a:font script="Laoo" typeface="DokChampa"/>
-        <a:font script="Sinh" typeface="Iskoola Pota"/>
-        <a:font script="Mong" typeface="Mongolian Baiti"/>
-        <a:font script="Viet" typeface="Arial"/>
-        <a:font script="Uigh" typeface="Microsoft Uighur"/>
-        <a:font script="Geor" typeface="Sylfaen"/>
-      </a:minorFont>
-    </a:fontScheme>
-    <a:fmtScheme name="Office">
-      <a:fillStyleLst>
-        <a:solidFill>
-          <a:schemeClr val="phClr"/>
-        </a:solidFill>
-        <a:gradFill rotWithShape="1">
-          <a:gsLst>
-            <a:gs pos="0">
-              <a:schemeClr val="phClr">
-                <a:tint val="50000"/>
-                <a:satMod val="300000"/>
-              </a:schemeClr>
-            </a:gs>
-            <a:gs pos="35000">
-              <a:schemeClr val="phClr">
-                <a:tint val="37000"/>
-                <a:satMod val="300000"/>
-              </a:schemeClr>
-            </a:gs>
-            <a:gs pos="100000">
-              <a:schemeClr val="phClr">
-                <a:tint val="15000"/>
-                <a:satMod val="350000"/>
-              </a:schemeClr>
-            </a:gs>
-          </a:gsLst>
-          <a:lin ang="16200000" scaled="1"/>
-        </a:gradFill>
-        <a:gradFill rotWithShape="1">
-          <a:gsLst>
-            <a:gs pos="0">
-              <a:schemeClr val="phClr">
-                <a:tint val="100000"/>
-                <a:shade val="100000"/>
-                <a:satMod val="130000"/>
-              </a:schemeClr>
-            </a:gs>
-            <a:gs pos="100000">
-              <a:schemeClr val="phClr">
-                <a:tint val="50000"/>
-                <a:shade val="100000"/>
-                <a:satMod val="350000"/>
-              </a:schemeClr>
-            </a:gs>
-          </a:gsLst>
-          <a:lin ang="16200000" scaled="0"/>
-        </a:gradFill>
-      </a:fillStyleLst>
-      <a:lnStyleLst>
-        <a:ln w="9525" cap="flat" cmpd="sng" algn="ctr">
-          <a:solidFill>
-            <a:schemeClr val="phClr">
-              <a:shade val="95000"/>
-              <a:satMod val="105000"/>
-            </a:schemeClr>
-          </a:solidFill>
-          <a:prstDash val="solid"/>
-        </a:ln>
-        <a:ln w="25400" cap="flat" cmpd="sng" algn="ctr">
-          <a:solidFill>
-            <a:schemeClr val="phClr"/>
-          </a:solidFill>
-          <a:prstDash val="solid"/>
-        </a:ln>
-        <a:ln w="38100" cap="flat" cmpd="sng" algn="ctr">
-          <a:solidFill>
-            <a:schemeClr val="phClr"/>
-          </a:solidFill>
-          <a:prstDash val="solid"/>
-        </a:ln>
-      </a:lnStyleLst>
-      <a:effectStyleLst>
-        <a:effectStyle>
-          <a:effectLst>
-            <a:outerShdw blurRad="40000" dist="20000" dir="5400000" rotWithShape="0">
-              <a:srgbClr val="000000">
-                <a:alpha val="38000"/>
-              </a:srgbClr>
-            </a:outerShdw>
-          </a:effectLst>
-        </a:effectStyle>
-        <a:effectStyle>
-          <a:effectLst>
-            <a:outerShdw blurRad="40000" dist="23000" dir="5400000" rotWithShape="0">
-              <a:srgbClr val="000000">
-                <a:alpha val="35000"/>
-              </a:srgbClr>
-            </a:outerShdw>
-          </a:effectLst>
-        </a:effectStyle>
-        <a:effectStyle>
-          <a:effectLst>
-            <a:outerShdw blurRad="40000" dist="23000" dir="5400000" rotWithShape="0">
-              <a:srgbClr val="000000">
-                <a:alpha val="35000"/>
-              </a:srgbClr>
-            </a:outerShdw>
-          </a:effectLst>
-          <a:scene3d>
-            <a:camera prst="orthographicFront">
-              <a:rot lat="0" lon="0" rev="0"/>
-            </a:camera>
-            <a:lightRig rig="threePt" dir="t">
-              <a:rot lat="0" lon="0" rev="1200000"/>
-            </a:lightRig>
-          </a:scene3d>
-          <a:sp3d>
-            <a:bevelT w="63500" h="25400"/>
-          </a:sp3d>
-        </a:effectStyle>
-      </a:effectStyleLst>
-      <a:bgFillStyleLst>
-        <a:solidFill>
-          <a:schemeClr val="phClr"/>
-        </a:solidFill>
-        <a:gradFill rotWithShape="1">
-          <a:gsLst>
-            <a:gs pos="0">
-              <a:schemeClr val="phClr">
-                <a:tint val="40000"/>
-                <a:satMod val="350000"/>
-              </a:schemeClr>
-            </a:gs>
-            <a:gs pos="40000">
-              <a:schemeClr val="phClr">
-                <a:tint val="45000"/>
-                <a:shade val="99000"/>
-                <a:satMod val="350000"/>
-              </a:schemeClr>
-            </a:gs>
-            <a:gs pos="100000">
-              <a:schemeClr val="phClr">
-                <a:shade val="20000"/>
-                <a:satMod val="255000"/>
-              </a:schemeClr>
-            </a:gs>
-          </a:gsLst>
-          <a:path path="circle">
-            <a:fillToRect l="50000" t="-80000" r="50000" b="180000"/>
-          </a:path>
-        </a:gradFill>
-        <a:gradFill rotWithShape="1">
-          <a:gsLst>
-            <a:gs pos="0">
-              <a:schemeClr val="phClr">
-                <a:tint val="80000"/>
-                <a:satMod val="300000"/>
-              </a:schemeClr>
-            </a:gs>
-            <a:gs pos="100000">
-              <a:schemeClr val="phClr">
-                <a:shade val="30000"/>
-                <a:satMod val="200000"/>
-              </a:schemeClr>
-            </a:gs>
-          </a:gsLst>
-          <a:path path="circle">
-            <a:fillToRect l="50000" t="50000" r="50000" b="50000"/>
-          </a:path>
-        </a:gradFill>
-      </a:bgFillStyleLst>
-    </a:fmtScheme>
-  </a:themeElements>
-  <a:objectDefaults>
-    <a:spDef>
-      <a:spPr/>
-      <a:bodyPr/>
-      <a:lstStyle/>
-      <a:style>
-        <a:lnRef idx="1">
-          <a:schemeClr val="accent1"/>
-        </a:lnRef>
-        <a:fillRef idx="3">
-          <a:schemeClr val="accent1"/>
-        </a:fillRef>
-        <a:effectRef idx="2">
-          <a:schemeClr val="accent1"/>
-        </a:effectRef>
-        <a:fontRef idx="minor">
-          <a:schemeClr val="lt1"/>
-        </a:fontRef>
-      </a:style>
-    </a:spDef>
-    <a:lnDef>
-      <a:spPr/>
-      <a:bodyPr/>
-      <a:lstStyle/>
-      <a:style>
-        <a:lnRef idx="2">
-          <a:schemeClr val="accent1"/>
-        </a:lnRef>
-        <a:fillRef idx="0">
-          <a:schemeClr val="accent1"/>
-        </a:fillRef>
-        <a:effectRef idx="1">
-          <a:schemeClr val="accent1"/>
-        </a:effectRef>
-        <a:fontRef idx="minor">
-          <a:schemeClr val="tx1"/>
-        </a:fontRef>
-      </a:style>
-    </a:lnDef>
-  </a:objectDefaults>
-  <a:extraClrSchemeLst/>
-</a:theme>
 </file>
</xml_diff>

<commit_message>
AI Agent workflow v3: KPI strip, metric chips, denser dashboard content
</commit_message>
<xml_diff>
--- a/benchmarks/manual_tasks/ai-agent-workflow/output/ai_agent_workflow.pptx
+++ b/benchmarks/manual_tasks/ai-agent-workflow/output/ai_agent_workflow.pptx
@@ -3104,7 +3104,7 @@
             <a:avLst/>
           </a:prstGeom>
           <a:solidFill>
-            <a:srgbClr val="101B2D"/>
+            <a:srgbClr val="0F1A2B"/>
           </a:solidFill>
           <a:ln>
             <a:noFill/>
@@ -3148,7 +3148,7 @@
             <a:avLst/>
           </a:prstGeom>
           <a:solidFill>
-            <a:srgbClr val="F5B341"/>
+            <a:srgbClr val="F6B544"/>
           </a:solidFill>
           <a:ln>
             <a:noFill/>
@@ -3179,14 +3179,58 @@
       </p:sp>
       <p:sp>
         <p:nvSpPr>
-          <p:cNvPr id="4" name="TextBox 3"/>
+          <p:cNvPr id="4" name="Rectangle 3"/>
+          <p:cNvSpPr/>
+          <p:nvPr/>
+        </p:nvSpPr>
+        <p:spPr>
+          <a:xfrm>
+            <a:off x="0" y="6528816"/>
+            <a:ext cx="12191695" cy="329184"/>
+          </a:xfrm>
+          <a:prstGeom prst="rect">
+            <a:avLst/>
+          </a:prstGeom>
+          <a:solidFill>
+            <a:srgbClr val="182B46"/>
+          </a:solidFill>
+          <a:ln>
+            <a:noFill/>
+          </a:ln>
+          <a:effectLst/>
+        </p:spPr>
+        <p:style>
+          <a:lnRef idx="1">
+            <a:schemeClr val="accent1"/>
+          </a:lnRef>
+          <a:fillRef idx="3">
+            <a:schemeClr val="accent1"/>
+          </a:fillRef>
+          <a:effectRef idx="2">
+            <a:schemeClr val="accent1"/>
+          </a:effectRef>
+          <a:fontRef idx="minor">
+            <a:schemeClr val="lt1"/>
+          </a:fontRef>
+        </p:style>
+        <p:txBody>
+          <a:bodyPr rtlCol="0" anchor="ctr"/>
+          <a:lstStyle/>
+          <a:p>
+            <a:pPr algn="ctr"/>
+          </a:p>
+        </p:txBody>
+      </p:sp>
+      <p:sp>
+        <p:nvSpPr>
+          <p:cNvPr id="5" name="TextBox 4"/>
           <p:cNvSpPr txBox="1"/>
           <p:nvPr/>
         </p:nvSpPr>
         <p:spPr>
           <a:xfrm>
-            <a:off x="822960" y="502920"/>
-            <a:ext cx="10515600" cy="365760"/>
+            <a:off x="777240" y="457200"/>
+            <a:ext cx="10607040" cy="365760"/>
           </a:xfrm>
           <a:prstGeom prst="rect">
             <a:avLst/>
@@ -3207,7 +3251,7 @@
             <a:r>
               <a:rPr sz="1200" b="1">
                 <a:solidFill>
-                  <a:srgbClr val="F5B341"/>
+                  <a:srgbClr val="F6B544"/>
                 </a:solidFill>
                 <a:latin typeface="Microsoft YaHei"/>
               </a:rPr>
@@ -3218,14 +3262,14 @@
       </p:sp>
       <p:sp>
         <p:nvSpPr>
-          <p:cNvPr id="5" name="TextBox 4"/>
+          <p:cNvPr id="6" name="TextBox 5"/>
           <p:cNvSpPr txBox="1"/>
           <p:nvPr/>
         </p:nvSpPr>
         <p:spPr>
           <a:xfrm>
-            <a:off x="822960" y="868680"/>
-            <a:ext cx="10515600" cy="1005840"/>
+            <a:off x="777240" y="804672"/>
+            <a:ext cx="10607040" cy="914400"/>
           </a:xfrm>
           <a:prstGeom prst="rect">
             <a:avLst/>
@@ -3244,7 +3288,7 @@
               </a:lnSpc>
             </a:pPr>
             <a:r>
-              <a:rPr sz="4200" b="1">
+              <a:rPr sz="4000" b="1">
                 <a:solidFill>
                   <a:srgbClr val="FFFFFF"/>
                 </a:solidFill>
@@ -3257,14 +3301,14 @@
       </p:sp>
       <p:sp>
         <p:nvSpPr>
-          <p:cNvPr id="6" name="TextBox 5"/>
+          <p:cNvPr id="7" name="TextBox 6"/>
           <p:cNvSpPr txBox="1"/>
           <p:nvPr/>
         </p:nvSpPr>
         <p:spPr>
           <a:xfrm>
-            <a:off x="822960" y="1874519"/>
-            <a:ext cx="10515600" cy="548640"/>
+            <a:off x="777240" y="1755648"/>
+            <a:ext cx="10607040" cy="502920"/>
           </a:xfrm>
           <a:prstGeom prst="rect">
             <a:avLst/>
@@ -3283,39 +3327,78 @@
               </a:lnSpc>
             </a:pPr>
             <a:r>
-              <a:rPr sz="1800" b="0">
-                <a:solidFill>
-                  <a:srgbClr val="B8C4D6"/>
+              <a:rPr sz="1700" b="0">
+                <a:solidFill>
+                  <a:srgbClr val="A8B8CE"/>
                 </a:solidFill>
                 <a:latin typeface="Microsoft YaHei"/>
               </a:rPr>
-              <a:t>从任务输入到可验证交付的六阶段闭环，每一步都沉淀为可审计证据</a:t>
-            </a:r>
-          </a:p>
-        </p:txBody>
-      </p:sp>
-      <p:sp>
-        <p:nvSpPr>
-          <p:cNvPr id="7" name="Rounded Rectangle 6"/>
+              <a:t>从任务输入到可验证交付的六阶段闭环，每个阶段都产出可审计证据</a:t>
+            </a:r>
+          </a:p>
+        </p:txBody>
+      </p:sp>
+      <p:sp>
+        <p:nvSpPr>
+          <p:cNvPr id="8" name="TextBox 7"/>
+          <p:cNvSpPr txBox="1"/>
+          <p:nvPr/>
+        </p:nvSpPr>
+        <p:spPr>
+          <a:xfrm>
+            <a:off x="777240" y="6291072"/>
+            <a:ext cx="10607040" cy="274320"/>
+          </a:xfrm>
+          <a:prstGeom prst="rect">
+            <a:avLst/>
+          </a:prstGeom>
+          <a:noFill/>
+        </p:spPr>
+        <p:txBody>
+          <a:bodyPr wrap="square" anchor="t">
+            <a:spAutoFit/>
+          </a:bodyPr>
+          <a:lstStyle/>
+          <a:p>
+            <a:pPr algn="ctr">
+              <a:lnSpc>
+                <a:spcPct val="100000"/>
+              </a:lnSpc>
+            </a:pPr>
+            <a:r>
+              <a:rPr sz="1100" b="0">
+                <a:solidFill>
+                  <a:srgbClr val="A8B8CE"/>
+                </a:solidFill>
+                <a:latin typeface="Microsoft YaHei"/>
+              </a:rPr>
+              <a:t>交付物 · 结构化证据 · 可恢复会话</a:t>
+            </a:r>
+          </a:p>
+        </p:txBody>
+      </p:sp>
+      <p:sp>
+        <p:nvSpPr>
+          <p:cNvPr id="9" name="Rounded Rectangle 8"/>
           <p:cNvSpPr/>
           <p:nvPr/>
         </p:nvSpPr>
         <p:spPr>
           <a:xfrm>
-            <a:off x="685800" y="3063240"/>
-            <a:ext cx="1938528" cy="2331720"/>
+            <a:off x="658368" y="2880360"/>
+            <a:ext cx="1975104" cy="2468880"/>
           </a:xfrm>
           <a:prstGeom prst="roundRect">
             <a:avLst>
-              <a:gd name="adj" fmla="val 10000"/>
+              <a:gd name="adj" fmla="val 9000"/>
             </a:avLst>
           </a:prstGeom>
           <a:solidFill>
-            <a:srgbClr val="182A44"/>
+            <a:srgbClr val="182B46"/>
           </a:solidFill>
           <a:ln w="9525">
             <a:solidFill>
-              <a:srgbClr val="2C3E5E"/>
+              <a:srgbClr val="2E4262"/>
             </a:solidFill>
           </a:ln>
           <a:effectLst/>
@@ -3344,14 +3427,14 @@
       </p:sp>
       <p:sp>
         <p:nvSpPr>
-          <p:cNvPr id="8" name="Rounded Rectangle 7"/>
+          <p:cNvPr id="10" name="Rounded Rectangle 9"/>
           <p:cNvSpPr/>
           <p:nvPr/>
         </p:nvSpPr>
         <p:spPr>
           <a:xfrm>
-            <a:off x="850392" y="3227832"/>
-            <a:ext cx="475488" cy="475488"/>
+            <a:off x="822959" y="3044952"/>
+            <a:ext cx="493776" cy="493776"/>
           </a:xfrm>
           <a:prstGeom prst="roundRect">
             <a:avLst>
@@ -3359,7 +3442,7 @@
             </a:avLst>
           </a:prstGeom>
           <a:solidFill>
-            <a:srgbClr val="F5B341"/>
+            <a:srgbClr val="F6B544"/>
           </a:solidFill>
           <a:ln>
             <a:noFill/>
@@ -3388,7 +3471,7 @@
             <a:r>
               <a:rPr sz="1300" b="1">
                 <a:solidFill>
-                  <a:srgbClr val="101B2D"/>
+                  <a:srgbClr val="0F1A2B"/>
                 </a:solidFill>
               </a:rPr>
               <a:t>01</a:t>
@@ -3398,14 +3481,14 @@
       </p:sp>
       <p:sp>
         <p:nvSpPr>
-          <p:cNvPr id="9" name="TextBox 8"/>
+          <p:cNvPr id="11" name="TextBox 10"/>
           <p:cNvSpPr txBox="1"/>
           <p:nvPr/>
         </p:nvSpPr>
         <p:spPr>
           <a:xfrm>
-            <a:off x="832104" y="3886200"/>
-            <a:ext cx="1645920" cy="411480"/>
+            <a:off x="804672" y="3721608"/>
+            <a:ext cx="1682496" cy="384048"/>
           </a:xfrm>
           <a:prstGeom prst="rect">
             <a:avLst/>
@@ -3424,7 +3507,7 @@
               </a:lnSpc>
             </a:pPr>
             <a:r>
-              <a:rPr sz="1500" b="1">
+              <a:rPr sz="1450" b="1">
                 <a:solidFill>
                   <a:srgbClr val="FFFFFF"/>
                 </a:solidFill>
@@ -3437,14 +3520,14 @@
       </p:sp>
       <p:sp>
         <p:nvSpPr>
-          <p:cNvPr id="10" name="TextBox 9"/>
+          <p:cNvPr id="12" name="TextBox 11"/>
           <p:cNvSpPr txBox="1"/>
           <p:nvPr/>
         </p:nvSpPr>
         <p:spPr>
           <a:xfrm>
-            <a:off x="832104" y="4389120"/>
-            <a:ext cx="1645920" cy="868680"/>
+            <a:off x="804672" y="4160520"/>
+            <a:ext cx="1682496" cy="685800"/>
           </a:xfrm>
           <a:prstGeom prst="rect">
             <a:avLst/>
@@ -3459,38 +3542,123 @@
           <a:p>
             <a:pPr algn="l">
               <a:lnSpc>
-                <a:spcPct val="105000"/>
+                <a:spcPct val="104000"/>
               </a:lnSpc>
             </a:pPr>
             <a:r>
-              <a:rPr sz="1150" b="0">
-                <a:solidFill>
-                  <a:srgbClr val="B8C4D6"/>
+              <a:rPr sz="1050" b="0">
+                <a:solidFill>
+                  <a:srgbClr val="A8B8CE"/>
                 </a:solidFill>
                 <a:latin typeface="Microsoft YaHei"/>
               </a:rPr>
-              <a:t>接收指令、文件与上下文</a:t>
+              <a:t>接收指令、附件与工作区上下文</a:t>
+            </a:r>
+          </a:p>
+        </p:txBody>
+      </p:sp>
+      <p:sp>
+        <p:nvSpPr>
+          <p:cNvPr id="13" name="Rounded Rectangle 12"/>
+          <p:cNvSpPr/>
+          <p:nvPr/>
+        </p:nvSpPr>
+        <p:spPr>
+          <a:xfrm>
+            <a:off x="804672" y="4910328"/>
+            <a:ext cx="1682496" cy="310896"/>
+          </a:xfrm>
+          <a:prstGeom prst="roundRect">
+            <a:avLst>
+              <a:gd name="adj" fmla="val 50000"/>
+            </a:avLst>
+          </a:prstGeom>
+          <a:solidFill>
+            <a:srgbClr val="213555"/>
+          </a:solidFill>
+          <a:ln>
+            <a:noFill/>
+          </a:ln>
+          <a:effectLst/>
+        </p:spPr>
+        <p:style>
+          <a:lnRef idx="1">
+            <a:schemeClr val="accent1"/>
+          </a:lnRef>
+          <a:fillRef idx="3">
+            <a:schemeClr val="accent1"/>
+          </a:fillRef>
+          <a:effectRef idx="2">
+            <a:schemeClr val="accent1"/>
+          </a:effectRef>
+          <a:fontRef idx="minor">
+            <a:schemeClr val="lt1"/>
+          </a:fontRef>
+        </p:style>
+        <p:txBody>
+          <a:bodyPr rtlCol="0" anchor="ctr"/>
+          <a:lstStyle/>
+          <a:p>
+            <a:pPr algn="ctr"/>
+          </a:p>
+        </p:txBody>
+      </p:sp>
+      <p:sp>
+        <p:nvSpPr>
+          <p:cNvPr id="14" name="TextBox 13"/>
+          <p:cNvSpPr txBox="1"/>
+          <p:nvPr/>
+        </p:nvSpPr>
+        <p:spPr>
+          <a:xfrm>
+            <a:off x="877824" y="4965192"/>
+            <a:ext cx="1536192" cy="201168"/>
+          </a:xfrm>
+          <a:prstGeom prst="rect">
+            <a:avLst/>
+          </a:prstGeom>
+          <a:noFill/>
+        </p:spPr>
+        <p:txBody>
+          <a:bodyPr wrap="square" anchor="t">
+            <a:spAutoFit/>
+          </a:bodyPr>
+          <a:lstStyle/>
+          <a:p>
+            <a:pPr algn="l">
+              <a:lnSpc>
+                <a:spcPct val="100000"/>
+              </a:lnSpc>
+            </a:pPr>
+            <a:r>
+              <a:rPr sz="850" b="0">
+                <a:solidFill>
+                  <a:srgbClr val="F6B544"/>
+                </a:solidFill>
+                <a:latin typeface="Microsoft YaHei"/>
+              </a:rPr>
+              <a:t>产出：结构化任务对象</a:t>
             </a:r>
           </a:p>
         </p:txBody>
       </p:sp>
       <p:cxnSp>
         <p:nvCxnSpPr>
-          <p:cNvPr id="11" name="Connector 10"/>
+          <p:cNvPr id="15" name="Connector 14"/>
           <p:cNvCxnSpPr/>
           <p:nvPr/>
         </p:nvCxnSpPr>
         <p:spPr>
           <a:xfrm>
-            <a:off x="2656332" y="4229100"/>
-            <a:ext cx="155448" cy="0"/>
+            <a:off x="2660903" y="4114800"/>
+            <a:ext cx="146305" cy="0"/>
           </a:xfrm>
           <a:prstGeom prst="line">
             <a:avLst/>
           </a:prstGeom>
           <a:ln w="25400">
             <a:solidFill>
-              <a:srgbClr val="F5B341"/>
+              <a:srgbClr val="F6B544"/>
             </a:solidFill>
             <a:headEnd type="arrow" w="med" len="med"/>
           </a:ln>
@@ -3512,26 +3680,26 @@
       </p:cxnSp>
       <p:sp>
         <p:nvSpPr>
-          <p:cNvPr id="12" name="Rounded Rectangle 11"/>
+          <p:cNvPr id="16" name="Rounded Rectangle 15"/>
           <p:cNvSpPr/>
           <p:nvPr/>
         </p:nvSpPr>
         <p:spPr>
           <a:xfrm>
-            <a:off x="2843784" y="3063240"/>
-            <a:ext cx="1938528" cy="2331720"/>
+            <a:off x="2834640" y="2880360"/>
+            <a:ext cx="1975104" cy="2468880"/>
           </a:xfrm>
           <a:prstGeom prst="roundRect">
             <a:avLst>
-              <a:gd name="adj" fmla="val 10000"/>
+              <a:gd name="adj" fmla="val 9000"/>
             </a:avLst>
           </a:prstGeom>
           <a:solidFill>
-            <a:srgbClr val="182A44"/>
+            <a:srgbClr val="182B46"/>
           </a:solidFill>
           <a:ln w="9525">
             <a:solidFill>
-              <a:srgbClr val="2C3E5E"/>
+              <a:srgbClr val="2E4262"/>
             </a:solidFill>
           </a:ln>
           <a:effectLst/>
@@ -3560,14 +3728,14 @@
       </p:sp>
       <p:sp>
         <p:nvSpPr>
-          <p:cNvPr id="13" name="Rounded Rectangle 12"/>
+          <p:cNvPr id="17" name="Rounded Rectangle 16"/>
           <p:cNvSpPr/>
           <p:nvPr/>
         </p:nvSpPr>
         <p:spPr>
           <a:xfrm>
-            <a:off x="3008376" y="3227832"/>
-            <a:ext cx="475488" cy="475488"/>
+            <a:off x="2999232" y="3044952"/>
+            <a:ext cx="493776" cy="493776"/>
           </a:xfrm>
           <a:prstGeom prst="roundRect">
             <a:avLst>
@@ -3575,7 +3743,7 @@
             </a:avLst>
           </a:prstGeom>
           <a:solidFill>
-            <a:srgbClr val="F5B341"/>
+            <a:srgbClr val="F6B544"/>
           </a:solidFill>
           <a:ln>
             <a:noFill/>
@@ -3604,7 +3772,7 @@
             <a:r>
               <a:rPr sz="1300" b="1">
                 <a:solidFill>
-                  <a:srgbClr val="101B2D"/>
+                  <a:srgbClr val="0F1A2B"/>
                 </a:solidFill>
               </a:rPr>
               <a:t>02</a:t>
@@ -3614,14 +3782,14 @@
       </p:sp>
       <p:sp>
         <p:nvSpPr>
-          <p:cNvPr id="14" name="TextBox 13"/>
+          <p:cNvPr id="18" name="TextBox 17"/>
           <p:cNvSpPr txBox="1"/>
           <p:nvPr/>
         </p:nvSpPr>
         <p:spPr>
           <a:xfrm>
-            <a:off x="2990088" y="3886200"/>
-            <a:ext cx="1645920" cy="411480"/>
+            <a:off x="2980944" y="3721608"/>
+            <a:ext cx="1682496" cy="384048"/>
           </a:xfrm>
           <a:prstGeom prst="rect">
             <a:avLst/>
@@ -3640,7 +3808,7 @@
               </a:lnSpc>
             </a:pPr>
             <a:r>
-              <a:rPr sz="1500" b="1">
+              <a:rPr sz="1450" b="1">
                 <a:solidFill>
                   <a:srgbClr val="FFFFFF"/>
                 </a:solidFill>
@@ -3653,14 +3821,14 @@
       </p:sp>
       <p:sp>
         <p:nvSpPr>
-          <p:cNvPr id="15" name="TextBox 14"/>
+          <p:cNvPr id="19" name="TextBox 18"/>
           <p:cNvSpPr txBox="1"/>
           <p:nvPr/>
         </p:nvSpPr>
         <p:spPr>
           <a:xfrm>
-            <a:off x="2990088" y="4389120"/>
-            <a:ext cx="1645920" cy="868680"/>
+            <a:off x="2980944" y="4160520"/>
+            <a:ext cx="1682496" cy="685800"/>
           </a:xfrm>
           <a:prstGeom prst="rect">
             <a:avLst/>
@@ -3675,38 +3843,123 @@
           <a:p>
             <a:pPr algn="l">
               <a:lnSpc>
-                <a:spcPct val="105000"/>
+                <a:spcPct val="104000"/>
               </a:lnSpc>
             </a:pPr>
             <a:r>
-              <a:rPr sz="1150" b="0">
-                <a:solidFill>
-                  <a:srgbClr val="B8C4D6"/>
+              <a:rPr sz="1050" b="0">
+                <a:solidFill>
+                  <a:srgbClr val="A8B8CE"/>
                 </a:solidFill>
                 <a:latin typeface="Microsoft YaHei"/>
               </a:rPr>
-              <a:t>任务分类、能力匹配与计划</a:t>
+              <a:t>任务分类、能力匹配与计划生成</a:t>
+            </a:r>
+          </a:p>
+        </p:txBody>
+      </p:sp>
+      <p:sp>
+        <p:nvSpPr>
+          <p:cNvPr id="20" name="Rounded Rectangle 19"/>
+          <p:cNvSpPr/>
+          <p:nvPr/>
+        </p:nvSpPr>
+        <p:spPr>
+          <a:xfrm>
+            <a:off x="2980944" y="4910328"/>
+            <a:ext cx="1682496" cy="310896"/>
+          </a:xfrm>
+          <a:prstGeom prst="roundRect">
+            <a:avLst>
+              <a:gd name="adj" fmla="val 50000"/>
+            </a:avLst>
+          </a:prstGeom>
+          <a:solidFill>
+            <a:srgbClr val="213555"/>
+          </a:solidFill>
+          <a:ln>
+            <a:noFill/>
+          </a:ln>
+          <a:effectLst/>
+        </p:spPr>
+        <p:style>
+          <a:lnRef idx="1">
+            <a:schemeClr val="accent1"/>
+          </a:lnRef>
+          <a:fillRef idx="3">
+            <a:schemeClr val="accent1"/>
+          </a:fillRef>
+          <a:effectRef idx="2">
+            <a:schemeClr val="accent1"/>
+          </a:effectRef>
+          <a:fontRef idx="minor">
+            <a:schemeClr val="lt1"/>
+          </a:fontRef>
+        </p:style>
+        <p:txBody>
+          <a:bodyPr rtlCol="0" anchor="ctr"/>
+          <a:lstStyle/>
+          <a:p>
+            <a:pPr algn="ctr"/>
+          </a:p>
+        </p:txBody>
+      </p:sp>
+      <p:sp>
+        <p:nvSpPr>
+          <p:cNvPr id="21" name="TextBox 20"/>
+          <p:cNvSpPr txBox="1"/>
+          <p:nvPr/>
+        </p:nvSpPr>
+        <p:spPr>
+          <a:xfrm>
+            <a:off x="3054096" y="4965192"/>
+            <a:ext cx="1536192" cy="201168"/>
+          </a:xfrm>
+          <a:prstGeom prst="rect">
+            <a:avLst/>
+          </a:prstGeom>
+          <a:noFill/>
+        </p:spPr>
+        <p:txBody>
+          <a:bodyPr wrap="square" anchor="t">
+            <a:spAutoFit/>
+          </a:bodyPr>
+          <a:lstStyle/>
+          <a:p>
+            <a:pPr algn="l">
+              <a:lnSpc>
+                <a:spcPct val="100000"/>
+              </a:lnSpc>
+            </a:pPr>
+            <a:r>
+              <a:rPr sz="850" b="0">
+                <a:solidFill>
+                  <a:srgbClr val="F6B544"/>
+                </a:solidFill>
+                <a:latin typeface="Microsoft YaHei"/>
+              </a:rPr>
+              <a:t>产出：执行合同与工具面</a:t>
             </a:r>
           </a:p>
         </p:txBody>
       </p:sp>
       <p:cxnSp>
         <p:nvCxnSpPr>
-          <p:cNvPr id="16" name="Connector 15"/>
+          <p:cNvPr id="22" name="Connector 21"/>
           <p:cNvCxnSpPr/>
           <p:nvPr/>
         </p:nvCxnSpPr>
         <p:spPr>
           <a:xfrm>
-            <a:off x="4814316" y="4229100"/>
-            <a:ext cx="155448" cy="0"/>
+            <a:off x="4837176" y="4114800"/>
+            <a:ext cx="146304" cy="0"/>
           </a:xfrm>
           <a:prstGeom prst="line">
             <a:avLst/>
           </a:prstGeom>
           <a:ln w="25400">
             <a:solidFill>
-              <a:srgbClr val="F5B341"/>
+              <a:srgbClr val="F6B544"/>
             </a:solidFill>
             <a:headEnd type="arrow" w="med" len="med"/>
           </a:ln>
@@ -3728,26 +3981,26 @@
       </p:cxnSp>
       <p:sp>
         <p:nvSpPr>
-          <p:cNvPr id="17" name="Rounded Rectangle 16"/>
+          <p:cNvPr id="23" name="Rounded Rectangle 22"/>
           <p:cNvSpPr/>
           <p:nvPr/>
         </p:nvSpPr>
         <p:spPr>
           <a:xfrm>
-            <a:off x="5001768" y="3063240"/>
-            <a:ext cx="1938528" cy="2331720"/>
+            <a:off x="5010912" y="2880360"/>
+            <a:ext cx="1975104" cy="2468880"/>
           </a:xfrm>
           <a:prstGeom prst="roundRect">
             <a:avLst>
-              <a:gd name="adj" fmla="val 10000"/>
+              <a:gd name="adj" fmla="val 9000"/>
             </a:avLst>
           </a:prstGeom>
           <a:solidFill>
-            <a:srgbClr val="182A44"/>
+            <a:srgbClr val="182B46"/>
           </a:solidFill>
           <a:ln w="9525">
             <a:solidFill>
-              <a:srgbClr val="2C3E5E"/>
+              <a:srgbClr val="2E4262"/>
             </a:solidFill>
           </a:ln>
           <a:effectLst/>
@@ -3776,14 +4029,14 @@
       </p:sp>
       <p:sp>
         <p:nvSpPr>
-          <p:cNvPr id="18" name="Rounded Rectangle 17"/>
+          <p:cNvPr id="24" name="Rounded Rectangle 23"/>
           <p:cNvSpPr/>
           <p:nvPr/>
         </p:nvSpPr>
         <p:spPr>
           <a:xfrm>
-            <a:off x="5166360" y="3227832"/>
-            <a:ext cx="475488" cy="475488"/>
+            <a:off x="5175504" y="3044952"/>
+            <a:ext cx="493776" cy="493776"/>
           </a:xfrm>
           <a:prstGeom prst="roundRect">
             <a:avLst>
@@ -3791,7 +4044,7 @@
             </a:avLst>
           </a:prstGeom>
           <a:solidFill>
-            <a:srgbClr val="F5B341"/>
+            <a:srgbClr val="F6B544"/>
           </a:solidFill>
           <a:ln>
             <a:noFill/>
@@ -3820,7 +4073,7 @@
             <a:r>
               <a:rPr sz="1300" b="1">
                 <a:solidFill>
-                  <a:srgbClr val="101B2D"/>
+                  <a:srgbClr val="0F1A2B"/>
                 </a:solidFill>
               </a:rPr>
               <a:t>03</a:t>
@@ -3830,14 +4083,14 @@
       </p:sp>
       <p:sp>
         <p:nvSpPr>
-          <p:cNvPr id="19" name="TextBox 18"/>
+          <p:cNvPr id="25" name="TextBox 24"/>
           <p:cNvSpPr txBox="1"/>
           <p:nvPr/>
         </p:nvSpPr>
         <p:spPr>
           <a:xfrm>
-            <a:off x="5148072" y="3886200"/>
-            <a:ext cx="1645920" cy="411480"/>
+            <a:off x="5157216" y="3721608"/>
+            <a:ext cx="1682496" cy="384048"/>
           </a:xfrm>
           <a:prstGeom prst="rect">
             <a:avLst/>
@@ -3856,7 +4109,7 @@
               </a:lnSpc>
             </a:pPr>
             <a:r>
-              <a:rPr sz="1500" b="1">
+              <a:rPr sz="1450" b="1">
                 <a:solidFill>
                   <a:srgbClr val="FFFFFF"/>
                 </a:solidFill>
@@ -3869,14 +4122,14 @@
       </p:sp>
       <p:sp>
         <p:nvSpPr>
-          <p:cNvPr id="20" name="TextBox 19"/>
+          <p:cNvPr id="26" name="TextBox 25"/>
           <p:cNvSpPr txBox="1"/>
           <p:nvPr/>
         </p:nvSpPr>
         <p:spPr>
           <a:xfrm>
-            <a:off x="5148072" y="4389120"/>
-            <a:ext cx="1645920" cy="868680"/>
+            <a:off x="5157216" y="4160520"/>
+            <a:ext cx="1682496" cy="685800"/>
           </a:xfrm>
           <a:prstGeom prst="rect">
             <a:avLst/>
@@ -3891,38 +4144,123 @@
           <a:p>
             <a:pPr algn="l">
               <a:lnSpc>
-                <a:spcPct val="105000"/>
+                <a:spcPct val="104000"/>
               </a:lnSpc>
             </a:pPr>
             <a:r>
-              <a:rPr sz="1150" b="0">
-                <a:solidFill>
-                  <a:srgbClr val="B8C4D6"/>
+              <a:rPr sz="1050" b="0">
+                <a:solidFill>
+                  <a:srgbClr val="A8B8CE"/>
                 </a:solidFill>
                 <a:latin typeface="Microsoft YaHei"/>
               </a:rPr>
-              <a:t>生成执行合同与工具面</a:t>
+              <a:t>拆解阶段、预检风险与依赖关系</a:t>
+            </a:r>
+          </a:p>
+        </p:txBody>
+      </p:sp>
+      <p:sp>
+        <p:nvSpPr>
+          <p:cNvPr id="27" name="Rounded Rectangle 26"/>
+          <p:cNvSpPr/>
+          <p:nvPr/>
+        </p:nvSpPr>
+        <p:spPr>
+          <a:xfrm>
+            <a:off x="5157216" y="4910328"/>
+            <a:ext cx="1682496" cy="310896"/>
+          </a:xfrm>
+          <a:prstGeom prst="roundRect">
+            <a:avLst>
+              <a:gd name="adj" fmla="val 50000"/>
+            </a:avLst>
+          </a:prstGeom>
+          <a:solidFill>
+            <a:srgbClr val="213555"/>
+          </a:solidFill>
+          <a:ln>
+            <a:noFill/>
+          </a:ln>
+          <a:effectLst/>
+        </p:spPr>
+        <p:style>
+          <a:lnRef idx="1">
+            <a:schemeClr val="accent1"/>
+          </a:lnRef>
+          <a:fillRef idx="3">
+            <a:schemeClr val="accent1"/>
+          </a:fillRef>
+          <a:effectRef idx="2">
+            <a:schemeClr val="accent1"/>
+          </a:effectRef>
+          <a:fontRef idx="minor">
+            <a:schemeClr val="lt1"/>
+          </a:fontRef>
+        </p:style>
+        <p:txBody>
+          <a:bodyPr rtlCol="0" anchor="ctr"/>
+          <a:lstStyle/>
+          <a:p>
+            <a:pPr algn="ctr"/>
+          </a:p>
+        </p:txBody>
+      </p:sp>
+      <p:sp>
+        <p:nvSpPr>
+          <p:cNvPr id="28" name="TextBox 27"/>
+          <p:cNvSpPr txBox="1"/>
+          <p:nvPr/>
+        </p:nvSpPr>
+        <p:spPr>
+          <a:xfrm>
+            <a:off x="5230368" y="4965192"/>
+            <a:ext cx="1536192" cy="201168"/>
+          </a:xfrm>
+          <a:prstGeom prst="rect">
+            <a:avLst/>
+          </a:prstGeom>
+          <a:noFill/>
+        </p:spPr>
+        <p:txBody>
+          <a:bodyPr wrap="square" anchor="t">
+            <a:spAutoFit/>
+          </a:bodyPr>
+          <a:lstStyle/>
+          <a:p>
+            <a:pPr algn="l">
+              <a:lnSpc>
+                <a:spcPct val="100000"/>
+              </a:lnSpc>
+            </a:pPr>
+            <a:r>
+              <a:rPr sz="850" b="0">
+                <a:solidFill>
+                  <a:srgbClr val="F6B544"/>
+                </a:solidFill>
+                <a:latin typeface="Microsoft YaHei"/>
+              </a:rPr>
+              <a:t>产出：执行计划</a:t>
             </a:r>
           </a:p>
         </p:txBody>
       </p:sp>
       <p:cxnSp>
         <p:nvCxnSpPr>
-          <p:cNvPr id="21" name="Connector 20"/>
+          <p:cNvPr id="29" name="Connector 28"/>
           <p:cNvCxnSpPr/>
           <p:nvPr/>
         </p:nvCxnSpPr>
         <p:spPr>
           <a:xfrm>
-            <a:off x="6972300" y="4229100"/>
-            <a:ext cx="155448" cy="0"/>
+            <a:off x="7013448" y="4114800"/>
+            <a:ext cx="146304" cy="0"/>
           </a:xfrm>
           <a:prstGeom prst="line">
             <a:avLst/>
           </a:prstGeom>
           <a:ln w="25400">
             <a:solidFill>
-              <a:srgbClr val="F5B341"/>
+              <a:srgbClr val="F6B544"/>
             </a:solidFill>
             <a:headEnd type="arrow" w="med" len="med"/>
           </a:ln>
@@ -3944,26 +4282,26 @@
       </p:cxnSp>
       <p:sp>
         <p:nvSpPr>
-          <p:cNvPr id="22" name="Rounded Rectangle 21"/>
+          <p:cNvPr id="30" name="Rounded Rectangle 29"/>
           <p:cNvSpPr/>
           <p:nvPr/>
         </p:nvSpPr>
         <p:spPr>
           <a:xfrm>
-            <a:off x="7159752" y="3063240"/>
-            <a:ext cx="1938528" cy="2331720"/>
+            <a:off x="7187184" y="2880360"/>
+            <a:ext cx="1975104" cy="2468880"/>
           </a:xfrm>
           <a:prstGeom prst="roundRect">
             <a:avLst>
-              <a:gd name="adj" fmla="val 10000"/>
+              <a:gd name="adj" fmla="val 9000"/>
             </a:avLst>
           </a:prstGeom>
           <a:solidFill>
-            <a:srgbClr val="182A44"/>
+            <a:srgbClr val="182B46"/>
           </a:solidFill>
           <a:ln w="9525">
             <a:solidFill>
-              <a:srgbClr val="2C3E5E"/>
+              <a:srgbClr val="2E4262"/>
             </a:solidFill>
           </a:ln>
           <a:effectLst/>
@@ -3992,14 +4330,14 @@
       </p:sp>
       <p:sp>
         <p:nvSpPr>
-          <p:cNvPr id="23" name="Rounded Rectangle 22"/>
+          <p:cNvPr id="31" name="Rounded Rectangle 30"/>
           <p:cNvSpPr/>
           <p:nvPr/>
         </p:nvSpPr>
         <p:spPr>
           <a:xfrm>
-            <a:off x="7324344" y="3227832"/>
-            <a:ext cx="475488" cy="475488"/>
+            <a:off x="7351776" y="3044952"/>
+            <a:ext cx="493776" cy="493776"/>
           </a:xfrm>
           <a:prstGeom prst="roundRect">
             <a:avLst>
@@ -4007,7 +4345,7 @@
             </a:avLst>
           </a:prstGeom>
           <a:solidFill>
-            <a:srgbClr val="F5B341"/>
+            <a:srgbClr val="F6B544"/>
           </a:solidFill>
           <a:ln>
             <a:noFill/>
@@ -4036,7 +4374,7 @@
             <a:r>
               <a:rPr sz="1300" b="1">
                 <a:solidFill>
-                  <a:srgbClr val="101B2D"/>
+                  <a:srgbClr val="0F1A2B"/>
                 </a:solidFill>
               </a:rPr>
               <a:t>04</a:t>
@@ -4046,14 +4384,14 @@
       </p:sp>
       <p:sp>
         <p:nvSpPr>
-          <p:cNvPr id="24" name="TextBox 23"/>
+          <p:cNvPr id="32" name="TextBox 31"/>
           <p:cNvSpPr txBox="1"/>
           <p:nvPr/>
         </p:nvSpPr>
         <p:spPr>
           <a:xfrm>
-            <a:off x="7306056" y="3886200"/>
-            <a:ext cx="1645920" cy="411480"/>
+            <a:off x="7333488" y="3721608"/>
+            <a:ext cx="1682496" cy="384048"/>
           </a:xfrm>
           <a:prstGeom prst="rect">
             <a:avLst/>
@@ -4072,7 +4410,7 @@
               </a:lnSpc>
             </a:pPr>
             <a:r>
-              <a:rPr sz="1500" b="1">
+              <a:rPr sz="1450" b="1">
                 <a:solidFill>
                   <a:srgbClr val="FFFFFF"/>
                 </a:solidFill>
@@ -4085,14 +4423,14 @@
       </p:sp>
       <p:sp>
         <p:nvSpPr>
-          <p:cNvPr id="25" name="TextBox 24"/>
+          <p:cNvPr id="33" name="TextBox 32"/>
           <p:cNvSpPr txBox="1"/>
           <p:nvPr/>
         </p:nvSpPr>
         <p:spPr>
           <a:xfrm>
-            <a:off x="7306056" y="4389120"/>
-            <a:ext cx="1645920" cy="868680"/>
+            <a:off x="7333488" y="4160520"/>
+            <a:ext cx="1682496" cy="685800"/>
           </a:xfrm>
           <a:prstGeom prst="rect">
             <a:avLst/>
@@ -4107,38 +4445,123 @@
           <a:p>
             <a:pPr algn="l">
               <a:lnSpc>
-                <a:spcPct val="105000"/>
+                <a:spcPct val="104000"/>
               </a:lnSpc>
             </a:pPr>
             <a:r>
-              <a:rPr sz="1150" b="0">
-                <a:solidFill>
-                  <a:srgbClr val="B8C4D6"/>
+              <a:rPr sz="1050" b="0">
+                <a:solidFill>
+                  <a:srgbClr val="A8B8CE"/>
                 </a:solidFill>
                 <a:latin typeface="Microsoft YaHei"/>
               </a:rPr>
-              <a:t>工具调用、事务与沙箱</a:t>
+              <a:t>工具调用、原子事务与权限审计</a:t>
+            </a:r>
+          </a:p>
+        </p:txBody>
+      </p:sp>
+      <p:sp>
+        <p:nvSpPr>
+          <p:cNvPr id="34" name="Rounded Rectangle 33"/>
+          <p:cNvSpPr/>
+          <p:nvPr/>
+        </p:nvSpPr>
+        <p:spPr>
+          <a:xfrm>
+            <a:off x="7333488" y="4910328"/>
+            <a:ext cx="1682496" cy="310896"/>
+          </a:xfrm>
+          <a:prstGeom prst="roundRect">
+            <a:avLst>
+              <a:gd name="adj" fmla="val 50000"/>
+            </a:avLst>
+          </a:prstGeom>
+          <a:solidFill>
+            <a:srgbClr val="213555"/>
+          </a:solidFill>
+          <a:ln>
+            <a:noFill/>
+          </a:ln>
+          <a:effectLst/>
+        </p:spPr>
+        <p:style>
+          <a:lnRef idx="1">
+            <a:schemeClr val="accent1"/>
+          </a:lnRef>
+          <a:fillRef idx="3">
+            <a:schemeClr val="accent1"/>
+          </a:fillRef>
+          <a:effectRef idx="2">
+            <a:schemeClr val="accent1"/>
+          </a:effectRef>
+          <a:fontRef idx="minor">
+            <a:schemeClr val="lt1"/>
+          </a:fontRef>
+        </p:style>
+        <p:txBody>
+          <a:bodyPr rtlCol="0" anchor="ctr"/>
+          <a:lstStyle/>
+          <a:p>
+            <a:pPr algn="ctr"/>
+          </a:p>
+        </p:txBody>
+      </p:sp>
+      <p:sp>
+        <p:nvSpPr>
+          <p:cNvPr id="35" name="TextBox 34"/>
+          <p:cNvSpPr txBox="1"/>
+          <p:nvPr/>
+        </p:nvSpPr>
+        <p:spPr>
+          <a:xfrm>
+            <a:off x="7406640" y="4965192"/>
+            <a:ext cx="1536192" cy="201168"/>
+          </a:xfrm>
+          <a:prstGeom prst="rect">
+            <a:avLst/>
+          </a:prstGeom>
+          <a:noFill/>
+        </p:spPr>
+        <p:txBody>
+          <a:bodyPr wrap="square" anchor="t">
+            <a:spAutoFit/>
+          </a:bodyPr>
+          <a:lstStyle/>
+          <a:p>
+            <a:pPr algn="l">
+              <a:lnSpc>
+                <a:spcPct val="100000"/>
+              </a:lnSpc>
+            </a:pPr>
+            <a:r>
+              <a:rPr sz="850" b="0">
+                <a:solidFill>
+                  <a:srgbClr val="F6B544"/>
+                </a:solidFill>
+                <a:latin typeface="Microsoft YaHei"/>
+              </a:rPr>
+              <a:t>产出：候选产物</a:t>
             </a:r>
           </a:p>
         </p:txBody>
       </p:sp>
       <p:cxnSp>
         <p:nvCxnSpPr>
-          <p:cNvPr id="26" name="Connector 25"/>
+          <p:cNvPr id="36" name="Connector 35"/>
           <p:cNvCxnSpPr/>
           <p:nvPr/>
         </p:nvCxnSpPr>
         <p:spPr>
           <a:xfrm>
-            <a:off x="9130284" y="4229100"/>
-            <a:ext cx="155448" cy="0"/>
+            <a:off x="9189719" y="4114800"/>
+            <a:ext cx="146305" cy="0"/>
           </a:xfrm>
           <a:prstGeom prst="line">
             <a:avLst/>
           </a:prstGeom>
           <a:ln w="25400">
             <a:solidFill>
-              <a:srgbClr val="F5B341"/>
+              <a:srgbClr val="F6B544"/>
             </a:solidFill>
             <a:headEnd type="arrow" w="med" len="med"/>
           </a:ln>
@@ -4160,26 +4583,26 @@
       </p:cxnSp>
       <p:sp>
         <p:nvSpPr>
-          <p:cNvPr id="27" name="Rounded Rectangle 26"/>
+          <p:cNvPr id="37" name="Rounded Rectangle 36"/>
           <p:cNvSpPr/>
           <p:nvPr/>
         </p:nvSpPr>
         <p:spPr>
           <a:xfrm>
-            <a:off x="9317736" y="3063240"/>
-            <a:ext cx="1938528" cy="2331720"/>
+            <a:off x="9363456" y="2880360"/>
+            <a:ext cx="1975104" cy="2468880"/>
           </a:xfrm>
           <a:prstGeom prst="roundRect">
             <a:avLst>
-              <a:gd name="adj" fmla="val 10000"/>
+              <a:gd name="adj" fmla="val 9000"/>
             </a:avLst>
           </a:prstGeom>
           <a:solidFill>
-            <a:srgbClr val="182A44"/>
+            <a:srgbClr val="182B46"/>
           </a:solidFill>
           <a:ln w="9525">
             <a:solidFill>
-              <a:srgbClr val="2C3E5E"/>
+              <a:srgbClr val="2E4262"/>
             </a:solidFill>
           </a:ln>
           <a:effectLst/>
@@ -4208,14 +4631,14 @@
       </p:sp>
       <p:sp>
         <p:nvSpPr>
-          <p:cNvPr id="28" name="Rounded Rectangle 27"/>
+          <p:cNvPr id="38" name="Rounded Rectangle 37"/>
           <p:cNvSpPr/>
           <p:nvPr/>
         </p:nvSpPr>
         <p:spPr>
           <a:xfrm>
-            <a:off x="9482328" y="3227832"/>
-            <a:ext cx="475488" cy="475488"/>
+            <a:off x="9528048" y="3044952"/>
+            <a:ext cx="493776" cy="493776"/>
           </a:xfrm>
           <a:prstGeom prst="roundRect">
             <a:avLst>
@@ -4223,7 +4646,7 @@
             </a:avLst>
           </a:prstGeom>
           <a:solidFill>
-            <a:srgbClr val="F5B341"/>
+            <a:srgbClr val="F6B544"/>
           </a:solidFill>
           <a:ln>
             <a:noFill/>
@@ -4252,7 +4675,7 @@
             <a:r>
               <a:rPr sz="1300" b="1">
                 <a:solidFill>
-                  <a:srgbClr val="101B2D"/>
+                  <a:srgbClr val="0F1A2B"/>
                 </a:solidFill>
               </a:rPr>
               <a:t>05</a:t>
@@ -4262,14 +4685,14 @@
       </p:sp>
       <p:sp>
         <p:nvSpPr>
-          <p:cNvPr id="29" name="TextBox 28"/>
+          <p:cNvPr id="39" name="TextBox 38"/>
           <p:cNvSpPr txBox="1"/>
           <p:nvPr/>
         </p:nvSpPr>
         <p:spPr>
           <a:xfrm>
-            <a:off x="9464040" y="3886200"/>
-            <a:ext cx="1645920" cy="411480"/>
+            <a:off x="9509760" y="3721608"/>
+            <a:ext cx="1682496" cy="384048"/>
           </a:xfrm>
           <a:prstGeom prst="rect">
             <a:avLst/>
@@ -4288,7 +4711,7 @@
               </a:lnSpc>
             </a:pPr>
             <a:r>
-              <a:rPr sz="1500" b="1">
+              <a:rPr sz="1450" b="1">
                 <a:solidFill>
                   <a:srgbClr val="FFFFFF"/>
                 </a:solidFill>
@@ -4301,14 +4724,14 @@
       </p:sp>
       <p:sp>
         <p:nvSpPr>
-          <p:cNvPr id="30" name="TextBox 29"/>
+          <p:cNvPr id="40" name="TextBox 39"/>
           <p:cNvSpPr txBox="1"/>
           <p:nvPr/>
         </p:nvSpPr>
         <p:spPr>
           <a:xfrm>
-            <a:off x="9464040" y="4389120"/>
-            <a:ext cx="1645920" cy="868680"/>
+            <a:off x="9509760" y="4160520"/>
+            <a:ext cx="1682496" cy="685800"/>
           </a:xfrm>
           <a:prstGeom prst="rect">
             <a:avLst/>
@@ -4323,31 +4746,31 @@
           <a:p>
             <a:pPr algn="l">
               <a:lnSpc>
-                <a:spcPct val="105000"/>
+                <a:spcPct val="104000"/>
               </a:lnSpc>
             </a:pPr>
             <a:r>
-              <a:rPr sz="1150" b="0">
-                <a:solidFill>
-                  <a:srgbClr val="B8C4D6"/>
+              <a:rPr sz="1050" b="0">
+                <a:solidFill>
+                  <a:srgbClr val="A8B8CE"/>
                 </a:solidFill>
                 <a:latin typeface="Microsoft YaHei"/>
               </a:rPr>
-              <a:t>结构、渲染、视觉与评估器</a:t>
-            </a:r>
-          </a:p>
-        </p:txBody>
-      </p:sp>
-      <p:sp>
-        <p:nvSpPr>
-          <p:cNvPr id="31" name="Rounded Rectangle 30"/>
+              <a:t>结构、渲染、视觉与官方评估器</a:t>
+            </a:r>
+          </a:p>
+        </p:txBody>
+      </p:sp>
+      <p:sp>
+        <p:nvSpPr>
+          <p:cNvPr id="41" name="Rounded Rectangle 40"/>
           <p:cNvSpPr/>
           <p:nvPr/>
         </p:nvSpPr>
         <p:spPr>
           <a:xfrm>
-            <a:off x="685800" y="5806440"/>
-            <a:ext cx="10817352" cy="566928"/>
+            <a:off x="9509760" y="4910328"/>
+            <a:ext cx="1682496" cy="310896"/>
           </a:xfrm>
           <a:prstGeom prst="roundRect">
             <a:avLst>
@@ -4355,12 +4778,10 @@
             </a:avLst>
           </a:prstGeom>
           <a:solidFill>
-            <a:srgbClr val="182A44"/>
+            <a:srgbClr val="213555"/>
           </a:solidFill>
-          <a:ln w="9525">
-            <a:solidFill>
-              <a:srgbClr val="2C3E5E"/>
-            </a:solidFill>
+          <a:ln>
+            <a:noFill/>
           </a:ln>
           <a:effectLst/>
         </p:spPr>
@@ -4388,14 +4809,101 @@
       </p:sp>
       <p:sp>
         <p:nvSpPr>
-          <p:cNvPr id="32" name="TextBox 31"/>
+          <p:cNvPr id="42" name="TextBox 41"/>
           <p:cNvSpPr txBox="1"/>
           <p:nvPr/>
         </p:nvSpPr>
         <p:spPr>
           <a:xfrm>
-            <a:off x="868680" y="5916168"/>
-            <a:ext cx="10424160" cy="365760"/>
+            <a:off x="9582912" y="4965192"/>
+            <a:ext cx="1536192" cy="201168"/>
+          </a:xfrm>
+          <a:prstGeom prst="rect">
+            <a:avLst/>
+          </a:prstGeom>
+          <a:noFill/>
+        </p:spPr>
+        <p:txBody>
+          <a:bodyPr wrap="square" anchor="t">
+            <a:spAutoFit/>
+          </a:bodyPr>
+          <a:lstStyle/>
+          <a:p>
+            <a:pPr algn="l">
+              <a:lnSpc>
+                <a:spcPct val="100000"/>
+              </a:lnSpc>
+            </a:pPr>
+            <a:r>
+              <a:rPr sz="850" b="0">
+                <a:solidFill>
+                  <a:srgbClr val="F6B544"/>
+                </a:solidFill>
+                <a:latin typeface="Microsoft YaHei"/>
+              </a:rPr>
+              <a:t>产出：验证证据</a:t>
+            </a:r>
+          </a:p>
+        </p:txBody>
+      </p:sp>
+      <p:sp>
+        <p:nvSpPr>
+          <p:cNvPr id="43" name="Rounded Rectangle 42"/>
+          <p:cNvSpPr/>
+          <p:nvPr/>
+        </p:nvSpPr>
+        <p:spPr>
+          <a:xfrm>
+            <a:off x="658368" y="5742432"/>
+            <a:ext cx="10881360" cy="512064"/>
+          </a:xfrm>
+          <a:prstGeom prst="roundRect">
+            <a:avLst>
+              <a:gd name="adj" fmla="val 50000"/>
+            </a:avLst>
+          </a:prstGeom>
+          <a:solidFill>
+            <a:srgbClr val="182B46"/>
+          </a:solidFill>
+          <a:ln w="9525">
+            <a:solidFill>
+              <a:srgbClr val="2E4262"/>
+            </a:solidFill>
+          </a:ln>
+          <a:effectLst/>
+        </p:spPr>
+        <p:style>
+          <a:lnRef idx="1">
+            <a:schemeClr val="accent1"/>
+          </a:lnRef>
+          <a:fillRef idx="3">
+            <a:schemeClr val="accent1"/>
+          </a:fillRef>
+          <a:effectRef idx="2">
+            <a:schemeClr val="accent1"/>
+          </a:effectRef>
+          <a:fontRef idx="minor">
+            <a:schemeClr val="lt1"/>
+          </a:fontRef>
+        </p:style>
+        <p:txBody>
+          <a:bodyPr rtlCol="0" anchor="ctr"/>
+          <a:lstStyle/>
+          <a:p>
+            <a:pPr algn="ctr"/>
+          </a:p>
+        </p:txBody>
+      </p:sp>
+      <p:sp>
+        <p:nvSpPr>
+          <p:cNvPr id="44" name="TextBox 43"/>
+          <p:cNvSpPr txBox="1"/>
+          <p:nvPr/>
+        </p:nvSpPr>
+        <p:spPr>
+          <a:xfrm>
+            <a:off x="841248" y="5852160"/>
+            <a:ext cx="10515600" cy="310896"/>
           </a:xfrm>
           <a:prstGeom prst="rect">
             <a:avLst/>
@@ -4414,9 +4922,9 @@
               </a:lnSpc>
             </a:pPr>
             <a:r>
-              <a:rPr sz="1300" b="1">
-                <a:solidFill>
-                  <a:srgbClr val="F5B341"/>
+              <a:rPr sz="1250" b="1">
+                <a:solidFill>
+                  <a:srgbClr val="F6B544"/>
                 </a:solidFill>
                 <a:latin typeface="Microsoft YaHei"/>
               </a:rPr>
@@ -4458,7 +4966,7 @@
             <a:avLst/>
           </a:prstGeom>
           <a:solidFill>
-            <a:srgbClr val="F4F6F9"/>
+            <a:srgbClr val="F3F5F8"/>
           </a:solidFill>
           <a:ln>
             <a:noFill/>
@@ -4506,7 +5014,7 @@
           </a:solidFill>
           <a:ln w="9525">
             <a:solidFill>
-              <a:srgbClr val="E3E8EE"/>
+              <a:srgbClr val="DFE5EC"/>
             </a:solidFill>
           </a:ln>
           <a:effectLst/>
@@ -4587,8 +5095,8 @@
         </p:nvSpPr>
         <p:spPr>
           <a:xfrm>
-            <a:off x="1005840" y="146304"/>
-            <a:ext cx="2743200" cy="411480"/>
+            <a:off x="987552" y="146304"/>
+            <a:ext cx="2926080" cy="411480"/>
           </a:xfrm>
           <a:prstGeom prst="rect">
             <a:avLst/>
@@ -4626,8 +5134,8 @@
         </p:nvSpPr>
         <p:spPr>
           <a:xfrm>
-            <a:off x="4160520" y="219456"/>
-            <a:ext cx="2011680" cy="320040"/>
+            <a:off x="4297680" y="228600"/>
+            <a:ext cx="1828800" cy="292608"/>
           </a:xfrm>
           <a:prstGeom prst="rect">
             <a:avLst/>
@@ -4646,7 +5154,7 @@
               </a:lnSpc>
             </a:pPr>
             <a:r>
-              <a:rPr sz="1100" b="1">
+              <a:rPr sz="1050" b="1">
                 <a:solidFill>
                   <a:srgbClr val="10B981"/>
                 </a:solidFill>
@@ -4750,8 +5258,8 @@
         </p:nvSpPr>
         <p:spPr>
           <a:xfrm>
-            <a:off x="685800" y="932688"/>
-            <a:ext cx="10789920" cy="502920"/>
+            <a:off x="685800" y="896112"/>
+            <a:ext cx="10789920" cy="475488"/>
           </a:xfrm>
           <a:prstGeom prst="rect">
             <a:avLst/>
@@ -4770,7 +5278,7 @@
               </a:lnSpc>
             </a:pPr>
             <a:r>
-              <a:rPr sz="2600" b="1">
+              <a:rPr sz="2500" b="1">
                 <a:solidFill>
                   <a:srgbClr val="222A35"/>
                 </a:solidFill>
@@ -4789,8 +5297,8 @@
         </p:nvSpPr>
         <p:spPr>
           <a:xfrm>
-            <a:off x="685800" y="1463040"/>
-            <a:ext cx="10789920" cy="365760"/>
+            <a:off x="685800" y="1353312"/>
+            <a:ext cx="10789920" cy="347472"/>
           </a:xfrm>
           <a:prstGeom prst="rect">
             <a:avLst/>
@@ -4809,13 +5317,13 @@
               </a:lnSpc>
             </a:pPr>
             <a:r>
-              <a:rPr sz="1300" b="0">
-                <a:solidFill>
-                  <a:srgbClr val="6B7480"/>
+              <a:rPr sz="1250" b="0">
+                <a:solidFill>
+                  <a:srgbClr val="66707D"/>
                 </a:solidFill>
                 <a:latin typeface="Microsoft YaHei"/>
               </a:rPr>
-              <a:t>将复杂任务拆解为可验证的阶段，实时跟踪每一步的状态与证据</a:t>
+              <a:t>复杂任务被拆解为可验证阶段，状态、指标与证据实时可见</a:t>
             </a:r>
           </a:p>
         </p:txBody>
@@ -4828,12 +5336,12 @@
         </p:nvSpPr>
         <p:spPr>
           <a:xfrm>
-            <a:off x="685800" y="2057400"/>
-            <a:ext cx="5212080" cy="2084831"/>
+            <a:off x="685800" y="1810512"/>
+            <a:ext cx="2615184" cy="804672"/>
           </a:xfrm>
           <a:prstGeom prst="roundRect">
             <a:avLst>
-              <a:gd name="adj" fmla="val 6000"/>
+              <a:gd name="adj" fmla="val 10000"/>
             </a:avLst>
           </a:prstGeom>
           <a:solidFill>
@@ -4841,7 +5349,7 @@
           </a:solidFill>
           <a:ln w="9525">
             <a:solidFill>
-              <a:srgbClr val="E3E8EE"/>
+              <a:srgbClr val="DFE5EC"/>
             </a:solidFill>
           </a:ln>
           <a:effectLst/>
@@ -4876,8 +5384,8 @@
         </p:nvSpPr>
         <p:spPr>
           <a:xfrm>
-            <a:off x="685800" y="2057400"/>
-            <a:ext cx="82296" cy="2084831"/>
+            <a:off x="685800" y="1810512"/>
+            <a:ext cx="73152" cy="804672"/>
           </a:xfrm>
           <a:prstGeom prst="rect">
             <a:avLst/>
@@ -4914,19 +5422,653 @@
       </p:sp>
       <p:sp>
         <p:nvSpPr>
-          <p:cNvPr id="13" name="Rounded Rectangle 12"/>
+          <p:cNvPr id="13" name="TextBox 12"/>
+          <p:cNvSpPr txBox="1"/>
+          <p:nvPr/>
+        </p:nvSpPr>
+        <p:spPr>
+          <a:xfrm>
+            <a:off x="886968" y="1901952"/>
+            <a:ext cx="2249424" cy="310896"/>
+          </a:xfrm>
+          <a:prstGeom prst="rect">
+            <a:avLst/>
+          </a:prstGeom>
+          <a:noFill/>
+        </p:spPr>
+        <p:txBody>
+          <a:bodyPr wrap="square" anchor="t">
+            <a:spAutoFit/>
+          </a:bodyPr>
+          <a:lstStyle/>
+          <a:p>
+            <a:pPr algn="l">
+              <a:lnSpc>
+                <a:spcPct val="100000"/>
+              </a:lnSpc>
+            </a:pPr>
+            <a:r>
+              <a:rPr sz="1900" b="1">
+                <a:solidFill>
+                  <a:srgbClr val="222A35"/>
+                </a:solidFill>
+                <a:latin typeface="Microsoft YaHei"/>
+              </a:rPr>
+              <a:t>1.2s</a:t>
+            </a:r>
+          </a:p>
+        </p:txBody>
+      </p:sp>
+      <p:sp>
+        <p:nvSpPr>
+          <p:cNvPr id="14" name="TextBox 13"/>
+          <p:cNvSpPr txBox="1"/>
+          <p:nvPr/>
+        </p:nvSpPr>
+        <p:spPr>
+          <a:xfrm>
+            <a:off x="886968" y="2267712"/>
+            <a:ext cx="2249424" cy="237744"/>
+          </a:xfrm>
+          <a:prstGeom prst="rect">
+            <a:avLst/>
+          </a:prstGeom>
+          <a:noFill/>
+        </p:spPr>
+        <p:txBody>
+          <a:bodyPr wrap="square" anchor="t">
+            <a:spAutoFit/>
+          </a:bodyPr>
+          <a:lstStyle/>
+          <a:p>
+            <a:pPr algn="l">
+              <a:lnSpc>
+                <a:spcPct val="100000"/>
+              </a:lnSpc>
+            </a:pPr>
+            <a:r>
+              <a:rPr sz="1000" b="0">
+                <a:solidFill>
+                  <a:srgbClr val="66707D"/>
+                </a:solidFill>
+                <a:latin typeface="Microsoft YaHei"/>
+              </a:rPr>
+              <a:t>平均响应</a:t>
+            </a:r>
+          </a:p>
+        </p:txBody>
+      </p:sp>
+      <p:sp>
+        <p:nvSpPr>
+          <p:cNvPr id="15" name="Rounded Rectangle 14"/>
           <p:cNvSpPr/>
           <p:nvPr/>
         </p:nvSpPr>
         <p:spPr>
           <a:xfrm>
-            <a:off x="960120" y="2258568"/>
-            <a:ext cx="566928" cy="566928"/>
+            <a:off x="3502152" y="1810512"/>
+            <a:ext cx="2615184" cy="804672"/>
           </a:xfrm>
           <a:prstGeom prst="roundRect">
             <a:avLst>
-              <a:gd name="adj" fmla="val 18000"/>
+              <a:gd name="adj" fmla="val 10000"/>
             </a:avLst>
+          </a:prstGeom>
+          <a:solidFill>
+            <a:srgbClr val="FFFFFF"/>
+          </a:solidFill>
+          <a:ln w="9525">
+            <a:solidFill>
+              <a:srgbClr val="DFE5EC"/>
+            </a:solidFill>
+          </a:ln>
+          <a:effectLst/>
+        </p:spPr>
+        <p:style>
+          <a:lnRef idx="1">
+            <a:schemeClr val="accent1"/>
+          </a:lnRef>
+          <a:fillRef idx="3">
+            <a:schemeClr val="accent1"/>
+          </a:fillRef>
+          <a:effectRef idx="2">
+            <a:schemeClr val="accent1"/>
+          </a:effectRef>
+          <a:fontRef idx="minor">
+            <a:schemeClr val="lt1"/>
+          </a:fontRef>
+        </p:style>
+        <p:txBody>
+          <a:bodyPr rtlCol="0" anchor="ctr"/>
+          <a:lstStyle/>
+          <a:p>
+            <a:pPr algn="ctr"/>
+          </a:p>
+        </p:txBody>
+      </p:sp>
+      <p:sp>
+        <p:nvSpPr>
+          <p:cNvPr id="16" name="Rectangle 15"/>
+          <p:cNvSpPr/>
+          <p:nvPr/>
+        </p:nvSpPr>
+        <p:spPr>
+          <a:xfrm>
+            <a:off x="3502152" y="1810512"/>
+            <a:ext cx="73152" cy="804672"/>
+          </a:xfrm>
+          <a:prstGeom prst="rect">
+            <a:avLst/>
+          </a:prstGeom>
+          <a:solidFill>
+            <a:srgbClr val="10B981"/>
+          </a:solidFill>
+          <a:ln>
+            <a:noFill/>
+          </a:ln>
+          <a:effectLst/>
+        </p:spPr>
+        <p:style>
+          <a:lnRef idx="1">
+            <a:schemeClr val="accent1"/>
+          </a:lnRef>
+          <a:fillRef idx="3">
+            <a:schemeClr val="accent1"/>
+          </a:fillRef>
+          <a:effectRef idx="2">
+            <a:schemeClr val="accent1"/>
+          </a:effectRef>
+          <a:fontRef idx="minor">
+            <a:schemeClr val="lt1"/>
+          </a:fontRef>
+        </p:style>
+        <p:txBody>
+          <a:bodyPr rtlCol="0" anchor="ctr"/>
+          <a:lstStyle/>
+          <a:p>
+            <a:pPr algn="ctr"/>
+          </a:p>
+        </p:txBody>
+      </p:sp>
+      <p:sp>
+        <p:nvSpPr>
+          <p:cNvPr id="17" name="TextBox 16"/>
+          <p:cNvSpPr txBox="1"/>
+          <p:nvPr/>
+        </p:nvSpPr>
+        <p:spPr>
+          <a:xfrm>
+            <a:off x="3703320" y="1901952"/>
+            <a:ext cx="2249424" cy="310896"/>
+          </a:xfrm>
+          <a:prstGeom prst="rect">
+            <a:avLst/>
+          </a:prstGeom>
+          <a:noFill/>
+        </p:spPr>
+        <p:txBody>
+          <a:bodyPr wrap="square" anchor="t">
+            <a:spAutoFit/>
+          </a:bodyPr>
+          <a:lstStyle/>
+          <a:p>
+            <a:pPr algn="l">
+              <a:lnSpc>
+                <a:spcPct val="100000"/>
+              </a:lnSpc>
+            </a:pPr>
+            <a:r>
+              <a:rPr sz="1900" b="1">
+                <a:solidFill>
+                  <a:srgbClr val="222A35"/>
+                </a:solidFill>
+                <a:latin typeface="Microsoft YaHei"/>
+              </a:rPr>
+              <a:t>98.2%</a:t>
+            </a:r>
+          </a:p>
+        </p:txBody>
+      </p:sp>
+      <p:sp>
+        <p:nvSpPr>
+          <p:cNvPr id="18" name="TextBox 17"/>
+          <p:cNvSpPr txBox="1"/>
+          <p:nvPr/>
+        </p:nvSpPr>
+        <p:spPr>
+          <a:xfrm>
+            <a:off x="3703320" y="2267712"/>
+            <a:ext cx="2249424" cy="237744"/>
+          </a:xfrm>
+          <a:prstGeom prst="rect">
+            <a:avLst/>
+          </a:prstGeom>
+          <a:noFill/>
+        </p:spPr>
+        <p:txBody>
+          <a:bodyPr wrap="square" anchor="t">
+            <a:spAutoFit/>
+          </a:bodyPr>
+          <a:lstStyle/>
+          <a:p>
+            <a:pPr algn="l">
+              <a:lnSpc>
+                <a:spcPct val="100000"/>
+              </a:lnSpc>
+            </a:pPr>
+            <a:r>
+              <a:rPr sz="1000" b="0">
+                <a:solidFill>
+                  <a:srgbClr val="66707D"/>
+                </a:solidFill>
+                <a:latin typeface="Microsoft YaHei"/>
+              </a:rPr>
+              <a:t>任务完成率</a:t>
+            </a:r>
+          </a:p>
+        </p:txBody>
+      </p:sp>
+      <p:sp>
+        <p:nvSpPr>
+          <p:cNvPr id="19" name="Rounded Rectangle 18"/>
+          <p:cNvSpPr/>
+          <p:nvPr/>
+        </p:nvSpPr>
+        <p:spPr>
+          <a:xfrm>
+            <a:off x="6318504" y="1810512"/>
+            <a:ext cx="2615184" cy="804672"/>
+          </a:xfrm>
+          <a:prstGeom prst="roundRect">
+            <a:avLst>
+              <a:gd name="adj" fmla="val 10000"/>
+            </a:avLst>
+          </a:prstGeom>
+          <a:solidFill>
+            <a:srgbClr val="FFFFFF"/>
+          </a:solidFill>
+          <a:ln w="9525">
+            <a:solidFill>
+              <a:srgbClr val="DFE5EC"/>
+            </a:solidFill>
+          </a:ln>
+          <a:effectLst/>
+        </p:spPr>
+        <p:style>
+          <a:lnRef idx="1">
+            <a:schemeClr val="accent1"/>
+          </a:lnRef>
+          <a:fillRef idx="3">
+            <a:schemeClr val="accent1"/>
+          </a:fillRef>
+          <a:effectRef idx="2">
+            <a:schemeClr val="accent1"/>
+          </a:effectRef>
+          <a:fontRef idx="minor">
+            <a:schemeClr val="lt1"/>
+          </a:fontRef>
+        </p:style>
+        <p:txBody>
+          <a:bodyPr rtlCol="0" anchor="ctr"/>
+          <a:lstStyle/>
+          <a:p>
+            <a:pPr algn="ctr"/>
+          </a:p>
+        </p:txBody>
+      </p:sp>
+      <p:sp>
+        <p:nvSpPr>
+          <p:cNvPr id="20" name="Rectangle 19"/>
+          <p:cNvSpPr/>
+          <p:nvPr/>
+        </p:nvSpPr>
+        <p:spPr>
+          <a:xfrm>
+            <a:off x="6318504" y="1810512"/>
+            <a:ext cx="73152" cy="804672"/>
+          </a:xfrm>
+          <a:prstGeom prst="rect">
+            <a:avLst/>
+          </a:prstGeom>
+          <a:solidFill>
+            <a:srgbClr val="F97A2E"/>
+          </a:solidFill>
+          <a:ln>
+            <a:noFill/>
+          </a:ln>
+          <a:effectLst/>
+        </p:spPr>
+        <p:style>
+          <a:lnRef idx="1">
+            <a:schemeClr val="accent1"/>
+          </a:lnRef>
+          <a:fillRef idx="3">
+            <a:schemeClr val="accent1"/>
+          </a:fillRef>
+          <a:effectRef idx="2">
+            <a:schemeClr val="accent1"/>
+          </a:effectRef>
+          <a:fontRef idx="minor">
+            <a:schemeClr val="lt1"/>
+          </a:fontRef>
+        </p:style>
+        <p:txBody>
+          <a:bodyPr rtlCol="0" anchor="ctr"/>
+          <a:lstStyle/>
+          <a:p>
+            <a:pPr algn="ctr"/>
+          </a:p>
+        </p:txBody>
+      </p:sp>
+      <p:sp>
+        <p:nvSpPr>
+          <p:cNvPr id="21" name="TextBox 20"/>
+          <p:cNvSpPr txBox="1"/>
+          <p:nvPr/>
+        </p:nvSpPr>
+        <p:spPr>
+          <a:xfrm>
+            <a:off x="6519672" y="1901952"/>
+            <a:ext cx="2249424" cy="310896"/>
+          </a:xfrm>
+          <a:prstGeom prst="rect">
+            <a:avLst/>
+          </a:prstGeom>
+          <a:noFill/>
+        </p:spPr>
+        <p:txBody>
+          <a:bodyPr wrap="square" anchor="t">
+            <a:spAutoFit/>
+          </a:bodyPr>
+          <a:lstStyle/>
+          <a:p>
+            <a:pPr algn="l">
+              <a:lnSpc>
+                <a:spcPct val="100000"/>
+              </a:lnSpc>
+            </a:pPr>
+            <a:r>
+              <a:rPr sz="1900" b="1">
+                <a:solidFill>
+                  <a:srgbClr val="222A35"/>
+                </a:solidFill>
+                <a:latin typeface="Microsoft YaHei"/>
+              </a:rPr>
+              <a:t>99.7%</a:t>
+            </a:r>
+          </a:p>
+        </p:txBody>
+      </p:sp>
+      <p:sp>
+        <p:nvSpPr>
+          <p:cNvPr id="22" name="TextBox 21"/>
+          <p:cNvSpPr txBox="1"/>
+          <p:nvPr/>
+        </p:nvSpPr>
+        <p:spPr>
+          <a:xfrm>
+            <a:off x="6519672" y="2267712"/>
+            <a:ext cx="2249424" cy="237744"/>
+          </a:xfrm>
+          <a:prstGeom prst="rect">
+            <a:avLst/>
+          </a:prstGeom>
+          <a:noFill/>
+        </p:spPr>
+        <p:txBody>
+          <a:bodyPr wrap="square" anchor="t">
+            <a:spAutoFit/>
+          </a:bodyPr>
+          <a:lstStyle/>
+          <a:p>
+            <a:pPr algn="l">
+              <a:lnSpc>
+                <a:spcPct val="100000"/>
+              </a:lnSpc>
+            </a:pPr>
+            <a:r>
+              <a:rPr sz="1000" b="0">
+                <a:solidFill>
+                  <a:srgbClr val="66707D"/>
+                </a:solidFill>
+                <a:latin typeface="Microsoft YaHei"/>
+              </a:rPr>
+              <a:t>工具调用成功率</a:t>
+            </a:r>
+          </a:p>
+        </p:txBody>
+      </p:sp>
+      <p:sp>
+        <p:nvSpPr>
+          <p:cNvPr id="23" name="Rounded Rectangle 22"/>
+          <p:cNvSpPr/>
+          <p:nvPr/>
+        </p:nvSpPr>
+        <p:spPr>
+          <a:xfrm>
+            <a:off x="9134856" y="1810512"/>
+            <a:ext cx="2615184" cy="804672"/>
+          </a:xfrm>
+          <a:prstGeom prst="roundRect">
+            <a:avLst>
+              <a:gd name="adj" fmla="val 10000"/>
+            </a:avLst>
+          </a:prstGeom>
+          <a:solidFill>
+            <a:srgbClr val="FFFFFF"/>
+          </a:solidFill>
+          <a:ln w="9525">
+            <a:solidFill>
+              <a:srgbClr val="DFE5EC"/>
+            </a:solidFill>
+          </a:ln>
+          <a:effectLst/>
+        </p:spPr>
+        <p:style>
+          <a:lnRef idx="1">
+            <a:schemeClr val="accent1"/>
+          </a:lnRef>
+          <a:fillRef idx="3">
+            <a:schemeClr val="accent1"/>
+          </a:fillRef>
+          <a:effectRef idx="2">
+            <a:schemeClr val="accent1"/>
+          </a:effectRef>
+          <a:fontRef idx="minor">
+            <a:schemeClr val="lt1"/>
+          </a:fontRef>
+        </p:style>
+        <p:txBody>
+          <a:bodyPr rtlCol="0" anchor="ctr"/>
+          <a:lstStyle/>
+          <a:p>
+            <a:pPr algn="ctr"/>
+          </a:p>
+        </p:txBody>
+      </p:sp>
+      <p:sp>
+        <p:nvSpPr>
+          <p:cNvPr id="24" name="Rectangle 23"/>
+          <p:cNvSpPr/>
+          <p:nvPr/>
+        </p:nvSpPr>
+        <p:spPr>
+          <a:xfrm>
+            <a:off x="9134856" y="1810512"/>
+            <a:ext cx="73152" cy="804672"/>
+          </a:xfrm>
+          <a:prstGeom prst="rect">
+            <a:avLst/>
+          </a:prstGeom>
+          <a:solidFill>
+            <a:srgbClr val="8B5CF6"/>
+          </a:solidFill>
+          <a:ln>
+            <a:noFill/>
+          </a:ln>
+          <a:effectLst/>
+        </p:spPr>
+        <p:style>
+          <a:lnRef idx="1">
+            <a:schemeClr val="accent1"/>
+          </a:lnRef>
+          <a:fillRef idx="3">
+            <a:schemeClr val="accent1"/>
+          </a:fillRef>
+          <a:effectRef idx="2">
+            <a:schemeClr val="accent1"/>
+          </a:effectRef>
+          <a:fontRef idx="minor">
+            <a:schemeClr val="lt1"/>
+          </a:fontRef>
+        </p:style>
+        <p:txBody>
+          <a:bodyPr rtlCol="0" anchor="ctr"/>
+          <a:lstStyle/>
+          <a:p>
+            <a:pPr algn="ctr"/>
+          </a:p>
+        </p:txBody>
+      </p:sp>
+      <p:sp>
+        <p:nvSpPr>
+          <p:cNvPr id="25" name="TextBox 24"/>
+          <p:cNvSpPr txBox="1"/>
+          <p:nvPr/>
+        </p:nvSpPr>
+        <p:spPr>
+          <a:xfrm>
+            <a:off x="9336024" y="1901952"/>
+            <a:ext cx="2249424" cy="310896"/>
+          </a:xfrm>
+          <a:prstGeom prst="rect">
+            <a:avLst/>
+          </a:prstGeom>
+          <a:noFill/>
+        </p:spPr>
+        <p:txBody>
+          <a:bodyPr wrap="square" anchor="t">
+            <a:spAutoFit/>
+          </a:bodyPr>
+          <a:lstStyle/>
+          <a:p>
+            <a:pPr algn="l">
+              <a:lnSpc>
+                <a:spcPct val="100000"/>
+              </a:lnSpc>
+            </a:pPr>
+            <a:r>
+              <a:rPr sz="1900" b="1">
+                <a:solidFill>
+                  <a:srgbClr val="222A35"/>
+                </a:solidFill>
+                <a:latin typeface="Microsoft YaHei"/>
+              </a:rPr>
+              <a:t>100%</a:t>
+            </a:r>
+          </a:p>
+        </p:txBody>
+      </p:sp>
+      <p:sp>
+        <p:nvSpPr>
+          <p:cNvPr id="26" name="TextBox 25"/>
+          <p:cNvSpPr txBox="1"/>
+          <p:nvPr/>
+        </p:nvSpPr>
+        <p:spPr>
+          <a:xfrm>
+            <a:off x="9336024" y="2267712"/>
+            <a:ext cx="2249424" cy="237744"/>
+          </a:xfrm>
+          <a:prstGeom prst="rect">
+            <a:avLst/>
+          </a:prstGeom>
+          <a:noFill/>
+        </p:spPr>
+        <p:txBody>
+          <a:bodyPr wrap="square" anchor="t">
+            <a:spAutoFit/>
+          </a:bodyPr>
+          <a:lstStyle/>
+          <a:p>
+            <a:pPr algn="l">
+              <a:lnSpc>
+                <a:spcPct val="100000"/>
+              </a:lnSpc>
+            </a:pPr>
+            <a:r>
+              <a:rPr sz="1000" b="0">
+                <a:solidFill>
+                  <a:srgbClr val="66707D"/>
+                </a:solidFill>
+                <a:latin typeface="Microsoft YaHei"/>
+              </a:rPr>
+              <a:t>证据覆盖率</a:t>
+            </a:r>
+          </a:p>
+        </p:txBody>
+      </p:sp>
+      <p:sp>
+        <p:nvSpPr>
+          <p:cNvPr id="27" name="Rounded Rectangle 26"/>
+          <p:cNvSpPr/>
+          <p:nvPr/>
+        </p:nvSpPr>
+        <p:spPr>
+          <a:xfrm>
+            <a:off x="685800" y="2761488"/>
+            <a:ext cx="5212080" cy="2267712"/>
+          </a:xfrm>
+          <a:prstGeom prst="roundRect">
+            <a:avLst>
+              <a:gd name="adj" fmla="val 6000"/>
+            </a:avLst>
+          </a:prstGeom>
+          <a:solidFill>
+            <a:srgbClr val="FFFFFF"/>
+          </a:solidFill>
+          <a:ln w="9525">
+            <a:solidFill>
+              <a:srgbClr val="DFE5EC"/>
+            </a:solidFill>
+          </a:ln>
+          <a:effectLst/>
+        </p:spPr>
+        <p:style>
+          <a:lnRef idx="1">
+            <a:schemeClr val="accent1"/>
+          </a:lnRef>
+          <a:fillRef idx="3">
+            <a:schemeClr val="accent1"/>
+          </a:fillRef>
+          <a:effectRef idx="2">
+            <a:schemeClr val="accent1"/>
+          </a:effectRef>
+          <a:fontRef idx="minor">
+            <a:schemeClr val="lt1"/>
+          </a:fontRef>
+        </p:style>
+        <p:txBody>
+          <a:bodyPr rtlCol="0" anchor="ctr"/>
+          <a:lstStyle/>
+          <a:p>
+            <a:pPr algn="ctr"/>
+          </a:p>
+        </p:txBody>
+      </p:sp>
+      <p:sp>
+        <p:nvSpPr>
+          <p:cNvPr id="28" name="Rectangle 27"/>
+          <p:cNvSpPr/>
+          <p:nvPr/>
+        </p:nvSpPr>
+        <p:spPr>
+          <a:xfrm>
+            <a:off x="685800" y="2761488"/>
+            <a:ext cx="82296" cy="2267712"/>
+          </a:xfrm>
+          <a:prstGeom prst="rect">
+            <a:avLst/>
           </a:prstGeom>
           <a:solidFill>
             <a:srgbClr val="3B82F6"/>
@@ -4960,13 +6102,59 @@
       </p:sp>
       <p:sp>
         <p:nvSpPr>
-          <p:cNvPr id="14" name="TextBox 13"/>
+          <p:cNvPr id="29" name="Rounded Rectangle 28"/>
+          <p:cNvSpPr/>
+          <p:nvPr/>
+        </p:nvSpPr>
+        <p:spPr>
+          <a:xfrm>
+            <a:off x="960120" y="2962656"/>
+            <a:ext cx="566928" cy="566928"/>
+          </a:xfrm>
+          <a:prstGeom prst="roundRect">
+            <a:avLst>
+              <a:gd name="adj" fmla="val 18000"/>
+            </a:avLst>
+          </a:prstGeom>
+          <a:solidFill>
+            <a:srgbClr val="3B82F6"/>
+          </a:solidFill>
+          <a:ln>
+            <a:noFill/>
+          </a:ln>
+          <a:effectLst/>
+        </p:spPr>
+        <p:style>
+          <a:lnRef idx="1">
+            <a:schemeClr val="accent1"/>
+          </a:lnRef>
+          <a:fillRef idx="3">
+            <a:schemeClr val="accent1"/>
+          </a:fillRef>
+          <a:effectRef idx="2">
+            <a:schemeClr val="accent1"/>
+          </a:effectRef>
+          <a:fontRef idx="minor">
+            <a:schemeClr val="lt1"/>
+          </a:fontRef>
+        </p:style>
+        <p:txBody>
+          <a:bodyPr rtlCol="0" anchor="ctr"/>
+          <a:lstStyle/>
+          <a:p>
+            <a:pPr algn="ctr"/>
+          </a:p>
+        </p:txBody>
+      </p:sp>
+      <p:sp>
+        <p:nvSpPr>
+          <p:cNvPr id="30" name="TextBox 29"/>
           <p:cNvSpPr txBox="1"/>
           <p:nvPr/>
         </p:nvSpPr>
         <p:spPr>
           <a:xfrm>
-            <a:off x="960120" y="2331720"/>
+            <a:off x="960120" y="3035808"/>
             <a:ext cx="566928" cy="411480"/>
           </a:xfrm>
           <a:prstGeom prst="rect">
@@ -4999,14 +6187,14 @@
       </p:sp>
       <p:sp>
         <p:nvSpPr>
-          <p:cNvPr id="15" name="TextBox 14"/>
+          <p:cNvPr id="31" name="TextBox 30"/>
           <p:cNvSpPr txBox="1"/>
           <p:nvPr/>
         </p:nvSpPr>
         <p:spPr>
           <a:xfrm>
-            <a:off x="1691640" y="2240280"/>
-            <a:ext cx="2926080" cy="365760"/>
+            <a:off x="1673352" y="2944368"/>
+            <a:ext cx="2377440" cy="365760"/>
           </a:xfrm>
           <a:prstGeom prst="rect">
             <a:avLst/>
@@ -5025,7 +6213,7 @@
               </a:lnSpc>
             </a:pPr>
             <a:r>
-              <a:rPr sz="1700" b="1">
+              <a:rPr sz="1600" b="1">
                 <a:solidFill>
                   <a:srgbClr val="222A35"/>
                 </a:solidFill>
@@ -5038,14 +6226,14 @@
       </p:sp>
       <p:sp>
         <p:nvSpPr>
-          <p:cNvPr id="16" name="Rounded Rectangle 15"/>
+          <p:cNvPr id="32" name="Rounded Rectangle 31"/>
           <p:cNvSpPr/>
           <p:nvPr/>
         </p:nvSpPr>
         <p:spPr>
           <a:xfrm>
-            <a:off x="4754880" y="2313432"/>
-            <a:ext cx="868680" cy="274320"/>
+            <a:off x="4526280" y="3017520"/>
+            <a:ext cx="1097280" cy="274320"/>
           </a:xfrm>
           <a:prstGeom prst="roundRect">
             <a:avLst>
@@ -5053,7 +6241,7 @@
             </a:avLst>
           </a:prstGeom>
           <a:solidFill>
-            <a:srgbClr val="F4F6F9"/>
+            <a:srgbClr val="F3F5F8"/>
           </a:solidFill>
           <a:ln>
             <a:noFill/>
@@ -5084,14 +6272,14 @@
       </p:sp>
       <p:sp>
         <p:nvSpPr>
-          <p:cNvPr id="17" name="TextBox 16"/>
+          <p:cNvPr id="33" name="TextBox 32"/>
           <p:cNvSpPr txBox="1"/>
           <p:nvPr/>
         </p:nvSpPr>
         <p:spPr>
           <a:xfrm>
-            <a:off x="4754880" y="2350008"/>
-            <a:ext cx="868680" cy="201168"/>
+            <a:off x="4526280" y="3054096"/>
+            <a:ext cx="1097280" cy="201168"/>
           </a:xfrm>
           <a:prstGeom prst="rect">
             <a:avLst/>
@@ -5110,7 +6298,7 @@
               </a:lnSpc>
             </a:pPr>
             <a:r>
-              <a:rPr sz="900" b="1">
+              <a:rPr sz="850" b="1">
                 <a:solidFill>
                   <a:srgbClr val="3B82F6"/>
                 </a:solidFill>
@@ -5123,14 +6311,14 @@
       </p:sp>
       <p:sp>
         <p:nvSpPr>
-          <p:cNvPr id="18" name="TextBox 17"/>
+          <p:cNvPr id="34" name="TextBox 33"/>
           <p:cNvSpPr txBox="1"/>
           <p:nvPr/>
         </p:nvSpPr>
         <p:spPr>
           <a:xfrm>
-            <a:off x="978408" y="2916936"/>
-            <a:ext cx="4626864" cy="566928"/>
+            <a:off x="978408" y="3639312"/>
+            <a:ext cx="4626864" cy="530352"/>
           </a:xfrm>
           <a:prstGeom prst="rect">
             <a:avLst/>
@@ -5145,31 +6333,31 @@
           <a:p>
             <a:pPr algn="l">
               <a:lnSpc>
-                <a:spcPct val="105000"/>
+                <a:spcPct val="104000"/>
               </a:lnSpc>
             </a:pPr>
             <a:r>
-              <a:rPr sz="1150" b="0">
-                <a:solidFill>
-                  <a:srgbClr val="6B7480"/>
+              <a:rPr sz="1100" b="0">
+                <a:solidFill>
+                  <a:srgbClr val="66707D"/>
                 </a:solidFill>
                 <a:latin typeface="Microsoft YaHei"/>
               </a:rPr>
-              <a:t>接收用户指令、附件与工作区上下文，完成意图澄清与队列排序。</a:t>
-            </a:r>
-          </a:p>
-        </p:txBody>
-      </p:sp>
-      <p:sp>
-        <p:nvSpPr>
-          <p:cNvPr id="19" name="TextBox 18"/>
+              <a:t>接收指令、附件与工作区上下文，完成意图澄清与队列排序。</a:t>
+            </a:r>
+          </a:p>
+        </p:txBody>
+      </p:sp>
+      <p:sp>
+        <p:nvSpPr>
+          <p:cNvPr id="35" name="TextBox 34"/>
           <p:cNvSpPr txBox="1"/>
           <p:nvPr/>
         </p:nvSpPr>
         <p:spPr>
           <a:xfrm>
-            <a:off x="978408" y="3447288"/>
-            <a:ext cx="4626864" cy="603504"/>
+            <a:off x="978408" y="4187952"/>
+            <a:ext cx="4023360" cy="640080"/>
           </a:xfrm>
           <a:prstGeom prst="rect">
             <a:avLst/>
@@ -5188,13 +6376,13 @@
               </a:lnSpc>
             </a:pPr>
             <a:r>
-              <a:rPr sz="1050" b="0">
+              <a:rPr sz="1000" b="0">
                 <a:solidFill>
                   <a:srgbClr val="222A35"/>
                 </a:solidFill>
                 <a:latin typeface="Microsoft YaHei"/>
               </a:rPr>
-              <a:t>•  支持自然语言与多模态输入</a:t>
+              <a:t>•  自然语言与多模态输入</a:t>
             </a:r>
           </a:p>
           <a:p>
@@ -5204,7 +6392,7 @@
               </a:lnSpc>
             </a:pPr>
             <a:r>
-              <a:rPr sz="1050" b="0">
+              <a:rPr sz="1000" b="0">
                 <a:solidFill>
                   <a:srgbClr val="222A35"/>
                 </a:solidFill>
@@ -5220,7 +6408,7 @@
               </a:lnSpc>
             </a:pPr>
             <a:r>
-              <a:rPr sz="1050" b="0">
+              <a:rPr sz="1000" b="0">
                 <a:solidFill>
                   <a:srgbClr val="222A35"/>
                 </a:solidFill>
@@ -5233,14 +6421,179 @@
       </p:sp>
       <p:sp>
         <p:nvSpPr>
-          <p:cNvPr id="20" name="Rounded Rectangle 19"/>
+          <p:cNvPr id="36" name="Rounded Rectangle 35"/>
           <p:cNvSpPr/>
           <p:nvPr/>
         </p:nvSpPr>
         <p:spPr>
           <a:xfrm>
-            <a:off x="6309360" y="2057400"/>
-            <a:ext cx="5212080" cy="2084831"/>
+            <a:off x="4892040" y="4187952"/>
+            <a:ext cx="713232" cy="640080"/>
+          </a:xfrm>
+          <a:prstGeom prst="roundRect">
+            <a:avLst>
+              <a:gd name="adj" fmla="val 10000"/>
+            </a:avLst>
+          </a:prstGeom>
+          <a:solidFill>
+            <a:srgbClr val="F3F5F8"/>
+          </a:solidFill>
+          <a:ln w="9525">
+            <a:solidFill>
+              <a:srgbClr val="DFE5EC"/>
+            </a:solidFill>
+          </a:ln>
+          <a:effectLst/>
+        </p:spPr>
+        <p:style>
+          <a:lnRef idx="1">
+            <a:schemeClr val="accent1"/>
+          </a:lnRef>
+          <a:fillRef idx="3">
+            <a:schemeClr val="accent1"/>
+          </a:fillRef>
+          <a:effectRef idx="2">
+            <a:schemeClr val="accent1"/>
+          </a:effectRef>
+          <a:fontRef idx="minor">
+            <a:schemeClr val="lt1"/>
+          </a:fontRef>
+        </p:style>
+        <p:txBody>
+          <a:bodyPr rtlCol="0" anchor="ctr"/>
+          <a:lstStyle/>
+          <a:p>
+            <a:pPr algn="ctr"/>
+          </a:p>
+        </p:txBody>
+      </p:sp>
+      <p:sp>
+        <p:nvSpPr>
+          <p:cNvPr id="37" name="TextBox 36"/>
+          <p:cNvSpPr txBox="1"/>
+          <p:nvPr/>
+        </p:nvSpPr>
+        <p:spPr>
+          <a:xfrm>
+            <a:off x="4892040" y="4261104"/>
+            <a:ext cx="713232" cy="256032"/>
+          </a:xfrm>
+          <a:prstGeom prst="rect">
+            <a:avLst/>
+          </a:prstGeom>
+          <a:noFill/>
+        </p:spPr>
+        <p:txBody>
+          <a:bodyPr wrap="square" anchor="t">
+            <a:spAutoFit/>
+          </a:bodyPr>
+          <a:lstStyle/>
+          <a:p>
+            <a:pPr algn="ctr">
+              <a:lnSpc>
+                <a:spcPct val="100000"/>
+              </a:lnSpc>
+            </a:pPr>
+            <a:r>
+              <a:rPr sz="1400" b="1">
+                <a:solidFill>
+                  <a:srgbClr val="3B82F6"/>
+                </a:solidFill>
+                <a:latin typeface="Microsoft YaHei"/>
+              </a:rPr>
+              <a:t>12+</a:t>
+            </a:r>
+          </a:p>
+        </p:txBody>
+      </p:sp>
+      <p:sp>
+        <p:nvSpPr>
+          <p:cNvPr id="38" name="TextBox 37"/>
+          <p:cNvSpPr txBox="1"/>
+          <p:nvPr/>
+        </p:nvSpPr>
+        <p:spPr>
+          <a:xfrm>
+            <a:off x="4892040" y="4553712"/>
+            <a:ext cx="713232" cy="201168"/>
+          </a:xfrm>
+          <a:prstGeom prst="rect">
+            <a:avLst/>
+          </a:prstGeom>
+          <a:noFill/>
+        </p:spPr>
+        <p:txBody>
+          <a:bodyPr wrap="square" anchor="t">
+            <a:spAutoFit/>
+          </a:bodyPr>
+          <a:lstStyle/>
+          <a:p>
+            <a:pPr algn="ctr">
+              <a:lnSpc>
+                <a:spcPct val="100000"/>
+              </a:lnSpc>
+            </a:pPr>
+            <a:r>
+              <a:rPr sz="750" b="0">
+                <a:solidFill>
+                  <a:srgbClr val="66707D"/>
+                </a:solidFill>
+                <a:latin typeface="Microsoft YaHei"/>
+              </a:rPr>
+              <a:t>输入类型</a:t>
+            </a:r>
+          </a:p>
+        </p:txBody>
+      </p:sp>
+      <p:sp>
+        <p:nvSpPr>
+          <p:cNvPr id="39" name="TextBox 38"/>
+          <p:cNvSpPr txBox="1"/>
+          <p:nvPr/>
+        </p:nvSpPr>
+        <p:spPr>
+          <a:xfrm>
+            <a:off x="978408" y="4864608"/>
+            <a:ext cx="1828800" cy="164592"/>
+          </a:xfrm>
+          <a:prstGeom prst="rect">
+            <a:avLst/>
+          </a:prstGeom>
+          <a:noFill/>
+        </p:spPr>
+        <p:txBody>
+          <a:bodyPr wrap="square" anchor="t">
+            <a:spAutoFit/>
+          </a:bodyPr>
+          <a:lstStyle/>
+          <a:p>
+            <a:pPr algn="l">
+              <a:lnSpc>
+                <a:spcPct val="100000"/>
+              </a:lnSpc>
+            </a:pPr>
+            <a:r>
+              <a:rPr sz="900" b="1">
+                <a:solidFill>
+                  <a:srgbClr val="3B82F6"/>
+                </a:solidFill>
+                <a:latin typeface="Microsoft YaHei"/>
+              </a:rPr>
+              <a:t>查看日志 →</a:t>
+            </a:r>
+          </a:p>
+        </p:txBody>
+      </p:sp>
+      <p:sp>
+        <p:nvSpPr>
+          <p:cNvPr id="40" name="Rounded Rectangle 39"/>
+          <p:cNvSpPr/>
+          <p:nvPr/>
+        </p:nvSpPr>
+        <p:spPr>
+          <a:xfrm>
+            <a:off x="6309360" y="2761488"/>
+            <a:ext cx="5212080" cy="2267712"/>
           </a:xfrm>
           <a:prstGeom prst="roundRect">
             <a:avLst>
@@ -5252,7 +6605,7 @@
           </a:solidFill>
           <a:ln w="9525">
             <a:solidFill>
-              <a:srgbClr val="E3E8EE"/>
+              <a:srgbClr val="DFE5EC"/>
             </a:solidFill>
           </a:ln>
           <a:effectLst/>
@@ -5281,14 +6634,14 @@
       </p:sp>
       <p:sp>
         <p:nvSpPr>
-          <p:cNvPr id="21" name="Rectangle 20"/>
+          <p:cNvPr id="41" name="Rectangle 40"/>
           <p:cNvSpPr/>
           <p:nvPr/>
         </p:nvSpPr>
         <p:spPr>
           <a:xfrm>
-            <a:off x="6309360" y="2057400"/>
-            <a:ext cx="82296" cy="2084831"/>
+            <a:off x="6309360" y="2761488"/>
+            <a:ext cx="82296" cy="2267712"/>
           </a:xfrm>
           <a:prstGeom prst="rect">
             <a:avLst/>
@@ -5325,13 +6678,13 @@
       </p:sp>
       <p:sp>
         <p:nvSpPr>
-          <p:cNvPr id="22" name="Rounded Rectangle 21"/>
+          <p:cNvPr id="42" name="Rounded Rectangle 41"/>
           <p:cNvSpPr/>
           <p:nvPr/>
         </p:nvSpPr>
         <p:spPr>
           <a:xfrm>
-            <a:off x="6583680" y="2258568"/>
+            <a:off x="6583680" y="2962656"/>
             <a:ext cx="566928" cy="566928"/>
           </a:xfrm>
           <a:prstGeom prst="roundRect">
@@ -5371,13 +6724,13 @@
       </p:sp>
       <p:sp>
         <p:nvSpPr>
-          <p:cNvPr id="23" name="TextBox 22"/>
+          <p:cNvPr id="43" name="TextBox 42"/>
           <p:cNvSpPr txBox="1"/>
           <p:nvPr/>
         </p:nvSpPr>
         <p:spPr>
           <a:xfrm>
-            <a:off x="6583680" y="2331720"/>
+            <a:off x="6583680" y="3035808"/>
             <a:ext cx="566928" cy="411480"/>
           </a:xfrm>
           <a:prstGeom prst="rect">
@@ -5410,14 +6763,14 @@
       </p:sp>
       <p:sp>
         <p:nvSpPr>
-          <p:cNvPr id="24" name="TextBox 23"/>
+          <p:cNvPr id="44" name="TextBox 43"/>
           <p:cNvSpPr txBox="1"/>
           <p:nvPr/>
         </p:nvSpPr>
         <p:spPr>
           <a:xfrm>
-            <a:off x="7315200" y="2240280"/>
-            <a:ext cx="2926080" cy="365760"/>
+            <a:off x="7296912" y="2944368"/>
+            <a:ext cx="2377440" cy="365760"/>
           </a:xfrm>
           <a:prstGeom prst="rect">
             <a:avLst/>
@@ -5436,7 +6789,7 @@
               </a:lnSpc>
             </a:pPr>
             <a:r>
-              <a:rPr sz="1700" b="1">
+              <a:rPr sz="1600" b="1">
                 <a:solidFill>
                   <a:srgbClr val="222A35"/>
                 </a:solidFill>
@@ -5449,14 +6802,14 @@
       </p:sp>
       <p:sp>
         <p:nvSpPr>
-          <p:cNvPr id="25" name="Rounded Rectangle 24"/>
+          <p:cNvPr id="45" name="Rounded Rectangle 44"/>
           <p:cNvSpPr/>
           <p:nvPr/>
         </p:nvSpPr>
         <p:spPr>
           <a:xfrm>
-            <a:off x="10378440" y="2313432"/>
-            <a:ext cx="868680" cy="274320"/>
+            <a:off x="10149840" y="3017520"/>
+            <a:ext cx="1097280" cy="274320"/>
           </a:xfrm>
           <a:prstGeom prst="roundRect">
             <a:avLst>
@@ -5464,7 +6817,7 @@
             </a:avLst>
           </a:prstGeom>
           <a:solidFill>
-            <a:srgbClr val="F4F6F9"/>
+            <a:srgbClr val="F3F5F8"/>
           </a:solidFill>
           <a:ln>
             <a:noFill/>
@@ -5495,14 +6848,14 @@
       </p:sp>
       <p:sp>
         <p:nvSpPr>
-          <p:cNvPr id="26" name="TextBox 25"/>
+          <p:cNvPr id="46" name="TextBox 45"/>
           <p:cNvSpPr txBox="1"/>
           <p:nvPr/>
         </p:nvSpPr>
         <p:spPr>
           <a:xfrm>
-            <a:off x="10378440" y="2350008"/>
-            <a:ext cx="868680" cy="201168"/>
+            <a:off x="10149840" y="3054096"/>
+            <a:ext cx="1097280" cy="201168"/>
           </a:xfrm>
           <a:prstGeom prst="rect">
             <a:avLst/>
@@ -5521,7 +6874,7 @@
               </a:lnSpc>
             </a:pPr>
             <a:r>
-              <a:rPr sz="900" b="1">
+              <a:rPr sz="850" b="1">
                 <a:solidFill>
                   <a:srgbClr val="10B981"/>
                 </a:solidFill>
@@ -5534,14 +6887,14 @@
       </p:sp>
       <p:sp>
         <p:nvSpPr>
-          <p:cNvPr id="27" name="TextBox 26"/>
+          <p:cNvPr id="47" name="TextBox 46"/>
           <p:cNvSpPr txBox="1"/>
           <p:nvPr/>
         </p:nvSpPr>
         <p:spPr>
           <a:xfrm>
-            <a:off x="6601968" y="2916936"/>
-            <a:ext cx="4626864" cy="566928"/>
+            <a:off x="6601968" y="3639312"/>
+            <a:ext cx="4626864" cy="530352"/>
           </a:xfrm>
           <a:prstGeom prst="rect">
             <a:avLst/>
@@ -5556,31 +6909,31 @@
           <a:p>
             <a:pPr algn="l">
               <a:lnSpc>
-                <a:spcPct val="105000"/>
+                <a:spcPct val="104000"/>
               </a:lnSpc>
             </a:pPr>
             <a:r>
-              <a:rPr sz="1150" b="0">
-                <a:solidFill>
-                  <a:srgbClr val="6B7480"/>
+              <a:rPr sz="1100" b="0">
+                <a:solidFill>
+                  <a:srgbClr val="66707D"/>
                 </a:solidFill>
                 <a:latin typeface="Microsoft YaHei"/>
               </a:rPr>
-              <a:t>解析任务语义，匹配任务类型、所需能力与执行合同。</a:t>
-            </a:r>
-          </a:p>
-        </p:txBody>
-      </p:sp>
-      <p:sp>
-        <p:nvSpPr>
-          <p:cNvPr id="28" name="TextBox 27"/>
+              <a:t>解析任务语义，匹配类型、能力与执行合同。</a:t>
+            </a:r>
+          </a:p>
+        </p:txBody>
+      </p:sp>
+      <p:sp>
+        <p:nvSpPr>
+          <p:cNvPr id="48" name="TextBox 47"/>
           <p:cNvSpPr txBox="1"/>
           <p:nvPr/>
         </p:nvSpPr>
         <p:spPr>
           <a:xfrm>
-            <a:off x="6601968" y="3447288"/>
-            <a:ext cx="4626864" cy="603504"/>
+            <a:off x="6601968" y="4187952"/>
+            <a:ext cx="4023360" cy="640080"/>
           </a:xfrm>
           <a:prstGeom prst="rect">
             <a:avLst/>
@@ -5599,7 +6952,7 @@
               </a:lnSpc>
             </a:pPr>
             <a:r>
-              <a:rPr sz="1050" b="0">
+              <a:rPr sz="1000" b="0">
                 <a:solidFill>
                   <a:srgbClr val="222A35"/>
                 </a:solidFill>
@@ -5615,7 +6968,7 @@
               </a:lnSpc>
             </a:pPr>
             <a:r>
-              <a:rPr sz="1050" b="0">
+              <a:rPr sz="1000" b="0">
                 <a:solidFill>
                   <a:srgbClr val="222A35"/>
                 </a:solidFill>
@@ -5631,7 +6984,7 @@
               </a:lnSpc>
             </a:pPr>
             <a:r>
-              <a:rPr sz="1050" b="0">
+              <a:rPr sz="1000" b="0">
                 <a:solidFill>
                   <a:srgbClr val="222A35"/>
                 </a:solidFill>
@@ -5644,14 +6997,179 @@
       </p:sp>
       <p:sp>
         <p:nvSpPr>
-          <p:cNvPr id="29" name="Rounded Rectangle 28"/>
+          <p:cNvPr id="49" name="Rounded Rectangle 48"/>
           <p:cNvSpPr/>
           <p:nvPr/>
         </p:nvSpPr>
         <p:spPr>
           <a:xfrm>
-            <a:off x="685800" y="4279392"/>
-            <a:ext cx="5212080" cy="2084831"/>
+            <a:off x="10515600" y="4187952"/>
+            <a:ext cx="713232" cy="640080"/>
+          </a:xfrm>
+          <a:prstGeom prst="roundRect">
+            <a:avLst>
+              <a:gd name="adj" fmla="val 10000"/>
+            </a:avLst>
+          </a:prstGeom>
+          <a:solidFill>
+            <a:srgbClr val="F3F5F8"/>
+          </a:solidFill>
+          <a:ln w="9525">
+            <a:solidFill>
+              <a:srgbClr val="DFE5EC"/>
+            </a:solidFill>
+          </a:ln>
+          <a:effectLst/>
+        </p:spPr>
+        <p:style>
+          <a:lnRef idx="1">
+            <a:schemeClr val="accent1"/>
+          </a:lnRef>
+          <a:fillRef idx="3">
+            <a:schemeClr val="accent1"/>
+          </a:fillRef>
+          <a:effectRef idx="2">
+            <a:schemeClr val="accent1"/>
+          </a:effectRef>
+          <a:fontRef idx="minor">
+            <a:schemeClr val="lt1"/>
+          </a:fontRef>
+        </p:style>
+        <p:txBody>
+          <a:bodyPr rtlCol="0" anchor="ctr"/>
+          <a:lstStyle/>
+          <a:p>
+            <a:pPr algn="ctr"/>
+          </a:p>
+        </p:txBody>
+      </p:sp>
+      <p:sp>
+        <p:nvSpPr>
+          <p:cNvPr id="50" name="TextBox 49"/>
+          <p:cNvSpPr txBox="1"/>
+          <p:nvPr/>
+        </p:nvSpPr>
+        <p:spPr>
+          <a:xfrm>
+            <a:off x="10515600" y="4261104"/>
+            <a:ext cx="713232" cy="256032"/>
+          </a:xfrm>
+          <a:prstGeom prst="rect">
+            <a:avLst/>
+          </a:prstGeom>
+          <a:noFill/>
+        </p:spPr>
+        <p:txBody>
+          <a:bodyPr wrap="square" anchor="t">
+            <a:spAutoFit/>
+          </a:bodyPr>
+          <a:lstStyle/>
+          <a:p>
+            <a:pPr algn="ctr">
+              <a:lnSpc>
+                <a:spcPct val="100000"/>
+              </a:lnSpc>
+            </a:pPr>
+            <a:r>
+              <a:rPr sz="1400" b="1">
+                <a:solidFill>
+                  <a:srgbClr val="10B981"/>
+                </a:solidFill>
+                <a:latin typeface="Microsoft YaHei"/>
+              </a:rPr>
+              <a:t>8</a:t>
+            </a:r>
+          </a:p>
+        </p:txBody>
+      </p:sp>
+      <p:sp>
+        <p:nvSpPr>
+          <p:cNvPr id="51" name="TextBox 50"/>
+          <p:cNvSpPr txBox="1"/>
+          <p:nvPr/>
+        </p:nvSpPr>
+        <p:spPr>
+          <a:xfrm>
+            <a:off x="10515600" y="4553712"/>
+            <a:ext cx="713232" cy="201168"/>
+          </a:xfrm>
+          <a:prstGeom prst="rect">
+            <a:avLst/>
+          </a:prstGeom>
+          <a:noFill/>
+        </p:spPr>
+        <p:txBody>
+          <a:bodyPr wrap="square" anchor="t">
+            <a:spAutoFit/>
+          </a:bodyPr>
+          <a:lstStyle/>
+          <a:p>
+            <a:pPr algn="ctr">
+              <a:lnSpc>
+                <a:spcPct val="100000"/>
+              </a:lnSpc>
+            </a:pPr>
+            <a:r>
+              <a:rPr sz="750" b="0">
+                <a:solidFill>
+                  <a:srgbClr val="66707D"/>
+                </a:solidFill>
+                <a:latin typeface="Microsoft YaHei"/>
+              </a:rPr>
+              <a:t>任务类型</a:t>
+            </a:r>
+          </a:p>
+        </p:txBody>
+      </p:sp>
+      <p:sp>
+        <p:nvSpPr>
+          <p:cNvPr id="52" name="TextBox 51"/>
+          <p:cNvSpPr txBox="1"/>
+          <p:nvPr/>
+        </p:nvSpPr>
+        <p:spPr>
+          <a:xfrm>
+            <a:off x="6601968" y="4864608"/>
+            <a:ext cx="1828800" cy="164592"/>
+          </a:xfrm>
+          <a:prstGeom prst="rect">
+            <a:avLst/>
+          </a:prstGeom>
+          <a:noFill/>
+        </p:spPr>
+        <p:txBody>
+          <a:bodyPr wrap="square" anchor="t">
+            <a:spAutoFit/>
+          </a:bodyPr>
+          <a:lstStyle/>
+          <a:p>
+            <a:pPr algn="l">
+              <a:lnSpc>
+                <a:spcPct val="100000"/>
+              </a:lnSpc>
+            </a:pPr>
+            <a:r>
+              <a:rPr sz="900" b="1">
+                <a:solidFill>
+                  <a:srgbClr val="10B981"/>
+                </a:solidFill>
+                <a:latin typeface="Microsoft YaHei"/>
+              </a:rPr>
+              <a:t>查看日志 →</a:t>
+            </a:r>
+          </a:p>
+        </p:txBody>
+      </p:sp>
+      <p:sp>
+        <p:nvSpPr>
+          <p:cNvPr id="53" name="Rounded Rectangle 52"/>
+          <p:cNvSpPr/>
+          <p:nvPr/>
+        </p:nvSpPr>
+        <p:spPr>
+          <a:xfrm>
+            <a:off x="685800" y="5230368"/>
+            <a:ext cx="5212080" cy="2267712"/>
           </a:xfrm>
           <a:prstGeom prst="roundRect">
             <a:avLst>
@@ -5663,7 +7181,7 @@
           </a:solidFill>
           <a:ln w="9525">
             <a:solidFill>
-              <a:srgbClr val="E3E8EE"/>
+              <a:srgbClr val="DFE5EC"/>
             </a:solidFill>
           </a:ln>
           <a:effectLst/>
@@ -5692,14 +7210,14 @@
       </p:sp>
       <p:sp>
         <p:nvSpPr>
-          <p:cNvPr id="30" name="Rectangle 29"/>
+          <p:cNvPr id="54" name="Rectangle 53"/>
           <p:cNvSpPr/>
           <p:nvPr/>
         </p:nvSpPr>
         <p:spPr>
           <a:xfrm>
-            <a:off x="685800" y="4279392"/>
-            <a:ext cx="82296" cy="2084831"/>
+            <a:off x="685800" y="5230368"/>
+            <a:ext cx="82296" cy="2267712"/>
           </a:xfrm>
           <a:prstGeom prst="rect">
             <a:avLst/>
@@ -5736,13 +7254,13 @@
       </p:sp>
       <p:sp>
         <p:nvSpPr>
-          <p:cNvPr id="31" name="Rounded Rectangle 30"/>
+          <p:cNvPr id="55" name="Rounded Rectangle 54"/>
           <p:cNvSpPr/>
           <p:nvPr/>
         </p:nvSpPr>
         <p:spPr>
           <a:xfrm>
-            <a:off x="960120" y="4480559"/>
+            <a:off x="960120" y="5431536"/>
             <a:ext cx="566928" cy="566928"/>
           </a:xfrm>
           <a:prstGeom prst="roundRect">
@@ -5782,13 +7300,13 @@
       </p:sp>
       <p:sp>
         <p:nvSpPr>
-          <p:cNvPr id="32" name="TextBox 31"/>
+          <p:cNvPr id="56" name="TextBox 55"/>
           <p:cNvSpPr txBox="1"/>
           <p:nvPr/>
         </p:nvSpPr>
         <p:spPr>
           <a:xfrm>
-            <a:off x="960120" y="4553712"/>
+            <a:off x="960120" y="5504688"/>
             <a:ext cx="566928" cy="411480"/>
           </a:xfrm>
           <a:prstGeom prst="rect">
@@ -5821,14 +7339,14 @@
       </p:sp>
       <p:sp>
         <p:nvSpPr>
-          <p:cNvPr id="33" name="TextBox 32"/>
+          <p:cNvPr id="57" name="TextBox 56"/>
           <p:cNvSpPr txBox="1"/>
           <p:nvPr/>
         </p:nvSpPr>
         <p:spPr>
           <a:xfrm>
-            <a:off x="1691640" y="4462272"/>
-            <a:ext cx="2926080" cy="365760"/>
+            <a:off x="1673352" y="5413248"/>
+            <a:ext cx="2377440" cy="365760"/>
           </a:xfrm>
           <a:prstGeom prst="rect">
             <a:avLst/>
@@ -5847,7 +7365,7 @@
               </a:lnSpc>
             </a:pPr>
             <a:r>
-              <a:rPr sz="1700" b="1">
+              <a:rPr sz="1600" b="1">
                 <a:solidFill>
                   <a:srgbClr val="222A35"/>
                 </a:solidFill>
@@ -5860,14 +7378,14 @@
       </p:sp>
       <p:sp>
         <p:nvSpPr>
-          <p:cNvPr id="34" name="Rounded Rectangle 33"/>
+          <p:cNvPr id="58" name="Rounded Rectangle 57"/>
           <p:cNvSpPr/>
           <p:nvPr/>
         </p:nvSpPr>
         <p:spPr>
           <a:xfrm>
-            <a:off x="4754880" y="4535424"/>
-            <a:ext cx="868680" cy="274320"/>
+            <a:off x="4526280" y="5486400"/>
+            <a:ext cx="1097280" cy="274320"/>
           </a:xfrm>
           <a:prstGeom prst="roundRect">
             <a:avLst>
@@ -5875,7 +7393,7 @@
             </a:avLst>
           </a:prstGeom>
           <a:solidFill>
-            <a:srgbClr val="F4F6F9"/>
+            <a:srgbClr val="F3F5F8"/>
           </a:solidFill>
           <a:ln>
             <a:noFill/>
@@ -5906,14 +7424,14 @@
       </p:sp>
       <p:sp>
         <p:nvSpPr>
-          <p:cNvPr id="35" name="TextBox 34"/>
+          <p:cNvPr id="59" name="TextBox 58"/>
           <p:cNvSpPr txBox="1"/>
           <p:nvPr/>
         </p:nvSpPr>
         <p:spPr>
           <a:xfrm>
-            <a:off x="4754880" y="4572000"/>
-            <a:ext cx="868680" cy="201168"/>
+            <a:off x="4526280" y="5522976"/>
+            <a:ext cx="1097280" cy="201168"/>
           </a:xfrm>
           <a:prstGeom prst="rect">
             <a:avLst/>
@@ -5932,7 +7450,7 @@
               </a:lnSpc>
             </a:pPr>
             <a:r>
-              <a:rPr sz="900" b="1">
+              <a:rPr sz="850" b="1">
                 <a:solidFill>
                   <a:srgbClr val="F97A2E"/>
                 </a:solidFill>
@@ -5945,14 +7463,14 @@
       </p:sp>
       <p:sp>
         <p:nvSpPr>
-          <p:cNvPr id="36" name="TextBox 35"/>
+          <p:cNvPr id="60" name="TextBox 59"/>
           <p:cNvSpPr txBox="1"/>
           <p:nvPr/>
         </p:nvSpPr>
         <p:spPr>
           <a:xfrm>
-            <a:off x="978408" y="5138927"/>
-            <a:ext cx="4626864" cy="566928"/>
+            <a:off x="978408" y="6108192"/>
+            <a:ext cx="4626864" cy="530352"/>
           </a:xfrm>
           <a:prstGeom prst="rect">
             <a:avLst/>
@@ -5967,31 +7485,31 @@
           <a:p>
             <a:pPr algn="l">
               <a:lnSpc>
-                <a:spcPct val="105000"/>
+                <a:spcPct val="104000"/>
               </a:lnSpc>
             </a:pPr>
             <a:r>
-              <a:rPr sz="1150" b="0">
-                <a:solidFill>
-                  <a:srgbClr val="6B7480"/>
+              <a:rPr sz="1100" b="0">
+                <a:solidFill>
+                  <a:srgbClr val="66707D"/>
                 </a:solidFill>
                 <a:latin typeface="Microsoft YaHei"/>
               </a:rPr>
-              <a:t>在阶段工具面内执行修改，所有变更走原子事务与权限审计。</a:t>
-            </a:r>
-          </a:p>
-        </p:txBody>
-      </p:sp>
-      <p:sp>
-        <p:nvSpPr>
-          <p:cNvPr id="37" name="TextBox 36"/>
+              <a:t>在阶段工具面内执行修改，全部变更走原子事务与审计。</a:t>
+            </a:r>
+          </a:p>
+        </p:txBody>
+      </p:sp>
+      <p:sp>
+        <p:nvSpPr>
+          <p:cNvPr id="61" name="TextBox 60"/>
           <p:cNvSpPr txBox="1"/>
           <p:nvPr/>
         </p:nvSpPr>
         <p:spPr>
           <a:xfrm>
-            <a:off x="978408" y="5669279"/>
-            <a:ext cx="4626864" cy="603504"/>
+            <a:off x="978408" y="6656831"/>
+            <a:ext cx="4023360" cy="640080"/>
           </a:xfrm>
           <a:prstGeom prst="rect">
             <a:avLst/>
@@ -6010,7 +7528,7 @@
               </a:lnSpc>
             </a:pPr>
             <a:r>
-              <a:rPr sz="1050" b="0">
+              <a:rPr sz="1000" b="0">
                 <a:solidFill>
                   <a:srgbClr val="222A35"/>
                 </a:solidFill>
@@ -6026,7 +7544,7 @@
               </a:lnSpc>
             </a:pPr>
             <a:r>
-              <a:rPr sz="1050" b="0">
+              <a:rPr sz="1000" b="0">
                 <a:solidFill>
                   <a:srgbClr val="222A35"/>
                 </a:solidFill>
@@ -6042,7 +7560,7 @@
               </a:lnSpc>
             </a:pPr>
             <a:r>
-              <a:rPr sz="1050" b="0">
+              <a:rPr sz="1000" b="0">
                 <a:solidFill>
                   <a:srgbClr val="222A35"/>
                 </a:solidFill>
@@ -6055,14 +7573,179 @@
       </p:sp>
       <p:sp>
         <p:nvSpPr>
-          <p:cNvPr id="38" name="Rounded Rectangle 37"/>
+          <p:cNvPr id="62" name="Rounded Rectangle 61"/>
           <p:cNvSpPr/>
           <p:nvPr/>
         </p:nvSpPr>
         <p:spPr>
           <a:xfrm>
-            <a:off x="6309360" y="4279392"/>
-            <a:ext cx="5212080" cy="2084831"/>
+            <a:off x="4892040" y="6656831"/>
+            <a:ext cx="713232" cy="640080"/>
+          </a:xfrm>
+          <a:prstGeom prst="roundRect">
+            <a:avLst>
+              <a:gd name="adj" fmla="val 10000"/>
+            </a:avLst>
+          </a:prstGeom>
+          <a:solidFill>
+            <a:srgbClr val="F3F5F8"/>
+          </a:solidFill>
+          <a:ln w="9525">
+            <a:solidFill>
+              <a:srgbClr val="DFE5EC"/>
+            </a:solidFill>
+          </a:ln>
+          <a:effectLst/>
+        </p:spPr>
+        <p:style>
+          <a:lnRef idx="1">
+            <a:schemeClr val="accent1"/>
+          </a:lnRef>
+          <a:fillRef idx="3">
+            <a:schemeClr val="accent1"/>
+          </a:fillRef>
+          <a:effectRef idx="2">
+            <a:schemeClr val="accent1"/>
+          </a:effectRef>
+          <a:fontRef idx="minor">
+            <a:schemeClr val="lt1"/>
+          </a:fontRef>
+        </p:style>
+        <p:txBody>
+          <a:bodyPr rtlCol="0" anchor="ctr"/>
+          <a:lstStyle/>
+          <a:p>
+            <a:pPr algn="ctr"/>
+          </a:p>
+        </p:txBody>
+      </p:sp>
+      <p:sp>
+        <p:nvSpPr>
+          <p:cNvPr id="63" name="TextBox 62"/>
+          <p:cNvSpPr txBox="1"/>
+          <p:nvPr/>
+        </p:nvSpPr>
+        <p:spPr>
+          <a:xfrm>
+            <a:off x="4892040" y="6729983"/>
+            <a:ext cx="713232" cy="256032"/>
+          </a:xfrm>
+          <a:prstGeom prst="rect">
+            <a:avLst/>
+          </a:prstGeom>
+          <a:noFill/>
+        </p:spPr>
+        <p:txBody>
+          <a:bodyPr wrap="square" anchor="t">
+            <a:spAutoFit/>
+          </a:bodyPr>
+          <a:lstStyle/>
+          <a:p>
+            <a:pPr algn="ctr">
+              <a:lnSpc>
+                <a:spcPct val="100000"/>
+              </a:lnSpc>
+            </a:pPr>
+            <a:r>
+              <a:rPr sz="1400" b="1">
+                <a:solidFill>
+                  <a:srgbClr val="F97A2E"/>
+                </a:solidFill>
+                <a:latin typeface="Microsoft YaHei"/>
+              </a:rPr>
+              <a:t>100%</a:t>
+            </a:r>
+          </a:p>
+        </p:txBody>
+      </p:sp>
+      <p:sp>
+        <p:nvSpPr>
+          <p:cNvPr id="64" name="TextBox 63"/>
+          <p:cNvSpPr txBox="1"/>
+          <p:nvPr/>
+        </p:nvSpPr>
+        <p:spPr>
+          <a:xfrm>
+            <a:off x="4892040" y="7022592"/>
+            <a:ext cx="713232" cy="201168"/>
+          </a:xfrm>
+          <a:prstGeom prst="rect">
+            <a:avLst/>
+          </a:prstGeom>
+          <a:noFill/>
+        </p:spPr>
+        <p:txBody>
+          <a:bodyPr wrap="square" anchor="t">
+            <a:spAutoFit/>
+          </a:bodyPr>
+          <a:lstStyle/>
+          <a:p>
+            <a:pPr algn="ctr">
+              <a:lnSpc>
+                <a:spcPct val="100000"/>
+              </a:lnSpc>
+            </a:pPr>
+            <a:r>
+              <a:rPr sz="750" b="0">
+                <a:solidFill>
+                  <a:srgbClr val="66707D"/>
+                </a:solidFill>
+                <a:latin typeface="Microsoft YaHei"/>
+              </a:rPr>
+              <a:t>事务回滚</a:t>
+            </a:r>
+          </a:p>
+        </p:txBody>
+      </p:sp>
+      <p:sp>
+        <p:nvSpPr>
+          <p:cNvPr id="65" name="TextBox 64"/>
+          <p:cNvSpPr txBox="1"/>
+          <p:nvPr/>
+        </p:nvSpPr>
+        <p:spPr>
+          <a:xfrm>
+            <a:off x="978408" y="7333488"/>
+            <a:ext cx="1828800" cy="164592"/>
+          </a:xfrm>
+          <a:prstGeom prst="rect">
+            <a:avLst/>
+          </a:prstGeom>
+          <a:noFill/>
+        </p:spPr>
+        <p:txBody>
+          <a:bodyPr wrap="square" anchor="t">
+            <a:spAutoFit/>
+          </a:bodyPr>
+          <a:lstStyle/>
+          <a:p>
+            <a:pPr algn="l">
+              <a:lnSpc>
+                <a:spcPct val="100000"/>
+              </a:lnSpc>
+            </a:pPr>
+            <a:r>
+              <a:rPr sz="900" b="1">
+                <a:solidFill>
+                  <a:srgbClr val="F97A2E"/>
+                </a:solidFill>
+                <a:latin typeface="Microsoft YaHei"/>
+              </a:rPr>
+              <a:t>查看日志 →</a:t>
+            </a:r>
+          </a:p>
+        </p:txBody>
+      </p:sp>
+      <p:sp>
+        <p:nvSpPr>
+          <p:cNvPr id="66" name="Rounded Rectangle 65"/>
+          <p:cNvSpPr/>
+          <p:nvPr/>
+        </p:nvSpPr>
+        <p:spPr>
+          <a:xfrm>
+            <a:off x="6309360" y="5230368"/>
+            <a:ext cx="5212080" cy="2267712"/>
           </a:xfrm>
           <a:prstGeom prst="roundRect">
             <a:avLst>
@@ -6074,7 +7757,7 @@
           </a:solidFill>
           <a:ln w="9525">
             <a:solidFill>
-              <a:srgbClr val="E3E8EE"/>
+              <a:srgbClr val="DFE5EC"/>
             </a:solidFill>
           </a:ln>
           <a:effectLst/>
@@ -6103,14 +7786,14 @@
       </p:sp>
       <p:sp>
         <p:nvSpPr>
-          <p:cNvPr id="39" name="Rectangle 38"/>
+          <p:cNvPr id="67" name="Rectangle 66"/>
           <p:cNvSpPr/>
           <p:nvPr/>
         </p:nvSpPr>
         <p:spPr>
           <a:xfrm>
-            <a:off x="6309360" y="4279392"/>
-            <a:ext cx="82296" cy="2084831"/>
+            <a:off x="6309360" y="5230368"/>
+            <a:ext cx="82296" cy="2267712"/>
           </a:xfrm>
           <a:prstGeom prst="rect">
             <a:avLst/>
@@ -6147,13 +7830,13 @@
       </p:sp>
       <p:sp>
         <p:nvSpPr>
-          <p:cNvPr id="40" name="Rounded Rectangle 39"/>
+          <p:cNvPr id="68" name="Rounded Rectangle 67"/>
           <p:cNvSpPr/>
           <p:nvPr/>
         </p:nvSpPr>
         <p:spPr>
           <a:xfrm>
-            <a:off x="6583680" y="4480559"/>
+            <a:off x="6583680" y="5431536"/>
             <a:ext cx="566928" cy="566928"/>
           </a:xfrm>
           <a:prstGeom prst="roundRect">
@@ -6193,13 +7876,13 @@
       </p:sp>
       <p:sp>
         <p:nvSpPr>
-          <p:cNvPr id="41" name="TextBox 40"/>
+          <p:cNvPr id="69" name="TextBox 68"/>
           <p:cNvSpPr txBox="1"/>
           <p:nvPr/>
         </p:nvSpPr>
         <p:spPr>
           <a:xfrm>
-            <a:off x="6583680" y="4553712"/>
+            <a:off x="6583680" y="5504688"/>
             <a:ext cx="566928" cy="411480"/>
           </a:xfrm>
           <a:prstGeom prst="rect">
@@ -6232,14 +7915,14 @@
       </p:sp>
       <p:sp>
         <p:nvSpPr>
-          <p:cNvPr id="42" name="TextBox 41"/>
+          <p:cNvPr id="70" name="TextBox 69"/>
           <p:cNvSpPr txBox="1"/>
           <p:nvPr/>
         </p:nvSpPr>
         <p:spPr>
           <a:xfrm>
-            <a:off x="7315200" y="4462272"/>
-            <a:ext cx="2926080" cy="365760"/>
+            <a:off x="7296912" y="5413248"/>
+            <a:ext cx="2377440" cy="365760"/>
           </a:xfrm>
           <a:prstGeom prst="rect">
             <a:avLst/>
@@ -6258,7 +7941,7 @@
               </a:lnSpc>
             </a:pPr>
             <a:r>
-              <a:rPr sz="1700" b="1">
+              <a:rPr sz="1600" b="1">
                 <a:solidFill>
                   <a:srgbClr val="222A35"/>
                 </a:solidFill>
@@ -6271,14 +7954,14 @@
       </p:sp>
       <p:sp>
         <p:nvSpPr>
-          <p:cNvPr id="43" name="Rounded Rectangle 42"/>
+          <p:cNvPr id="71" name="Rounded Rectangle 70"/>
           <p:cNvSpPr/>
           <p:nvPr/>
         </p:nvSpPr>
         <p:spPr>
           <a:xfrm>
-            <a:off x="10378440" y="4535424"/>
-            <a:ext cx="868680" cy="274320"/>
+            <a:off x="10149840" y="5486400"/>
+            <a:ext cx="1097280" cy="274320"/>
           </a:xfrm>
           <a:prstGeom prst="roundRect">
             <a:avLst>
@@ -6286,7 +7969,7 @@
             </a:avLst>
           </a:prstGeom>
           <a:solidFill>
-            <a:srgbClr val="F4F6F9"/>
+            <a:srgbClr val="F3F5F8"/>
           </a:solidFill>
           <a:ln>
             <a:noFill/>
@@ -6317,14 +8000,14 @@
       </p:sp>
       <p:sp>
         <p:nvSpPr>
-          <p:cNvPr id="44" name="TextBox 43"/>
+          <p:cNvPr id="72" name="TextBox 71"/>
           <p:cNvSpPr txBox="1"/>
           <p:nvPr/>
         </p:nvSpPr>
         <p:spPr>
           <a:xfrm>
-            <a:off x="10378440" y="4572000"/>
-            <a:ext cx="868680" cy="201168"/>
+            <a:off x="10149840" y="5522976"/>
+            <a:ext cx="1097280" cy="201168"/>
           </a:xfrm>
           <a:prstGeom prst="rect">
             <a:avLst/>
@@ -6343,7 +8026,7 @@
               </a:lnSpc>
             </a:pPr>
             <a:r>
-              <a:rPr sz="900" b="1">
+              <a:rPr sz="850" b="1">
                 <a:solidFill>
                   <a:srgbClr val="8B5CF6"/>
                 </a:solidFill>
@@ -6356,14 +8039,14 @@
       </p:sp>
       <p:sp>
         <p:nvSpPr>
-          <p:cNvPr id="45" name="TextBox 44"/>
+          <p:cNvPr id="73" name="TextBox 72"/>
           <p:cNvSpPr txBox="1"/>
           <p:nvPr/>
         </p:nvSpPr>
         <p:spPr>
           <a:xfrm>
-            <a:off x="6601968" y="5138927"/>
-            <a:ext cx="4626864" cy="566928"/>
+            <a:off x="6601968" y="6108192"/>
+            <a:ext cx="4626864" cy="530352"/>
           </a:xfrm>
           <a:prstGeom prst="rect">
             <a:avLst/>
@@ -6378,31 +8061,31 @@
           <a:p>
             <a:pPr algn="l">
               <a:lnSpc>
-                <a:spcPct val="105000"/>
+                <a:spcPct val="104000"/>
               </a:lnSpc>
             </a:pPr>
             <a:r>
-              <a:rPr sz="1150" b="0">
-                <a:solidFill>
-                  <a:srgbClr val="6B7480"/>
+              <a:rPr sz="1100" b="0">
+                <a:solidFill>
+                  <a:srgbClr val="66707D"/>
                 </a:solidFill>
                 <a:latin typeface="Microsoft YaHei"/>
               </a:rPr>
-              <a:t>用结构、渲染、视觉与官方评估器四层证据确认交付质量。</a:t>
-            </a:r>
-          </a:p>
-        </p:txBody>
-      </p:sp>
-      <p:sp>
-        <p:nvSpPr>
-          <p:cNvPr id="46" name="TextBox 45"/>
+              <a:t>以结构、渲染、视觉与官方评估器四层证据确认交付质量。</a:t>
+            </a:r>
+          </a:p>
+        </p:txBody>
+      </p:sp>
+      <p:sp>
+        <p:nvSpPr>
+          <p:cNvPr id="74" name="TextBox 73"/>
           <p:cNvSpPr txBox="1"/>
           <p:nvPr/>
         </p:nvSpPr>
         <p:spPr>
           <a:xfrm>
-            <a:off x="6601968" y="5669279"/>
-            <a:ext cx="4626864" cy="603504"/>
+            <a:off x="6601968" y="6656831"/>
+            <a:ext cx="4023360" cy="640080"/>
           </a:xfrm>
           <a:prstGeom prst="rect">
             <a:avLst/>
@@ -6421,7 +8104,7 @@
               </a:lnSpc>
             </a:pPr>
             <a:r>
-              <a:rPr sz="1050" b="0">
+              <a:rPr sz="1000" b="0">
                 <a:solidFill>
                   <a:srgbClr val="222A35"/>
                 </a:solidFill>
@@ -6437,7 +8120,7 @@
               </a:lnSpc>
             </a:pPr>
             <a:r>
-              <a:rPr sz="1050" b="0">
+              <a:rPr sz="1000" b="0">
                 <a:solidFill>
                   <a:srgbClr val="222A35"/>
                 </a:solidFill>
@@ -6453,7 +8136,7 @@
               </a:lnSpc>
             </a:pPr>
             <a:r>
-              <a:rPr sz="1050" b="0">
+              <a:rPr sz="1000" b="0">
                 <a:solidFill>
                   <a:srgbClr val="222A35"/>
                 </a:solidFill>
@@ -6466,7 +8149,172 @@
       </p:sp>
       <p:sp>
         <p:nvSpPr>
-          <p:cNvPr id="47" name="Rectangle 46"/>
+          <p:cNvPr id="75" name="Rounded Rectangle 74"/>
+          <p:cNvSpPr/>
+          <p:nvPr/>
+        </p:nvSpPr>
+        <p:spPr>
+          <a:xfrm>
+            <a:off x="10515600" y="6656831"/>
+            <a:ext cx="713232" cy="640080"/>
+          </a:xfrm>
+          <a:prstGeom prst="roundRect">
+            <a:avLst>
+              <a:gd name="adj" fmla="val 10000"/>
+            </a:avLst>
+          </a:prstGeom>
+          <a:solidFill>
+            <a:srgbClr val="F3F5F8"/>
+          </a:solidFill>
+          <a:ln w="9525">
+            <a:solidFill>
+              <a:srgbClr val="DFE5EC"/>
+            </a:solidFill>
+          </a:ln>
+          <a:effectLst/>
+        </p:spPr>
+        <p:style>
+          <a:lnRef idx="1">
+            <a:schemeClr val="accent1"/>
+          </a:lnRef>
+          <a:fillRef idx="3">
+            <a:schemeClr val="accent1"/>
+          </a:fillRef>
+          <a:effectRef idx="2">
+            <a:schemeClr val="accent1"/>
+          </a:effectRef>
+          <a:fontRef idx="minor">
+            <a:schemeClr val="lt1"/>
+          </a:fontRef>
+        </p:style>
+        <p:txBody>
+          <a:bodyPr rtlCol="0" anchor="ctr"/>
+          <a:lstStyle/>
+          <a:p>
+            <a:pPr algn="ctr"/>
+          </a:p>
+        </p:txBody>
+      </p:sp>
+      <p:sp>
+        <p:nvSpPr>
+          <p:cNvPr id="76" name="TextBox 75"/>
+          <p:cNvSpPr txBox="1"/>
+          <p:nvPr/>
+        </p:nvSpPr>
+        <p:spPr>
+          <a:xfrm>
+            <a:off x="10515600" y="6729983"/>
+            <a:ext cx="713232" cy="256032"/>
+          </a:xfrm>
+          <a:prstGeom prst="rect">
+            <a:avLst/>
+          </a:prstGeom>
+          <a:noFill/>
+        </p:spPr>
+        <p:txBody>
+          <a:bodyPr wrap="square" anchor="t">
+            <a:spAutoFit/>
+          </a:bodyPr>
+          <a:lstStyle/>
+          <a:p>
+            <a:pPr algn="ctr">
+              <a:lnSpc>
+                <a:spcPct val="100000"/>
+              </a:lnSpc>
+            </a:pPr>
+            <a:r>
+              <a:rPr sz="1400" b="1">
+                <a:solidFill>
+                  <a:srgbClr val="8B5CF6"/>
+                </a:solidFill>
+                <a:latin typeface="Microsoft YaHei"/>
+              </a:rPr>
+              <a:t>4</a:t>
+            </a:r>
+          </a:p>
+        </p:txBody>
+      </p:sp>
+      <p:sp>
+        <p:nvSpPr>
+          <p:cNvPr id="77" name="TextBox 76"/>
+          <p:cNvSpPr txBox="1"/>
+          <p:nvPr/>
+        </p:nvSpPr>
+        <p:spPr>
+          <a:xfrm>
+            <a:off x="10515600" y="7022592"/>
+            <a:ext cx="713232" cy="201168"/>
+          </a:xfrm>
+          <a:prstGeom prst="rect">
+            <a:avLst/>
+          </a:prstGeom>
+          <a:noFill/>
+        </p:spPr>
+        <p:txBody>
+          <a:bodyPr wrap="square" anchor="t">
+            <a:spAutoFit/>
+          </a:bodyPr>
+          <a:lstStyle/>
+          <a:p>
+            <a:pPr algn="ctr">
+              <a:lnSpc>
+                <a:spcPct val="100000"/>
+              </a:lnSpc>
+            </a:pPr>
+            <a:r>
+              <a:rPr sz="750" b="0">
+                <a:solidFill>
+                  <a:srgbClr val="66707D"/>
+                </a:solidFill>
+                <a:latin typeface="Microsoft YaHei"/>
+              </a:rPr>
+              <a:t>证据层</a:t>
+            </a:r>
+          </a:p>
+        </p:txBody>
+      </p:sp>
+      <p:sp>
+        <p:nvSpPr>
+          <p:cNvPr id="78" name="TextBox 77"/>
+          <p:cNvSpPr txBox="1"/>
+          <p:nvPr/>
+        </p:nvSpPr>
+        <p:spPr>
+          <a:xfrm>
+            <a:off x="6601968" y="7333488"/>
+            <a:ext cx="1828800" cy="164592"/>
+          </a:xfrm>
+          <a:prstGeom prst="rect">
+            <a:avLst/>
+          </a:prstGeom>
+          <a:noFill/>
+        </p:spPr>
+        <p:txBody>
+          <a:bodyPr wrap="square" anchor="t">
+            <a:spAutoFit/>
+          </a:bodyPr>
+          <a:lstStyle/>
+          <a:p>
+            <a:pPr algn="l">
+              <a:lnSpc>
+                <a:spcPct val="100000"/>
+              </a:lnSpc>
+            </a:pPr>
+            <a:r>
+              <a:rPr sz="900" b="1">
+                <a:solidFill>
+                  <a:srgbClr val="8B5CF6"/>
+                </a:solidFill>
+                <a:latin typeface="Microsoft YaHei"/>
+              </a:rPr>
+              <a:t>查看日志 →</a:t>
+            </a:r>
+          </a:p>
+        </p:txBody>
+      </p:sp>
+      <p:sp>
+        <p:nvSpPr>
+          <p:cNvPr id="79" name="Rectangle 78"/>
           <p:cNvSpPr/>
           <p:nvPr/>
         </p:nvSpPr>
@@ -6483,7 +8331,7 @@
           </a:solidFill>
           <a:ln w="9525">
             <a:solidFill>
-              <a:srgbClr val="E3E8EE"/>
+              <a:srgbClr val="DFE5EC"/>
             </a:solidFill>
           </a:ln>
           <a:effectLst/>
@@ -6512,7 +8360,7 @@
       </p:sp>
       <p:sp>
         <p:nvSpPr>
-          <p:cNvPr id="48" name="TextBox 47"/>
+          <p:cNvPr id="80" name="TextBox 79"/>
           <p:cNvSpPr txBox="1"/>
           <p:nvPr/>
         </p:nvSpPr>
@@ -6540,7 +8388,7 @@
             <a:r>
               <a:rPr sz="1000" b="0">
                 <a:solidFill>
-                  <a:srgbClr val="6B7480"/>
+                  <a:srgbClr val="66707D"/>
                 </a:solidFill>
                 <a:latin typeface="Microsoft YaHei"/>
               </a:rPr>

</xml_diff>

<commit_message>
AI Agent workflow v4: progress bars, status chip, action buttons
</commit_message>
<xml_diff>
--- a/benchmarks/manual_tasks/ai-agent-workflow/output/ai_agent_workflow.pptx
+++ b/benchmarks/manual_tasks/ai-agent-workflow/output/ai_agent_workflow.pptx
@@ -3230,7 +3230,7 @@
         <p:spPr>
           <a:xfrm>
             <a:off x="777240" y="457200"/>
-            <a:ext cx="10607040" cy="365760"/>
+            <a:ext cx="7498079" cy="365760"/>
           </a:xfrm>
           <a:prstGeom prst="rect">
             <a:avLst/>
@@ -3262,7 +3262,92 @@
       </p:sp>
       <p:sp>
         <p:nvSpPr>
-          <p:cNvPr id="6" name="TextBox 5"/>
+          <p:cNvPr id="6" name="Rounded Rectangle 5"/>
+          <p:cNvSpPr/>
+          <p:nvPr/>
+        </p:nvSpPr>
+        <p:spPr>
+          <a:xfrm>
+            <a:off x="9738360" y="457200"/>
+            <a:ext cx="1691640" cy="402336"/>
+          </a:xfrm>
+          <a:prstGeom prst="roundRect">
+            <a:avLst>
+              <a:gd name="adj" fmla="val 50000"/>
+            </a:avLst>
+          </a:prstGeom>
+          <a:solidFill>
+            <a:srgbClr val="10B981"/>
+          </a:solidFill>
+          <a:ln>
+            <a:noFill/>
+          </a:ln>
+          <a:effectLst/>
+        </p:spPr>
+        <p:style>
+          <a:lnRef idx="1">
+            <a:schemeClr val="accent1"/>
+          </a:lnRef>
+          <a:fillRef idx="3">
+            <a:schemeClr val="accent1"/>
+          </a:fillRef>
+          <a:effectRef idx="2">
+            <a:schemeClr val="accent1"/>
+          </a:effectRef>
+          <a:fontRef idx="minor">
+            <a:schemeClr val="lt1"/>
+          </a:fontRef>
+        </p:style>
+        <p:txBody>
+          <a:bodyPr rtlCol="0" anchor="ctr"/>
+          <a:lstStyle/>
+          <a:p>
+            <a:pPr algn="ctr"/>
+          </a:p>
+        </p:txBody>
+      </p:sp>
+      <p:sp>
+        <p:nvSpPr>
+          <p:cNvPr id="7" name="TextBox 6"/>
+          <p:cNvSpPr txBox="1"/>
+          <p:nvPr/>
+        </p:nvSpPr>
+        <p:spPr>
+          <a:xfrm>
+            <a:off x="9738360" y="512064"/>
+            <a:ext cx="1691640" cy="274320"/>
+          </a:xfrm>
+          <a:prstGeom prst="rect">
+            <a:avLst/>
+          </a:prstGeom>
+          <a:noFill/>
+        </p:spPr>
+        <p:txBody>
+          <a:bodyPr wrap="square" anchor="t">
+            <a:spAutoFit/>
+          </a:bodyPr>
+          <a:lstStyle/>
+          <a:p>
+            <a:pPr algn="ctr">
+              <a:lnSpc>
+                <a:spcPct val="100000"/>
+              </a:lnSpc>
+            </a:pPr>
+            <a:r>
+              <a:rPr sz="1050" b="1">
+                <a:solidFill>
+                  <a:srgbClr val="FFFFFF"/>
+                </a:solidFill>
+                <a:latin typeface="Microsoft YaHei"/>
+              </a:rPr>
+              <a:t>● 系统就绪</a:t>
+            </a:r>
+          </a:p>
+        </p:txBody>
+      </p:sp>
+      <p:sp>
+        <p:nvSpPr>
+          <p:cNvPr id="8" name="TextBox 7"/>
           <p:cNvSpPr txBox="1"/>
           <p:nvPr/>
         </p:nvSpPr>
@@ -3301,7 +3386,7 @@
       </p:sp>
       <p:sp>
         <p:nvSpPr>
-          <p:cNvPr id="7" name="TextBox 6"/>
+          <p:cNvPr id="9" name="TextBox 8"/>
           <p:cNvSpPr txBox="1"/>
           <p:nvPr/>
         </p:nvSpPr>
@@ -3340,7 +3425,7 @@
       </p:sp>
       <p:sp>
         <p:nvSpPr>
-          <p:cNvPr id="8" name="TextBox 7"/>
+          <p:cNvPr id="10" name="TextBox 9"/>
           <p:cNvSpPr txBox="1"/>
           <p:nvPr/>
         </p:nvSpPr>
@@ -3379,14 +3464,14 @@
       </p:sp>
       <p:sp>
         <p:nvSpPr>
-          <p:cNvPr id="9" name="Rounded Rectangle 8"/>
+          <p:cNvPr id="11" name="Rounded Rectangle 10"/>
           <p:cNvSpPr/>
           <p:nvPr/>
         </p:nvSpPr>
         <p:spPr>
           <a:xfrm>
-            <a:off x="658368" y="2880360"/>
-            <a:ext cx="1975104" cy="2468880"/>
+            <a:off x="658368" y="2788920"/>
+            <a:ext cx="1975104" cy="2615184"/>
           </a:xfrm>
           <a:prstGeom prst="roundRect">
             <a:avLst>
@@ -3427,13 +3512,13 @@
       </p:sp>
       <p:sp>
         <p:nvSpPr>
-          <p:cNvPr id="10" name="Rounded Rectangle 9"/>
+          <p:cNvPr id="12" name="Rounded Rectangle 11"/>
           <p:cNvSpPr/>
           <p:nvPr/>
         </p:nvSpPr>
         <p:spPr>
           <a:xfrm>
-            <a:off x="822959" y="3044952"/>
+            <a:off x="822959" y="2953512"/>
             <a:ext cx="493776" cy="493776"/>
           </a:xfrm>
           <a:prstGeom prst="roundRect">
@@ -3481,13 +3566,13 @@
       </p:sp>
       <p:sp>
         <p:nvSpPr>
-          <p:cNvPr id="11" name="TextBox 10"/>
+          <p:cNvPr id="13" name="TextBox 12"/>
           <p:cNvSpPr txBox="1"/>
           <p:nvPr/>
         </p:nvSpPr>
         <p:spPr>
           <a:xfrm>
-            <a:off x="804672" y="3721608"/>
+            <a:off x="804672" y="3630168"/>
             <a:ext cx="1682496" cy="384048"/>
           </a:xfrm>
           <a:prstGeom prst="rect">
@@ -3520,13 +3605,13 @@
       </p:sp>
       <p:sp>
         <p:nvSpPr>
-          <p:cNvPr id="12" name="TextBox 11"/>
+          <p:cNvPr id="14" name="TextBox 13"/>
           <p:cNvSpPr txBox="1"/>
           <p:nvPr/>
         </p:nvSpPr>
         <p:spPr>
           <a:xfrm>
-            <a:off x="804672" y="4160520"/>
+            <a:off x="804672" y="4050791"/>
             <a:ext cx="1682496" cy="685800"/>
           </a:xfrm>
           <a:prstGeom prst="rect">
@@ -3559,13 +3644,13 @@
       </p:sp>
       <p:sp>
         <p:nvSpPr>
-          <p:cNvPr id="13" name="Rounded Rectangle 12"/>
+          <p:cNvPr id="15" name="Rounded Rectangle 14"/>
           <p:cNvSpPr/>
           <p:nvPr/>
         </p:nvSpPr>
         <p:spPr>
           <a:xfrm>
-            <a:off x="804672" y="4910328"/>
+            <a:off x="804672" y="4800600"/>
             <a:ext cx="1682496" cy="310896"/>
           </a:xfrm>
           <a:prstGeom prst="roundRect">
@@ -3605,13 +3690,13 @@
       </p:sp>
       <p:sp>
         <p:nvSpPr>
-          <p:cNvPr id="14" name="TextBox 13"/>
+          <p:cNvPr id="16" name="TextBox 15"/>
           <p:cNvSpPr txBox="1"/>
           <p:nvPr/>
         </p:nvSpPr>
         <p:spPr>
           <a:xfrm>
-            <a:off x="877824" y="4965192"/>
+            <a:off x="877824" y="4855464"/>
             <a:ext cx="1536192" cy="201168"/>
           </a:xfrm>
           <a:prstGeom prst="rect">
@@ -3642,15 +3727,107 @@
           </a:p>
         </p:txBody>
       </p:sp>
+      <p:sp>
+        <p:nvSpPr>
+          <p:cNvPr id="17" name="Rounded Rectangle 16"/>
+          <p:cNvSpPr/>
+          <p:nvPr/>
+        </p:nvSpPr>
+        <p:spPr>
+          <a:xfrm>
+            <a:off x="804672" y="5221224"/>
+            <a:ext cx="1682496" cy="91440"/>
+          </a:xfrm>
+          <a:prstGeom prst="roundRect">
+            <a:avLst>
+              <a:gd name="adj" fmla="val 50000"/>
+            </a:avLst>
+          </a:prstGeom>
+          <a:solidFill>
+            <a:srgbClr val="2A3D5A"/>
+          </a:solidFill>
+          <a:ln>
+            <a:noFill/>
+          </a:ln>
+          <a:effectLst/>
+        </p:spPr>
+        <p:style>
+          <a:lnRef idx="1">
+            <a:schemeClr val="accent1"/>
+          </a:lnRef>
+          <a:fillRef idx="3">
+            <a:schemeClr val="accent1"/>
+          </a:fillRef>
+          <a:effectRef idx="2">
+            <a:schemeClr val="accent1"/>
+          </a:effectRef>
+          <a:fontRef idx="minor">
+            <a:schemeClr val="lt1"/>
+          </a:fontRef>
+        </p:style>
+        <p:txBody>
+          <a:bodyPr rtlCol="0" anchor="ctr"/>
+          <a:lstStyle/>
+          <a:p>
+            <a:pPr algn="ctr"/>
+          </a:p>
+        </p:txBody>
+      </p:sp>
+      <p:sp>
+        <p:nvSpPr>
+          <p:cNvPr id="18" name="Rounded Rectangle 17"/>
+          <p:cNvSpPr/>
+          <p:nvPr/>
+        </p:nvSpPr>
+        <p:spPr>
+          <a:xfrm>
+            <a:off x="804672" y="5221224"/>
+            <a:ext cx="1682496" cy="91440"/>
+          </a:xfrm>
+          <a:prstGeom prst="roundRect">
+            <a:avLst>
+              <a:gd name="adj" fmla="val 50000"/>
+            </a:avLst>
+          </a:prstGeom>
+          <a:solidFill>
+            <a:srgbClr val="F6B544"/>
+          </a:solidFill>
+          <a:ln>
+            <a:noFill/>
+          </a:ln>
+          <a:effectLst/>
+        </p:spPr>
+        <p:style>
+          <a:lnRef idx="1">
+            <a:schemeClr val="accent1"/>
+          </a:lnRef>
+          <a:fillRef idx="3">
+            <a:schemeClr val="accent1"/>
+          </a:fillRef>
+          <a:effectRef idx="2">
+            <a:schemeClr val="accent1"/>
+          </a:effectRef>
+          <a:fontRef idx="minor">
+            <a:schemeClr val="lt1"/>
+          </a:fontRef>
+        </p:style>
+        <p:txBody>
+          <a:bodyPr rtlCol="0" anchor="ctr"/>
+          <a:lstStyle/>
+          <a:p>
+            <a:pPr algn="ctr"/>
+          </a:p>
+        </p:txBody>
+      </p:sp>
       <p:cxnSp>
         <p:nvCxnSpPr>
-          <p:cNvPr id="15" name="Connector 14"/>
+          <p:cNvPr id="19" name="Connector 18"/>
           <p:cNvCxnSpPr/>
           <p:nvPr/>
         </p:nvCxnSpPr>
         <p:spPr>
           <a:xfrm>
-            <a:off x="2660903" y="4114800"/>
+            <a:off x="2660903" y="4096511"/>
             <a:ext cx="146305" cy="0"/>
           </a:xfrm>
           <a:prstGeom prst="line">
@@ -3680,14 +3857,14 @@
       </p:cxnSp>
       <p:sp>
         <p:nvSpPr>
-          <p:cNvPr id="16" name="Rounded Rectangle 15"/>
+          <p:cNvPr id="20" name="Rounded Rectangle 19"/>
           <p:cNvSpPr/>
           <p:nvPr/>
         </p:nvSpPr>
         <p:spPr>
           <a:xfrm>
-            <a:off x="2834640" y="2880360"/>
-            <a:ext cx="1975104" cy="2468880"/>
+            <a:off x="2834640" y="2788920"/>
+            <a:ext cx="1975104" cy="2615184"/>
           </a:xfrm>
           <a:prstGeom prst="roundRect">
             <a:avLst>
@@ -3728,13 +3905,13 @@
       </p:sp>
       <p:sp>
         <p:nvSpPr>
-          <p:cNvPr id="17" name="Rounded Rectangle 16"/>
+          <p:cNvPr id="21" name="Rounded Rectangle 20"/>
           <p:cNvSpPr/>
           <p:nvPr/>
         </p:nvSpPr>
         <p:spPr>
           <a:xfrm>
-            <a:off x="2999232" y="3044952"/>
+            <a:off x="2999232" y="2953512"/>
             <a:ext cx="493776" cy="493776"/>
           </a:xfrm>
           <a:prstGeom prst="roundRect">
@@ -3743,7 +3920,7 @@
             </a:avLst>
           </a:prstGeom>
           <a:solidFill>
-            <a:srgbClr val="F6B544"/>
+            <a:srgbClr val="3B82F6"/>
           </a:solidFill>
           <a:ln>
             <a:noFill/>
@@ -3782,13 +3959,13 @@
       </p:sp>
       <p:sp>
         <p:nvSpPr>
-          <p:cNvPr id="18" name="TextBox 17"/>
+          <p:cNvPr id="22" name="TextBox 21"/>
           <p:cNvSpPr txBox="1"/>
           <p:nvPr/>
         </p:nvSpPr>
         <p:spPr>
           <a:xfrm>
-            <a:off x="2980944" y="3721608"/>
+            <a:off x="2980944" y="3630168"/>
             <a:ext cx="1682496" cy="384048"/>
           </a:xfrm>
           <a:prstGeom prst="rect">
@@ -3821,13 +3998,13 @@
       </p:sp>
       <p:sp>
         <p:nvSpPr>
-          <p:cNvPr id="19" name="TextBox 18"/>
+          <p:cNvPr id="23" name="TextBox 22"/>
           <p:cNvSpPr txBox="1"/>
           <p:nvPr/>
         </p:nvSpPr>
         <p:spPr>
           <a:xfrm>
-            <a:off x="2980944" y="4160520"/>
+            <a:off x="2980944" y="4050791"/>
             <a:ext cx="1682496" cy="685800"/>
           </a:xfrm>
           <a:prstGeom prst="rect">
@@ -3860,13 +4037,13 @@
       </p:sp>
       <p:sp>
         <p:nvSpPr>
-          <p:cNvPr id="20" name="Rounded Rectangle 19"/>
+          <p:cNvPr id="24" name="Rounded Rectangle 23"/>
           <p:cNvSpPr/>
           <p:nvPr/>
         </p:nvSpPr>
         <p:spPr>
           <a:xfrm>
-            <a:off x="2980944" y="4910328"/>
+            <a:off x="2980944" y="4800600"/>
             <a:ext cx="1682496" cy="310896"/>
           </a:xfrm>
           <a:prstGeom prst="roundRect">
@@ -3906,13 +4083,13 @@
       </p:sp>
       <p:sp>
         <p:nvSpPr>
-          <p:cNvPr id="21" name="TextBox 20"/>
+          <p:cNvPr id="25" name="TextBox 24"/>
           <p:cNvSpPr txBox="1"/>
           <p:nvPr/>
         </p:nvSpPr>
         <p:spPr>
           <a:xfrm>
-            <a:off x="3054096" y="4965192"/>
+            <a:off x="3054096" y="4855464"/>
             <a:ext cx="1536192" cy="201168"/>
           </a:xfrm>
           <a:prstGeom prst="rect">
@@ -3934,7 +4111,7 @@
             <a:r>
               <a:rPr sz="850" b="0">
                 <a:solidFill>
-                  <a:srgbClr val="F6B544"/>
+                  <a:srgbClr val="3B82F6"/>
                 </a:solidFill>
                 <a:latin typeface="Microsoft YaHei"/>
               </a:rPr>
@@ -3943,15 +4120,107 @@
           </a:p>
         </p:txBody>
       </p:sp>
+      <p:sp>
+        <p:nvSpPr>
+          <p:cNvPr id="26" name="Rounded Rectangle 25"/>
+          <p:cNvSpPr/>
+          <p:nvPr/>
+        </p:nvSpPr>
+        <p:spPr>
+          <a:xfrm>
+            <a:off x="2980944" y="5221224"/>
+            <a:ext cx="1682496" cy="91440"/>
+          </a:xfrm>
+          <a:prstGeom prst="roundRect">
+            <a:avLst>
+              <a:gd name="adj" fmla="val 50000"/>
+            </a:avLst>
+          </a:prstGeom>
+          <a:solidFill>
+            <a:srgbClr val="2A3D5A"/>
+          </a:solidFill>
+          <a:ln>
+            <a:noFill/>
+          </a:ln>
+          <a:effectLst/>
+        </p:spPr>
+        <p:style>
+          <a:lnRef idx="1">
+            <a:schemeClr val="accent1"/>
+          </a:lnRef>
+          <a:fillRef idx="3">
+            <a:schemeClr val="accent1"/>
+          </a:fillRef>
+          <a:effectRef idx="2">
+            <a:schemeClr val="accent1"/>
+          </a:effectRef>
+          <a:fontRef idx="minor">
+            <a:schemeClr val="lt1"/>
+          </a:fontRef>
+        </p:style>
+        <p:txBody>
+          <a:bodyPr rtlCol="0" anchor="ctr"/>
+          <a:lstStyle/>
+          <a:p>
+            <a:pPr algn="ctr"/>
+          </a:p>
+        </p:txBody>
+      </p:sp>
+      <p:sp>
+        <p:nvSpPr>
+          <p:cNvPr id="27" name="Rounded Rectangle 26"/>
+          <p:cNvSpPr/>
+          <p:nvPr/>
+        </p:nvSpPr>
+        <p:spPr>
+          <a:xfrm>
+            <a:off x="2980944" y="5221224"/>
+            <a:ext cx="1682496" cy="91440"/>
+          </a:xfrm>
+          <a:prstGeom prst="roundRect">
+            <a:avLst>
+              <a:gd name="adj" fmla="val 50000"/>
+            </a:avLst>
+          </a:prstGeom>
+          <a:solidFill>
+            <a:srgbClr val="3B82F6"/>
+          </a:solidFill>
+          <a:ln>
+            <a:noFill/>
+          </a:ln>
+          <a:effectLst/>
+        </p:spPr>
+        <p:style>
+          <a:lnRef idx="1">
+            <a:schemeClr val="accent1"/>
+          </a:lnRef>
+          <a:fillRef idx="3">
+            <a:schemeClr val="accent1"/>
+          </a:fillRef>
+          <a:effectRef idx="2">
+            <a:schemeClr val="accent1"/>
+          </a:effectRef>
+          <a:fontRef idx="minor">
+            <a:schemeClr val="lt1"/>
+          </a:fontRef>
+        </p:style>
+        <p:txBody>
+          <a:bodyPr rtlCol="0" anchor="ctr"/>
+          <a:lstStyle/>
+          <a:p>
+            <a:pPr algn="ctr"/>
+          </a:p>
+        </p:txBody>
+      </p:sp>
       <p:cxnSp>
         <p:nvCxnSpPr>
-          <p:cNvPr id="22" name="Connector 21"/>
+          <p:cNvPr id="28" name="Connector 27"/>
           <p:cNvCxnSpPr/>
           <p:nvPr/>
         </p:nvCxnSpPr>
         <p:spPr>
           <a:xfrm>
-            <a:off x="4837176" y="4114800"/>
+            <a:off x="4837176" y="4096511"/>
             <a:ext cx="146304" cy="0"/>
           </a:xfrm>
           <a:prstGeom prst="line">
@@ -3981,14 +4250,14 @@
       </p:cxnSp>
       <p:sp>
         <p:nvSpPr>
-          <p:cNvPr id="23" name="Rounded Rectangle 22"/>
+          <p:cNvPr id="29" name="Rounded Rectangle 28"/>
           <p:cNvSpPr/>
           <p:nvPr/>
         </p:nvSpPr>
         <p:spPr>
           <a:xfrm>
-            <a:off x="5010912" y="2880360"/>
-            <a:ext cx="1975104" cy="2468880"/>
+            <a:off x="5010912" y="2788920"/>
+            <a:ext cx="1975104" cy="2615184"/>
           </a:xfrm>
           <a:prstGeom prst="roundRect">
             <a:avLst>
@@ -4029,13 +4298,13 @@
       </p:sp>
       <p:sp>
         <p:nvSpPr>
-          <p:cNvPr id="24" name="Rounded Rectangle 23"/>
+          <p:cNvPr id="30" name="Rounded Rectangle 29"/>
           <p:cNvSpPr/>
           <p:nvPr/>
         </p:nvSpPr>
         <p:spPr>
           <a:xfrm>
-            <a:off x="5175504" y="3044952"/>
+            <a:off x="5175504" y="2953512"/>
             <a:ext cx="493776" cy="493776"/>
           </a:xfrm>
           <a:prstGeom prst="roundRect">
@@ -4044,7 +4313,7 @@
             </a:avLst>
           </a:prstGeom>
           <a:solidFill>
-            <a:srgbClr val="F6B544"/>
+            <a:srgbClr val="06B6D4"/>
           </a:solidFill>
           <a:ln>
             <a:noFill/>
@@ -4083,13 +4352,13 @@
       </p:sp>
       <p:sp>
         <p:nvSpPr>
-          <p:cNvPr id="25" name="TextBox 24"/>
+          <p:cNvPr id="31" name="TextBox 30"/>
           <p:cNvSpPr txBox="1"/>
           <p:nvPr/>
         </p:nvSpPr>
         <p:spPr>
           <a:xfrm>
-            <a:off x="5157216" y="3721608"/>
+            <a:off x="5157216" y="3630168"/>
             <a:ext cx="1682496" cy="384048"/>
           </a:xfrm>
           <a:prstGeom prst="rect">
@@ -4122,13 +4391,13 @@
       </p:sp>
       <p:sp>
         <p:nvSpPr>
-          <p:cNvPr id="26" name="TextBox 25"/>
+          <p:cNvPr id="32" name="TextBox 31"/>
           <p:cNvSpPr txBox="1"/>
           <p:nvPr/>
         </p:nvSpPr>
         <p:spPr>
           <a:xfrm>
-            <a:off x="5157216" y="4160520"/>
+            <a:off x="5157216" y="4050791"/>
             <a:ext cx="1682496" cy="685800"/>
           </a:xfrm>
           <a:prstGeom prst="rect">
@@ -4161,13 +4430,13 @@
       </p:sp>
       <p:sp>
         <p:nvSpPr>
-          <p:cNvPr id="27" name="Rounded Rectangle 26"/>
+          <p:cNvPr id="33" name="Rounded Rectangle 32"/>
           <p:cNvSpPr/>
           <p:nvPr/>
         </p:nvSpPr>
         <p:spPr>
           <a:xfrm>
-            <a:off x="5157216" y="4910328"/>
+            <a:off x="5157216" y="4800600"/>
             <a:ext cx="1682496" cy="310896"/>
           </a:xfrm>
           <a:prstGeom prst="roundRect">
@@ -4207,13 +4476,13 @@
       </p:sp>
       <p:sp>
         <p:nvSpPr>
-          <p:cNvPr id="28" name="TextBox 27"/>
+          <p:cNvPr id="34" name="TextBox 33"/>
           <p:cNvSpPr txBox="1"/>
           <p:nvPr/>
         </p:nvSpPr>
         <p:spPr>
           <a:xfrm>
-            <a:off x="5230368" y="4965192"/>
+            <a:off x="5230368" y="4855464"/>
             <a:ext cx="1536192" cy="201168"/>
           </a:xfrm>
           <a:prstGeom prst="rect">
@@ -4235,7 +4504,7 @@
             <a:r>
               <a:rPr sz="850" b="0">
                 <a:solidFill>
-                  <a:srgbClr val="F6B544"/>
+                  <a:srgbClr val="06B6D4"/>
                 </a:solidFill>
                 <a:latin typeface="Microsoft YaHei"/>
               </a:rPr>
@@ -4244,15 +4513,107 @@
           </a:p>
         </p:txBody>
       </p:sp>
+      <p:sp>
+        <p:nvSpPr>
+          <p:cNvPr id="35" name="Rounded Rectangle 34"/>
+          <p:cNvSpPr/>
+          <p:nvPr/>
+        </p:nvSpPr>
+        <p:spPr>
+          <a:xfrm>
+            <a:off x="5157216" y="5221224"/>
+            <a:ext cx="1682496" cy="91440"/>
+          </a:xfrm>
+          <a:prstGeom prst="roundRect">
+            <a:avLst>
+              <a:gd name="adj" fmla="val 50000"/>
+            </a:avLst>
+          </a:prstGeom>
+          <a:solidFill>
+            <a:srgbClr val="2A3D5A"/>
+          </a:solidFill>
+          <a:ln>
+            <a:noFill/>
+          </a:ln>
+          <a:effectLst/>
+        </p:spPr>
+        <p:style>
+          <a:lnRef idx="1">
+            <a:schemeClr val="accent1"/>
+          </a:lnRef>
+          <a:fillRef idx="3">
+            <a:schemeClr val="accent1"/>
+          </a:fillRef>
+          <a:effectRef idx="2">
+            <a:schemeClr val="accent1"/>
+          </a:effectRef>
+          <a:fontRef idx="minor">
+            <a:schemeClr val="lt1"/>
+          </a:fontRef>
+        </p:style>
+        <p:txBody>
+          <a:bodyPr rtlCol="0" anchor="ctr"/>
+          <a:lstStyle/>
+          <a:p>
+            <a:pPr algn="ctr"/>
+          </a:p>
+        </p:txBody>
+      </p:sp>
+      <p:sp>
+        <p:nvSpPr>
+          <p:cNvPr id="36" name="Rounded Rectangle 35"/>
+          <p:cNvSpPr/>
+          <p:nvPr/>
+        </p:nvSpPr>
+        <p:spPr>
+          <a:xfrm>
+            <a:off x="5157216" y="5221224"/>
+            <a:ext cx="1514246" cy="91440"/>
+          </a:xfrm>
+          <a:prstGeom prst="roundRect">
+            <a:avLst>
+              <a:gd name="adj" fmla="val 50000"/>
+            </a:avLst>
+          </a:prstGeom>
+          <a:solidFill>
+            <a:srgbClr val="06B6D4"/>
+          </a:solidFill>
+          <a:ln>
+            <a:noFill/>
+          </a:ln>
+          <a:effectLst/>
+        </p:spPr>
+        <p:style>
+          <a:lnRef idx="1">
+            <a:schemeClr val="accent1"/>
+          </a:lnRef>
+          <a:fillRef idx="3">
+            <a:schemeClr val="accent1"/>
+          </a:fillRef>
+          <a:effectRef idx="2">
+            <a:schemeClr val="accent1"/>
+          </a:effectRef>
+          <a:fontRef idx="minor">
+            <a:schemeClr val="lt1"/>
+          </a:fontRef>
+        </p:style>
+        <p:txBody>
+          <a:bodyPr rtlCol="0" anchor="ctr"/>
+          <a:lstStyle/>
+          <a:p>
+            <a:pPr algn="ctr"/>
+          </a:p>
+        </p:txBody>
+      </p:sp>
       <p:cxnSp>
         <p:nvCxnSpPr>
-          <p:cNvPr id="29" name="Connector 28"/>
+          <p:cNvPr id="37" name="Connector 36"/>
           <p:cNvCxnSpPr/>
           <p:nvPr/>
         </p:nvCxnSpPr>
         <p:spPr>
           <a:xfrm>
-            <a:off x="7013448" y="4114800"/>
+            <a:off x="7013448" y="4096511"/>
             <a:ext cx="146304" cy="0"/>
           </a:xfrm>
           <a:prstGeom prst="line">
@@ -4282,14 +4643,14 @@
       </p:cxnSp>
       <p:sp>
         <p:nvSpPr>
-          <p:cNvPr id="30" name="Rounded Rectangle 29"/>
+          <p:cNvPr id="38" name="Rounded Rectangle 37"/>
           <p:cNvSpPr/>
           <p:nvPr/>
         </p:nvSpPr>
         <p:spPr>
           <a:xfrm>
-            <a:off x="7187184" y="2880360"/>
-            <a:ext cx="1975104" cy="2468880"/>
+            <a:off x="7187184" y="2788920"/>
+            <a:ext cx="1975104" cy="2615184"/>
           </a:xfrm>
           <a:prstGeom prst="roundRect">
             <a:avLst>
@@ -4330,13 +4691,13 @@
       </p:sp>
       <p:sp>
         <p:nvSpPr>
-          <p:cNvPr id="31" name="Rounded Rectangle 30"/>
+          <p:cNvPr id="39" name="Rounded Rectangle 38"/>
           <p:cNvSpPr/>
           <p:nvPr/>
         </p:nvSpPr>
         <p:spPr>
           <a:xfrm>
-            <a:off x="7351776" y="3044952"/>
+            <a:off x="7351776" y="2953512"/>
             <a:ext cx="493776" cy="493776"/>
           </a:xfrm>
           <a:prstGeom prst="roundRect">
@@ -4345,7 +4706,7 @@
             </a:avLst>
           </a:prstGeom>
           <a:solidFill>
-            <a:srgbClr val="F6B544"/>
+            <a:srgbClr val="F97A2E"/>
           </a:solidFill>
           <a:ln>
             <a:noFill/>
@@ -4384,13 +4745,13 @@
       </p:sp>
       <p:sp>
         <p:nvSpPr>
-          <p:cNvPr id="32" name="TextBox 31"/>
+          <p:cNvPr id="40" name="TextBox 39"/>
           <p:cNvSpPr txBox="1"/>
           <p:nvPr/>
         </p:nvSpPr>
         <p:spPr>
           <a:xfrm>
-            <a:off x="7333488" y="3721608"/>
+            <a:off x="7333488" y="3630168"/>
             <a:ext cx="1682496" cy="384048"/>
           </a:xfrm>
           <a:prstGeom prst="rect">
@@ -4423,13 +4784,13 @@
       </p:sp>
       <p:sp>
         <p:nvSpPr>
-          <p:cNvPr id="33" name="TextBox 32"/>
+          <p:cNvPr id="41" name="TextBox 40"/>
           <p:cNvSpPr txBox="1"/>
           <p:nvPr/>
         </p:nvSpPr>
         <p:spPr>
           <a:xfrm>
-            <a:off x="7333488" y="4160520"/>
+            <a:off x="7333488" y="4050791"/>
             <a:ext cx="1682496" cy="685800"/>
           </a:xfrm>
           <a:prstGeom prst="rect">
@@ -4462,13 +4823,13 @@
       </p:sp>
       <p:sp>
         <p:nvSpPr>
-          <p:cNvPr id="34" name="Rounded Rectangle 33"/>
+          <p:cNvPr id="42" name="Rounded Rectangle 41"/>
           <p:cNvSpPr/>
           <p:nvPr/>
         </p:nvSpPr>
         <p:spPr>
           <a:xfrm>
-            <a:off x="7333488" y="4910328"/>
+            <a:off x="7333488" y="4800600"/>
             <a:ext cx="1682496" cy="310896"/>
           </a:xfrm>
           <a:prstGeom prst="roundRect">
@@ -4508,13 +4869,13 @@
       </p:sp>
       <p:sp>
         <p:nvSpPr>
-          <p:cNvPr id="35" name="TextBox 34"/>
+          <p:cNvPr id="43" name="TextBox 42"/>
           <p:cNvSpPr txBox="1"/>
           <p:nvPr/>
         </p:nvSpPr>
         <p:spPr>
           <a:xfrm>
-            <a:off x="7406640" y="4965192"/>
+            <a:off x="7406640" y="4855464"/>
             <a:ext cx="1536192" cy="201168"/>
           </a:xfrm>
           <a:prstGeom prst="rect">
@@ -4536,7 +4897,7 @@
             <a:r>
               <a:rPr sz="850" b="0">
                 <a:solidFill>
-                  <a:srgbClr val="F6B544"/>
+                  <a:srgbClr val="F97A2E"/>
                 </a:solidFill>
                 <a:latin typeface="Microsoft YaHei"/>
               </a:rPr>
@@ -4545,15 +4906,107 @@
           </a:p>
         </p:txBody>
       </p:sp>
+      <p:sp>
+        <p:nvSpPr>
+          <p:cNvPr id="44" name="Rounded Rectangle 43"/>
+          <p:cNvSpPr/>
+          <p:nvPr/>
+        </p:nvSpPr>
+        <p:spPr>
+          <a:xfrm>
+            <a:off x="7333488" y="5221224"/>
+            <a:ext cx="1682496" cy="91440"/>
+          </a:xfrm>
+          <a:prstGeom prst="roundRect">
+            <a:avLst>
+              <a:gd name="adj" fmla="val 50000"/>
+            </a:avLst>
+          </a:prstGeom>
+          <a:solidFill>
+            <a:srgbClr val="2A3D5A"/>
+          </a:solidFill>
+          <a:ln>
+            <a:noFill/>
+          </a:ln>
+          <a:effectLst/>
+        </p:spPr>
+        <p:style>
+          <a:lnRef idx="1">
+            <a:schemeClr val="accent1"/>
+          </a:lnRef>
+          <a:fillRef idx="3">
+            <a:schemeClr val="accent1"/>
+          </a:fillRef>
+          <a:effectRef idx="2">
+            <a:schemeClr val="accent1"/>
+          </a:effectRef>
+          <a:fontRef idx="minor">
+            <a:schemeClr val="lt1"/>
+          </a:fontRef>
+        </p:style>
+        <p:txBody>
+          <a:bodyPr rtlCol="0" anchor="ctr"/>
+          <a:lstStyle/>
+          <a:p>
+            <a:pPr algn="ctr"/>
+          </a:p>
+        </p:txBody>
+      </p:sp>
+      <p:sp>
+        <p:nvSpPr>
+          <p:cNvPr id="45" name="Rounded Rectangle 44"/>
+          <p:cNvSpPr/>
+          <p:nvPr/>
+        </p:nvSpPr>
+        <p:spPr>
+          <a:xfrm>
+            <a:off x="7333488" y="5221224"/>
+            <a:ext cx="1261872" cy="91440"/>
+          </a:xfrm>
+          <a:prstGeom prst="roundRect">
+            <a:avLst>
+              <a:gd name="adj" fmla="val 50000"/>
+            </a:avLst>
+          </a:prstGeom>
+          <a:solidFill>
+            <a:srgbClr val="F97A2E"/>
+          </a:solidFill>
+          <a:ln>
+            <a:noFill/>
+          </a:ln>
+          <a:effectLst/>
+        </p:spPr>
+        <p:style>
+          <a:lnRef idx="1">
+            <a:schemeClr val="accent1"/>
+          </a:lnRef>
+          <a:fillRef idx="3">
+            <a:schemeClr val="accent1"/>
+          </a:fillRef>
+          <a:effectRef idx="2">
+            <a:schemeClr val="accent1"/>
+          </a:effectRef>
+          <a:fontRef idx="minor">
+            <a:schemeClr val="lt1"/>
+          </a:fontRef>
+        </p:style>
+        <p:txBody>
+          <a:bodyPr rtlCol="0" anchor="ctr"/>
+          <a:lstStyle/>
+          <a:p>
+            <a:pPr algn="ctr"/>
+          </a:p>
+        </p:txBody>
+      </p:sp>
       <p:cxnSp>
         <p:nvCxnSpPr>
-          <p:cNvPr id="36" name="Connector 35"/>
+          <p:cNvPr id="46" name="Connector 45"/>
           <p:cNvCxnSpPr/>
           <p:nvPr/>
         </p:nvCxnSpPr>
         <p:spPr>
           <a:xfrm>
-            <a:off x="9189719" y="4114800"/>
+            <a:off x="9189719" y="4096511"/>
             <a:ext cx="146305" cy="0"/>
           </a:xfrm>
           <a:prstGeom prst="line">
@@ -4583,14 +5036,14 @@
       </p:cxnSp>
       <p:sp>
         <p:nvSpPr>
-          <p:cNvPr id="37" name="Rounded Rectangle 36"/>
+          <p:cNvPr id="47" name="Rounded Rectangle 46"/>
           <p:cNvSpPr/>
           <p:nvPr/>
         </p:nvSpPr>
         <p:spPr>
           <a:xfrm>
-            <a:off x="9363456" y="2880360"/>
-            <a:ext cx="1975104" cy="2468880"/>
+            <a:off x="9363456" y="2788920"/>
+            <a:ext cx="1975104" cy="2615184"/>
           </a:xfrm>
           <a:prstGeom prst="roundRect">
             <a:avLst>
@@ -4631,13 +5084,13 @@
       </p:sp>
       <p:sp>
         <p:nvSpPr>
-          <p:cNvPr id="38" name="Rounded Rectangle 37"/>
+          <p:cNvPr id="48" name="Rounded Rectangle 47"/>
           <p:cNvSpPr/>
           <p:nvPr/>
         </p:nvSpPr>
         <p:spPr>
           <a:xfrm>
-            <a:off x="9528048" y="3044952"/>
+            <a:off x="9528048" y="2953512"/>
             <a:ext cx="493776" cy="493776"/>
           </a:xfrm>
           <a:prstGeom prst="roundRect">
@@ -4646,7 +5099,7 @@
             </a:avLst>
           </a:prstGeom>
           <a:solidFill>
-            <a:srgbClr val="F6B544"/>
+            <a:srgbClr val="10B981"/>
           </a:solidFill>
           <a:ln>
             <a:noFill/>
@@ -4685,13 +5138,13 @@
       </p:sp>
       <p:sp>
         <p:nvSpPr>
-          <p:cNvPr id="39" name="TextBox 38"/>
+          <p:cNvPr id="49" name="TextBox 48"/>
           <p:cNvSpPr txBox="1"/>
           <p:nvPr/>
         </p:nvSpPr>
         <p:spPr>
           <a:xfrm>
-            <a:off x="9509760" y="3721608"/>
+            <a:off x="9509760" y="3630168"/>
             <a:ext cx="1682496" cy="384048"/>
           </a:xfrm>
           <a:prstGeom prst="rect">
@@ -4724,13 +5177,13 @@
       </p:sp>
       <p:sp>
         <p:nvSpPr>
-          <p:cNvPr id="40" name="TextBox 39"/>
+          <p:cNvPr id="50" name="TextBox 49"/>
           <p:cNvSpPr txBox="1"/>
           <p:nvPr/>
         </p:nvSpPr>
         <p:spPr>
           <a:xfrm>
-            <a:off x="9509760" y="4160520"/>
+            <a:off x="9509760" y="4050791"/>
             <a:ext cx="1682496" cy="685800"/>
           </a:xfrm>
           <a:prstGeom prst="rect">
@@ -4763,13 +5216,13 @@
       </p:sp>
       <p:sp>
         <p:nvSpPr>
-          <p:cNvPr id="41" name="Rounded Rectangle 40"/>
+          <p:cNvPr id="51" name="Rounded Rectangle 50"/>
           <p:cNvSpPr/>
           <p:nvPr/>
         </p:nvSpPr>
         <p:spPr>
           <a:xfrm>
-            <a:off x="9509760" y="4910328"/>
+            <a:off x="9509760" y="4800600"/>
             <a:ext cx="1682496" cy="310896"/>
           </a:xfrm>
           <a:prstGeom prst="roundRect">
@@ -4809,13 +5262,13 @@
       </p:sp>
       <p:sp>
         <p:nvSpPr>
-          <p:cNvPr id="42" name="TextBox 41"/>
+          <p:cNvPr id="52" name="TextBox 51"/>
           <p:cNvSpPr txBox="1"/>
           <p:nvPr/>
         </p:nvSpPr>
         <p:spPr>
           <a:xfrm>
-            <a:off x="9582912" y="4965192"/>
+            <a:off x="9582912" y="4855464"/>
             <a:ext cx="1536192" cy="201168"/>
           </a:xfrm>
           <a:prstGeom prst="rect">
@@ -4837,7 +5290,7 @@
             <a:r>
               <a:rPr sz="850" b="0">
                 <a:solidFill>
-                  <a:srgbClr val="F6B544"/>
+                  <a:srgbClr val="10B981"/>
                 </a:solidFill>
                 <a:latin typeface="Microsoft YaHei"/>
               </a:rPr>
@@ -4848,7 +5301,99 @@
       </p:sp>
       <p:sp>
         <p:nvSpPr>
-          <p:cNvPr id="43" name="Rounded Rectangle 42"/>
+          <p:cNvPr id="53" name="Rounded Rectangle 52"/>
+          <p:cNvSpPr/>
+          <p:nvPr/>
+        </p:nvSpPr>
+        <p:spPr>
+          <a:xfrm>
+            <a:off x="9509760" y="5221224"/>
+            <a:ext cx="1682496" cy="91440"/>
+          </a:xfrm>
+          <a:prstGeom prst="roundRect">
+            <a:avLst>
+              <a:gd name="adj" fmla="val 50000"/>
+            </a:avLst>
+          </a:prstGeom>
+          <a:solidFill>
+            <a:srgbClr val="2A3D5A"/>
+          </a:solidFill>
+          <a:ln>
+            <a:noFill/>
+          </a:ln>
+          <a:effectLst/>
+        </p:spPr>
+        <p:style>
+          <a:lnRef idx="1">
+            <a:schemeClr val="accent1"/>
+          </a:lnRef>
+          <a:fillRef idx="3">
+            <a:schemeClr val="accent1"/>
+          </a:fillRef>
+          <a:effectRef idx="2">
+            <a:schemeClr val="accent1"/>
+          </a:effectRef>
+          <a:fontRef idx="minor">
+            <a:schemeClr val="lt1"/>
+          </a:fontRef>
+        </p:style>
+        <p:txBody>
+          <a:bodyPr rtlCol="0" anchor="ctr"/>
+          <a:lstStyle/>
+          <a:p>
+            <a:pPr algn="ctr"/>
+          </a:p>
+        </p:txBody>
+      </p:sp>
+      <p:sp>
+        <p:nvSpPr>
+          <p:cNvPr id="54" name="Rounded Rectangle 53"/>
+          <p:cNvSpPr/>
+          <p:nvPr/>
+        </p:nvSpPr>
+        <p:spPr>
+          <a:xfrm>
+            <a:off x="9509760" y="5221224"/>
+            <a:ext cx="1009497" cy="91440"/>
+          </a:xfrm>
+          <a:prstGeom prst="roundRect">
+            <a:avLst>
+              <a:gd name="adj" fmla="val 50000"/>
+            </a:avLst>
+          </a:prstGeom>
+          <a:solidFill>
+            <a:srgbClr val="10B981"/>
+          </a:solidFill>
+          <a:ln>
+            <a:noFill/>
+          </a:ln>
+          <a:effectLst/>
+        </p:spPr>
+        <p:style>
+          <a:lnRef idx="1">
+            <a:schemeClr val="accent1"/>
+          </a:lnRef>
+          <a:fillRef idx="3">
+            <a:schemeClr val="accent1"/>
+          </a:fillRef>
+          <a:effectRef idx="2">
+            <a:schemeClr val="accent1"/>
+          </a:effectRef>
+          <a:fontRef idx="minor">
+            <a:schemeClr val="lt1"/>
+          </a:fontRef>
+        </p:style>
+        <p:txBody>
+          <a:bodyPr rtlCol="0" anchor="ctr"/>
+          <a:lstStyle/>
+          <a:p>
+            <a:pPr algn="ctr"/>
+          </a:p>
+        </p:txBody>
+      </p:sp>
+      <p:sp>
+        <p:nvSpPr>
+          <p:cNvPr id="55" name="Rounded Rectangle 54"/>
           <p:cNvSpPr/>
           <p:nvPr/>
         </p:nvSpPr>
@@ -4896,7 +5441,7 @@
       </p:sp>
       <p:sp>
         <p:nvSpPr>
-          <p:cNvPr id="44" name="TextBox 43"/>
+          <p:cNvPr id="56" name="TextBox 55"/>
           <p:cNvSpPr txBox="1"/>
           <p:nvPr/>
         </p:nvSpPr>
@@ -5173,175 +5718,12 @@
         </p:nvSpPr>
         <p:spPr>
           <a:xfrm>
-            <a:off x="9646920" y="173736"/>
-            <a:ext cx="2057400" cy="384048"/>
+            <a:off x="8275320" y="173736"/>
+            <a:ext cx="1234440" cy="384048"/>
           </a:xfrm>
           <a:prstGeom prst="roundRect">
             <a:avLst>
               <a:gd name="adj" fmla="val 50000"/>
-            </a:avLst>
-          </a:prstGeom>
-          <a:solidFill>
-            <a:srgbClr val="3B82F6"/>
-          </a:solidFill>
-          <a:ln>
-            <a:noFill/>
-          </a:ln>
-          <a:effectLst/>
-        </p:spPr>
-        <p:style>
-          <a:lnRef idx="1">
-            <a:schemeClr val="accent1"/>
-          </a:lnRef>
-          <a:fillRef idx="3">
-            <a:schemeClr val="accent1"/>
-          </a:fillRef>
-          <a:effectRef idx="2">
-            <a:schemeClr val="accent1"/>
-          </a:effectRef>
-          <a:fontRef idx="minor">
-            <a:schemeClr val="lt1"/>
-          </a:fontRef>
-        </p:style>
-        <p:txBody>
-          <a:bodyPr rtlCol="0" anchor="ctr"/>
-          <a:lstStyle/>
-          <a:p>
-            <a:pPr algn="ctr"/>
-          </a:p>
-        </p:txBody>
-      </p:sp>
-      <p:sp>
-        <p:nvSpPr>
-          <p:cNvPr id="8" name="TextBox 7"/>
-          <p:cNvSpPr txBox="1"/>
-          <p:nvPr/>
-        </p:nvSpPr>
-        <p:spPr>
-          <a:xfrm>
-            <a:off x="9646920" y="237744"/>
-            <a:ext cx="2057400" cy="274320"/>
-          </a:xfrm>
-          <a:prstGeom prst="rect">
-            <a:avLst/>
-          </a:prstGeom>
-          <a:noFill/>
-        </p:spPr>
-        <p:txBody>
-          <a:bodyPr wrap="square" anchor="t">
-            <a:spAutoFit/>
-          </a:bodyPr>
-          <a:lstStyle/>
-          <a:p>
-            <a:pPr algn="ctr">
-              <a:lnSpc>
-                <a:spcPct val="100000"/>
-              </a:lnSpc>
-            </a:pPr>
-            <a:r>
-              <a:rPr sz="1150" b="1">
-                <a:solidFill>
-                  <a:srgbClr val="FFFFFF"/>
-                </a:solidFill>
-                <a:latin typeface="Microsoft YaHei"/>
-              </a:rPr>
-              <a:t>＋ 新建任务</a:t>
-            </a:r>
-          </a:p>
-        </p:txBody>
-      </p:sp>
-      <p:sp>
-        <p:nvSpPr>
-          <p:cNvPr id="9" name="TextBox 8"/>
-          <p:cNvSpPr txBox="1"/>
-          <p:nvPr/>
-        </p:nvSpPr>
-        <p:spPr>
-          <a:xfrm>
-            <a:off x="685800" y="896112"/>
-            <a:ext cx="10789920" cy="475488"/>
-          </a:xfrm>
-          <a:prstGeom prst="rect">
-            <a:avLst/>
-          </a:prstGeom>
-          <a:noFill/>
-        </p:spPr>
-        <p:txBody>
-          <a:bodyPr wrap="square" anchor="t">
-            <a:spAutoFit/>
-          </a:bodyPr>
-          <a:lstStyle/>
-          <a:p>
-            <a:pPr algn="l">
-              <a:lnSpc>
-                <a:spcPct val="100000"/>
-              </a:lnSpc>
-            </a:pPr>
-            <a:r>
-              <a:rPr sz="2500" b="1">
-                <a:solidFill>
-                  <a:srgbClr val="222A35"/>
-                </a:solidFill>
-                <a:latin typeface="Microsoft YaHei"/>
-              </a:rPr>
-              <a:t>工作台 · 四阶段运行视图</a:t>
-            </a:r>
-          </a:p>
-        </p:txBody>
-      </p:sp>
-      <p:sp>
-        <p:nvSpPr>
-          <p:cNvPr id="10" name="TextBox 9"/>
-          <p:cNvSpPr txBox="1"/>
-          <p:nvPr/>
-        </p:nvSpPr>
-        <p:spPr>
-          <a:xfrm>
-            <a:off x="685800" y="1353312"/>
-            <a:ext cx="10789920" cy="347472"/>
-          </a:xfrm>
-          <a:prstGeom prst="rect">
-            <a:avLst/>
-          </a:prstGeom>
-          <a:noFill/>
-        </p:spPr>
-        <p:txBody>
-          <a:bodyPr wrap="square" anchor="t">
-            <a:spAutoFit/>
-          </a:bodyPr>
-          <a:lstStyle/>
-          <a:p>
-            <a:pPr algn="l">
-              <a:lnSpc>
-                <a:spcPct val="100000"/>
-              </a:lnSpc>
-            </a:pPr>
-            <a:r>
-              <a:rPr sz="1250" b="0">
-                <a:solidFill>
-                  <a:srgbClr val="66707D"/>
-                </a:solidFill>
-                <a:latin typeface="Microsoft YaHei"/>
-              </a:rPr>
-              <a:t>复杂任务被拆解为可验证阶段，状态、指标与证据实时可见</a:t>
-            </a:r>
-          </a:p>
-        </p:txBody>
-      </p:sp>
-      <p:sp>
-        <p:nvSpPr>
-          <p:cNvPr id="11" name="Rounded Rectangle 10"/>
-          <p:cNvSpPr/>
-          <p:nvPr/>
-        </p:nvSpPr>
-        <p:spPr>
-          <a:xfrm>
-            <a:off x="685800" y="1810512"/>
-            <a:ext cx="2615184" cy="804672"/>
-          </a:xfrm>
-          <a:prstGeom prst="roundRect">
-            <a:avLst>
-              <a:gd name="adj" fmla="val 10000"/>
             </a:avLst>
           </a:prstGeom>
           <a:solidFill>
@@ -5378,17 +5760,58 @@
       </p:sp>
       <p:sp>
         <p:nvSpPr>
-          <p:cNvPr id="12" name="Rectangle 11"/>
-          <p:cNvSpPr/>
-          <p:nvPr/>
-        </p:nvSpPr>
-        <p:spPr>
-          <a:xfrm>
-            <a:off x="685800" y="1810512"/>
-            <a:ext cx="73152" cy="804672"/>
+          <p:cNvPr id="8" name="TextBox 7"/>
+          <p:cNvSpPr txBox="1"/>
+          <p:nvPr/>
+        </p:nvSpPr>
+        <p:spPr>
+          <a:xfrm>
+            <a:off x="8275320" y="246888"/>
+            <a:ext cx="1234440" cy="237744"/>
           </a:xfrm>
           <a:prstGeom prst="rect">
             <a:avLst/>
+          </a:prstGeom>
+          <a:noFill/>
+        </p:spPr>
+        <p:txBody>
+          <a:bodyPr wrap="square" anchor="t">
+            <a:spAutoFit/>
+          </a:bodyPr>
+          <a:lstStyle/>
+          <a:p>
+            <a:pPr algn="ctr">
+              <a:lnSpc>
+                <a:spcPct val="100000"/>
+              </a:lnSpc>
+            </a:pPr>
+            <a:r>
+              <a:rPr sz="1050" b="0">
+                <a:solidFill>
+                  <a:srgbClr val="66707D"/>
+                </a:solidFill>
+                <a:latin typeface="Microsoft YaHei"/>
+              </a:rPr>
+              <a:t>帮助文档</a:t>
+            </a:r>
+          </a:p>
+        </p:txBody>
+      </p:sp>
+      <p:sp>
+        <p:nvSpPr>
+          <p:cNvPr id="9" name="Rounded Rectangle 8"/>
+          <p:cNvSpPr/>
+          <p:nvPr/>
+        </p:nvSpPr>
+        <p:spPr>
+          <a:xfrm>
+            <a:off x="9646920" y="173736"/>
+            <a:ext cx="2057400" cy="384048"/>
+          </a:xfrm>
+          <a:prstGeom prst="roundRect">
+            <a:avLst>
+              <a:gd name="adj" fmla="val 50000"/>
+            </a:avLst>
           </a:prstGeom>
           <a:solidFill>
             <a:srgbClr val="3B82F6"/>
@@ -5422,14 +5845,53 @@
       </p:sp>
       <p:sp>
         <p:nvSpPr>
-          <p:cNvPr id="13" name="TextBox 12"/>
+          <p:cNvPr id="10" name="TextBox 9"/>
           <p:cNvSpPr txBox="1"/>
           <p:nvPr/>
         </p:nvSpPr>
         <p:spPr>
           <a:xfrm>
-            <a:off x="886968" y="1901952"/>
-            <a:ext cx="2249424" cy="310896"/>
+            <a:off x="9646920" y="237744"/>
+            <a:ext cx="2057400" cy="274320"/>
+          </a:xfrm>
+          <a:prstGeom prst="rect">
+            <a:avLst/>
+          </a:prstGeom>
+          <a:noFill/>
+        </p:spPr>
+        <p:txBody>
+          <a:bodyPr wrap="square" anchor="t">
+            <a:spAutoFit/>
+          </a:bodyPr>
+          <a:lstStyle/>
+          <a:p>
+            <a:pPr algn="ctr">
+              <a:lnSpc>
+                <a:spcPct val="100000"/>
+              </a:lnSpc>
+            </a:pPr>
+            <a:r>
+              <a:rPr sz="1150" b="1">
+                <a:solidFill>
+                  <a:srgbClr val="FFFFFF"/>
+                </a:solidFill>
+                <a:latin typeface="Microsoft YaHei"/>
+              </a:rPr>
+              <a:t>＋ 新建任务</a:t>
+            </a:r>
+          </a:p>
+        </p:txBody>
+      </p:sp>
+      <p:sp>
+        <p:nvSpPr>
+          <p:cNvPr id="11" name="TextBox 10"/>
+          <p:cNvSpPr txBox="1"/>
+          <p:nvPr/>
+        </p:nvSpPr>
+        <p:spPr>
+          <a:xfrm>
+            <a:off x="685800" y="896112"/>
+            <a:ext cx="10789920" cy="475488"/>
           </a:xfrm>
           <a:prstGeom prst="rect">
             <a:avLst/>
@@ -5448,27 +5910,27 @@
               </a:lnSpc>
             </a:pPr>
             <a:r>
-              <a:rPr sz="1900" b="1">
+              <a:rPr sz="2500" b="1">
                 <a:solidFill>
                   <a:srgbClr val="222A35"/>
                 </a:solidFill>
                 <a:latin typeface="Microsoft YaHei"/>
               </a:rPr>
-              <a:t>1.2s</a:t>
-            </a:r>
-          </a:p>
-        </p:txBody>
-      </p:sp>
-      <p:sp>
-        <p:nvSpPr>
-          <p:cNvPr id="14" name="TextBox 13"/>
+              <a:t>工作台 · 四阶段运行视图</a:t>
+            </a:r>
+          </a:p>
+        </p:txBody>
+      </p:sp>
+      <p:sp>
+        <p:nvSpPr>
+          <p:cNvPr id="12" name="TextBox 11"/>
           <p:cNvSpPr txBox="1"/>
           <p:nvPr/>
         </p:nvSpPr>
         <p:spPr>
           <a:xfrm>
-            <a:off x="886968" y="2267712"/>
-            <a:ext cx="2249424" cy="237744"/>
+            <a:off x="685800" y="1353312"/>
+            <a:ext cx="10789920" cy="347472"/>
           </a:xfrm>
           <a:prstGeom prst="rect">
             <a:avLst/>
@@ -5487,26 +5949,26 @@
               </a:lnSpc>
             </a:pPr>
             <a:r>
-              <a:rPr sz="1000" b="0">
+              <a:rPr sz="1250" b="0">
                 <a:solidFill>
                   <a:srgbClr val="66707D"/>
                 </a:solidFill>
                 <a:latin typeface="Microsoft YaHei"/>
               </a:rPr>
-              <a:t>平均响应</a:t>
-            </a:r>
-          </a:p>
-        </p:txBody>
-      </p:sp>
-      <p:sp>
-        <p:nvSpPr>
-          <p:cNvPr id="15" name="Rounded Rectangle 14"/>
+              <a:t>复杂任务被拆解为可验证阶段，状态、指标与证据实时可见</a:t>
+            </a:r>
+          </a:p>
+        </p:txBody>
+      </p:sp>
+      <p:sp>
+        <p:nvSpPr>
+          <p:cNvPr id="13" name="Rounded Rectangle 12"/>
           <p:cNvSpPr/>
           <p:nvPr/>
         </p:nvSpPr>
         <p:spPr>
           <a:xfrm>
-            <a:off x="3502152" y="1810512"/>
+            <a:off x="685800" y="1810512"/>
             <a:ext cx="2615184" cy="804672"/>
           </a:xfrm>
           <a:prstGeom prst="roundRect">
@@ -5548,20 +6010,20 @@
       </p:sp>
       <p:sp>
         <p:nvSpPr>
-          <p:cNvPr id="16" name="Rectangle 15"/>
+          <p:cNvPr id="14" name="Rectangle 13"/>
           <p:cNvSpPr/>
           <p:nvPr/>
         </p:nvSpPr>
         <p:spPr>
           <a:xfrm>
-            <a:off x="3502152" y="1810512"/>
+            <a:off x="685800" y="1810512"/>
             <a:ext cx="73152" cy="804672"/>
           </a:xfrm>
           <a:prstGeom prst="rect">
             <a:avLst/>
           </a:prstGeom>
           <a:solidFill>
-            <a:srgbClr val="10B981"/>
+            <a:srgbClr val="3B82F6"/>
           </a:solidFill>
           <a:ln>
             <a:noFill/>
@@ -5592,13 +6054,13 @@
       </p:sp>
       <p:sp>
         <p:nvSpPr>
-          <p:cNvPr id="17" name="TextBox 16"/>
+          <p:cNvPr id="15" name="TextBox 14"/>
           <p:cNvSpPr txBox="1"/>
           <p:nvPr/>
         </p:nvSpPr>
         <p:spPr>
           <a:xfrm>
-            <a:off x="3703320" y="1901952"/>
+            <a:off x="886968" y="1901952"/>
             <a:ext cx="2249424" cy="310896"/>
           </a:xfrm>
           <a:prstGeom prst="rect">
@@ -5624,20 +6086,20 @@
                 </a:solidFill>
                 <a:latin typeface="Microsoft YaHei"/>
               </a:rPr>
-              <a:t>98.2%</a:t>
-            </a:r>
-          </a:p>
-        </p:txBody>
-      </p:sp>
-      <p:sp>
-        <p:nvSpPr>
-          <p:cNvPr id="18" name="TextBox 17"/>
+              <a:t>1.2s</a:t>
+            </a:r>
+          </a:p>
+        </p:txBody>
+      </p:sp>
+      <p:sp>
+        <p:nvSpPr>
+          <p:cNvPr id="16" name="TextBox 15"/>
           <p:cNvSpPr txBox="1"/>
           <p:nvPr/>
         </p:nvSpPr>
         <p:spPr>
           <a:xfrm>
-            <a:off x="3703320" y="2267712"/>
+            <a:off x="886968" y="2267712"/>
             <a:ext cx="2249424" cy="237744"/>
           </a:xfrm>
           <a:prstGeom prst="rect">
@@ -5663,20 +6125,20 @@
                 </a:solidFill>
                 <a:latin typeface="Microsoft YaHei"/>
               </a:rPr>
-              <a:t>任务完成率</a:t>
-            </a:r>
-          </a:p>
-        </p:txBody>
-      </p:sp>
-      <p:sp>
-        <p:nvSpPr>
-          <p:cNvPr id="19" name="Rounded Rectangle 18"/>
+              <a:t>平均响应</a:t>
+            </a:r>
+          </a:p>
+        </p:txBody>
+      </p:sp>
+      <p:sp>
+        <p:nvSpPr>
+          <p:cNvPr id="17" name="Rounded Rectangle 16"/>
           <p:cNvSpPr/>
           <p:nvPr/>
         </p:nvSpPr>
         <p:spPr>
           <a:xfrm>
-            <a:off x="6318504" y="1810512"/>
+            <a:off x="3502152" y="1810512"/>
             <a:ext cx="2615184" cy="804672"/>
           </a:xfrm>
           <a:prstGeom prst="roundRect">
@@ -5718,20 +6180,20 @@
       </p:sp>
       <p:sp>
         <p:nvSpPr>
-          <p:cNvPr id="20" name="Rectangle 19"/>
+          <p:cNvPr id="18" name="Rectangle 17"/>
           <p:cNvSpPr/>
           <p:nvPr/>
         </p:nvSpPr>
         <p:spPr>
           <a:xfrm>
-            <a:off x="6318504" y="1810512"/>
+            <a:off x="3502152" y="1810512"/>
             <a:ext cx="73152" cy="804672"/>
           </a:xfrm>
           <a:prstGeom prst="rect">
             <a:avLst/>
           </a:prstGeom>
           <a:solidFill>
-            <a:srgbClr val="F97A2E"/>
+            <a:srgbClr val="10B981"/>
           </a:solidFill>
           <a:ln>
             <a:noFill/>
@@ -5762,13 +6224,13 @@
       </p:sp>
       <p:sp>
         <p:nvSpPr>
-          <p:cNvPr id="21" name="TextBox 20"/>
+          <p:cNvPr id="19" name="TextBox 18"/>
           <p:cNvSpPr txBox="1"/>
           <p:nvPr/>
         </p:nvSpPr>
         <p:spPr>
           <a:xfrm>
-            <a:off x="6519672" y="1901952"/>
+            <a:off x="3703320" y="1901952"/>
             <a:ext cx="2249424" cy="310896"/>
           </a:xfrm>
           <a:prstGeom prst="rect">
@@ -5794,20 +6256,20 @@
                 </a:solidFill>
                 <a:latin typeface="Microsoft YaHei"/>
               </a:rPr>
-              <a:t>99.7%</a:t>
-            </a:r>
-          </a:p>
-        </p:txBody>
-      </p:sp>
-      <p:sp>
-        <p:nvSpPr>
-          <p:cNvPr id="22" name="TextBox 21"/>
+              <a:t>98.2%</a:t>
+            </a:r>
+          </a:p>
+        </p:txBody>
+      </p:sp>
+      <p:sp>
+        <p:nvSpPr>
+          <p:cNvPr id="20" name="TextBox 19"/>
           <p:cNvSpPr txBox="1"/>
           <p:nvPr/>
         </p:nvSpPr>
         <p:spPr>
           <a:xfrm>
-            <a:off x="6519672" y="2267712"/>
+            <a:off x="3703320" y="2267712"/>
             <a:ext cx="2249424" cy="237744"/>
           </a:xfrm>
           <a:prstGeom prst="rect">
@@ -5833,20 +6295,20 @@
                 </a:solidFill>
                 <a:latin typeface="Microsoft YaHei"/>
               </a:rPr>
-              <a:t>工具调用成功率</a:t>
-            </a:r>
-          </a:p>
-        </p:txBody>
-      </p:sp>
-      <p:sp>
-        <p:nvSpPr>
-          <p:cNvPr id="23" name="Rounded Rectangle 22"/>
+              <a:t>任务完成率</a:t>
+            </a:r>
+          </a:p>
+        </p:txBody>
+      </p:sp>
+      <p:sp>
+        <p:nvSpPr>
+          <p:cNvPr id="21" name="Rounded Rectangle 20"/>
           <p:cNvSpPr/>
           <p:nvPr/>
         </p:nvSpPr>
         <p:spPr>
           <a:xfrm>
-            <a:off x="9134856" y="1810512"/>
+            <a:off x="6318504" y="1810512"/>
             <a:ext cx="2615184" cy="804672"/>
           </a:xfrm>
           <a:prstGeom prst="roundRect">
@@ -5888,20 +6350,20 @@
       </p:sp>
       <p:sp>
         <p:nvSpPr>
-          <p:cNvPr id="24" name="Rectangle 23"/>
+          <p:cNvPr id="22" name="Rectangle 21"/>
           <p:cNvSpPr/>
           <p:nvPr/>
         </p:nvSpPr>
         <p:spPr>
           <a:xfrm>
-            <a:off x="9134856" y="1810512"/>
+            <a:off x="6318504" y="1810512"/>
             <a:ext cx="73152" cy="804672"/>
           </a:xfrm>
           <a:prstGeom prst="rect">
             <a:avLst/>
           </a:prstGeom>
           <a:solidFill>
-            <a:srgbClr val="8B5CF6"/>
+            <a:srgbClr val="F97A2E"/>
           </a:solidFill>
           <a:ln>
             <a:noFill/>
@@ -5932,13 +6394,13 @@
       </p:sp>
       <p:sp>
         <p:nvSpPr>
-          <p:cNvPr id="25" name="TextBox 24"/>
+          <p:cNvPr id="23" name="TextBox 22"/>
           <p:cNvSpPr txBox="1"/>
           <p:nvPr/>
         </p:nvSpPr>
         <p:spPr>
           <a:xfrm>
-            <a:off x="9336024" y="1901952"/>
+            <a:off x="6519672" y="1901952"/>
             <a:ext cx="2249424" cy="310896"/>
           </a:xfrm>
           <a:prstGeom prst="rect">
@@ -5964,20 +6426,20 @@
                 </a:solidFill>
                 <a:latin typeface="Microsoft YaHei"/>
               </a:rPr>
-              <a:t>100%</a:t>
-            </a:r>
-          </a:p>
-        </p:txBody>
-      </p:sp>
-      <p:sp>
-        <p:nvSpPr>
-          <p:cNvPr id="26" name="TextBox 25"/>
+              <a:t>99.7%</a:t>
+            </a:r>
+          </a:p>
+        </p:txBody>
+      </p:sp>
+      <p:sp>
+        <p:nvSpPr>
+          <p:cNvPr id="24" name="TextBox 23"/>
           <p:cNvSpPr txBox="1"/>
           <p:nvPr/>
         </p:nvSpPr>
         <p:spPr>
           <a:xfrm>
-            <a:off x="9336024" y="2267712"/>
+            <a:off x="6519672" y="2267712"/>
             <a:ext cx="2249424" cy="237744"/>
           </a:xfrm>
           <a:prstGeom prst="rect">
@@ -6003,25 +6465,25 @@
                 </a:solidFill>
                 <a:latin typeface="Microsoft YaHei"/>
               </a:rPr>
-              <a:t>证据覆盖率</a:t>
-            </a:r>
-          </a:p>
-        </p:txBody>
-      </p:sp>
-      <p:sp>
-        <p:nvSpPr>
-          <p:cNvPr id="27" name="Rounded Rectangle 26"/>
+              <a:t>工具调用成功率</a:t>
+            </a:r>
+          </a:p>
+        </p:txBody>
+      </p:sp>
+      <p:sp>
+        <p:nvSpPr>
+          <p:cNvPr id="25" name="Rounded Rectangle 24"/>
           <p:cNvSpPr/>
           <p:nvPr/>
         </p:nvSpPr>
         <p:spPr>
           <a:xfrm>
-            <a:off x="685800" y="2761488"/>
-            <a:ext cx="5212080" cy="2267712"/>
+            <a:off x="9134856" y="1810512"/>
+            <a:ext cx="2615184" cy="804672"/>
           </a:xfrm>
           <a:prstGeom prst="roundRect">
             <a:avLst>
-              <a:gd name="adj" fmla="val 6000"/>
+              <a:gd name="adj" fmla="val 10000"/>
             </a:avLst>
           </a:prstGeom>
           <a:solidFill>
@@ -6058,7 +6520,177 @@
       </p:sp>
       <p:sp>
         <p:nvSpPr>
-          <p:cNvPr id="28" name="Rectangle 27"/>
+          <p:cNvPr id="26" name="Rectangle 25"/>
+          <p:cNvSpPr/>
+          <p:nvPr/>
+        </p:nvSpPr>
+        <p:spPr>
+          <a:xfrm>
+            <a:off x="9134856" y="1810512"/>
+            <a:ext cx="73152" cy="804672"/>
+          </a:xfrm>
+          <a:prstGeom prst="rect">
+            <a:avLst/>
+          </a:prstGeom>
+          <a:solidFill>
+            <a:srgbClr val="8B5CF6"/>
+          </a:solidFill>
+          <a:ln>
+            <a:noFill/>
+          </a:ln>
+          <a:effectLst/>
+        </p:spPr>
+        <p:style>
+          <a:lnRef idx="1">
+            <a:schemeClr val="accent1"/>
+          </a:lnRef>
+          <a:fillRef idx="3">
+            <a:schemeClr val="accent1"/>
+          </a:fillRef>
+          <a:effectRef idx="2">
+            <a:schemeClr val="accent1"/>
+          </a:effectRef>
+          <a:fontRef idx="minor">
+            <a:schemeClr val="lt1"/>
+          </a:fontRef>
+        </p:style>
+        <p:txBody>
+          <a:bodyPr rtlCol="0" anchor="ctr"/>
+          <a:lstStyle/>
+          <a:p>
+            <a:pPr algn="ctr"/>
+          </a:p>
+        </p:txBody>
+      </p:sp>
+      <p:sp>
+        <p:nvSpPr>
+          <p:cNvPr id="27" name="TextBox 26"/>
+          <p:cNvSpPr txBox="1"/>
+          <p:nvPr/>
+        </p:nvSpPr>
+        <p:spPr>
+          <a:xfrm>
+            <a:off x="9336024" y="1901952"/>
+            <a:ext cx="2249424" cy="310896"/>
+          </a:xfrm>
+          <a:prstGeom prst="rect">
+            <a:avLst/>
+          </a:prstGeom>
+          <a:noFill/>
+        </p:spPr>
+        <p:txBody>
+          <a:bodyPr wrap="square" anchor="t">
+            <a:spAutoFit/>
+          </a:bodyPr>
+          <a:lstStyle/>
+          <a:p>
+            <a:pPr algn="l">
+              <a:lnSpc>
+                <a:spcPct val="100000"/>
+              </a:lnSpc>
+            </a:pPr>
+            <a:r>
+              <a:rPr sz="1900" b="1">
+                <a:solidFill>
+                  <a:srgbClr val="222A35"/>
+                </a:solidFill>
+                <a:latin typeface="Microsoft YaHei"/>
+              </a:rPr>
+              <a:t>100%</a:t>
+            </a:r>
+          </a:p>
+        </p:txBody>
+      </p:sp>
+      <p:sp>
+        <p:nvSpPr>
+          <p:cNvPr id="28" name="TextBox 27"/>
+          <p:cNvSpPr txBox="1"/>
+          <p:nvPr/>
+        </p:nvSpPr>
+        <p:spPr>
+          <a:xfrm>
+            <a:off x="9336024" y="2267712"/>
+            <a:ext cx="2249424" cy="237744"/>
+          </a:xfrm>
+          <a:prstGeom prst="rect">
+            <a:avLst/>
+          </a:prstGeom>
+          <a:noFill/>
+        </p:spPr>
+        <p:txBody>
+          <a:bodyPr wrap="square" anchor="t">
+            <a:spAutoFit/>
+          </a:bodyPr>
+          <a:lstStyle/>
+          <a:p>
+            <a:pPr algn="l">
+              <a:lnSpc>
+                <a:spcPct val="100000"/>
+              </a:lnSpc>
+            </a:pPr>
+            <a:r>
+              <a:rPr sz="1000" b="0">
+                <a:solidFill>
+                  <a:srgbClr val="66707D"/>
+                </a:solidFill>
+                <a:latin typeface="Microsoft YaHei"/>
+              </a:rPr>
+              <a:t>证据覆盖率</a:t>
+            </a:r>
+          </a:p>
+        </p:txBody>
+      </p:sp>
+      <p:sp>
+        <p:nvSpPr>
+          <p:cNvPr id="29" name="Rounded Rectangle 28"/>
+          <p:cNvSpPr/>
+          <p:nvPr/>
+        </p:nvSpPr>
+        <p:spPr>
+          <a:xfrm>
+            <a:off x="685800" y="2761488"/>
+            <a:ext cx="5212080" cy="2267712"/>
+          </a:xfrm>
+          <a:prstGeom prst="roundRect">
+            <a:avLst>
+              <a:gd name="adj" fmla="val 6000"/>
+            </a:avLst>
+          </a:prstGeom>
+          <a:solidFill>
+            <a:srgbClr val="FFFFFF"/>
+          </a:solidFill>
+          <a:ln w="9525">
+            <a:solidFill>
+              <a:srgbClr val="DFE5EC"/>
+            </a:solidFill>
+          </a:ln>
+          <a:effectLst/>
+        </p:spPr>
+        <p:style>
+          <a:lnRef idx="1">
+            <a:schemeClr val="accent1"/>
+          </a:lnRef>
+          <a:fillRef idx="3">
+            <a:schemeClr val="accent1"/>
+          </a:fillRef>
+          <a:effectRef idx="2">
+            <a:schemeClr val="accent1"/>
+          </a:effectRef>
+          <a:fontRef idx="minor">
+            <a:schemeClr val="lt1"/>
+          </a:fontRef>
+        </p:style>
+        <p:txBody>
+          <a:bodyPr rtlCol="0" anchor="ctr"/>
+          <a:lstStyle/>
+          <a:p>
+            <a:pPr algn="ctr"/>
+          </a:p>
+        </p:txBody>
+      </p:sp>
+      <p:sp>
+        <p:nvSpPr>
+          <p:cNvPr id="30" name="Rectangle 29"/>
           <p:cNvSpPr/>
           <p:nvPr/>
         </p:nvSpPr>
@@ -6102,7 +6734,7 @@
       </p:sp>
       <p:sp>
         <p:nvSpPr>
-          <p:cNvPr id="29" name="Rounded Rectangle 28"/>
+          <p:cNvPr id="31" name="Rounded Rectangle 30"/>
           <p:cNvSpPr/>
           <p:nvPr/>
         </p:nvSpPr>
@@ -6148,7 +6780,7 @@
       </p:sp>
       <p:sp>
         <p:nvSpPr>
-          <p:cNvPr id="30" name="TextBox 29"/>
+          <p:cNvPr id="32" name="TextBox 31"/>
           <p:cNvSpPr txBox="1"/>
           <p:nvPr/>
         </p:nvSpPr>
@@ -6187,7 +6819,7 @@
       </p:sp>
       <p:sp>
         <p:nvSpPr>
-          <p:cNvPr id="31" name="TextBox 30"/>
+          <p:cNvPr id="33" name="TextBox 32"/>
           <p:cNvSpPr txBox="1"/>
           <p:nvPr/>
         </p:nvSpPr>
@@ -6226,7 +6858,7 @@
       </p:sp>
       <p:sp>
         <p:nvSpPr>
-          <p:cNvPr id="32" name="Rounded Rectangle 31"/>
+          <p:cNvPr id="34" name="Rounded Rectangle 33"/>
           <p:cNvSpPr/>
           <p:nvPr/>
         </p:nvSpPr>
@@ -6272,7 +6904,7 @@
       </p:sp>
       <p:sp>
         <p:nvSpPr>
-          <p:cNvPr id="33" name="TextBox 32"/>
+          <p:cNvPr id="35" name="TextBox 34"/>
           <p:cNvSpPr txBox="1"/>
           <p:nvPr/>
         </p:nvSpPr>
@@ -6311,13 +6943,13 @@
       </p:sp>
       <p:sp>
         <p:nvSpPr>
-          <p:cNvPr id="34" name="TextBox 33"/>
+          <p:cNvPr id="36" name="TextBox 35"/>
           <p:cNvSpPr txBox="1"/>
           <p:nvPr/>
         </p:nvSpPr>
         <p:spPr>
           <a:xfrm>
-            <a:off x="978408" y="3639312"/>
+            <a:off x="978408" y="3621024"/>
             <a:ext cx="4626864" cy="530352"/>
           </a:xfrm>
           <a:prstGeom prst="rect">
@@ -6350,13 +6982,13 @@
       </p:sp>
       <p:sp>
         <p:nvSpPr>
-          <p:cNvPr id="35" name="TextBox 34"/>
+          <p:cNvPr id="37" name="TextBox 36"/>
           <p:cNvSpPr txBox="1"/>
           <p:nvPr/>
         </p:nvSpPr>
         <p:spPr>
           <a:xfrm>
-            <a:off x="978408" y="4187952"/>
+            <a:off x="978408" y="4169664"/>
             <a:ext cx="4023360" cy="640080"/>
           </a:xfrm>
           <a:prstGeom prst="rect">
@@ -6421,13 +7053,13 @@
       </p:sp>
       <p:sp>
         <p:nvSpPr>
-          <p:cNvPr id="36" name="Rounded Rectangle 35"/>
+          <p:cNvPr id="38" name="Rounded Rectangle 37"/>
           <p:cNvSpPr/>
           <p:nvPr/>
         </p:nvSpPr>
         <p:spPr>
           <a:xfrm>
-            <a:off x="4892040" y="4187952"/>
+            <a:off x="4892040" y="4169664"/>
             <a:ext cx="713232" cy="640080"/>
           </a:xfrm>
           <a:prstGeom prst="roundRect">
@@ -6469,13 +7101,13 @@
       </p:sp>
       <p:sp>
         <p:nvSpPr>
-          <p:cNvPr id="37" name="TextBox 36"/>
+          <p:cNvPr id="39" name="TextBox 38"/>
           <p:cNvSpPr txBox="1"/>
           <p:nvPr/>
         </p:nvSpPr>
         <p:spPr>
           <a:xfrm>
-            <a:off x="4892040" y="4261104"/>
+            <a:off x="4892040" y="4242816"/>
             <a:ext cx="713232" cy="256032"/>
           </a:xfrm>
           <a:prstGeom prst="rect">
@@ -6508,13 +7140,13 @@
       </p:sp>
       <p:sp>
         <p:nvSpPr>
-          <p:cNvPr id="38" name="TextBox 37"/>
+          <p:cNvPr id="40" name="TextBox 39"/>
           <p:cNvSpPr txBox="1"/>
           <p:nvPr/>
         </p:nvSpPr>
         <p:spPr>
           <a:xfrm>
-            <a:off x="4892040" y="4553712"/>
+            <a:off x="4892040" y="4535424"/>
             <a:ext cx="713232" cy="201168"/>
           </a:xfrm>
           <a:prstGeom prst="rect">
@@ -6547,14 +7179,106 @@
       </p:sp>
       <p:sp>
         <p:nvSpPr>
-          <p:cNvPr id="39" name="TextBox 38"/>
+          <p:cNvPr id="41" name="Rounded Rectangle 40"/>
+          <p:cNvSpPr/>
+          <p:nvPr/>
+        </p:nvSpPr>
+        <p:spPr>
+          <a:xfrm>
+            <a:off x="978408" y="4901183"/>
+            <a:ext cx="4023360" cy="91440"/>
+          </a:xfrm>
+          <a:prstGeom prst="roundRect">
+            <a:avLst>
+              <a:gd name="adj" fmla="val 50000"/>
+            </a:avLst>
+          </a:prstGeom>
+          <a:solidFill>
+            <a:srgbClr val="2A3D5A"/>
+          </a:solidFill>
+          <a:ln>
+            <a:noFill/>
+          </a:ln>
+          <a:effectLst/>
+        </p:spPr>
+        <p:style>
+          <a:lnRef idx="1">
+            <a:schemeClr val="accent1"/>
+          </a:lnRef>
+          <a:fillRef idx="3">
+            <a:schemeClr val="accent1"/>
+          </a:fillRef>
+          <a:effectRef idx="2">
+            <a:schemeClr val="accent1"/>
+          </a:effectRef>
+          <a:fontRef idx="minor">
+            <a:schemeClr val="lt1"/>
+          </a:fontRef>
+        </p:style>
+        <p:txBody>
+          <a:bodyPr rtlCol="0" anchor="ctr"/>
+          <a:lstStyle/>
+          <a:p>
+            <a:pPr algn="ctr"/>
+          </a:p>
+        </p:txBody>
+      </p:sp>
+      <p:sp>
+        <p:nvSpPr>
+          <p:cNvPr id="42" name="Rounded Rectangle 41"/>
+          <p:cNvSpPr/>
+          <p:nvPr/>
+        </p:nvSpPr>
+        <p:spPr>
+          <a:xfrm>
+            <a:off x="978408" y="4901183"/>
+            <a:ext cx="4023360" cy="91440"/>
+          </a:xfrm>
+          <a:prstGeom prst="roundRect">
+            <a:avLst>
+              <a:gd name="adj" fmla="val 50000"/>
+            </a:avLst>
+          </a:prstGeom>
+          <a:solidFill>
+            <a:srgbClr val="3B82F6"/>
+          </a:solidFill>
+          <a:ln>
+            <a:noFill/>
+          </a:ln>
+          <a:effectLst/>
+        </p:spPr>
+        <p:style>
+          <a:lnRef idx="1">
+            <a:schemeClr val="accent1"/>
+          </a:lnRef>
+          <a:fillRef idx="3">
+            <a:schemeClr val="accent1"/>
+          </a:fillRef>
+          <a:effectRef idx="2">
+            <a:schemeClr val="accent1"/>
+          </a:effectRef>
+          <a:fontRef idx="minor">
+            <a:schemeClr val="lt1"/>
+          </a:fontRef>
+        </p:style>
+        <p:txBody>
+          <a:bodyPr rtlCol="0" anchor="ctr"/>
+          <a:lstStyle/>
+          <a:p>
+            <a:pPr algn="ctr"/>
+          </a:p>
+        </p:txBody>
+      </p:sp>
+      <p:sp>
+        <p:nvSpPr>
+          <p:cNvPr id="43" name="TextBox 42"/>
           <p:cNvSpPr txBox="1"/>
           <p:nvPr/>
         </p:nvSpPr>
         <p:spPr>
           <a:xfrm>
-            <a:off x="978408" y="4864608"/>
-            <a:ext cx="1828800" cy="164592"/>
+            <a:off x="978408" y="5010912"/>
+            <a:ext cx="914400" cy="164592"/>
           </a:xfrm>
           <a:prstGeom prst="rect">
             <a:avLst/>
@@ -6573,20 +7297,98 @@
               </a:lnSpc>
             </a:pPr>
             <a:r>
-              <a:rPr sz="900" b="1">
+              <a:rPr sz="850" b="1">
                 <a:solidFill>
                   <a:srgbClr val="3B82F6"/>
                 </a:solidFill>
                 <a:latin typeface="Microsoft YaHei"/>
               </a:rPr>
-              <a:t>查看日志 →</a:t>
-            </a:r>
-          </a:p>
-        </p:txBody>
-      </p:sp>
-      <p:sp>
-        <p:nvSpPr>
-          <p:cNvPr id="40" name="Rounded Rectangle 39"/>
+              <a:t>查看日志</a:t>
+            </a:r>
+          </a:p>
+        </p:txBody>
+      </p:sp>
+      <p:sp>
+        <p:nvSpPr>
+          <p:cNvPr id="44" name="TextBox 43"/>
+          <p:cNvSpPr txBox="1"/>
+          <p:nvPr/>
+        </p:nvSpPr>
+        <p:spPr>
+          <a:xfrm>
+            <a:off x="1874519" y="5010912"/>
+            <a:ext cx="914400" cy="164592"/>
+          </a:xfrm>
+          <a:prstGeom prst="rect">
+            <a:avLst/>
+          </a:prstGeom>
+          <a:noFill/>
+        </p:spPr>
+        <p:txBody>
+          <a:bodyPr wrap="square" anchor="t">
+            <a:spAutoFit/>
+          </a:bodyPr>
+          <a:lstStyle/>
+          <a:p>
+            <a:pPr algn="l">
+              <a:lnSpc>
+                <a:spcPct val="100000"/>
+              </a:lnSpc>
+            </a:pPr>
+            <a:r>
+              <a:rPr sz="850" b="1">
+                <a:solidFill>
+                  <a:srgbClr val="3B82F6"/>
+                </a:solidFill>
+                <a:latin typeface="Microsoft YaHei"/>
+              </a:rPr>
+              <a:t>查看证据</a:t>
+            </a:r>
+          </a:p>
+        </p:txBody>
+      </p:sp>
+      <p:sp>
+        <p:nvSpPr>
+          <p:cNvPr id="45" name="TextBox 44"/>
+          <p:cNvSpPr txBox="1"/>
+          <p:nvPr/>
+        </p:nvSpPr>
+        <p:spPr>
+          <a:xfrm>
+            <a:off x="2770632" y="5010912"/>
+            <a:ext cx="914400" cy="164592"/>
+          </a:xfrm>
+          <a:prstGeom prst="rect">
+            <a:avLst/>
+          </a:prstGeom>
+          <a:noFill/>
+        </p:spPr>
+        <p:txBody>
+          <a:bodyPr wrap="square" anchor="t">
+            <a:spAutoFit/>
+          </a:bodyPr>
+          <a:lstStyle/>
+          <a:p>
+            <a:pPr algn="l">
+              <a:lnSpc>
+                <a:spcPct val="100000"/>
+              </a:lnSpc>
+            </a:pPr>
+            <a:r>
+              <a:rPr sz="850" b="1">
+                <a:solidFill>
+                  <a:srgbClr val="3B82F6"/>
+                </a:solidFill>
+                <a:latin typeface="Microsoft YaHei"/>
+              </a:rPr>
+              <a:t>导出</a:t>
+            </a:r>
+          </a:p>
+        </p:txBody>
+      </p:sp>
+      <p:sp>
+        <p:nvSpPr>
+          <p:cNvPr id="46" name="Rounded Rectangle 45"/>
           <p:cNvSpPr/>
           <p:nvPr/>
         </p:nvSpPr>
@@ -6634,7 +7436,7 @@
       </p:sp>
       <p:sp>
         <p:nvSpPr>
-          <p:cNvPr id="41" name="Rectangle 40"/>
+          <p:cNvPr id="47" name="Rectangle 46"/>
           <p:cNvSpPr/>
           <p:nvPr/>
         </p:nvSpPr>
@@ -6678,7 +7480,7 @@
       </p:sp>
       <p:sp>
         <p:nvSpPr>
-          <p:cNvPr id="42" name="Rounded Rectangle 41"/>
+          <p:cNvPr id="48" name="Rounded Rectangle 47"/>
           <p:cNvSpPr/>
           <p:nvPr/>
         </p:nvSpPr>
@@ -6724,7 +7526,7 @@
       </p:sp>
       <p:sp>
         <p:nvSpPr>
-          <p:cNvPr id="43" name="TextBox 42"/>
+          <p:cNvPr id="49" name="TextBox 48"/>
           <p:cNvSpPr txBox="1"/>
           <p:nvPr/>
         </p:nvSpPr>
@@ -6763,7 +7565,7 @@
       </p:sp>
       <p:sp>
         <p:nvSpPr>
-          <p:cNvPr id="44" name="TextBox 43"/>
+          <p:cNvPr id="50" name="TextBox 49"/>
           <p:cNvSpPr txBox="1"/>
           <p:nvPr/>
         </p:nvSpPr>
@@ -6802,7 +7604,7 @@
       </p:sp>
       <p:sp>
         <p:nvSpPr>
-          <p:cNvPr id="45" name="Rounded Rectangle 44"/>
+          <p:cNvPr id="51" name="Rounded Rectangle 50"/>
           <p:cNvSpPr/>
           <p:nvPr/>
         </p:nvSpPr>
@@ -6848,7 +7650,7 @@
       </p:sp>
       <p:sp>
         <p:nvSpPr>
-          <p:cNvPr id="46" name="TextBox 45"/>
+          <p:cNvPr id="52" name="TextBox 51"/>
           <p:cNvSpPr txBox="1"/>
           <p:nvPr/>
         </p:nvSpPr>
@@ -6887,13 +7689,13 @@
       </p:sp>
       <p:sp>
         <p:nvSpPr>
-          <p:cNvPr id="47" name="TextBox 46"/>
+          <p:cNvPr id="53" name="TextBox 52"/>
           <p:cNvSpPr txBox="1"/>
           <p:nvPr/>
         </p:nvSpPr>
         <p:spPr>
           <a:xfrm>
-            <a:off x="6601968" y="3639312"/>
+            <a:off x="6601968" y="3621024"/>
             <a:ext cx="4626864" cy="530352"/>
           </a:xfrm>
           <a:prstGeom prst="rect">
@@ -6926,13 +7728,13 @@
       </p:sp>
       <p:sp>
         <p:nvSpPr>
-          <p:cNvPr id="48" name="TextBox 47"/>
+          <p:cNvPr id="54" name="TextBox 53"/>
           <p:cNvSpPr txBox="1"/>
           <p:nvPr/>
         </p:nvSpPr>
         <p:spPr>
           <a:xfrm>
-            <a:off x="6601968" y="4187952"/>
+            <a:off x="6601968" y="4169664"/>
             <a:ext cx="4023360" cy="640080"/>
           </a:xfrm>
           <a:prstGeom prst="rect">
@@ -6997,13 +7799,13 @@
       </p:sp>
       <p:sp>
         <p:nvSpPr>
-          <p:cNvPr id="49" name="Rounded Rectangle 48"/>
+          <p:cNvPr id="55" name="Rounded Rectangle 54"/>
           <p:cNvSpPr/>
           <p:nvPr/>
         </p:nvSpPr>
         <p:spPr>
           <a:xfrm>
-            <a:off x="10515600" y="4187952"/>
+            <a:off x="10515600" y="4169664"/>
             <a:ext cx="713232" cy="640080"/>
           </a:xfrm>
           <a:prstGeom prst="roundRect">
@@ -7045,13 +7847,13 @@
       </p:sp>
       <p:sp>
         <p:nvSpPr>
-          <p:cNvPr id="50" name="TextBox 49"/>
+          <p:cNvPr id="56" name="TextBox 55"/>
           <p:cNvSpPr txBox="1"/>
           <p:nvPr/>
         </p:nvSpPr>
         <p:spPr>
           <a:xfrm>
-            <a:off x="10515600" y="4261104"/>
+            <a:off x="10515600" y="4242816"/>
             <a:ext cx="713232" cy="256032"/>
           </a:xfrm>
           <a:prstGeom prst="rect">
@@ -7084,13 +7886,13 @@
       </p:sp>
       <p:sp>
         <p:nvSpPr>
-          <p:cNvPr id="51" name="TextBox 50"/>
+          <p:cNvPr id="57" name="TextBox 56"/>
           <p:cNvSpPr txBox="1"/>
           <p:nvPr/>
         </p:nvSpPr>
         <p:spPr>
           <a:xfrm>
-            <a:off x="10515600" y="4553712"/>
+            <a:off x="10515600" y="4535424"/>
             <a:ext cx="713232" cy="201168"/>
           </a:xfrm>
           <a:prstGeom prst="rect">
@@ -7123,14 +7925,106 @@
       </p:sp>
       <p:sp>
         <p:nvSpPr>
-          <p:cNvPr id="52" name="TextBox 51"/>
+          <p:cNvPr id="58" name="Rounded Rectangle 57"/>
+          <p:cNvSpPr/>
+          <p:nvPr/>
+        </p:nvSpPr>
+        <p:spPr>
+          <a:xfrm>
+            <a:off x="6601968" y="4901183"/>
+            <a:ext cx="4023360" cy="91440"/>
+          </a:xfrm>
+          <a:prstGeom prst="roundRect">
+            <a:avLst>
+              <a:gd name="adj" fmla="val 50000"/>
+            </a:avLst>
+          </a:prstGeom>
+          <a:solidFill>
+            <a:srgbClr val="2A3D5A"/>
+          </a:solidFill>
+          <a:ln>
+            <a:noFill/>
+          </a:ln>
+          <a:effectLst/>
+        </p:spPr>
+        <p:style>
+          <a:lnRef idx="1">
+            <a:schemeClr val="accent1"/>
+          </a:lnRef>
+          <a:fillRef idx="3">
+            <a:schemeClr val="accent1"/>
+          </a:fillRef>
+          <a:effectRef idx="2">
+            <a:schemeClr val="accent1"/>
+          </a:effectRef>
+          <a:fontRef idx="minor">
+            <a:schemeClr val="lt1"/>
+          </a:fontRef>
+        </p:style>
+        <p:txBody>
+          <a:bodyPr rtlCol="0" anchor="ctr"/>
+          <a:lstStyle/>
+          <a:p>
+            <a:pPr algn="ctr"/>
+          </a:p>
+        </p:txBody>
+      </p:sp>
+      <p:sp>
+        <p:nvSpPr>
+          <p:cNvPr id="59" name="Rounded Rectangle 58"/>
+          <p:cNvSpPr/>
+          <p:nvPr/>
+        </p:nvSpPr>
+        <p:spPr>
+          <a:xfrm>
+            <a:off x="6601968" y="4901183"/>
+            <a:ext cx="4023360" cy="91440"/>
+          </a:xfrm>
+          <a:prstGeom prst="roundRect">
+            <a:avLst>
+              <a:gd name="adj" fmla="val 50000"/>
+            </a:avLst>
+          </a:prstGeom>
+          <a:solidFill>
+            <a:srgbClr val="10B981"/>
+          </a:solidFill>
+          <a:ln>
+            <a:noFill/>
+          </a:ln>
+          <a:effectLst/>
+        </p:spPr>
+        <p:style>
+          <a:lnRef idx="1">
+            <a:schemeClr val="accent1"/>
+          </a:lnRef>
+          <a:fillRef idx="3">
+            <a:schemeClr val="accent1"/>
+          </a:fillRef>
+          <a:effectRef idx="2">
+            <a:schemeClr val="accent1"/>
+          </a:effectRef>
+          <a:fontRef idx="minor">
+            <a:schemeClr val="lt1"/>
+          </a:fontRef>
+        </p:style>
+        <p:txBody>
+          <a:bodyPr rtlCol="0" anchor="ctr"/>
+          <a:lstStyle/>
+          <a:p>
+            <a:pPr algn="ctr"/>
+          </a:p>
+        </p:txBody>
+      </p:sp>
+      <p:sp>
+        <p:nvSpPr>
+          <p:cNvPr id="60" name="TextBox 59"/>
           <p:cNvSpPr txBox="1"/>
           <p:nvPr/>
         </p:nvSpPr>
         <p:spPr>
           <a:xfrm>
-            <a:off x="6601968" y="4864608"/>
-            <a:ext cx="1828800" cy="164592"/>
+            <a:off x="6601968" y="5010912"/>
+            <a:ext cx="914400" cy="164592"/>
           </a:xfrm>
           <a:prstGeom prst="rect">
             <a:avLst/>
@@ -7149,20 +8043,98 @@
               </a:lnSpc>
             </a:pPr>
             <a:r>
-              <a:rPr sz="900" b="1">
+              <a:rPr sz="850" b="1">
                 <a:solidFill>
                   <a:srgbClr val="10B981"/>
                 </a:solidFill>
                 <a:latin typeface="Microsoft YaHei"/>
               </a:rPr>
-              <a:t>查看日志 →</a:t>
-            </a:r>
-          </a:p>
-        </p:txBody>
-      </p:sp>
-      <p:sp>
-        <p:nvSpPr>
-          <p:cNvPr id="53" name="Rounded Rectangle 52"/>
+              <a:t>查看日志</a:t>
+            </a:r>
+          </a:p>
+        </p:txBody>
+      </p:sp>
+      <p:sp>
+        <p:nvSpPr>
+          <p:cNvPr id="61" name="TextBox 60"/>
+          <p:cNvSpPr txBox="1"/>
+          <p:nvPr/>
+        </p:nvSpPr>
+        <p:spPr>
+          <a:xfrm>
+            <a:off x="7498080" y="5010912"/>
+            <a:ext cx="914400" cy="164592"/>
+          </a:xfrm>
+          <a:prstGeom prst="rect">
+            <a:avLst/>
+          </a:prstGeom>
+          <a:noFill/>
+        </p:spPr>
+        <p:txBody>
+          <a:bodyPr wrap="square" anchor="t">
+            <a:spAutoFit/>
+          </a:bodyPr>
+          <a:lstStyle/>
+          <a:p>
+            <a:pPr algn="l">
+              <a:lnSpc>
+                <a:spcPct val="100000"/>
+              </a:lnSpc>
+            </a:pPr>
+            <a:r>
+              <a:rPr sz="850" b="1">
+                <a:solidFill>
+                  <a:srgbClr val="10B981"/>
+                </a:solidFill>
+                <a:latin typeface="Microsoft YaHei"/>
+              </a:rPr>
+              <a:t>查看证据</a:t>
+            </a:r>
+          </a:p>
+        </p:txBody>
+      </p:sp>
+      <p:sp>
+        <p:nvSpPr>
+          <p:cNvPr id="62" name="TextBox 61"/>
+          <p:cNvSpPr txBox="1"/>
+          <p:nvPr/>
+        </p:nvSpPr>
+        <p:spPr>
+          <a:xfrm>
+            <a:off x="8394192" y="5010912"/>
+            <a:ext cx="914400" cy="164592"/>
+          </a:xfrm>
+          <a:prstGeom prst="rect">
+            <a:avLst/>
+          </a:prstGeom>
+          <a:noFill/>
+        </p:spPr>
+        <p:txBody>
+          <a:bodyPr wrap="square" anchor="t">
+            <a:spAutoFit/>
+          </a:bodyPr>
+          <a:lstStyle/>
+          <a:p>
+            <a:pPr algn="l">
+              <a:lnSpc>
+                <a:spcPct val="100000"/>
+              </a:lnSpc>
+            </a:pPr>
+            <a:r>
+              <a:rPr sz="850" b="1">
+                <a:solidFill>
+                  <a:srgbClr val="10B981"/>
+                </a:solidFill>
+                <a:latin typeface="Microsoft YaHei"/>
+              </a:rPr>
+              <a:t>导出</a:t>
+            </a:r>
+          </a:p>
+        </p:txBody>
+      </p:sp>
+      <p:sp>
+        <p:nvSpPr>
+          <p:cNvPr id="63" name="Rounded Rectangle 62"/>
           <p:cNvSpPr/>
           <p:nvPr/>
         </p:nvSpPr>
@@ -7210,7 +8182,7 @@
       </p:sp>
       <p:sp>
         <p:nvSpPr>
-          <p:cNvPr id="54" name="Rectangle 53"/>
+          <p:cNvPr id="64" name="Rectangle 63"/>
           <p:cNvSpPr/>
           <p:nvPr/>
         </p:nvSpPr>
@@ -7254,7 +8226,7 @@
       </p:sp>
       <p:sp>
         <p:nvSpPr>
-          <p:cNvPr id="55" name="Rounded Rectangle 54"/>
+          <p:cNvPr id="65" name="Rounded Rectangle 64"/>
           <p:cNvSpPr/>
           <p:nvPr/>
         </p:nvSpPr>
@@ -7300,7 +8272,7 @@
       </p:sp>
       <p:sp>
         <p:nvSpPr>
-          <p:cNvPr id="56" name="TextBox 55"/>
+          <p:cNvPr id="66" name="TextBox 65"/>
           <p:cNvSpPr txBox="1"/>
           <p:nvPr/>
         </p:nvSpPr>
@@ -7339,7 +8311,7 @@
       </p:sp>
       <p:sp>
         <p:nvSpPr>
-          <p:cNvPr id="57" name="TextBox 56"/>
+          <p:cNvPr id="67" name="TextBox 66"/>
           <p:cNvSpPr txBox="1"/>
           <p:nvPr/>
         </p:nvSpPr>
@@ -7378,7 +8350,7 @@
       </p:sp>
       <p:sp>
         <p:nvSpPr>
-          <p:cNvPr id="58" name="Rounded Rectangle 57"/>
+          <p:cNvPr id="68" name="Rounded Rectangle 67"/>
           <p:cNvSpPr/>
           <p:nvPr/>
         </p:nvSpPr>
@@ -7424,7 +8396,7 @@
       </p:sp>
       <p:sp>
         <p:nvSpPr>
-          <p:cNvPr id="59" name="TextBox 58"/>
+          <p:cNvPr id="69" name="TextBox 68"/>
           <p:cNvSpPr txBox="1"/>
           <p:nvPr/>
         </p:nvSpPr>
@@ -7463,13 +8435,13 @@
       </p:sp>
       <p:sp>
         <p:nvSpPr>
-          <p:cNvPr id="60" name="TextBox 59"/>
+          <p:cNvPr id="70" name="TextBox 69"/>
           <p:cNvSpPr txBox="1"/>
           <p:nvPr/>
         </p:nvSpPr>
         <p:spPr>
           <a:xfrm>
-            <a:off x="978408" y="6108192"/>
+            <a:off x="978408" y="6089904"/>
             <a:ext cx="4626864" cy="530352"/>
           </a:xfrm>
           <a:prstGeom prst="rect">
@@ -7502,13 +8474,13 @@
       </p:sp>
       <p:sp>
         <p:nvSpPr>
-          <p:cNvPr id="61" name="TextBox 60"/>
+          <p:cNvPr id="71" name="TextBox 70"/>
           <p:cNvSpPr txBox="1"/>
           <p:nvPr/>
         </p:nvSpPr>
         <p:spPr>
           <a:xfrm>
-            <a:off x="978408" y="6656831"/>
+            <a:off x="978408" y="6638544"/>
             <a:ext cx="4023360" cy="640080"/>
           </a:xfrm>
           <a:prstGeom prst="rect">
@@ -7573,13 +8545,13 @@
       </p:sp>
       <p:sp>
         <p:nvSpPr>
-          <p:cNvPr id="62" name="Rounded Rectangle 61"/>
+          <p:cNvPr id="72" name="Rounded Rectangle 71"/>
           <p:cNvSpPr/>
           <p:nvPr/>
         </p:nvSpPr>
         <p:spPr>
           <a:xfrm>
-            <a:off x="4892040" y="6656831"/>
+            <a:off x="4892040" y="6638544"/>
             <a:ext cx="713232" cy="640080"/>
           </a:xfrm>
           <a:prstGeom prst="roundRect">
@@ -7621,13 +8593,13 @@
       </p:sp>
       <p:sp>
         <p:nvSpPr>
-          <p:cNvPr id="63" name="TextBox 62"/>
+          <p:cNvPr id="73" name="TextBox 72"/>
           <p:cNvSpPr txBox="1"/>
           <p:nvPr/>
         </p:nvSpPr>
         <p:spPr>
           <a:xfrm>
-            <a:off x="4892040" y="6729983"/>
+            <a:off x="4892040" y="6711696"/>
             <a:ext cx="713232" cy="256032"/>
           </a:xfrm>
           <a:prstGeom prst="rect">
@@ -7660,13 +8632,13 @@
       </p:sp>
       <p:sp>
         <p:nvSpPr>
-          <p:cNvPr id="64" name="TextBox 63"/>
+          <p:cNvPr id="74" name="TextBox 73"/>
           <p:cNvSpPr txBox="1"/>
           <p:nvPr/>
         </p:nvSpPr>
         <p:spPr>
           <a:xfrm>
-            <a:off x="4892040" y="7022592"/>
+            <a:off x="4892040" y="7004304"/>
             <a:ext cx="713232" cy="201168"/>
           </a:xfrm>
           <a:prstGeom prst="rect">
@@ -7699,14 +8671,106 @@
       </p:sp>
       <p:sp>
         <p:nvSpPr>
-          <p:cNvPr id="65" name="TextBox 64"/>
+          <p:cNvPr id="75" name="Rounded Rectangle 74"/>
+          <p:cNvSpPr/>
+          <p:nvPr/>
+        </p:nvSpPr>
+        <p:spPr>
+          <a:xfrm>
+            <a:off x="978408" y="7370063"/>
+            <a:ext cx="4023360" cy="91440"/>
+          </a:xfrm>
+          <a:prstGeom prst="roundRect">
+            <a:avLst>
+              <a:gd name="adj" fmla="val 50000"/>
+            </a:avLst>
+          </a:prstGeom>
+          <a:solidFill>
+            <a:srgbClr val="2A3D5A"/>
+          </a:solidFill>
+          <a:ln>
+            <a:noFill/>
+          </a:ln>
+          <a:effectLst/>
+        </p:spPr>
+        <p:style>
+          <a:lnRef idx="1">
+            <a:schemeClr val="accent1"/>
+          </a:lnRef>
+          <a:fillRef idx="3">
+            <a:schemeClr val="accent1"/>
+          </a:fillRef>
+          <a:effectRef idx="2">
+            <a:schemeClr val="accent1"/>
+          </a:effectRef>
+          <a:fontRef idx="minor">
+            <a:schemeClr val="lt1"/>
+          </a:fontRef>
+        </p:style>
+        <p:txBody>
+          <a:bodyPr rtlCol="0" anchor="ctr"/>
+          <a:lstStyle/>
+          <a:p>
+            <a:pPr algn="ctr"/>
+          </a:p>
+        </p:txBody>
+      </p:sp>
+      <p:sp>
+        <p:nvSpPr>
+          <p:cNvPr id="76" name="Rounded Rectangle 75"/>
+          <p:cNvSpPr/>
+          <p:nvPr/>
+        </p:nvSpPr>
+        <p:spPr>
+          <a:xfrm>
+            <a:off x="978408" y="7370063"/>
+            <a:ext cx="3218688" cy="91440"/>
+          </a:xfrm>
+          <a:prstGeom prst="roundRect">
+            <a:avLst>
+              <a:gd name="adj" fmla="val 50000"/>
+            </a:avLst>
+          </a:prstGeom>
+          <a:solidFill>
+            <a:srgbClr val="F97A2E"/>
+          </a:solidFill>
+          <a:ln>
+            <a:noFill/>
+          </a:ln>
+          <a:effectLst/>
+        </p:spPr>
+        <p:style>
+          <a:lnRef idx="1">
+            <a:schemeClr val="accent1"/>
+          </a:lnRef>
+          <a:fillRef idx="3">
+            <a:schemeClr val="accent1"/>
+          </a:fillRef>
+          <a:effectRef idx="2">
+            <a:schemeClr val="accent1"/>
+          </a:effectRef>
+          <a:fontRef idx="minor">
+            <a:schemeClr val="lt1"/>
+          </a:fontRef>
+        </p:style>
+        <p:txBody>
+          <a:bodyPr rtlCol="0" anchor="ctr"/>
+          <a:lstStyle/>
+          <a:p>
+            <a:pPr algn="ctr"/>
+          </a:p>
+        </p:txBody>
+      </p:sp>
+      <p:sp>
+        <p:nvSpPr>
+          <p:cNvPr id="77" name="TextBox 76"/>
           <p:cNvSpPr txBox="1"/>
           <p:nvPr/>
         </p:nvSpPr>
         <p:spPr>
           <a:xfrm>
-            <a:off x="978408" y="7333488"/>
-            <a:ext cx="1828800" cy="164592"/>
+            <a:off x="978408" y="7479792"/>
+            <a:ext cx="914400" cy="164592"/>
           </a:xfrm>
           <a:prstGeom prst="rect">
             <a:avLst/>
@@ -7725,20 +8789,98 @@
               </a:lnSpc>
             </a:pPr>
             <a:r>
-              <a:rPr sz="900" b="1">
+              <a:rPr sz="850" b="1">
                 <a:solidFill>
                   <a:srgbClr val="F97A2E"/>
                 </a:solidFill>
                 <a:latin typeface="Microsoft YaHei"/>
               </a:rPr>
-              <a:t>查看日志 →</a:t>
-            </a:r>
-          </a:p>
-        </p:txBody>
-      </p:sp>
-      <p:sp>
-        <p:nvSpPr>
-          <p:cNvPr id="66" name="Rounded Rectangle 65"/>
+              <a:t>查看日志</a:t>
+            </a:r>
+          </a:p>
+        </p:txBody>
+      </p:sp>
+      <p:sp>
+        <p:nvSpPr>
+          <p:cNvPr id="78" name="TextBox 77"/>
+          <p:cNvSpPr txBox="1"/>
+          <p:nvPr/>
+        </p:nvSpPr>
+        <p:spPr>
+          <a:xfrm>
+            <a:off x="1874519" y="7479792"/>
+            <a:ext cx="914400" cy="164592"/>
+          </a:xfrm>
+          <a:prstGeom prst="rect">
+            <a:avLst/>
+          </a:prstGeom>
+          <a:noFill/>
+        </p:spPr>
+        <p:txBody>
+          <a:bodyPr wrap="square" anchor="t">
+            <a:spAutoFit/>
+          </a:bodyPr>
+          <a:lstStyle/>
+          <a:p>
+            <a:pPr algn="l">
+              <a:lnSpc>
+                <a:spcPct val="100000"/>
+              </a:lnSpc>
+            </a:pPr>
+            <a:r>
+              <a:rPr sz="850" b="1">
+                <a:solidFill>
+                  <a:srgbClr val="F97A2E"/>
+                </a:solidFill>
+                <a:latin typeface="Microsoft YaHei"/>
+              </a:rPr>
+              <a:t>查看证据</a:t>
+            </a:r>
+          </a:p>
+        </p:txBody>
+      </p:sp>
+      <p:sp>
+        <p:nvSpPr>
+          <p:cNvPr id="79" name="TextBox 78"/>
+          <p:cNvSpPr txBox="1"/>
+          <p:nvPr/>
+        </p:nvSpPr>
+        <p:spPr>
+          <a:xfrm>
+            <a:off x="2770632" y="7479792"/>
+            <a:ext cx="914400" cy="164592"/>
+          </a:xfrm>
+          <a:prstGeom prst="rect">
+            <a:avLst/>
+          </a:prstGeom>
+          <a:noFill/>
+        </p:spPr>
+        <p:txBody>
+          <a:bodyPr wrap="square" anchor="t">
+            <a:spAutoFit/>
+          </a:bodyPr>
+          <a:lstStyle/>
+          <a:p>
+            <a:pPr algn="l">
+              <a:lnSpc>
+                <a:spcPct val="100000"/>
+              </a:lnSpc>
+            </a:pPr>
+            <a:r>
+              <a:rPr sz="850" b="1">
+                <a:solidFill>
+                  <a:srgbClr val="F97A2E"/>
+                </a:solidFill>
+                <a:latin typeface="Microsoft YaHei"/>
+              </a:rPr>
+              <a:t>导出</a:t>
+            </a:r>
+          </a:p>
+        </p:txBody>
+      </p:sp>
+      <p:sp>
+        <p:nvSpPr>
+          <p:cNvPr id="80" name="Rounded Rectangle 79"/>
           <p:cNvSpPr/>
           <p:nvPr/>
         </p:nvSpPr>
@@ -7786,7 +8928,7 @@
       </p:sp>
       <p:sp>
         <p:nvSpPr>
-          <p:cNvPr id="67" name="Rectangle 66"/>
+          <p:cNvPr id="81" name="Rectangle 80"/>
           <p:cNvSpPr/>
           <p:nvPr/>
         </p:nvSpPr>
@@ -7830,7 +8972,7 @@
       </p:sp>
       <p:sp>
         <p:nvSpPr>
-          <p:cNvPr id="68" name="Rounded Rectangle 67"/>
+          <p:cNvPr id="82" name="Rounded Rectangle 81"/>
           <p:cNvSpPr/>
           <p:nvPr/>
         </p:nvSpPr>
@@ -7876,7 +9018,7 @@
       </p:sp>
       <p:sp>
         <p:nvSpPr>
-          <p:cNvPr id="69" name="TextBox 68"/>
+          <p:cNvPr id="83" name="TextBox 82"/>
           <p:cNvSpPr txBox="1"/>
           <p:nvPr/>
         </p:nvSpPr>
@@ -7915,7 +9057,7 @@
       </p:sp>
       <p:sp>
         <p:nvSpPr>
-          <p:cNvPr id="70" name="TextBox 69"/>
+          <p:cNvPr id="84" name="TextBox 83"/>
           <p:cNvSpPr txBox="1"/>
           <p:nvPr/>
         </p:nvSpPr>
@@ -7954,7 +9096,7 @@
       </p:sp>
       <p:sp>
         <p:nvSpPr>
-          <p:cNvPr id="71" name="Rounded Rectangle 70"/>
+          <p:cNvPr id="85" name="Rounded Rectangle 84"/>
           <p:cNvSpPr/>
           <p:nvPr/>
         </p:nvSpPr>
@@ -8000,7 +9142,7 @@
       </p:sp>
       <p:sp>
         <p:nvSpPr>
-          <p:cNvPr id="72" name="TextBox 71"/>
+          <p:cNvPr id="86" name="TextBox 85"/>
           <p:cNvSpPr txBox="1"/>
           <p:nvPr/>
         </p:nvSpPr>
@@ -8039,13 +9181,13 @@
       </p:sp>
       <p:sp>
         <p:nvSpPr>
-          <p:cNvPr id="73" name="TextBox 72"/>
+          <p:cNvPr id="87" name="TextBox 86"/>
           <p:cNvSpPr txBox="1"/>
           <p:nvPr/>
         </p:nvSpPr>
         <p:spPr>
           <a:xfrm>
-            <a:off x="6601968" y="6108192"/>
+            <a:off x="6601968" y="6089904"/>
             <a:ext cx="4626864" cy="530352"/>
           </a:xfrm>
           <a:prstGeom prst="rect">
@@ -8078,13 +9220,13 @@
       </p:sp>
       <p:sp>
         <p:nvSpPr>
-          <p:cNvPr id="74" name="TextBox 73"/>
+          <p:cNvPr id="88" name="TextBox 87"/>
           <p:cNvSpPr txBox="1"/>
           <p:nvPr/>
         </p:nvSpPr>
         <p:spPr>
           <a:xfrm>
-            <a:off x="6601968" y="6656831"/>
+            <a:off x="6601968" y="6638544"/>
             <a:ext cx="4023360" cy="640080"/>
           </a:xfrm>
           <a:prstGeom prst="rect">
@@ -8149,13 +9291,13 @@
       </p:sp>
       <p:sp>
         <p:nvSpPr>
-          <p:cNvPr id="75" name="Rounded Rectangle 74"/>
+          <p:cNvPr id="89" name="Rounded Rectangle 88"/>
           <p:cNvSpPr/>
           <p:nvPr/>
         </p:nvSpPr>
         <p:spPr>
           <a:xfrm>
-            <a:off x="10515600" y="6656831"/>
+            <a:off x="10515600" y="6638544"/>
             <a:ext cx="713232" cy="640080"/>
           </a:xfrm>
           <a:prstGeom prst="roundRect">
@@ -8197,13 +9339,13 @@
       </p:sp>
       <p:sp>
         <p:nvSpPr>
-          <p:cNvPr id="76" name="TextBox 75"/>
+          <p:cNvPr id="90" name="TextBox 89"/>
           <p:cNvSpPr txBox="1"/>
           <p:nvPr/>
         </p:nvSpPr>
         <p:spPr>
           <a:xfrm>
-            <a:off x="10515600" y="6729983"/>
+            <a:off x="10515600" y="6711696"/>
             <a:ext cx="713232" cy="256032"/>
           </a:xfrm>
           <a:prstGeom prst="rect">
@@ -8236,13 +9378,13 @@
       </p:sp>
       <p:sp>
         <p:nvSpPr>
-          <p:cNvPr id="77" name="TextBox 76"/>
+          <p:cNvPr id="91" name="TextBox 90"/>
           <p:cNvSpPr txBox="1"/>
           <p:nvPr/>
         </p:nvSpPr>
         <p:spPr>
           <a:xfrm>
-            <a:off x="10515600" y="7022592"/>
+            <a:off x="10515600" y="7004304"/>
             <a:ext cx="713232" cy="201168"/>
           </a:xfrm>
           <a:prstGeom prst="rect">
@@ -8275,14 +9417,106 @@
       </p:sp>
       <p:sp>
         <p:nvSpPr>
-          <p:cNvPr id="78" name="TextBox 77"/>
+          <p:cNvPr id="92" name="Rounded Rectangle 91"/>
+          <p:cNvSpPr/>
+          <p:nvPr/>
+        </p:nvSpPr>
+        <p:spPr>
+          <a:xfrm>
+            <a:off x="6601968" y="7370063"/>
+            <a:ext cx="4023360" cy="91440"/>
+          </a:xfrm>
+          <a:prstGeom prst="roundRect">
+            <a:avLst>
+              <a:gd name="adj" fmla="val 50000"/>
+            </a:avLst>
+          </a:prstGeom>
+          <a:solidFill>
+            <a:srgbClr val="2A3D5A"/>
+          </a:solidFill>
+          <a:ln>
+            <a:noFill/>
+          </a:ln>
+          <a:effectLst/>
+        </p:spPr>
+        <p:style>
+          <a:lnRef idx="1">
+            <a:schemeClr val="accent1"/>
+          </a:lnRef>
+          <a:fillRef idx="3">
+            <a:schemeClr val="accent1"/>
+          </a:fillRef>
+          <a:effectRef idx="2">
+            <a:schemeClr val="accent1"/>
+          </a:effectRef>
+          <a:fontRef idx="minor">
+            <a:schemeClr val="lt1"/>
+          </a:fontRef>
+        </p:style>
+        <p:txBody>
+          <a:bodyPr rtlCol="0" anchor="ctr"/>
+          <a:lstStyle/>
+          <a:p>
+            <a:pPr algn="ctr"/>
+          </a:p>
+        </p:txBody>
+      </p:sp>
+      <p:sp>
+        <p:nvSpPr>
+          <p:cNvPr id="93" name="Rounded Rectangle 92"/>
+          <p:cNvSpPr/>
+          <p:nvPr/>
+        </p:nvSpPr>
+        <p:spPr>
+          <a:xfrm>
+            <a:off x="6601968" y="7370063"/>
+            <a:ext cx="2816352" cy="91440"/>
+          </a:xfrm>
+          <a:prstGeom prst="roundRect">
+            <a:avLst>
+              <a:gd name="adj" fmla="val 50000"/>
+            </a:avLst>
+          </a:prstGeom>
+          <a:solidFill>
+            <a:srgbClr val="8B5CF6"/>
+          </a:solidFill>
+          <a:ln>
+            <a:noFill/>
+          </a:ln>
+          <a:effectLst/>
+        </p:spPr>
+        <p:style>
+          <a:lnRef idx="1">
+            <a:schemeClr val="accent1"/>
+          </a:lnRef>
+          <a:fillRef idx="3">
+            <a:schemeClr val="accent1"/>
+          </a:fillRef>
+          <a:effectRef idx="2">
+            <a:schemeClr val="accent1"/>
+          </a:effectRef>
+          <a:fontRef idx="minor">
+            <a:schemeClr val="lt1"/>
+          </a:fontRef>
+        </p:style>
+        <p:txBody>
+          <a:bodyPr rtlCol="0" anchor="ctr"/>
+          <a:lstStyle/>
+          <a:p>
+            <a:pPr algn="ctr"/>
+          </a:p>
+        </p:txBody>
+      </p:sp>
+      <p:sp>
+        <p:nvSpPr>
+          <p:cNvPr id="94" name="TextBox 93"/>
           <p:cNvSpPr txBox="1"/>
           <p:nvPr/>
         </p:nvSpPr>
         <p:spPr>
           <a:xfrm>
-            <a:off x="6601968" y="7333488"/>
-            <a:ext cx="1828800" cy="164592"/>
+            <a:off x="6601968" y="7479792"/>
+            <a:ext cx="914400" cy="164592"/>
           </a:xfrm>
           <a:prstGeom prst="rect">
             <a:avLst/>
@@ -8301,20 +9535,98 @@
               </a:lnSpc>
             </a:pPr>
             <a:r>
-              <a:rPr sz="900" b="1">
+              <a:rPr sz="850" b="1">
                 <a:solidFill>
                   <a:srgbClr val="8B5CF6"/>
                 </a:solidFill>
                 <a:latin typeface="Microsoft YaHei"/>
               </a:rPr>
-              <a:t>查看日志 →</a:t>
-            </a:r>
-          </a:p>
-        </p:txBody>
-      </p:sp>
-      <p:sp>
-        <p:nvSpPr>
-          <p:cNvPr id="79" name="Rectangle 78"/>
+              <a:t>查看日志</a:t>
+            </a:r>
+          </a:p>
+        </p:txBody>
+      </p:sp>
+      <p:sp>
+        <p:nvSpPr>
+          <p:cNvPr id="95" name="TextBox 94"/>
+          <p:cNvSpPr txBox="1"/>
+          <p:nvPr/>
+        </p:nvSpPr>
+        <p:spPr>
+          <a:xfrm>
+            <a:off x="7498080" y="7479792"/>
+            <a:ext cx="914400" cy="164592"/>
+          </a:xfrm>
+          <a:prstGeom prst="rect">
+            <a:avLst/>
+          </a:prstGeom>
+          <a:noFill/>
+        </p:spPr>
+        <p:txBody>
+          <a:bodyPr wrap="square" anchor="t">
+            <a:spAutoFit/>
+          </a:bodyPr>
+          <a:lstStyle/>
+          <a:p>
+            <a:pPr algn="l">
+              <a:lnSpc>
+                <a:spcPct val="100000"/>
+              </a:lnSpc>
+            </a:pPr>
+            <a:r>
+              <a:rPr sz="850" b="1">
+                <a:solidFill>
+                  <a:srgbClr val="8B5CF6"/>
+                </a:solidFill>
+                <a:latin typeface="Microsoft YaHei"/>
+              </a:rPr>
+              <a:t>查看证据</a:t>
+            </a:r>
+          </a:p>
+        </p:txBody>
+      </p:sp>
+      <p:sp>
+        <p:nvSpPr>
+          <p:cNvPr id="96" name="TextBox 95"/>
+          <p:cNvSpPr txBox="1"/>
+          <p:nvPr/>
+        </p:nvSpPr>
+        <p:spPr>
+          <a:xfrm>
+            <a:off x="8394192" y="7479792"/>
+            <a:ext cx="914400" cy="164592"/>
+          </a:xfrm>
+          <a:prstGeom prst="rect">
+            <a:avLst/>
+          </a:prstGeom>
+          <a:noFill/>
+        </p:spPr>
+        <p:txBody>
+          <a:bodyPr wrap="square" anchor="t">
+            <a:spAutoFit/>
+          </a:bodyPr>
+          <a:lstStyle/>
+          <a:p>
+            <a:pPr algn="l">
+              <a:lnSpc>
+                <a:spcPct val="100000"/>
+              </a:lnSpc>
+            </a:pPr>
+            <a:r>
+              <a:rPr sz="850" b="1">
+                <a:solidFill>
+                  <a:srgbClr val="8B5CF6"/>
+                </a:solidFill>
+                <a:latin typeface="Microsoft YaHei"/>
+              </a:rPr>
+              <a:t>导出</a:t>
+            </a:r>
+          </a:p>
+        </p:txBody>
+      </p:sp>
+      <p:sp>
+        <p:nvSpPr>
+          <p:cNvPr id="97" name="Rectangle 96"/>
           <p:cNvSpPr/>
           <p:nvPr/>
         </p:nvSpPr>
@@ -8360,7 +9672,7 @@
       </p:sp>
       <p:sp>
         <p:nvSpPr>
-          <p:cNvPr id="80" name="TextBox 79"/>
+          <p:cNvPr id="98" name="TextBox 97"/>
           <p:cNvSpPr txBox="1"/>
           <p:nvPr/>
         </p:nvSpPr>

</xml_diff>

<commit_message>
AI Agent workflow v5: nav tabs, compact dashboard grid, layout fits slide
</commit_message>
<xml_diff>
--- a/benchmarks/manual_tasks/ai-agent-workflow/output/ai_agent_workflow.pptx
+++ b/benchmarks/manual_tasks/ai-agent-workflow/output/ai_agent_workflow.pptx
@@ -5673,14 +5673,216 @@
       </p:sp>
       <p:sp>
         <p:nvSpPr>
-          <p:cNvPr id="6" name="TextBox 5"/>
+          <p:cNvPr id="6" name="Rounded Rectangle 5"/>
+          <p:cNvSpPr/>
+          <p:nvPr/>
+        </p:nvSpPr>
+        <p:spPr>
+          <a:xfrm>
+            <a:off x="4160520" y="246888"/>
+            <a:ext cx="658368" cy="256032"/>
+          </a:xfrm>
+          <a:prstGeom prst="roundRect">
+            <a:avLst>
+              <a:gd name="adj" fmla="val 50000"/>
+            </a:avLst>
+          </a:prstGeom>
+          <a:solidFill>
+            <a:srgbClr val="3B82F6"/>
+          </a:solidFill>
+          <a:ln>
+            <a:noFill/>
+          </a:ln>
+          <a:effectLst/>
+        </p:spPr>
+        <p:style>
+          <a:lnRef idx="1">
+            <a:schemeClr val="accent1"/>
+          </a:lnRef>
+          <a:fillRef idx="3">
+            <a:schemeClr val="accent1"/>
+          </a:fillRef>
+          <a:effectRef idx="2">
+            <a:schemeClr val="accent1"/>
+          </a:effectRef>
+          <a:fontRef idx="minor">
+            <a:schemeClr val="lt1"/>
+          </a:fontRef>
+        </p:style>
+        <p:txBody>
+          <a:bodyPr rtlCol="0" anchor="ctr"/>
+          <a:lstStyle/>
+          <a:p>
+            <a:pPr algn="ctr"/>
+          </a:p>
+        </p:txBody>
+      </p:sp>
+      <p:sp>
+        <p:nvSpPr>
+          <p:cNvPr id="7" name="TextBox 6"/>
           <p:cNvSpPr txBox="1"/>
           <p:nvPr/>
         </p:nvSpPr>
         <p:spPr>
           <a:xfrm>
-            <a:off x="4297680" y="228600"/>
-            <a:ext cx="1828800" cy="292608"/>
+            <a:off x="4160520" y="283464"/>
+            <a:ext cx="658368" cy="201168"/>
+          </a:xfrm>
+          <a:prstGeom prst="rect">
+            <a:avLst/>
+          </a:prstGeom>
+          <a:noFill/>
+        </p:spPr>
+        <p:txBody>
+          <a:bodyPr wrap="square" anchor="t">
+            <a:spAutoFit/>
+          </a:bodyPr>
+          <a:lstStyle/>
+          <a:p>
+            <a:pPr algn="ctr">
+              <a:lnSpc>
+                <a:spcPct val="100000"/>
+              </a:lnSpc>
+            </a:pPr>
+            <a:r>
+              <a:rPr sz="1050" b="1">
+                <a:solidFill>
+                  <a:srgbClr val="FFFFFF"/>
+                </a:solidFill>
+                <a:latin typeface="Microsoft YaHei"/>
+              </a:rPr>
+              <a:t>总览</a:t>
+            </a:r>
+          </a:p>
+        </p:txBody>
+      </p:sp>
+      <p:sp>
+        <p:nvSpPr>
+          <p:cNvPr id="8" name="TextBox 7"/>
+          <p:cNvSpPr txBox="1"/>
+          <p:nvPr/>
+        </p:nvSpPr>
+        <p:spPr>
+          <a:xfrm>
+            <a:off x="4983479" y="283464"/>
+            <a:ext cx="658368" cy="201168"/>
+          </a:xfrm>
+          <a:prstGeom prst="rect">
+            <a:avLst/>
+          </a:prstGeom>
+          <a:noFill/>
+        </p:spPr>
+        <p:txBody>
+          <a:bodyPr wrap="square" anchor="t">
+            <a:spAutoFit/>
+          </a:bodyPr>
+          <a:lstStyle/>
+          <a:p>
+            <a:pPr algn="ctr">
+              <a:lnSpc>
+                <a:spcPct val="100000"/>
+              </a:lnSpc>
+            </a:pPr>
+            <a:r>
+              <a:rPr sz="1050" b="0">
+                <a:solidFill>
+                  <a:srgbClr val="66707D"/>
+                </a:solidFill>
+                <a:latin typeface="Microsoft YaHei"/>
+              </a:rPr>
+              <a:t>执行</a:t>
+            </a:r>
+          </a:p>
+        </p:txBody>
+      </p:sp>
+      <p:sp>
+        <p:nvSpPr>
+          <p:cNvPr id="9" name="TextBox 8"/>
+          <p:cNvSpPr txBox="1"/>
+          <p:nvPr/>
+        </p:nvSpPr>
+        <p:spPr>
+          <a:xfrm>
+            <a:off x="5806440" y="283464"/>
+            <a:ext cx="658368" cy="201168"/>
+          </a:xfrm>
+          <a:prstGeom prst="rect">
+            <a:avLst/>
+          </a:prstGeom>
+          <a:noFill/>
+        </p:spPr>
+        <p:txBody>
+          <a:bodyPr wrap="square" anchor="t">
+            <a:spAutoFit/>
+          </a:bodyPr>
+          <a:lstStyle/>
+          <a:p>
+            <a:pPr algn="ctr">
+              <a:lnSpc>
+                <a:spcPct val="100000"/>
+              </a:lnSpc>
+            </a:pPr>
+            <a:r>
+              <a:rPr sz="1050" b="0">
+                <a:solidFill>
+                  <a:srgbClr val="66707D"/>
+                </a:solidFill>
+                <a:latin typeface="Microsoft YaHei"/>
+              </a:rPr>
+              <a:t>验证</a:t>
+            </a:r>
+          </a:p>
+        </p:txBody>
+      </p:sp>
+      <p:sp>
+        <p:nvSpPr>
+          <p:cNvPr id="10" name="TextBox 9"/>
+          <p:cNvSpPr txBox="1"/>
+          <p:nvPr/>
+        </p:nvSpPr>
+        <p:spPr>
+          <a:xfrm>
+            <a:off x="6629400" y="283464"/>
+            <a:ext cx="658368" cy="201168"/>
+          </a:xfrm>
+          <a:prstGeom prst="rect">
+            <a:avLst/>
+          </a:prstGeom>
+          <a:noFill/>
+        </p:spPr>
+        <p:txBody>
+          <a:bodyPr wrap="square" anchor="t">
+            <a:spAutoFit/>
+          </a:bodyPr>
+          <a:lstStyle/>
+          <a:p>
+            <a:pPr algn="ctr">
+              <a:lnSpc>
+                <a:spcPct val="100000"/>
+              </a:lnSpc>
+            </a:pPr>
+            <a:r>
+              <a:rPr sz="1050" b="0">
+                <a:solidFill>
+                  <a:srgbClr val="66707D"/>
+                </a:solidFill>
+                <a:latin typeface="Microsoft YaHei"/>
+              </a:rPr>
+              <a:t>设置</a:t>
+            </a:r>
+          </a:p>
+        </p:txBody>
+      </p:sp>
+      <p:sp>
+        <p:nvSpPr>
+          <p:cNvPr id="11" name="TextBox 10"/>
+          <p:cNvSpPr txBox="1"/>
+          <p:nvPr/>
+        </p:nvSpPr>
+        <p:spPr>
+          <a:xfrm>
+            <a:off x="8183879" y="228600"/>
+            <a:ext cx="1463040" cy="292608"/>
           </a:xfrm>
           <a:prstGeom prst="rect">
             <a:avLst/>
@@ -5712,18 +5914,181 @@
       </p:sp>
       <p:sp>
         <p:nvSpPr>
-          <p:cNvPr id="7" name="Rounded Rectangle 6"/>
+          <p:cNvPr id="12" name="Rounded Rectangle 11"/>
           <p:cNvSpPr/>
           <p:nvPr/>
         </p:nvSpPr>
         <p:spPr>
           <a:xfrm>
-            <a:off x="8275320" y="173736"/>
-            <a:ext cx="1234440" cy="384048"/>
+            <a:off x="9646920" y="173736"/>
+            <a:ext cx="2057400" cy="384048"/>
           </a:xfrm>
           <a:prstGeom prst="roundRect">
             <a:avLst>
               <a:gd name="adj" fmla="val 50000"/>
+            </a:avLst>
+          </a:prstGeom>
+          <a:solidFill>
+            <a:srgbClr val="3B82F6"/>
+          </a:solidFill>
+          <a:ln>
+            <a:noFill/>
+          </a:ln>
+          <a:effectLst/>
+        </p:spPr>
+        <p:style>
+          <a:lnRef idx="1">
+            <a:schemeClr val="accent1"/>
+          </a:lnRef>
+          <a:fillRef idx="3">
+            <a:schemeClr val="accent1"/>
+          </a:fillRef>
+          <a:effectRef idx="2">
+            <a:schemeClr val="accent1"/>
+          </a:effectRef>
+          <a:fontRef idx="minor">
+            <a:schemeClr val="lt1"/>
+          </a:fontRef>
+        </p:style>
+        <p:txBody>
+          <a:bodyPr rtlCol="0" anchor="ctr"/>
+          <a:lstStyle/>
+          <a:p>
+            <a:pPr algn="ctr"/>
+          </a:p>
+        </p:txBody>
+      </p:sp>
+      <p:sp>
+        <p:nvSpPr>
+          <p:cNvPr id="13" name="TextBox 12"/>
+          <p:cNvSpPr txBox="1"/>
+          <p:nvPr/>
+        </p:nvSpPr>
+        <p:spPr>
+          <a:xfrm>
+            <a:off x="9646920" y="237744"/>
+            <a:ext cx="2057400" cy="274320"/>
+          </a:xfrm>
+          <a:prstGeom prst="rect">
+            <a:avLst/>
+          </a:prstGeom>
+          <a:noFill/>
+        </p:spPr>
+        <p:txBody>
+          <a:bodyPr wrap="square" anchor="t">
+            <a:spAutoFit/>
+          </a:bodyPr>
+          <a:lstStyle/>
+          <a:p>
+            <a:pPr algn="ctr">
+              <a:lnSpc>
+                <a:spcPct val="100000"/>
+              </a:lnSpc>
+            </a:pPr>
+            <a:r>
+              <a:rPr sz="1150" b="1">
+                <a:solidFill>
+                  <a:srgbClr val="FFFFFF"/>
+                </a:solidFill>
+                <a:latin typeface="Microsoft YaHei"/>
+              </a:rPr>
+              <a:t>＋ 新建任务</a:t>
+            </a:r>
+          </a:p>
+        </p:txBody>
+      </p:sp>
+      <p:sp>
+        <p:nvSpPr>
+          <p:cNvPr id="14" name="TextBox 13"/>
+          <p:cNvSpPr txBox="1"/>
+          <p:nvPr/>
+        </p:nvSpPr>
+        <p:spPr>
+          <a:xfrm>
+            <a:off x="685800" y="859536"/>
+            <a:ext cx="10789920" cy="438912"/>
+          </a:xfrm>
+          <a:prstGeom prst="rect">
+            <a:avLst/>
+          </a:prstGeom>
+          <a:noFill/>
+        </p:spPr>
+        <p:txBody>
+          <a:bodyPr wrap="square" anchor="t">
+            <a:spAutoFit/>
+          </a:bodyPr>
+          <a:lstStyle/>
+          <a:p>
+            <a:pPr algn="l">
+              <a:lnSpc>
+                <a:spcPct val="100000"/>
+              </a:lnSpc>
+            </a:pPr>
+            <a:r>
+              <a:rPr sz="2300" b="1">
+                <a:solidFill>
+                  <a:srgbClr val="222A35"/>
+                </a:solidFill>
+                <a:latin typeface="Microsoft YaHei"/>
+              </a:rPr>
+              <a:t>工作台 · 四阶段运行视图</a:t>
+            </a:r>
+          </a:p>
+        </p:txBody>
+      </p:sp>
+      <p:sp>
+        <p:nvSpPr>
+          <p:cNvPr id="15" name="TextBox 14"/>
+          <p:cNvSpPr txBox="1"/>
+          <p:nvPr/>
+        </p:nvSpPr>
+        <p:spPr>
+          <a:xfrm>
+            <a:off x="685800" y="1280160"/>
+            <a:ext cx="10789920" cy="310896"/>
+          </a:xfrm>
+          <a:prstGeom prst="rect">
+            <a:avLst/>
+          </a:prstGeom>
+          <a:noFill/>
+        </p:spPr>
+        <p:txBody>
+          <a:bodyPr wrap="square" anchor="t">
+            <a:spAutoFit/>
+          </a:bodyPr>
+          <a:lstStyle/>
+          <a:p>
+            <a:pPr algn="l">
+              <a:lnSpc>
+                <a:spcPct val="100000"/>
+              </a:lnSpc>
+            </a:pPr>
+            <a:r>
+              <a:rPr sz="1200" b="0">
+                <a:solidFill>
+                  <a:srgbClr val="66707D"/>
+                </a:solidFill>
+                <a:latin typeface="Microsoft YaHei"/>
+              </a:rPr>
+              <a:t>复杂任务被拆解为可验证阶段，状态、指标与证据实时可见</a:t>
+            </a:r>
+          </a:p>
+        </p:txBody>
+      </p:sp>
+      <p:sp>
+        <p:nvSpPr>
+          <p:cNvPr id="16" name="Rounded Rectangle 15"/>
+          <p:cNvSpPr/>
+          <p:nvPr/>
+        </p:nvSpPr>
+        <p:spPr>
+          <a:xfrm>
+            <a:off x="685800" y="1682496"/>
+            <a:ext cx="2615184" cy="713232"/>
+          </a:xfrm>
+          <a:prstGeom prst="roundRect">
+            <a:avLst>
+              <a:gd name="adj" fmla="val 10000"/>
             </a:avLst>
           </a:prstGeom>
           <a:solidFill>
@@ -5760,58 +6125,17 @@
       </p:sp>
       <p:sp>
         <p:nvSpPr>
-          <p:cNvPr id="8" name="TextBox 7"/>
-          <p:cNvSpPr txBox="1"/>
-          <p:nvPr/>
-        </p:nvSpPr>
-        <p:spPr>
-          <a:xfrm>
-            <a:off x="8275320" y="246888"/>
-            <a:ext cx="1234440" cy="237744"/>
+          <p:cNvPr id="17" name="Rectangle 16"/>
+          <p:cNvSpPr/>
+          <p:nvPr/>
+        </p:nvSpPr>
+        <p:spPr>
+          <a:xfrm>
+            <a:off x="685800" y="1682496"/>
+            <a:ext cx="73152" cy="713232"/>
           </a:xfrm>
           <a:prstGeom prst="rect">
             <a:avLst/>
-          </a:prstGeom>
-          <a:noFill/>
-        </p:spPr>
-        <p:txBody>
-          <a:bodyPr wrap="square" anchor="t">
-            <a:spAutoFit/>
-          </a:bodyPr>
-          <a:lstStyle/>
-          <a:p>
-            <a:pPr algn="ctr">
-              <a:lnSpc>
-                <a:spcPct val="100000"/>
-              </a:lnSpc>
-            </a:pPr>
-            <a:r>
-              <a:rPr sz="1050" b="0">
-                <a:solidFill>
-                  <a:srgbClr val="66707D"/>
-                </a:solidFill>
-                <a:latin typeface="Microsoft YaHei"/>
-              </a:rPr>
-              <a:t>帮助文档</a:t>
-            </a:r>
-          </a:p>
-        </p:txBody>
-      </p:sp>
-      <p:sp>
-        <p:nvSpPr>
-          <p:cNvPr id="9" name="Rounded Rectangle 8"/>
-          <p:cNvSpPr/>
-          <p:nvPr/>
-        </p:nvSpPr>
-        <p:spPr>
-          <a:xfrm>
-            <a:off x="9646920" y="173736"/>
-            <a:ext cx="2057400" cy="384048"/>
-          </a:xfrm>
-          <a:prstGeom prst="roundRect">
-            <a:avLst>
-              <a:gd name="adj" fmla="val 50000"/>
-            </a:avLst>
           </a:prstGeom>
           <a:solidFill>
             <a:srgbClr val="3B82F6"/>
@@ -5845,53 +6169,14 @@
       </p:sp>
       <p:sp>
         <p:nvSpPr>
-          <p:cNvPr id="10" name="TextBox 9"/>
+          <p:cNvPr id="18" name="TextBox 17"/>
           <p:cNvSpPr txBox="1"/>
           <p:nvPr/>
         </p:nvSpPr>
         <p:spPr>
           <a:xfrm>
-            <a:off x="9646920" y="237744"/>
-            <a:ext cx="2057400" cy="274320"/>
-          </a:xfrm>
-          <a:prstGeom prst="rect">
-            <a:avLst/>
-          </a:prstGeom>
-          <a:noFill/>
-        </p:spPr>
-        <p:txBody>
-          <a:bodyPr wrap="square" anchor="t">
-            <a:spAutoFit/>
-          </a:bodyPr>
-          <a:lstStyle/>
-          <a:p>
-            <a:pPr algn="ctr">
-              <a:lnSpc>
-                <a:spcPct val="100000"/>
-              </a:lnSpc>
-            </a:pPr>
-            <a:r>
-              <a:rPr sz="1150" b="1">
-                <a:solidFill>
-                  <a:srgbClr val="FFFFFF"/>
-                </a:solidFill>
-                <a:latin typeface="Microsoft YaHei"/>
-              </a:rPr>
-              <a:t>＋ 新建任务</a:t>
-            </a:r>
-          </a:p>
-        </p:txBody>
-      </p:sp>
-      <p:sp>
-        <p:nvSpPr>
-          <p:cNvPr id="11" name="TextBox 10"/>
-          <p:cNvSpPr txBox="1"/>
-          <p:nvPr/>
-        </p:nvSpPr>
-        <p:spPr>
-          <a:xfrm>
-            <a:off x="685800" y="896112"/>
-            <a:ext cx="10789920" cy="475488"/>
+            <a:off x="886968" y="1755648"/>
+            <a:ext cx="2249424" cy="274320"/>
           </a:xfrm>
           <a:prstGeom prst="rect">
             <a:avLst/>
@@ -5910,27 +6195,27 @@
               </a:lnSpc>
             </a:pPr>
             <a:r>
-              <a:rPr sz="2500" b="1">
+              <a:rPr sz="1800" b="1">
                 <a:solidFill>
                   <a:srgbClr val="222A35"/>
                 </a:solidFill>
                 <a:latin typeface="Microsoft YaHei"/>
               </a:rPr>
-              <a:t>工作台 · 四阶段运行视图</a:t>
-            </a:r>
-          </a:p>
-        </p:txBody>
-      </p:sp>
-      <p:sp>
-        <p:nvSpPr>
-          <p:cNvPr id="12" name="TextBox 11"/>
+              <a:t>1.2s</a:t>
+            </a:r>
+          </a:p>
+        </p:txBody>
+      </p:sp>
+      <p:sp>
+        <p:nvSpPr>
+          <p:cNvPr id="19" name="TextBox 18"/>
           <p:cNvSpPr txBox="1"/>
           <p:nvPr/>
         </p:nvSpPr>
         <p:spPr>
           <a:xfrm>
-            <a:off x="685800" y="1353312"/>
-            <a:ext cx="10789920" cy="347472"/>
+            <a:off x="886968" y="2103120"/>
+            <a:ext cx="2249424" cy="219456"/>
           </a:xfrm>
           <a:prstGeom prst="rect">
             <a:avLst/>
@@ -5949,27 +6234,27 @@
               </a:lnSpc>
             </a:pPr>
             <a:r>
-              <a:rPr sz="1250" b="0">
+              <a:rPr sz="950" b="0">
                 <a:solidFill>
                   <a:srgbClr val="66707D"/>
                 </a:solidFill>
                 <a:latin typeface="Microsoft YaHei"/>
               </a:rPr>
-              <a:t>复杂任务被拆解为可验证阶段，状态、指标与证据实时可见</a:t>
-            </a:r>
-          </a:p>
-        </p:txBody>
-      </p:sp>
-      <p:sp>
-        <p:nvSpPr>
-          <p:cNvPr id="13" name="Rounded Rectangle 12"/>
+              <a:t>平均响应</a:t>
+            </a:r>
+          </a:p>
+        </p:txBody>
+      </p:sp>
+      <p:sp>
+        <p:nvSpPr>
+          <p:cNvPr id="20" name="Rounded Rectangle 19"/>
           <p:cNvSpPr/>
           <p:nvPr/>
         </p:nvSpPr>
         <p:spPr>
           <a:xfrm>
-            <a:off x="685800" y="1810512"/>
-            <a:ext cx="2615184" cy="804672"/>
+            <a:off x="3502152" y="1682496"/>
+            <a:ext cx="2615184" cy="713232"/>
           </a:xfrm>
           <a:prstGeom prst="roundRect">
             <a:avLst>
@@ -6010,20 +6295,20 @@
       </p:sp>
       <p:sp>
         <p:nvSpPr>
-          <p:cNvPr id="14" name="Rectangle 13"/>
+          <p:cNvPr id="21" name="Rectangle 20"/>
           <p:cNvSpPr/>
           <p:nvPr/>
         </p:nvSpPr>
         <p:spPr>
           <a:xfrm>
-            <a:off x="685800" y="1810512"/>
-            <a:ext cx="73152" cy="804672"/>
+            <a:off x="3502152" y="1682496"/>
+            <a:ext cx="73152" cy="713232"/>
           </a:xfrm>
           <a:prstGeom prst="rect">
             <a:avLst/>
           </a:prstGeom>
           <a:solidFill>
-            <a:srgbClr val="3B82F6"/>
+            <a:srgbClr val="10B981"/>
           </a:solidFill>
           <a:ln>
             <a:noFill/>
@@ -6054,14 +6339,14 @@
       </p:sp>
       <p:sp>
         <p:nvSpPr>
-          <p:cNvPr id="15" name="TextBox 14"/>
+          <p:cNvPr id="22" name="TextBox 21"/>
           <p:cNvSpPr txBox="1"/>
           <p:nvPr/>
         </p:nvSpPr>
         <p:spPr>
           <a:xfrm>
-            <a:off x="886968" y="1901952"/>
-            <a:ext cx="2249424" cy="310896"/>
+            <a:off x="3703320" y="1755648"/>
+            <a:ext cx="2249424" cy="274320"/>
           </a:xfrm>
           <a:prstGeom prst="rect">
             <a:avLst/>
@@ -6080,27 +6365,27 @@
               </a:lnSpc>
             </a:pPr>
             <a:r>
-              <a:rPr sz="1900" b="1">
+              <a:rPr sz="1800" b="1">
                 <a:solidFill>
                   <a:srgbClr val="222A35"/>
                 </a:solidFill>
                 <a:latin typeface="Microsoft YaHei"/>
               </a:rPr>
-              <a:t>1.2s</a:t>
-            </a:r>
-          </a:p>
-        </p:txBody>
-      </p:sp>
-      <p:sp>
-        <p:nvSpPr>
-          <p:cNvPr id="16" name="TextBox 15"/>
+              <a:t>98.2%</a:t>
+            </a:r>
+          </a:p>
+        </p:txBody>
+      </p:sp>
+      <p:sp>
+        <p:nvSpPr>
+          <p:cNvPr id="23" name="TextBox 22"/>
           <p:cNvSpPr txBox="1"/>
           <p:nvPr/>
         </p:nvSpPr>
         <p:spPr>
           <a:xfrm>
-            <a:off x="886968" y="2267712"/>
-            <a:ext cx="2249424" cy="237744"/>
+            <a:off x="3703320" y="2103120"/>
+            <a:ext cx="2249424" cy="219456"/>
           </a:xfrm>
           <a:prstGeom prst="rect">
             <a:avLst/>
@@ -6119,27 +6404,27 @@
               </a:lnSpc>
             </a:pPr>
             <a:r>
-              <a:rPr sz="1000" b="0">
+              <a:rPr sz="950" b="0">
                 <a:solidFill>
                   <a:srgbClr val="66707D"/>
                 </a:solidFill>
                 <a:latin typeface="Microsoft YaHei"/>
               </a:rPr>
-              <a:t>平均响应</a:t>
-            </a:r>
-          </a:p>
-        </p:txBody>
-      </p:sp>
-      <p:sp>
-        <p:nvSpPr>
-          <p:cNvPr id="17" name="Rounded Rectangle 16"/>
+              <a:t>任务完成率</a:t>
+            </a:r>
+          </a:p>
+        </p:txBody>
+      </p:sp>
+      <p:sp>
+        <p:nvSpPr>
+          <p:cNvPr id="24" name="Rounded Rectangle 23"/>
           <p:cNvSpPr/>
           <p:nvPr/>
         </p:nvSpPr>
         <p:spPr>
           <a:xfrm>
-            <a:off x="3502152" y="1810512"/>
-            <a:ext cx="2615184" cy="804672"/>
+            <a:off x="6318504" y="1682496"/>
+            <a:ext cx="2615184" cy="713232"/>
           </a:xfrm>
           <a:prstGeom prst="roundRect">
             <a:avLst>
@@ -6180,20 +6465,20 @@
       </p:sp>
       <p:sp>
         <p:nvSpPr>
-          <p:cNvPr id="18" name="Rectangle 17"/>
+          <p:cNvPr id="25" name="Rectangle 24"/>
           <p:cNvSpPr/>
           <p:nvPr/>
         </p:nvSpPr>
         <p:spPr>
           <a:xfrm>
-            <a:off x="3502152" y="1810512"/>
-            <a:ext cx="73152" cy="804672"/>
+            <a:off x="6318504" y="1682496"/>
+            <a:ext cx="73152" cy="713232"/>
           </a:xfrm>
           <a:prstGeom prst="rect">
             <a:avLst/>
           </a:prstGeom>
           <a:solidFill>
-            <a:srgbClr val="10B981"/>
+            <a:srgbClr val="F97A2E"/>
           </a:solidFill>
           <a:ln>
             <a:noFill/>
@@ -6224,14 +6509,14 @@
       </p:sp>
       <p:sp>
         <p:nvSpPr>
-          <p:cNvPr id="19" name="TextBox 18"/>
+          <p:cNvPr id="26" name="TextBox 25"/>
           <p:cNvSpPr txBox="1"/>
           <p:nvPr/>
         </p:nvSpPr>
         <p:spPr>
           <a:xfrm>
-            <a:off x="3703320" y="1901952"/>
-            <a:ext cx="2249424" cy="310896"/>
+            <a:off x="6519672" y="1755648"/>
+            <a:ext cx="2249424" cy="274320"/>
           </a:xfrm>
           <a:prstGeom prst="rect">
             <a:avLst/>
@@ -6250,27 +6535,27 @@
               </a:lnSpc>
             </a:pPr>
             <a:r>
-              <a:rPr sz="1900" b="1">
+              <a:rPr sz="1800" b="1">
                 <a:solidFill>
                   <a:srgbClr val="222A35"/>
                 </a:solidFill>
                 <a:latin typeface="Microsoft YaHei"/>
               </a:rPr>
-              <a:t>98.2%</a:t>
-            </a:r>
-          </a:p>
-        </p:txBody>
-      </p:sp>
-      <p:sp>
-        <p:nvSpPr>
-          <p:cNvPr id="20" name="TextBox 19"/>
+              <a:t>99.7%</a:t>
+            </a:r>
+          </a:p>
+        </p:txBody>
+      </p:sp>
+      <p:sp>
+        <p:nvSpPr>
+          <p:cNvPr id="27" name="TextBox 26"/>
           <p:cNvSpPr txBox="1"/>
           <p:nvPr/>
         </p:nvSpPr>
         <p:spPr>
           <a:xfrm>
-            <a:off x="3703320" y="2267712"/>
-            <a:ext cx="2249424" cy="237744"/>
+            <a:off x="6519672" y="2103120"/>
+            <a:ext cx="2249424" cy="219456"/>
           </a:xfrm>
           <a:prstGeom prst="rect">
             <a:avLst/>
@@ -6289,27 +6574,27 @@
               </a:lnSpc>
             </a:pPr>
             <a:r>
-              <a:rPr sz="1000" b="0">
+              <a:rPr sz="950" b="0">
                 <a:solidFill>
                   <a:srgbClr val="66707D"/>
                 </a:solidFill>
                 <a:latin typeface="Microsoft YaHei"/>
               </a:rPr>
-              <a:t>任务完成率</a:t>
-            </a:r>
-          </a:p>
-        </p:txBody>
-      </p:sp>
-      <p:sp>
-        <p:nvSpPr>
-          <p:cNvPr id="21" name="Rounded Rectangle 20"/>
+              <a:t>工具调用成功率</a:t>
+            </a:r>
+          </a:p>
+        </p:txBody>
+      </p:sp>
+      <p:sp>
+        <p:nvSpPr>
+          <p:cNvPr id="28" name="Rounded Rectangle 27"/>
           <p:cNvSpPr/>
           <p:nvPr/>
         </p:nvSpPr>
         <p:spPr>
           <a:xfrm>
-            <a:off x="6318504" y="1810512"/>
-            <a:ext cx="2615184" cy="804672"/>
+            <a:off x="9134856" y="1682496"/>
+            <a:ext cx="2615184" cy="713232"/>
           </a:xfrm>
           <a:prstGeom prst="roundRect">
             <a:avLst>
@@ -6350,20 +6635,20 @@
       </p:sp>
       <p:sp>
         <p:nvSpPr>
-          <p:cNvPr id="22" name="Rectangle 21"/>
+          <p:cNvPr id="29" name="Rectangle 28"/>
           <p:cNvSpPr/>
           <p:nvPr/>
         </p:nvSpPr>
         <p:spPr>
           <a:xfrm>
-            <a:off x="6318504" y="1810512"/>
-            <a:ext cx="73152" cy="804672"/>
+            <a:off x="9134856" y="1682496"/>
+            <a:ext cx="73152" cy="713232"/>
           </a:xfrm>
           <a:prstGeom prst="rect">
             <a:avLst/>
           </a:prstGeom>
           <a:solidFill>
-            <a:srgbClr val="F97A2E"/>
+            <a:srgbClr val="8B5CF6"/>
           </a:solidFill>
           <a:ln>
             <a:noFill/>
@@ -6394,14 +6679,14 @@
       </p:sp>
       <p:sp>
         <p:nvSpPr>
-          <p:cNvPr id="23" name="TextBox 22"/>
+          <p:cNvPr id="30" name="TextBox 29"/>
           <p:cNvSpPr txBox="1"/>
           <p:nvPr/>
         </p:nvSpPr>
         <p:spPr>
           <a:xfrm>
-            <a:off x="6519672" y="1901952"/>
-            <a:ext cx="2249424" cy="310896"/>
+            <a:off x="9336024" y="1755648"/>
+            <a:ext cx="2249424" cy="274320"/>
           </a:xfrm>
           <a:prstGeom prst="rect">
             <a:avLst/>
@@ -6420,27 +6705,27 @@
               </a:lnSpc>
             </a:pPr>
             <a:r>
-              <a:rPr sz="1900" b="1">
+              <a:rPr sz="1800" b="1">
                 <a:solidFill>
                   <a:srgbClr val="222A35"/>
                 </a:solidFill>
                 <a:latin typeface="Microsoft YaHei"/>
               </a:rPr>
-              <a:t>99.7%</a:t>
-            </a:r>
-          </a:p>
-        </p:txBody>
-      </p:sp>
-      <p:sp>
-        <p:nvSpPr>
-          <p:cNvPr id="24" name="TextBox 23"/>
+              <a:t>100%</a:t>
+            </a:r>
+          </a:p>
+        </p:txBody>
+      </p:sp>
+      <p:sp>
+        <p:nvSpPr>
+          <p:cNvPr id="31" name="TextBox 30"/>
           <p:cNvSpPr txBox="1"/>
           <p:nvPr/>
         </p:nvSpPr>
         <p:spPr>
           <a:xfrm>
-            <a:off x="6519672" y="2267712"/>
-            <a:ext cx="2249424" cy="237744"/>
+            <a:off x="9336024" y="2103120"/>
+            <a:ext cx="2249424" cy="219456"/>
           </a:xfrm>
           <a:prstGeom prst="rect">
             <a:avLst/>
@@ -6459,31 +6744,31 @@
               </a:lnSpc>
             </a:pPr>
             <a:r>
-              <a:rPr sz="1000" b="0">
+              <a:rPr sz="950" b="0">
                 <a:solidFill>
                   <a:srgbClr val="66707D"/>
                 </a:solidFill>
                 <a:latin typeface="Microsoft YaHei"/>
               </a:rPr>
-              <a:t>工具调用成功率</a:t>
-            </a:r>
-          </a:p>
-        </p:txBody>
-      </p:sp>
-      <p:sp>
-        <p:nvSpPr>
-          <p:cNvPr id="25" name="Rounded Rectangle 24"/>
+              <a:t>证据覆盖率</a:t>
+            </a:r>
+          </a:p>
+        </p:txBody>
+      </p:sp>
+      <p:sp>
+        <p:nvSpPr>
+          <p:cNvPr id="32" name="Rounded Rectangle 31"/>
           <p:cNvSpPr/>
           <p:nvPr/>
         </p:nvSpPr>
         <p:spPr>
           <a:xfrm>
-            <a:off x="9134856" y="1810512"/>
-            <a:ext cx="2615184" cy="804672"/>
+            <a:off x="685800" y="2523744"/>
+            <a:ext cx="5212080" cy="1810512"/>
           </a:xfrm>
           <a:prstGeom prst="roundRect">
             <a:avLst>
-              <a:gd name="adj" fmla="val 10000"/>
+              <a:gd name="adj" fmla="val 7000"/>
             </a:avLst>
           </a:prstGeom>
           <a:solidFill>
@@ -6520,20 +6805,20 @@
       </p:sp>
       <p:sp>
         <p:nvSpPr>
-          <p:cNvPr id="26" name="Rectangle 25"/>
+          <p:cNvPr id="33" name="Rectangle 32"/>
           <p:cNvSpPr/>
           <p:nvPr/>
         </p:nvSpPr>
         <p:spPr>
           <a:xfrm>
-            <a:off x="9134856" y="1810512"/>
-            <a:ext cx="73152" cy="804672"/>
+            <a:off x="685800" y="2523744"/>
+            <a:ext cx="82296" cy="1810512"/>
           </a:xfrm>
           <a:prstGeom prst="rect">
             <a:avLst/>
           </a:prstGeom>
           <a:solidFill>
-            <a:srgbClr val="8B5CF6"/>
+            <a:srgbClr val="3B82F6"/>
           </a:solidFill>
           <a:ln>
             <a:noFill/>
@@ -6564,14 +6849,99 @@
       </p:sp>
       <p:sp>
         <p:nvSpPr>
-          <p:cNvPr id="27" name="TextBox 26"/>
+          <p:cNvPr id="34" name="Rounded Rectangle 33"/>
+          <p:cNvSpPr/>
+          <p:nvPr/>
+        </p:nvSpPr>
+        <p:spPr>
+          <a:xfrm>
+            <a:off x="923544" y="2688336"/>
+            <a:ext cx="457200" cy="457200"/>
+          </a:xfrm>
+          <a:prstGeom prst="roundRect">
+            <a:avLst>
+              <a:gd name="adj" fmla="val 20000"/>
+            </a:avLst>
+          </a:prstGeom>
+          <a:solidFill>
+            <a:srgbClr val="3B82F6"/>
+          </a:solidFill>
+          <a:ln>
+            <a:noFill/>
+          </a:ln>
+          <a:effectLst/>
+        </p:spPr>
+        <p:style>
+          <a:lnRef idx="1">
+            <a:schemeClr val="accent1"/>
+          </a:lnRef>
+          <a:fillRef idx="3">
+            <a:schemeClr val="accent1"/>
+          </a:fillRef>
+          <a:effectRef idx="2">
+            <a:schemeClr val="accent1"/>
+          </a:effectRef>
+          <a:fontRef idx="minor">
+            <a:schemeClr val="lt1"/>
+          </a:fontRef>
+        </p:style>
+        <p:txBody>
+          <a:bodyPr rtlCol="0" anchor="ctr"/>
+          <a:lstStyle/>
+          <a:p>
+            <a:pPr algn="ctr"/>
+          </a:p>
+        </p:txBody>
+      </p:sp>
+      <p:sp>
+        <p:nvSpPr>
+          <p:cNvPr id="35" name="TextBox 34"/>
           <p:cNvSpPr txBox="1"/>
           <p:nvPr/>
         </p:nvSpPr>
         <p:spPr>
           <a:xfrm>
-            <a:off x="9336024" y="1901952"/>
-            <a:ext cx="2249424" cy="310896"/>
+            <a:off x="923544" y="2743200"/>
+            <a:ext cx="457200" cy="329184"/>
+          </a:xfrm>
+          <a:prstGeom prst="rect">
+            <a:avLst/>
+          </a:prstGeom>
+          <a:noFill/>
+        </p:spPr>
+        <p:txBody>
+          <a:bodyPr wrap="square" anchor="t">
+            <a:spAutoFit/>
+          </a:bodyPr>
+          <a:lstStyle/>
+          <a:p>
+            <a:pPr algn="ctr">
+              <a:lnSpc>
+                <a:spcPct val="100000"/>
+              </a:lnSpc>
+            </a:pPr>
+            <a:r>
+              <a:rPr sz="1300" b="1">
+                <a:solidFill>
+                  <a:srgbClr val="FFFFFF"/>
+                </a:solidFill>
+                <a:latin typeface="Microsoft YaHei"/>
+              </a:rPr>
+              <a:t>01</a:t>
+            </a:r>
+          </a:p>
+        </p:txBody>
+      </p:sp>
+      <p:sp>
+        <p:nvSpPr>
+          <p:cNvPr id="36" name="TextBox 35"/>
+          <p:cNvSpPr txBox="1"/>
+          <p:nvPr/>
+        </p:nvSpPr>
+        <p:spPr>
+          <a:xfrm>
+            <a:off x="1508760" y="2670048"/>
+            <a:ext cx="2194560" cy="310896"/>
           </a:xfrm>
           <a:prstGeom prst="rect">
             <a:avLst/>
@@ -6590,27 +6960,440 @@
               </a:lnSpc>
             </a:pPr>
             <a:r>
-              <a:rPr sz="1900" b="1">
+              <a:rPr sz="1450" b="1">
                 <a:solidFill>
                   <a:srgbClr val="222A35"/>
                 </a:solidFill>
                 <a:latin typeface="Microsoft YaHei"/>
               </a:rPr>
-              <a:t>100%</a:t>
-            </a:r>
-          </a:p>
-        </p:txBody>
-      </p:sp>
-      <p:sp>
-        <p:nvSpPr>
-          <p:cNvPr id="28" name="TextBox 27"/>
+              <a:t>输入 Input</a:t>
+            </a:r>
+          </a:p>
+        </p:txBody>
+      </p:sp>
+      <p:sp>
+        <p:nvSpPr>
+          <p:cNvPr id="37" name="Rounded Rectangle 36"/>
+          <p:cNvSpPr/>
+          <p:nvPr/>
+        </p:nvSpPr>
+        <p:spPr>
+          <a:xfrm>
+            <a:off x="4599432" y="2724912"/>
+            <a:ext cx="1042415" cy="256032"/>
+          </a:xfrm>
+          <a:prstGeom prst="roundRect">
+            <a:avLst>
+              <a:gd name="adj" fmla="val 50000"/>
+            </a:avLst>
+          </a:prstGeom>
+          <a:solidFill>
+            <a:srgbClr val="F3F5F8"/>
+          </a:solidFill>
+          <a:ln>
+            <a:noFill/>
+          </a:ln>
+          <a:effectLst/>
+        </p:spPr>
+        <p:style>
+          <a:lnRef idx="1">
+            <a:schemeClr val="accent1"/>
+          </a:lnRef>
+          <a:fillRef idx="3">
+            <a:schemeClr val="accent1"/>
+          </a:fillRef>
+          <a:effectRef idx="2">
+            <a:schemeClr val="accent1"/>
+          </a:effectRef>
+          <a:fontRef idx="minor">
+            <a:schemeClr val="lt1"/>
+          </a:fontRef>
+        </p:style>
+        <p:txBody>
+          <a:bodyPr rtlCol="0" anchor="ctr"/>
+          <a:lstStyle/>
+          <a:p>
+            <a:pPr algn="ctr"/>
+          </a:p>
+        </p:txBody>
+      </p:sp>
+      <p:sp>
+        <p:nvSpPr>
+          <p:cNvPr id="38" name="TextBox 37"/>
           <p:cNvSpPr txBox="1"/>
           <p:nvPr/>
         </p:nvSpPr>
         <p:spPr>
           <a:xfrm>
-            <a:off x="9336024" y="2267712"/>
-            <a:ext cx="2249424" cy="237744"/>
+            <a:off x="4599432" y="2752344"/>
+            <a:ext cx="1042415" cy="182880"/>
+          </a:xfrm>
+          <a:prstGeom prst="rect">
+            <a:avLst/>
+          </a:prstGeom>
+          <a:noFill/>
+        </p:spPr>
+        <p:txBody>
+          <a:bodyPr wrap="square" anchor="t">
+            <a:spAutoFit/>
+          </a:bodyPr>
+          <a:lstStyle/>
+          <a:p>
+            <a:pPr algn="ctr">
+              <a:lnSpc>
+                <a:spcPct val="100000"/>
+              </a:lnSpc>
+            </a:pPr>
+            <a:r>
+              <a:rPr sz="800" b="1">
+                <a:solidFill>
+                  <a:srgbClr val="3B82F6"/>
+                </a:solidFill>
+                <a:latin typeface="Microsoft YaHei"/>
+              </a:rPr>
+              <a:t>INPUT</a:t>
+            </a:r>
+          </a:p>
+        </p:txBody>
+      </p:sp>
+      <p:sp>
+        <p:nvSpPr>
+          <p:cNvPr id="39" name="TextBox 38"/>
+          <p:cNvSpPr txBox="1"/>
+          <p:nvPr/>
+        </p:nvSpPr>
+        <p:spPr>
+          <a:xfrm>
+            <a:off x="941832" y="3218687"/>
+            <a:ext cx="4700016" cy="420624"/>
+          </a:xfrm>
+          <a:prstGeom prst="rect">
+            <a:avLst/>
+          </a:prstGeom>
+          <a:noFill/>
+        </p:spPr>
+        <p:txBody>
+          <a:bodyPr wrap="square" anchor="t">
+            <a:spAutoFit/>
+          </a:bodyPr>
+          <a:lstStyle/>
+          <a:p>
+            <a:pPr algn="l">
+              <a:lnSpc>
+                <a:spcPct val="102000"/>
+              </a:lnSpc>
+            </a:pPr>
+            <a:r>
+              <a:rPr sz="1050" b="0">
+                <a:solidFill>
+                  <a:srgbClr val="66707D"/>
+                </a:solidFill>
+                <a:latin typeface="Microsoft YaHei"/>
+              </a:rPr>
+              <a:t>接收指令、附件与工作区上下文，完成意图澄清与队列排序。</a:t>
+            </a:r>
+          </a:p>
+        </p:txBody>
+      </p:sp>
+      <p:sp>
+        <p:nvSpPr>
+          <p:cNvPr id="40" name="TextBox 39"/>
+          <p:cNvSpPr txBox="1"/>
+          <p:nvPr/>
+        </p:nvSpPr>
+        <p:spPr>
+          <a:xfrm>
+            <a:off x="941832" y="3657600"/>
+            <a:ext cx="4059936" cy="530352"/>
+          </a:xfrm>
+          <a:prstGeom prst="rect">
+            <a:avLst/>
+          </a:prstGeom>
+          <a:noFill/>
+        </p:spPr>
+        <p:txBody>
+          <a:bodyPr wrap="square" anchor="t">
+            <a:spAutoFit/>
+          </a:bodyPr>
+          <a:lstStyle/>
+          <a:p>
+            <a:pPr algn="l">
+              <a:lnSpc>
+                <a:spcPct val="98000"/>
+              </a:lnSpc>
+            </a:pPr>
+            <a:r>
+              <a:rPr sz="950" b="0">
+                <a:solidFill>
+                  <a:srgbClr val="222A35"/>
+                </a:solidFill>
+                <a:latin typeface="Microsoft YaHei"/>
+              </a:rPr>
+              <a:t>•  自然语言与多模态输入</a:t>
+            </a:r>
+          </a:p>
+          <a:p>
+            <a:pPr algn="l">
+              <a:lnSpc>
+                <a:spcPct val="98000"/>
+              </a:lnSpc>
+            </a:pPr>
+            <a:r>
+              <a:rPr sz="950" b="0">
+                <a:solidFill>
+                  <a:srgbClr val="222A35"/>
+                </a:solidFill>
+                <a:latin typeface="Microsoft YaHei"/>
+              </a:rPr>
+              <a:t>•  自动发现任务相关文件</a:t>
+            </a:r>
+          </a:p>
+          <a:p>
+            <a:pPr algn="l">
+              <a:lnSpc>
+                <a:spcPct val="98000"/>
+              </a:lnSpc>
+            </a:pPr>
+            <a:r>
+              <a:rPr sz="950" b="0">
+                <a:solidFill>
+                  <a:srgbClr val="222A35"/>
+                </a:solidFill>
+                <a:latin typeface="Microsoft YaHei"/>
+              </a:rPr>
+              <a:t>•  生成结构化任务对象</a:t>
+            </a:r>
+          </a:p>
+        </p:txBody>
+      </p:sp>
+      <p:sp>
+        <p:nvSpPr>
+          <p:cNvPr id="41" name="Rounded Rectangle 40"/>
+          <p:cNvSpPr/>
+          <p:nvPr/>
+        </p:nvSpPr>
+        <p:spPr>
+          <a:xfrm>
+            <a:off x="4928616" y="3657600"/>
+            <a:ext cx="694944" cy="530352"/>
+          </a:xfrm>
+          <a:prstGeom prst="roundRect">
+            <a:avLst>
+              <a:gd name="adj" fmla="val 10000"/>
+            </a:avLst>
+          </a:prstGeom>
+          <a:solidFill>
+            <a:srgbClr val="F3F5F8"/>
+          </a:solidFill>
+          <a:ln w="9525">
+            <a:solidFill>
+              <a:srgbClr val="DFE5EC"/>
+            </a:solidFill>
+          </a:ln>
+          <a:effectLst/>
+        </p:spPr>
+        <p:style>
+          <a:lnRef idx="1">
+            <a:schemeClr val="accent1"/>
+          </a:lnRef>
+          <a:fillRef idx="3">
+            <a:schemeClr val="accent1"/>
+          </a:fillRef>
+          <a:effectRef idx="2">
+            <a:schemeClr val="accent1"/>
+          </a:effectRef>
+          <a:fontRef idx="minor">
+            <a:schemeClr val="lt1"/>
+          </a:fontRef>
+        </p:style>
+        <p:txBody>
+          <a:bodyPr rtlCol="0" anchor="ctr"/>
+          <a:lstStyle/>
+          <a:p>
+            <a:pPr algn="ctr"/>
+          </a:p>
+        </p:txBody>
+      </p:sp>
+      <p:sp>
+        <p:nvSpPr>
+          <p:cNvPr id="42" name="TextBox 41"/>
+          <p:cNvSpPr txBox="1"/>
+          <p:nvPr/>
+        </p:nvSpPr>
+        <p:spPr>
+          <a:xfrm>
+            <a:off x="4928616" y="3712463"/>
+            <a:ext cx="694944" cy="219456"/>
+          </a:xfrm>
+          <a:prstGeom prst="rect">
+            <a:avLst/>
+          </a:prstGeom>
+          <a:noFill/>
+        </p:spPr>
+        <p:txBody>
+          <a:bodyPr wrap="square" anchor="t">
+            <a:spAutoFit/>
+          </a:bodyPr>
+          <a:lstStyle/>
+          <a:p>
+            <a:pPr algn="ctr">
+              <a:lnSpc>
+                <a:spcPct val="100000"/>
+              </a:lnSpc>
+            </a:pPr>
+            <a:r>
+              <a:rPr sz="1250" b="1">
+                <a:solidFill>
+                  <a:srgbClr val="3B82F6"/>
+                </a:solidFill>
+                <a:latin typeface="Microsoft YaHei"/>
+              </a:rPr>
+              <a:t>12+</a:t>
+            </a:r>
+          </a:p>
+        </p:txBody>
+      </p:sp>
+      <p:sp>
+        <p:nvSpPr>
+          <p:cNvPr id="43" name="TextBox 42"/>
+          <p:cNvSpPr txBox="1"/>
+          <p:nvPr/>
+        </p:nvSpPr>
+        <p:spPr>
+          <a:xfrm>
+            <a:off x="4928616" y="3968496"/>
+            <a:ext cx="694944" cy="182880"/>
+          </a:xfrm>
+          <a:prstGeom prst="rect">
+            <a:avLst/>
+          </a:prstGeom>
+          <a:noFill/>
+        </p:spPr>
+        <p:txBody>
+          <a:bodyPr wrap="square" anchor="t">
+            <a:spAutoFit/>
+          </a:bodyPr>
+          <a:lstStyle/>
+          <a:p>
+            <a:pPr algn="ctr">
+              <a:lnSpc>
+                <a:spcPct val="100000"/>
+              </a:lnSpc>
+            </a:pPr>
+            <a:r>
+              <a:rPr sz="700" b="0">
+                <a:solidFill>
+                  <a:srgbClr val="66707D"/>
+                </a:solidFill>
+                <a:latin typeface="Microsoft YaHei"/>
+              </a:rPr>
+              <a:t>输入类型</a:t>
+            </a:r>
+          </a:p>
+        </p:txBody>
+      </p:sp>
+      <p:sp>
+        <p:nvSpPr>
+          <p:cNvPr id="44" name="Rounded Rectangle 43"/>
+          <p:cNvSpPr/>
+          <p:nvPr/>
+        </p:nvSpPr>
+        <p:spPr>
+          <a:xfrm>
+            <a:off x="941832" y="4279392"/>
+            <a:ext cx="4059936" cy="91440"/>
+          </a:xfrm>
+          <a:prstGeom prst="roundRect">
+            <a:avLst>
+              <a:gd name="adj" fmla="val 50000"/>
+            </a:avLst>
+          </a:prstGeom>
+          <a:solidFill>
+            <a:srgbClr val="2A3D5A"/>
+          </a:solidFill>
+          <a:ln>
+            <a:noFill/>
+          </a:ln>
+          <a:effectLst/>
+        </p:spPr>
+        <p:style>
+          <a:lnRef idx="1">
+            <a:schemeClr val="accent1"/>
+          </a:lnRef>
+          <a:fillRef idx="3">
+            <a:schemeClr val="accent1"/>
+          </a:fillRef>
+          <a:effectRef idx="2">
+            <a:schemeClr val="accent1"/>
+          </a:effectRef>
+          <a:fontRef idx="minor">
+            <a:schemeClr val="lt1"/>
+          </a:fontRef>
+        </p:style>
+        <p:txBody>
+          <a:bodyPr rtlCol="0" anchor="ctr"/>
+          <a:lstStyle/>
+          <a:p>
+            <a:pPr algn="ctr"/>
+          </a:p>
+        </p:txBody>
+      </p:sp>
+      <p:sp>
+        <p:nvSpPr>
+          <p:cNvPr id="45" name="Rounded Rectangle 44"/>
+          <p:cNvSpPr/>
+          <p:nvPr/>
+        </p:nvSpPr>
+        <p:spPr>
+          <a:xfrm>
+            <a:off x="941832" y="4279392"/>
+            <a:ext cx="4059936" cy="91440"/>
+          </a:xfrm>
+          <a:prstGeom prst="roundRect">
+            <a:avLst>
+              <a:gd name="adj" fmla="val 50000"/>
+            </a:avLst>
+          </a:prstGeom>
+          <a:solidFill>
+            <a:srgbClr val="3B82F6"/>
+          </a:solidFill>
+          <a:ln>
+            <a:noFill/>
+          </a:ln>
+          <a:effectLst/>
+        </p:spPr>
+        <p:style>
+          <a:lnRef idx="1">
+            <a:schemeClr val="accent1"/>
+          </a:lnRef>
+          <a:fillRef idx="3">
+            <a:schemeClr val="accent1"/>
+          </a:fillRef>
+          <a:effectRef idx="2">
+            <a:schemeClr val="accent1"/>
+          </a:effectRef>
+          <a:fontRef idx="minor">
+            <a:schemeClr val="lt1"/>
+          </a:fontRef>
+        </p:style>
+        <p:txBody>
+          <a:bodyPr rtlCol="0" anchor="ctr"/>
+          <a:lstStyle/>
+          <a:p>
+            <a:pPr algn="ctr"/>
+          </a:p>
+        </p:txBody>
+      </p:sp>
+      <p:sp>
+        <p:nvSpPr>
+          <p:cNvPr id="46" name="TextBox 45"/>
+          <p:cNvSpPr txBox="1"/>
+          <p:nvPr/>
+        </p:nvSpPr>
+        <p:spPr>
+          <a:xfrm>
+            <a:off x="941832" y="4334256"/>
+            <a:ext cx="914400" cy="146304"/>
           </a:xfrm>
           <a:prstGeom prst="rect">
             <a:avLst/>
@@ -6629,31 +7412,109 @@
               </a:lnSpc>
             </a:pPr>
             <a:r>
-              <a:rPr sz="1000" b="0">
-                <a:solidFill>
-                  <a:srgbClr val="66707D"/>
+              <a:rPr sz="750" b="1">
+                <a:solidFill>
+                  <a:srgbClr val="3B82F6"/>
                 </a:solidFill>
                 <a:latin typeface="Microsoft YaHei"/>
               </a:rPr>
-              <a:t>证据覆盖率</a:t>
-            </a:r>
-          </a:p>
-        </p:txBody>
-      </p:sp>
-      <p:sp>
-        <p:nvSpPr>
-          <p:cNvPr id="29" name="Rounded Rectangle 28"/>
+              <a:t>查看日志</a:t>
+            </a:r>
+          </a:p>
+        </p:txBody>
+      </p:sp>
+      <p:sp>
+        <p:nvSpPr>
+          <p:cNvPr id="47" name="TextBox 46"/>
+          <p:cNvSpPr txBox="1"/>
+          <p:nvPr/>
+        </p:nvSpPr>
+        <p:spPr>
+          <a:xfrm>
+            <a:off x="1819656" y="4334256"/>
+            <a:ext cx="914400" cy="146304"/>
+          </a:xfrm>
+          <a:prstGeom prst="rect">
+            <a:avLst/>
+          </a:prstGeom>
+          <a:noFill/>
+        </p:spPr>
+        <p:txBody>
+          <a:bodyPr wrap="square" anchor="t">
+            <a:spAutoFit/>
+          </a:bodyPr>
+          <a:lstStyle/>
+          <a:p>
+            <a:pPr algn="l">
+              <a:lnSpc>
+                <a:spcPct val="100000"/>
+              </a:lnSpc>
+            </a:pPr>
+            <a:r>
+              <a:rPr sz="750" b="1">
+                <a:solidFill>
+                  <a:srgbClr val="3B82F6"/>
+                </a:solidFill>
+                <a:latin typeface="Microsoft YaHei"/>
+              </a:rPr>
+              <a:t>查看证据</a:t>
+            </a:r>
+          </a:p>
+        </p:txBody>
+      </p:sp>
+      <p:sp>
+        <p:nvSpPr>
+          <p:cNvPr id="48" name="TextBox 47"/>
+          <p:cNvSpPr txBox="1"/>
+          <p:nvPr/>
+        </p:nvSpPr>
+        <p:spPr>
+          <a:xfrm>
+            <a:off x="2697480" y="4334256"/>
+            <a:ext cx="914400" cy="146304"/>
+          </a:xfrm>
+          <a:prstGeom prst="rect">
+            <a:avLst/>
+          </a:prstGeom>
+          <a:noFill/>
+        </p:spPr>
+        <p:txBody>
+          <a:bodyPr wrap="square" anchor="t">
+            <a:spAutoFit/>
+          </a:bodyPr>
+          <a:lstStyle/>
+          <a:p>
+            <a:pPr algn="l">
+              <a:lnSpc>
+                <a:spcPct val="100000"/>
+              </a:lnSpc>
+            </a:pPr>
+            <a:r>
+              <a:rPr sz="750" b="1">
+                <a:solidFill>
+                  <a:srgbClr val="3B82F6"/>
+                </a:solidFill>
+                <a:latin typeface="Microsoft YaHei"/>
+              </a:rPr>
+              <a:t>导出</a:t>
+            </a:r>
+          </a:p>
+        </p:txBody>
+      </p:sp>
+      <p:sp>
+        <p:nvSpPr>
+          <p:cNvPr id="49" name="Rounded Rectangle 48"/>
           <p:cNvSpPr/>
           <p:nvPr/>
         </p:nvSpPr>
         <p:spPr>
           <a:xfrm>
-            <a:off x="685800" y="2761488"/>
-            <a:ext cx="5212080" cy="2267712"/>
+            <a:off x="6309360" y="2523744"/>
+            <a:ext cx="5212080" cy="1810512"/>
           </a:xfrm>
           <a:prstGeom prst="roundRect">
             <a:avLst>
-              <a:gd name="adj" fmla="val 6000"/>
+              <a:gd name="adj" fmla="val 7000"/>
             </a:avLst>
           </a:prstGeom>
           <a:solidFill>
@@ -6690,20 +7551,20 @@
       </p:sp>
       <p:sp>
         <p:nvSpPr>
-          <p:cNvPr id="30" name="Rectangle 29"/>
+          <p:cNvPr id="50" name="Rectangle 49"/>
           <p:cNvSpPr/>
           <p:nvPr/>
         </p:nvSpPr>
         <p:spPr>
           <a:xfrm>
-            <a:off x="685800" y="2761488"/>
-            <a:ext cx="82296" cy="2267712"/>
+            <a:off x="6309360" y="2523744"/>
+            <a:ext cx="82296" cy="1810512"/>
           </a:xfrm>
           <a:prstGeom prst="rect">
             <a:avLst/>
           </a:prstGeom>
           <a:solidFill>
-            <a:srgbClr val="3B82F6"/>
+            <a:srgbClr val="10B981"/>
           </a:solidFill>
           <a:ln>
             <a:noFill/>
@@ -6734,22 +7595,22 @@
       </p:sp>
       <p:sp>
         <p:nvSpPr>
-          <p:cNvPr id="31" name="Rounded Rectangle 30"/>
+          <p:cNvPr id="51" name="Rounded Rectangle 50"/>
           <p:cNvSpPr/>
           <p:nvPr/>
         </p:nvSpPr>
         <p:spPr>
           <a:xfrm>
-            <a:off x="960120" y="2962656"/>
-            <a:ext cx="566928" cy="566928"/>
+            <a:off x="6547104" y="2688336"/>
+            <a:ext cx="457200" cy="457200"/>
           </a:xfrm>
           <a:prstGeom prst="roundRect">
             <a:avLst>
-              <a:gd name="adj" fmla="val 18000"/>
+              <a:gd name="adj" fmla="val 20000"/>
             </a:avLst>
           </a:prstGeom>
           <a:solidFill>
-            <a:srgbClr val="3B82F6"/>
+            <a:srgbClr val="10B981"/>
           </a:solidFill>
           <a:ln>
             <a:noFill/>
@@ -6780,14 +7641,14 @@
       </p:sp>
       <p:sp>
         <p:nvSpPr>
-          <p:cNvPr id="32" name="TextBox 31"/>
+          <p:cNvPr id="52" name="TextBox 51"/>
           <p:cNvSpPr txBox="1"/>
           <p:nvPr/>
         </p:nvSpPr>
         <p:spPr>
           <a:xfrm>
-            <a:off x="960120" y="3035808"/>
-            <a:ext cx="566928" cy="411480"/>
+            <a:off x="6547104" y="2743200"/>
+            <a:ext cx="457200" cy="329184"/>
           </a:xfrm>
           <a:prstGeom prst="rect">
             <a:avLst/>
@@ -6806,27 +7667,27 @@
               </a:lnSpc>
             </a:pPr>
             <a:r>
-              <a:rPr sz="1400" b="1">
+              <a:rPr sz="1300" b="1">
                 <a:solidFill>
                   <a:srgbClr val="FFFFFF"/>
                 </a:solidFill>
                 <a:latin typeface="Microsoft YaHei"/>
               </a:rPr>
-              <a:t>01</a:t>
-            </a:r>
-          </a:p>
-        </p:txBody>
-      </p:sp>
-      <p:sp>
-        <p:nvSpPr>
-          <p:cNvPr id="33" name="TextBox 32"/>
+              <a:t>02</a:t>
+            </a:r>
+          </a:p>
+        </p:txBody>
+      </p:sp>
+      <p:sp>
+        <p:nvSpPr>
+          <p:cNvPr id="53" name="TextBox 52"/>
           <p:cNvSpPr txBox="1"/>
           <p:nvPr/>
         </p:nvSpPr>
         <p:spPr>
           <a:xfrm>
-            <a:off x="1673352" y="2944368"/>
-            <a:ext cx="2377440" cy="365760"/>
+            <a:off x="7132320" y="2670048"/>
+            <a:ext cx="2194560" cy="310896"/>
           </a:xfrm>
           <a:prstGeom prst="rect">
             <a:avLst/>
@@ -6845,27 +7706,27 @@
               </a:lnSpc>
             </a:pPr>
             <a:r>
-              <a:rPr sz="1600" b="1">
+              <a:rPr sz="1450" b="1">
                 <a:solidFill>
                   <a:srgbClr val="222A35"/>
                 </a:solidFill>
                 <a:latin typeface="Microsoft YaHei"/>
               </a:rPr>
-              <a:t>输入 Input</a:t>
-            </a:r>
-          </a:p>
-        </p:txBody>
-      </p:sp>
-      <p:sp>
-        <p:nvSpPr>
-          <p:cNvPr id="34" name="Rounded Rectangle 33"/>
+              <a:t>理解 Understand</a:t>
+            </a:r>
+          </a:p>
+        </p:txBody>
+      </p:sp>
+      <p:sp>
+        <p:nvSpPr>
+          <p:cNvPr id="54" name="Rounded Rectangle 53"/>
           <p:cNvSpPr/>
           <p:nvPr/>
         </p:nvSpPr>
         <p:spPr>
           <a:xfrm>
-            <a:off x="4526280" y="3017520"/>
-            <a:ext cx="1097280" cy="274320"/>
+            <a:off x="10222992" y="2724912"/>
+            <a:ext cx="1042415" cy="256032"/>
           </a:xfrm>
           <a:prstGeom prst="roundRect">
             <a:avLst>
@@ -6904,14 +7765,14 @@
       </p:sp>
       <p:sp>
         <p:nvSpPr>
-          <p:cNvPr id="35" name="TextBox 34"/>
+          <p:cNvPr id="55" name="TextBox 54"/>
           <p:cNvSpPr txBox="1"/>
           <p:nvPr/>
         </p:nvSpPr>
         <p:spPr>
           <a:xfrm>
-            <a:off x="4526280" y="3054096"/>
-            <a:ext cx="1097280" cy="201168"/>
+            <a:off x="10222992" y="2752344"/>
+            <a:ext cx="1042415" cy="182880"/>
           </a:xfrm>
           <a:prstGeom prst="rect">
             <a:avLst/>
@@ -6930,66 +7791,27 @@
               </a:lnSpc>
             </a:pPr>
             <a:r>
-              <a:rPr sz="850" b="1">
-                <a:solidFill>
-                  <a:srgbClr val="3B82F6"/>
+              <a:rPr sz="800" b="1">
+                <a:solidFill>
+                  <a:srgbClr val="10B981"/>
                 </a:solidFill>
                 <a:latin typeface="Microsoft YaHei"/>
               </a:rPr>
-              <a:t>INPUT</a:t>
-            </a:r>
-          </a:p>
-        </p:txBody>
-      </p:sp>
-      <p:sp>
-        <p:nvSpPr>
-          <p:cNvPr id="36" name="TextBox 35"/>
+              <a:t>UNDERSTAND</a:t>
+            </a:r>
+          </a:p>
+        </p:txBody>
+      </p:sp>
+      <p:sp>
+        <p:nvSpPr>
+          <p:cNvPr id="56" name="TextBox 55"/>
           <p:cNvSpPr txBox="1"/>
           <p:nvPr/>
         </p:nvSpPr>
         <p:spPr>
           <a:xfrm>
-            <a:off x="978408" y="3621024"/>
-            <a:ext cx="4626864" cy="530352"/>
-          </a:xfrm>
-          <a:prstGeom prst="rect">
-            <a:avLst/>
-          </a:prstGeom>
-          <a:noFill/>
-        </p:spPr>
-        <p:txBody>
-          <a:bodyPr wrap="square" anchor="t">
-            <a:spAutoFit/>
-          </a:bodyPr>
-          <a:lstStyle/>
-          <a:p>
-            <a:pPr algn="l">
-              <a:lnSpc>
-                <a:spcPct val="104000"/>
-              </a:lnSpc>
-            </a:pPr>
-            <a:r>
-              <a:rPr sz="1100" b="0">
-                <a:solidFill>
-                  <a:srgbClr val="66707D"/>
-                </a:solidFill>
-                <a:latin typeface="Microsoft YaHei"/>
-              </a:rPr>
-              <a:t>接收指令、附件与工作区上下文，完成意图澄清与队列排序。</a:t>
-            </a:r>
-          </a:p>
-        </p:txBody>
-      </p:sp>
-      <p:sp>
-        <p:nvSpPr>
-          <p:cNvPr id="37" name="TextBox 36"/>
-          <p:cNvSpPr txBox="1"/>
-          <p:nvPr/>
-        </p:nvSpPr>
-        <p:spPr>
-          <a:xfrm>
-            <a:off x="978408" y="4169664"/>
-            <a:ext cx="4023360" cy="640080"/>
+            <a:off x="6565392" y="3218687"/>
+            <a:ext cx="4700016" cy="420624"/>
           </a:xfrm>
           <a:prstGeom prst="rect">
             <a:avLst/>
@@ -7008,59 +7830,98 @@
               </a:lnSpc>
             </a:pPr>
             <a:r>
-              <a:rPr sz="1000" b="0">
-                <a:solidFill>
-                  <a:srgbClr val="222A35"/>
+              <a:rPr sz="1050" b="0">
+                <a:solidFill>
+                  <a:srgbClr val="66707D"/>
                 </a:solidFill>
                 <a:latin typeface="Microsoft YaHei"/>
               </a:rPr>
-              <a:t>•  自然语言与多模态输入</a:t>
-            </a:r>
-          </a:p>
+              <a:t>解析任务语义，匹配类型、能力与执行合同。</a:t>
+            </a:r>
+          </a:p>
+        </p:txBody>
+      </p:sp>
+      <p:sp>
+        <p:nvSpPr>
+          <p:cNvPr id="57" name="TextBox 56"/>
+          <p:cNvSpPr txBox="1"/>
+          <p:nvPr/>
+        </p:nvSpPr>
+        <p:spPr>
+          <a:xfrm>
+            <a:off x="6565392" y="3657600"/>
+            <a:ext cx="4059936" cy="530352"/>
+          </a:xfrm>
+          <a:prstGeom prst="rect">
+            <a:avLst/>
+          </a:prstGeom>
+          <a:noFill/>
+        </p:spPr>
+        <p:txBody>
+          <a:bodyPr wrap="square" anchor="t">
+            <a:spAutoFit/>
+          </a:bodyPr>
+          <a:lstStyle/>
           <a:p>
             <a:pPr algn="l">
               <a:lnSpc>
-                <a:spcPct val="102000"/>
+                <a:spcPct val="98000"/>
               </a:lnSpc>
             </a:pPr>
             <a:r>
-              <a:rPr sz="1000" b="0">
+              <a:rPr sz="950" b="0">
                 <a:solidFill>
                   <a:srgbClr val="222A35"/>
                 </a:solidFill>
                 <a:latin typeface="Microsoft YaHei"/>
               </a:rPr>
-              <a:t>•  自动发现任务相关文件</a:t>
+              <a:t>•  任务分类与 Skill 选择</a:t>
             </a:r>
           </a:p>
           <a:p>
             <a:pPr algn="l">
               <a:lnSpc>
-                <a:spcPct val="102000"/>
+                <a:spcPct val="98000"/>
               </a:lnSpc>
             </a:pPr>
             <a:r>
-              <a:rPr sz="1000" b="0">
+              <a:rPr sz="950" b="0">
                 <a:solidFill>
                   <a:srgbClr val="222A35"/>
                 </a:solidFill>
                 <a:latin typeface="Microsoft YaHei"/>
               </a:rPr>
-              <a:t>•  生成结构化任务对象</a:t>
-            </a:r>
-          </a:p>
-        </p:txBody>
-      </p:sp>
-      <p:sp>
-        <p:nvSpPr>
-          <p:cNvPr id="38" name="Rounded Rectangle 37"/>
+              <a:t>•  能力与工具面解析</a:t>
+            </a:r>
+          </a:p>
+          <a:p>
+            <a:pPr algn="l">
+              <a:lnSpc>
+                <a:spcPct val="98000"/>
+              </a:lnSpc>
+            </a:pPr>
+            <a:r>
+              <a:rPr sz="950" b="0">
+                <a:solidFill>
+                  <a:srgbClr val="222A35"/>
+                </a:solidFill>
+                <a:latin typeface="Microsoft YaHei"/>
+              </a:rPr>
+              <a:t>•  风险与依赖预检</a:t>
+            </a:r>
+          </a:p>
+        </p:txBody>
+      </p:sp>
+      <p:sp>
+        <p:nvSpPr>
+          <p:cNvPr id="58" name="Rounded Rectangle 57"/>
           <p:cNvSpPr/>
           <p:nvPr/>
         </p:nvSpPr>
         <p:spPr>
           <a:xfrm>
-            <a:off x="4892040" y="4169664"/>
-            <a:ext cx="713232" cy="640080"/>
+            <a:off x="10552176" y="3657600"/>
+            <a:ext cx="694944" cy="530352"/>
           </a:xfrm>
           <a:prstGeom prst="roundRect">
             <a:avLst>
@@ -7101,14 +7962,14 @@
       </p:sp>
       <p:sp>
         <p:nvSpPr>
-          <p:cNvPr id="39" name="TextBox 38"/>
+          <p:cNvPr id="59" name="TextBox 58"/>
           <p:cNvSpPr txBox="1"/>
           <p:nvPr/>
         </p:nvSpPr>
         <p:spPr>
           <a:xfrm>
-            <a:off x="4892040" y="4242816"/>
-            <a:ext cx="713232" cy="256032"/>
+            <a:off x="10552176" y="3712463"/>
+            <a:ext cx="694944" cy="219456"/>
           </a:xfrm>
           <a:prstGeom prst="rect">
             <a:avLst/>
@@ -7127,27 +7988,27 @@
               </a:lnSpc>
             </a:pPr>
             <a:r>
-              <a:rPr sz="1400" b="1">
-                <a:solidFill>
-                  <a:srgbClr val="3B82F6"/>
+              <a:rPr sz="1250" b="1">
+                <a:solidFill>
+                  <a:srgbClr val="10B981"/>
                 </a:solidFill>
                 <a:latin typeface="Microsoft YaHei"/>
               </a:rPr>
-              <a:t>12+</a:t>
-            </a:r>
-          </a:p>
-        </p:txBody>
-      </p:sp>
-      <p:sp>
-        <p:nvSpPr>
-          <p:cNvPr id="40" name="TextBox 39"/>
+              <a:t>8</a:t>
+            </a:r>
+          </a:p>
+        </p:txBody>
+      </p:sp>
+      <p:sp>
+        <p:nvSpPr>
+          <p:cNvPr id="60" name="TextBox 59"/>
           <p:cNvSpPr txBox="1"/>
           <p:nvPr/>
         </p:nvSpPr>
         <p:spPr>
           <a:xfrm>
-            <a:off x="4892040" y="4535424"/>
-            <a:ext cx="713232" cy="201168"/>
+            <a:off x="10552176" y="3968496"/>
+            <a:ext cx="694944" cy="182880"/>
           </a:xfrm>
           <a:prstGeom prst="rect">
             <a:avLst/>
@@ -7166,27 +8027,27 @@
               </a:lnSpc>
             </a:pPr>
             <a:r>
-              <a:rPr sz="750" b="0">
+              <a:rPr sz="700" b="0">
                 <a:solidFill>
                   <a:srgbClr val="66707D"/>
                 </a:solidFill>
                 <a:latin typeface="Microsoft YaHei"/>
               </a:rPr>
-              <a:t>输入类型</a:t>
-            </a:r>
-          </a:p>
-        </p:txBody>
-      </p:sp>
-      <p:sp>
-        <p:nvSpPr>
-          <p:cNvPr id="41" name="Rounded Rectangle 40"/>
+              <a:t>任务类型</a:t>
+            </a:r>
+          </a:p>
+        </p:txBody>
+      </p:sp>
+      <p:sp>
+        <p:nvSpPr>
+          <p:cNvPr id="61" name="Rounded Rectangle 60"/>
           <p:cNvSpPr/>
           <p:nvPr/>
         </p:nvSpPr>
         <p:spPr>
           <a:xfrm>
-            <a:off x="978408" y="4901183"/>
-            <a:ext cx="4023360" cy="91440"/>
+            <a:off x="6565392" y="4279392"/>
+            <a:ext cx="4059936" cy="91440"/>
           </a:xfrm>
           <a:prstGeom prst="roundRect">
             <a:avLst>
@@ -7225,14 +8086,14 @@
       </p:sp>
       <p:sp>
         <p:nvSpPr>
-          <p:cNvPr id="42" name="Rounded Rectangle 41"/>
+          <p:cNvPr id="62" name="Rounded Rectangle 61"/>
           <p:cNvSpPr/>
           <p:nvPr/>
         </p:nvSpPr>
         <p:spPr>
           <a:xfrm>
-            <a:off x="978408" y="4901183"/>
-            <a:ext cx="4023360" cy="91440"/>
+            <a:off x="6565392" y="4279392"/>
+            <a:ext cx="4059936" cy="91440"/>
           </a:xfrm>
           <a:prstGeom prst="roundRect">
             <a:avLst>
@@ -7240,7 +8101,7 @@
             </a:avLst>
           </a:prstGeom>
           <a:solidFill>
-            <a:srgbClr val="3B82F6"/>
+            <a:srgbClr val="10B981"/>
           </a:solidFill>
           <a:ln>
             <a:noFill/>
@@ -7271,14 +8132,14 @@
       </p:sp>
       <p:sp>
         <p:nvSpPr>
-          <p:cNvPr id="43" name="TextBox 42"/>
+          <p:cNvPr id="63" name="TextBox 62"/>
           <p:cNvSpPr txBox="1"/>
           <p:nvPr/>
         </p:nvSpPr>
         <p:spPr>
           <a:xfrm>
-            <a:off x="978408" y="5010912"/>
-            <a:ext cx="914400" cy="164592"/>
+            <a:off x="6565392" y="4334256"/>
+            <a:ext cx="914400" cy="146304"/>
           </a:xfrm>
           <a:prstGeom prst="rect">
             <a:avLst/>
@@ -7297,9 +8158,9 @@
               </a:lnSpc>
             </a:pPr>
             <a:r>
-              <a:rPr sz="850" b="1">
-                <a:solidFill>
-                  <a:srgbClr val="3B82F6"/>
+              <a:rPr sz="750" b="1">
+                <a:solidFill>
+                  <a:srgbClr val="10B981"/>
                 </a:solidFill>
                 <a:latin typeface="Microsoft YaHei"/>
               </a:rPr>
@@ -7310,14 +8171,14 @@
       </p:sp>
       <p:sp>
         <p:nvSpPr>
-          <p:cNvPr id="44" name="TextBox 43"/>
+          <p:cNvPr id="64" name="TextBox 63"/>
           <p:cNvSpPr txBox="1"/>
           <p:nvPr/>
         </p:nvSpPr>
         <p:spPr>
           <a:xfrm>
-            <a:off x="1874519" y="5010912"/>
-            <a:ext cx="914400" cy="164592"/>
+            <a:off x="7443216" y="4334256"/>
+            <a:ext cx="914400" cy="146304"/>
           </a:xfrm>
           <a:prstGeom prst="rect">
             <a:avLst/>
@@ -7336,9 +8197,9 @@
               </a:lnSpc>
             </a:pPr>
             <a:r>
-              <a:rPr sz="850" b="1">
-                <a:solidFill>
-                  <a:srgbClr val="3B82F6"/>
+              <a:rPr sz="750" b="1">
+                <a:solidFill>
+                  <a:srgbClr val="10B981"/>
                 </a:solidFill>
                 <a:latin typeface="Microsoft YaHei"/>
               </a:rPr>
@@ -7349,14 +8210,14 @@
       </p:sp>
       <p:sp>
         <p:nvSpPr>
-          <p:cNvPr id="45" name="TextBox 44"/>
+          <p:cNvPr id="65" name="TextBox 64"/>
           <p:cNvSpPr txBox="1"/>
           <p:nvPr/>
         </p:nvSpPr>
         <p:spPr>
           <a:xfrm>
-            <a:off x="2770632" y="5010912"/>
-            <a:ext cx="914400" cy="164592"/>
+            <a:off x="8321040" y="4334256"/>
+            <a:ext cx="914400" cy="146304"/>
           </a:xfrm>
           <a:prstGeom prst="rect">
             <a:avLst/>
@@ -7375,9 +8236,9 @@
               </a:lnSpc>
             </a:pPr>
             <a:r>
-              <a:rPr sz="850" b="1">
-                <a:solidFill>
-                  <a:srgbClr val="3B82F6"/>
+              <a:rPr sz="750" b="1">
+                <a:solidFill>
+                  <a:srgbClr val="10B981"/>
                 </a:solidFill>
                 <a:latin typeface="Microsoft YaHei"/>
               </a:rPr>
@@ -7388,18 +8249,18 @@
       </p:sp>
       <p:sp>
         <p:nvSpPr>
-          <p:cNvPr id="46" name="Rounded Rectangle 45"/>
+          <p:cNvPr id="66" name="Rounded Rectangle 65"/>
           <p:cNvSpPr/>
           <p:nvPr/>
         </p:nvSpPr>
         <p:spPr>
           <a:xfrm>
-            <a:off x="6309360" y="2761488"/>
-            <a:ext cx="5212080" cy="2267712"/>
+            <a:off x="685800" y="4443984"/>
+            <a:ext cx="5212080" cy="1810512"/>
           </a:xfrm>
           <a:prstGeom prst="roundRect">
             <a:avLst>
-              <a:gd name="adj" fmla="val 6000"/>
+              <a:gd name="adj" fmla="val 7000"/>
             </a:avLst>
           </a:prstGeom>
           <a:solidFill>
@@ -7436,20 +8297,20 @@
       </p:sp>
       <p:sp>
         <p:nvSpPr>
-          <p:cNvPr id="47" name="Rectangle 46"/>
+          <p:cNvPr id="67" name="Rectangle 66"/>
           <p:cNvSpPr/>
           <p:nvPr/>
         </p:nvSpPr>
         <p:spPr>
           <a:xfrm>
-            <a:off x="6309360" y="2761488"/>
-            <a:ext cx="82296" cy="2267712"/>
+            <a:off x="685800" y="4443984"/>
+            <a:ext cx="82296" cy="1810512"/>
           </a:xfrm>
           <a:prstGeom prst="rect">
             <a:avLst/>
           </a:prstGeom>
           <a:solidFill>
-            <a:srgbClr val="10B981"/>
+            <a:srgbClr val="F97A2E"/>
           </a:solidFill>
           <a:ln>
             <a:noFill/>
@@ -7480,22 +8341,22 @@
       </p:sp>
       <p:sp>
         <p:nvSpPr>
-          <p:cNvPr id="48" name="Rounded Rectangle 47"/>
+          <p:cNvPr id="68" name="Rounded Rectangle 67"/>
           <p:cNvSpPr/>
           <p:nvPr/>
         </p:nvSpPr>
         <p:spPr>
           <a:xfrm>
-            <a:off x="6583680" y="2962656"/>
-            <a:ext cx="566928" cy="566928"/>
+            <a:off x="923544" y="4608576"/>
+            <a:ext cx="457200" cy="457200"/>
           </a:xfrm>
           <a:prstGeom prst="roundRect">
             <a:avLst>
-              <a:gd name="adj" fmla="val 18000"/>
+              <a:gd name="adj" fmla="val 20000"/>
             </a:avLst>
           </a:prstGeom>
           <a:solidFill>
-            <a:srgbClr val="10B981"/>
+            <a:srgbClr val="F97A2E"/>
           </a:solidFill>
           <a:ln>
             <a:noFill/>
@@ -7526,14 +8387,14 @@
       </p:sp>
       <p:sp>
         <p:nvSpPr>
-          <p:cNvPr id="49" name="TextBox 48"/>
+          <p:cNvPr id="69" name="TextBox 68"/>
           <p:cNvSpPr txBox="1"/>
           <p:nvPr/>
         </p:nvSpPr>
         <p:spPr>
           <a:xfrm>
-            <a:off x="6583680" y="3035808"/>
-            <a:ext cx="566928" cy="411480"/>
+            <a:off x="923544" y="4663440"/>
+            <a:ext cx="457200" cy="329184"/>
           </a:xfrm>
           <a:prstGeom prst="rect">
             <a:avLst/>
@@ -7552,27 +8413,27 @@
               </a:lnSpc>
             </a:pPr>
             <a:r>
-              <a:rPr sz="1400" b="1">
+              <a:rPr sz="1300" b="1">
                 <a:solidFill>
                   <a:srgbClr val="FFFFFF"/>
                 </a:solidFill>
                 <a:latin typeface="Microsoft YaHei"/>
               </a:rPr>
-              <a:t>02</a:t>
-            </a:r>
-          </a:p>
-        </p:txBody>
-      </p:sp>
-      <p:sp>
-        <p:nvSpPr>
-          <p:cNvPr id="50" name="TextBox 49"/>
+              <a:t>03</a:t>
+            </a:r>
+          </a:p>
+        </p:txBody>
+      </p:sp>
+      <p:sp>
+        <p:nvSpPr>
+          <p:cNvPr id="70" name="TextBox 69"/>
           <p:cNvSpPr txBox="1"/>
           <p:nvPr/>
         </p:nvSpPr>
         <p:spPr>
           <a:xfrm>
-            <a:off x="7296912" y="2944368"/>
-            <a:ext cx="2377440" cy="365760"/>
+            <a:off x="1508760" y="4590288"/>
+            <a:ext cx="2194560" cy="310896"/>
           </a:xfrm>
           <a:prstGeom prst="rect">
             <a:avLst/>
@@ -7591,27 +8452,27 @@
               </a:lnSpc>
             </a:pPr>
             <a:r>
-              <a:rPr sz="1600" b="1">
+              <a:rPr sz="1450" b="1">
                 <a:solidFill>
                   <a:srgbClr val="222A35"/>
                 </a:solidFill>
                 <a:latin typeface="Microsoft YaHei"/>
               </a:rPr>
-              <a:t>理解 Understand</a:t>
-            </a:r>
-          </a:p>
-        </p:txBody>
-      </p:sp>
-      <p:sp>
-        <p:nvSpPr>
-          <p:cNvPr id="51" name="Rounded Rectangle 50"/>
+              <a:t>执行 Execute</a:t>
+            </a:r>
+          </a:p>
+        </p:txBody>
+      </p:sp>
+      <p:sp>
+        <p:nvSpPr>
+          <p:cNvPr id="71" name="Rounded Rectangle 70"/>
           <p:cNvSpPr/>
           <p:nvPr/>
         </p:nvSpPr>
         <p:spPr>
           <a:xfrm>
-            <a:off x="10149840" y="3017520"/>
-            <a:ext cx="1097280" cy="274320"/>
+            <a:off x="4599432" y="4645152"/>
+            <a:ext cx="1042415" cy="256032"/>
           </a:xfrm>
           <a:prstGeom prst="roundRect">
             <a:avLst>
@@ -7650,14 +8511,14 @@
       </p:sp>
       <p:sp>
         <p:nvSpPr>
-          <p:cNvPr id="52" name="TextBox 51"/>
+          <p:cNvPr id="72" name="TextBox 71"/>
           <p:cNvSpPr txBox="1"/>
           <p:nvPr/>
         </p:nvSpPr>
         <p:spPr>
           <a:xfrm>
-            <a:off x="10149840" y="3054096"/>
-            <a:ext cx="1097280" cy="201168"/>
+            <a:off x="4599432" y="4672584"/>
+            <a:ext cx="1042415" cy="182880"/>
           </a:xfrm>
           <a:prstGeom prst="rect">
             <a:avLst/>
@@ -7676,66 +8537,27 @@
               </a:lnSpc>
             </a:pPr>
             <a:r>
-              <a:rPr sz="850" b="1">
-                <a:solidFill>
-                  <a:srgbClr val="10B981"/>
+              <a:rPr sz="800" b="1">
+                <a:solidFill>
+                  <a:srgbClr val="F97A2E"/>
                 </a:solidFill>
                 <a:latin typeface="Microsoft YaHei"/>
               </a:rPr>
-              <a:t>UNDERSTAND</a:t>
-            </a:r>
-          </a:p>
-        </p:txBody>
-      </p:sp>
-      <p:sp>
-        <p:nvSpPr>
-          <p:cNvPr id="53" name="TextBox 52"/>
+              <a:t>EXECUTE</a:t>
+            </a:r>
+          </a:p>
+        </p:txBody>
+      </p:sp>
+      <p:sp>
+        <p:nvSpPr>
+          <p:cNvPr id="73" name="TextBox 72"/>
           <p:cNvSpPr txBox="1"/>
           <p:nvPr/>
         </p:nvSpPr>
         <p:spPr>
           <a:xfrm>
-            <a:off x="6601968" y="3621024"/>
-            <a:ext cx="4626864" cy="530352"/>
-          </a:xfrm>
-          <a:prstGeom prst="rect">
-            <a:avLst/>
-          </a:prstGeom>
-          <a:noFill/>
-        </p:spPr>
-        <p:txBody>
-          <a:bodyPr wrap="square" anchor="t">
-            <a:spAutoFit/>
-          </a:bodyPr>
-          <a:lstStyle/>
-          <a:p>
-            <a:pPr algn="l">
-              <a:lnSpc>
-                <a:spcPct val="104000"/>
-              </a:lnSpc>
-            </a:pPr>
-            <a:r>
-              <a:rPr sz="1100" b="0">
-                <a:solidFill>
-                  <a:srgbClr val="66707D"/>
-                </a:solidFill>
-                <a:latin typeface="Microsoft YaHei"/>
-              </a:rPr>
-              <a:t>解析任务语义，匹配类型、能力与执行合同。</a:t>
-            </a:r>
-          </a:p>
-        </p:txBody>
-      </p:sp>
-      <p:sp>
-        <p:nvSpPr>
-          <p:cNvPr id="54" name="TextBox 53"/>
-          <p:cNvSpPr txBox="1"/>
-          <p:nvPr/>
-        </p:nvSpPr>
-        <p:spPr>
-          <a:xfrm>
-            <a:off x="6601968" y="4169664"/>
-            <a:ext cx="4023360" cy="640080"/>
+            <a:off x="941832" y="5138928"/>
+            <a:ext cx="4700016" cy="420624"/>
           </a:xfrm>
           <a:prstGeom prst="rect">
             <a:avLst/>
@@ -7754,59 +8576,98 @@
               </a:lnSpc>
             </a:pPr>
             <a:r>
-              <a:rPr sz="1000" b="0">
-                <a:solidFill>
-                  <a:srgbClr val="222A35"/>
+              <a:rPr sz="1050" b="0">
+                <a:solidFill>
+                  <a:srgbClr val="66707D"/>
                 </a:solidFill>
                 <a:latin typeface="Microsoft YaHei"/>
               </a:rPr>
-              <a:t>•  任务分类与 Skill 选择</a:t>
-            </a:r>
-          </a:p>
+              <a:t>在阶段工具面内执行修改，全部变更走原子事务与审计。</a:t>
+            </a:r>
+          </a:p>
+        </p:txBody>
+      </p:sp>
+      <p:sp>
+        <p:nvSpPr>
+          <p:cNvPr id="74" name="TextBox 73"/>
+          <p:cNvSpPr txBox="1"/>
+          <p:nvPr/>
+        </p:nvSpPr>
+        <p:spPr>
+          <a:xfrm>
+            <a:off x="941832" y="5577840"/>
+            <a:ext cx="4059936" cy="530352"/>
+          </a:xfrm>
+          <a:prstGeom prst="rect">
+            <a:avLst/>
+          </a:prstGeom>
+          <a:noFill/>
+        </p:spPr>
+        <p:txBody>
+          <a:bodyPr wrap="square" anchor="t">
+            <a:spAutoFit/>
+          </a:bodyPr>
+          <a:lstStyle/>
           <a:p>
             <a:pPr algn="l">
               <a:lnSpc>
-                <a:spcPct val="102000"/>
+                <a:spcPct val="98000"/>
               </a:lnSpc>
             </a:pPr>
             <a:r>
-              <a:rPr sz="1000" b="0">
+              <a:rPr sz="950" b="0">
                 <a:solidFill>
                   <a:srgbClr val="222A35"/>
                 </a:solidFill>
                 <a:latin typeface="Microsoft YaHei"/>
               </a:rPr>
-              <a:t>•  能力与工具面解析</a:t>
+              <a:t>•  阶段化工具准入</a:t>
             </a:r>
           </a:p>
           <a:p>
             <a:pPr algn="l">
               <a:lnSpc>
-                <a:spcPct val="102000"/>
+                <a:spcPct val="98000"/>
               </a:lnSpc>
             </a:pPr>
             <a:r>
-              <a:rPr sz="1000" b="0">
+              <a:rPr sz="950" b="0">
                 <a:solidFill>
                   <a:srgbClr val="222A35"/>
                 </a:solidFill>
                 <a:latin typeface="Microsoft YaHei"/>
               </a:rPr>
-              <a:t>•  风险与依赖预检</a:t>
-            </a:r>
-          </a:p>
-        </p:txBody>
-      </p:sp>
-      <p:sp>
-        <p:nvSpPr>
-          <p:cNvPr id="55" name="Rounded Rectangle 54"/>
+              <a:t>•  原子批量事务</a:t>
+            </a:r>
+          </a:p>
+          <a:p>
+            <a:pPr algn="l">
+              <a:lnSpc>
+                <a:spcPct val="98000"/>
+              </a:lnSpc>
+            </a:pPr>
+            <a:r>
+              <a:rPr sz="950" b="0">
+                <a:solidFill>
+                  <a:srgbClr val="222A35"/>
+                </a:solidFill>
+                <a:latin typeface="Microsoft YaHei"/>
+              </a:rPr>
+              <a:t>•  失败自动回滚</a:t>
+            </a:r>
+          </a:p>
+        </p:txBody>
+      </p:sp>
+      <p:sp>
+        <p:nvSpPr>
+          <p:cNvPr id="75" name="Rounded Rectangle 74"/>
           <p:cNvSpPr/>
           <p:nvPr/>
         </p:nvSpPr>
         <p:spPr>
           <a:xfrm>
-            <a:off x="10515600" y="4169664"/>
-            <a:ext cx="713232" cy="640080"/>
+            <a:off x="4928616" y="5577840"/>
+            <a:ext cx="694944" cy="530352"/>
           </a:xfrm>
           <a:prstGeom prst="roundRect">
             <a:avLst>
@@ -7847,14 +8708,14 @@
       </p:sp>
       <p:sp>
         <p:nvSpPr>
-          <p:cNvPr id="56" name="TextBox 55"/>
+          <p:cNvPr id="76" name="TextBox 75"/>
           <p:cNvSpPr txBox="1"/>
           <p:nvPr/>
         </p:nvSpPr>
         <p:spPr>
           <a:xfrm>
-            <a:off x="10515600" y="4242816"/>
-            <a:ext cx="713232" cy="256032"/>
+            <a:off x="4928616" y="5632704"/>
+            <a:ext cx="694944" cy="219456"/>
           </a:xfrm>
           <a:prstGeom prst="rect">
             <a:avLst/>
@@ -7873,27 +8734,27 @@
               </a:lnSpc>
             </a:pPr>
             <a:r>
-              <a:rPr sz="1400" b="1">
-                <a:solidFill>
-                  <a:srgbClr val="10B981"/>
+              <a:rPr sz="1250" b="1">
+                <a:solidFill>
+                  <a:srgbClr val="F97A2E"/>
                 </a:solidFill>
                 <a:latin typeface="Microsoft YaHei"/>
               </a:rPr>
-              <a:t>8</a:t>
-            </a:r>
-          </a:p>
-        </p:txBody>
-      </p:sp>
-      <p:sp>
-        <p:nvSpPr>
-          <p:cNvPr id="57" name="TextBox 56"/>
+              <a:t>100%</a:t>
+            </a:r>
+          </a:p>
+        </p:txBody>
+      </p:sp>
+      <p:sp>
+        <p:nvSpPr>
+          <p:cNvPr id="77" name="TextBox 76"/>
           <p:cNvSpPr txBox="1"/>
           <p:nvPr/>
         </p:nvSpPr>
         <p:spPr>
           <a:xfrm>
-            <a:off x="10515600" y="4535424"/>
-            <a:ext cx="713232" cy="201168"/>
+            <a:off x="4928616" y="5888736"/>
+            <a:ext cx="694944" cy="182880"/>
           </a:xfrm>
           <a:prstGeom prst="rect">
             <a:avLst/>
@@ -7912,27 +8773,27 @@
               </a:lnSpc>
             </a:pPr>
             <a:r>
-              <a:rPr sz="750" b="0">
+              <a:rPr sz="700" b="0">
                 <a:solidFill>
                   <a:srgbClr val="66707D"/>
                 </a:solidFill>
                 <a:latin typeface="Microsoft YaHei"/>
               </a:rPr>
-              <a:t>任务类型</a:t>
-            </a:r>
-          </a:p>
-        </p:txBody>
-      </p:sp>
-      <p:sp>
-        <p:nvSpPr>
-          <p:cNvPr id="58" name="Rounded Rectangle 57"/>
+              <a:t>事务回滚</a:t>
+            </a:r>
+          </a:p>
+        </p:txBody>
+      </p:sp>
+      <p:sp>
+        <p:nvSpPr>
+          <p:cNvPr id="78" name="Rounded Rectangle 77"/>
           <p:cNvSpPr/>
           <p:nvPr/>
         </p:nvSpPr>
         <p:spPr>
           <a:xfrm>
-            <a:off x="6601968" y="4901183"/>
-            <a:ext cx="4023360" cy="91440"/>
+            <a:off x="941832" y="6199632"/>
+            <a:ext cx="4059936" cy="91440"/>
           </a:xfrm>
           <a:prstGeom prst="roundRect">
             <a:avLst>
@@ -7971,14 +8832,14 @@
       </p:sp>
       <p:sp>
         <p:nvSpPr>
-          <p:cNvPr id="59" name="Rounded Rectangle 58"/>
+          <p:cNvPr id="79" name="Rounded Rectangle 78"/>
           <p:cNvSpPr/>
           <p:nvPr/>
         </p:nvSpPr>
         <p:spPr>
           <a:xfrm>
-            <a:off x="6601968" y="4901183"/>
-            <a:ext cx="4023360" cy="91440"/>
+            <a:off x="941832" y="6199632"/>
+            <a:ext cx="3247948" cy="91440"/>
           </a:xfrm>
           <a:prstGeom prst="roundRect">
             <a:avLst>
@@ -7986,7 +8847,7 @@
             </a:avLst>
           </a:prstGeom>
           <a:solidFill>
-            <a:srgbClr val="10B981"/>
+            <a:srgbClr val="F97A2E"/>
           </a:solidFill>
           <a:ln>
             <a:noFill/>
@@ -8017,14 +8878,14 @@
       </p:sp>
       <p:sp>
         <p:nvSpPr>
-          <p:cNvPr id="60" name="TextBox 59"/>
+          <p:cNvPr id="80" name="TextBox 79"/>
           <p:cNvSpPr txBox="1"/>
           <p:nvPr/>
         </p:nvSpPr>
         <p:spPr>
           <a:xfrm>
-            <a:off x="6601968" y="5010912"/>
-            <a:ext cx="914400" cy="164592"/>
+            <a:off x="941832" y="6254496"/>
+            <a:ext cx="914400" cy="146304"/>
           </a:xfrm>
           <a:prstGeom prst="rect">
             <a:avLst/>
@@ -8043,9 +8904,9 @@
               </a:lnSpc>
             </a:pPr>
             <a:r>
-              <a:rPr sz="850" b="1">
-                <a:solidFill>
-                  <a:srgbClr val="10B981"/>
+              <a:rPr sz="750" b="1">
+                <a:solidFill>
+                  <a:srgbClr val="F97A2E"/>
                 </a:solidFill>
                 <a:latin typeface="Microsoft YaHei"/>
               </a:rPr>
@@ -8056,14 +8917,14 @@
       </p:sp>
       <p:sp>
         <p:nvSpPr>
-          <p:cNvPr id="61" name="TextBox 60"/>
+          <p:cNvPr id="81" name="TextBox 80"/>
           <p:cNvSpPr txBox="1"/>
           <p:nvPr/>
         </p:nvSpPr>
         <p:spPr>
           <a:xfrm>
-            <a:off x="7498080" y="5010912"/>
-            <a:ext cx="914400" cy="164592"/>
+            <a:off x="1819656" y="6254496"/>
+            <a:ext cx="914400" cy="146304"/>
           </a:xfrm>
           <a:prstGeom prst="rect">
             <a:avLst/>
@@ -8082,9 +8943,9 @@
               </a:lnSpc>
             </a:pPr>
             <a:r>
-              <a:rPr sz="850" b="1">
-                <a:solidFill>
-                  <a:srgbClr val="10B981"/>
+              <a:rPr sz="750" b="1">
+                <a:solidFill>
+                  <a:srgbClr val="F97A2E"/>
                 </a:solidFill>
                 <a:latin typeface="Microsoft YaHei"/>
               </a:rPr>
@@ -8095,14 +8956,14 @@
       </p:sp>
       <p:sp>
         <p:nvSpPr>
-          <p:cNvPr id="62" name="TextBox 61"/>
+          <p:cNvPr id="82" name="TextBox 81"/>
           <p:cNvSpPr txBox="1"/>
           <p:nvPr/>
         </p:nvSpPr>
         <p:spPr>
           <a:xfrm>
-            <a:off x="8394192" y="5010912"/>
-            <a:ext cx="914400" cy="164592"/>
+            <a:off x="2697480" y="6254496"/>
+            <a:ext cx="914400" cy="146304"/>
           </a:xfrm>
           <a:prstGeom prst="rect">
             <a:avLst/>
@@ -8121,9 +8982,9 @@
               </a:lnSpc>
             </a:pPr>
             <a:r>
-              <a:rPr sz="850" b="1">
-                <a:solidFill>
-                  <a:srgbClr val="10B981"/>
+              <a:rPr sz="750" b="1">
+                <a:solidFill>
+                  <a:srgbClr val="F97A2E"/>
                 </a:solidFill>
                 <a:latin typeface="Microsoft YaHei"/>
               </a:rPr>
@@ -8134,18 +8995,18 @@
       </p:sp>
       <p:sp>
         <p:nvSpPr>
-          <p:cNvPr id="63" name="Rounded Rectangle 62"/>
+          <p:cNvPr id="83" name="Rounded Rectangle 82"/>
           <p:cNvSpPr/>
           <p:nvPr/>
         </p:nvSpPr>
         <p:spPr>
           <a:xfrm>
-            <a:off x="685800" y="5230368"/>
-            <a:ext cx="5212080" cy="2267712"/>
+            <a:off x="6309360" y="4443984"/>
+            <a:ext cx="5212080" cy="1810512"/>
           </a:xfrm>
           <a:prstGeom prst="roundRect">
             <a:avLst>
-              <a:gd name="adj" fmla="val 6000"/>
+              <a:gd name="adj" fmla="val 7000"/>
             </a:avLst>
           </a:prstGeom>
           <a:solidFill>
@@ -8182,20 +9043,20 @@
       </p:sp>
       <p:sp>
         <p:nvSpPr>
-          <p:cNvPr id="64" name="Rectangle 63"/>
+          <p:cNvPr id="84" name="Rectangle 83"/>
           <p:cNvSpPr/>
           <p:nvPr/>
         </p:nvSpPr>
         <p:spPr>
           <a:xfrm>
-            <a:off x="685800" y="5230368"/>
-            <a:ext cx="82296" cy="2267712"/>
+            <a:off x="6309360" y="4443984"/>
+            <a:ext cx="82296" cy="1810512"/>
           </a:xfrm>
           <a:prstGeom prst="rect">
             <a:avLst/>
           </a:prstGeom>
           <a:solidFill>
-            <a:srgbClr val="F97A2E"/>
+            <a:srgbClr val="8B5CF6"/>
           </a:solidFill>
           <a:ln>
             <a:noFill/>
@@ -8226,22 +9087,22 @@
       </p:sp>
       <p:sp>
         <p:nvSpPr>
-          <p:cNvPr id="65" name="Rounded Rectangle 64"/>
+          <p:cNvPr id="85" name="Rounded Rectangle 84"/>
           <p:cNvSpPr/>
           <p:nvPr/>
         </p:nvSpPr>
         <p:spPr>
           <a:xfrm>
-            <a:off x="960120" y="5431536"/>
-            <a:ext cx="566928" cy="566928"/>
+            <a:off x="6547104" y="4608576"/>
+            <a:ext cx="457200" cy="457200"/>
           </a:xfrm>
           <a:prstGeom prst="roundRect">
             <a:avLst>
-              <a:gd name="adj" fmla="val 18000"/>
+              <a:gd name="adj" fmla="val 20000"/>
             </a:avLst>
           </a:prstGeom>
           <a:solidFill>
-            <a:srgbClr val="F97A2E"/>
+            <a:srgbClr val="8B5CF6"/>
           </a:solidFill>
           <a:ln>
             <a:noFill/>
@@ -8272,14 +9133,14 @@
       </p:sp>
       <p:sp>
         <p:nvSpPr>
-          <p:cNvPr id="66" name="TextBox 65"/>
+          <p:cNvPr id="86" name="TextBox 85"/>
           <p:cNvSpPr txBox="1"/>
           <p:nvPr/>
         </p:nvSpPr>
         <p:spPr>
           <a:xfrm>
-            <a:off x="960120" y="5504688"/>
-            <a:ext cx="566928" cy="411480"/>
+            <a:off x="6547104" y="4663440"/>
+            <a:ext cx="457200" cy="329184"/>
           </a:xfrm>
           <a:prstGeom prst="rect">
             <a:avLst/>
@@ -8298,27 +9159,27 @@
               </a:lnSpc>
             </a:pPr>
             <a:r>
-              <a:rPr sz="1400" b="1">
+              <a:rPr sz="1300" b="1">
                 <a:solidFill>
                   <a:srgbClr val="FFFFFF"/>
                 </a:solidFill>
                 <a:latin typeface="Microsoft YaHei"/>
               </a:rPr>
-              <a:t>03</a:t>
-            </a:r>
-          </a:p>
-        </p:txBody>
-      </p:sp>
-      <p:sp>
-        <p:nvSpPr>
-          <p:cNvPr id="67" name="TextBox 66"/>
+              <a:t>04</a:t>
+            </a:r>
+          </a:p>
+        </p:txBody>
+      </p:sp>
+      <p:sp>
+        <p:nvSpPr>
+          <p:cNvPr id="87" name="TextBox 86"/>
           <p:cNvSpPr txBox="1"/>
           <p:nvPr/>
         </p:nvSpPr>
         <p:spPr>
           <a:xfrm>
-            <a:off x="1673352" y="5413248"/>
-            <a:ext cx="2377440" cy="365760"/>
+            <a:off x="7132320" y="4590288"/>
+            <a:ext cx="2194560" cy="310896"/>
           </a:xfrm>
           <a:prstGeom prst="rect">
             <a:avLst/>
@@ -8337,27 +9198,27 @@
               </a:lnSpc>
             </a:pPr>
             <a:r>
-              <a:rPr sz="1600" b="1">
+              <a:rPr sz="1450" b="1">
                 <a:solidFill>
                   <a:srgbClr val="222A35"/>
                 </a:solidFill>
                 <a:latin typeface="Microsoft YaHei"/>
               </a:rPr>
-              <a:t>执行 Execute</a:t>
-            </a:r>
-          </a:p>
-        </p:txBody>
-      </p:sp>
-      <p:sp>
-        <p:nvSpPr>
-          <p:cNvPr id="68" name="Rounded Rectangle 67"/>
+              <a:t>验证 Verify</a:t>
+            </a:r>
+          </a:p>
+        </p:txBody>
+      </p:sp>
+      <p:sp>
+        <p:nvSpPr>
+          <p:cNvPr id="88" name="Rounded Rectangle 87"/>
           <p:cNvSpPr/>
           <p:nvPr/>
         </p:nvSpPr>
         <p:spPr>
           <a:xfrm>
-            <a:off x="4526280" y="5486400"/>
-            <a:ext cx="1097280" cy="274320"/>
+            <a:off x="10222992" y="4645152"/>
+            <a:ext cx="1042415" cy="256032"/>
           </a:xfrm>
           <a:prstGeom prst="roundRect">
             <a:avLst>
@@ -8396,14 +9257,14 @@
       </p:sp>
       <p:sp>
         <p:nvSpPr>
-          <p:cNvPr id="69" name="TextBox 68"/>
+          <p:cNvPr id="89" name="TextBox 88"/>
           <p:cNvSpPr txBox="1"/>
           <p:nvPr/>
         </p:nvSpPr>
         <p:spPr>
           <a:xfrm>
-            <a:off x="4526280" y="5522976"/>
-            <a:ext cx="1097280" cy="201168"/>
+            <a:off x="10222992" y="4672584"/>
+            <a:ext cx="1042415" cy="182880"/>
           </a:xfrm>
           <a:prstGeom prst="rect">
             <a:avLst/>
@@ -8422,66 +9283,27 @@
               </a:lnSpc>
             </a:pPr>
             <a:r>
-              <a:rPr sz="850" b="1">
-                <a:solidFill>
-                  <a:srgbClr val="F97A2E"/>
+              <a:rPr sz="800" b="1">
+                <a:solidFill>
+                  <a:srgbClr val="8B5CF6"/>
                 </a:solidFill>
                 <a:latin typeface="Microsoft YaHei"/>
               </a:rPr>
-              <a:t>EXECUTE</a:t>
-            </a:r>
-          </a:p>
-        </p:txBody>
-      </p:sp>
-      <p:sp>
-        <p:nvSpPr>
-          <p:cNvPr id="70" name="TextBox 69"/>
+              <a:t>VERIFY</a:t>
+            </a:r>
+          </a:p>
+        </p:txBody>
+      </p:sp>
+      <p:sp>
+        <p:nvSpPr>
+          <p:cNvPr id="90" name="TextBox 89"/>
           <p:cNvSpPr txBox="1"/>
           <p:nvPr/>
         </p:nvSpPr>
         <p:spPr>
           <a:xfrm>
-            <a:off x="978408" y="6089904"/>
-            <a:ext cx="4626864" cy="530352"/>
-          </a:xfrm>
-          <a:prstGeom prst="rect">
-            <a:avLst/>
-          </a:prstGeom>
-          <a:noFill/>
-        </p:spPr>
-        <p:txBody>
-          <a:bodyPr wrap="square" anchor="t">
-            <a:spAutoFit/>
-          </a:bodyPr>
-          <a:lstStyle/>
-          <a:p>
-            <a:pPr algn="l">
-              <a:lnSpc>
-                <a:spcPct val="104000"/>
-              </a:lnSpc>
-            </a:pPr>
-            <a:r>
-              <a:rPr sz="1100" b="0">
-                <a:solidFill>
-                  <a:srgbClr val="66707D"/>
-                </a:solidFill>
-                <a:latin typeface="Microsoft YaHei"/>
-              </a:rPr>
-              <a:t>在阶段工具面内执行修改，全部变更走原子事务与审计。</a:t>
-            </a:r>
-          </a:p>
-        </p:txBody>
-      </p:sp>
-      <p:sp>
-        <p:nvSpPr>
-          <p:cNvPr id="71" name="TextBox 70"/>
-          <p:cNvSpPr txBox="1"/>
-          <p:nvPr/>
-        </p:nvSpPr>
-        <p:spPr>
-          <a:xfrm>
-            <a:off x="978408" y="6638544"/>
-            <a:ext cx="4023360" cy="640080"/>
+            <a:off x="6565392" y="5138928"/>
+            <a:ext cx="4700016" cy="420624"/>
           </a:xfrm>
           <a:prstGeom prst="rect">
             <a:avLst/>
@@ -8500,59 +9322,98 @@
               </a:lnSpc>
             </a:pPr>
             <a:r>
-              <a:rPr sz="1000" b="0">
-                <a:solidFill>
-                  <a:srgbClr val="222A35"/>
+              <a:rPr sz="1050" b="0">
+                <a:solidFill>
+                  <a:srgbClr val="66707D"/>
                 </a:solidFill>
                 <a:latin typeface="Microsoft YaHei"/>
               </a:rPr>
-              <a:t>•  阶段化工具准入</a:t>
-            </a:r>
-          </a:p>
+              <a:t>以结构、渲染、视觉与官方评估器四层证据确认交付质量。</a:t>
+            </a:r>
+          </a:p>
+        </p:txBody>
+      </p:sp>
+      <p:sp>
+        <p:nvSpPr>
+          <p:cNvPr id="91" name="TextBox 90"/>
+          <p:cNvSpPr txBox="1"/>
+          <p:nvPr/>
+        </p:nvSpPr>
+        <p:spPr>
+          <a:xfrm>
+            <a:off x="6565392" y="5577840"/>
+            <a:ext cx="4059936" cy="530352"/>
+          </a:xfrm>
+          <a:prstGeom prst="rect">
+            <a:avLst/>
+          </a:prstGeom>
+          <a:noFill/>
+        </p:spPr>
+        <p:txBody>
+          <a:bodyPr wrap="square" anchor="t">
+            <a:spAutoFit/>
+          </a:bodyPr>
+          <a:lstStyle/>
           <a:p>
             <a:pPr algn="l">
               <a:lnSpc>
-                <a:spcPct val="102000"/>
+                <a:spcPct val="98000"/>
               </a:lnSpc>
             </a:pPr>
             <a:r>
-              <a:rPr sz="1000" b="0">
+              <a:rPr sz="950" b="0">
                 <a:solidFill>
                   <a:srgbClr val="222A35"/>
                 </a:solidFill>
                 <a:latin typeface="Microsoft YaHei"/>
               </a:rPr>
-              <a:t>•  原子批量事务</a:t>
+              <a:t>•  反例定位与局部修复</a:t>
             </a:r>
           </a:p>
           <a:p>
             <a:pPr algn="l">
               <a:lnSpc>
-                <a:spcPct val="102000"/>
+                <a:spcPct val="98000"/>
               </a:lnSpc>
             </a:pPr>
             <a:r>
-              <a:rPr sz="1000" b="0">
+              <a:rPr sz="950" b="0">
                 <a:solidFill>
                   <a:srgbClr val="222A35"/>
                 </a:solidFill>
                 <a:latin typeface="Microsoft YaHei"/>
               </a:rPr>
-              <a:t>•  失败自动回滚</a:t>
-            </a:r>
-          </a:p>
-        </p:txBody>
-      </p:sp>
-      <p:sp>
-        <p:nvSpPr>
-          <p:cNvPr id="72" name="Rounded Rectangle 71"/>
+              <a:t>•  证据新鲜度管理</a:t>
+            </a:r>
+          </a:p>
+          <a:p>
+            <a:pPr algn="l">
+              <a:lnSpc>
+                <a:spcPct val="98000"/>
+              </a:lnSpc>
+            </a:pPr>
+            <a:r>
+              <a:rPr sz="950" b="0">
+                <a:solidFill>
+                  <a:srgbClr val="222A35"/>
+                </a:solidFill>
+                <a:latin typeface="Microsoft YaHei"/>
+              </a:rPr>
+              <a:t>•  交付前强制 gate</a:t>
+            </a:r>
+          </a:p>
+        </p:txBody>
+      </p:sp>
+      <p:sp>
+        <p:nvSpPr>
+          <p:cNvPr id="92" name="Rounded Rectangle 91"/>
           <p:cNvSpPr/>
           <p:nvPr/>
         </p:nvSpPr>
         <p:spPr>
           <a:xfrm>
-            <a:off x="4892040" y="6638544"/>
-            <a:ext cx="713232" cy="640080"/>
+            <a:off x="10552176" y="5577840"/>
+            <a:ext cx="694944" cy="530352"/>
           </a:xfrm>
           <a:prstGeom prst="roundRect">
             <a:avLst>
@@ -8593,14 +9454,14 @@
       </p:sp>
       <p:sp>
         <p:nvSpPr>
-          <p:cNvPr id="73" name="TextBox 72"/>
+          <p:cNvPr id="93" name="TextBox 92"/>
           <p:cNvSpPr txBox="1"/>
           <p:nvPr/>
         </p:nvSpPr>
         <p:spPr>
           <a:xfrm>
-            <a:off x="4892040" y="6711696"/>
-            <a:ext cx="713232" cy="256032"/>
+            <a:off x="10552176" y="5632704"/>
+            <a:ext cx="694944" cy="219456"/>
           </a:xfrm>
           <a:prstGeom prst="rect">
             <a:avLst/>
@@ -8619,27 +9480,27 @@
               </a:lnSpc>
             </a:pPr>
             <a:r>
-              <a:rPr sz="1400" b="1">
-                <a:solidFill>
-                  <a:srgbClr val="F97A2E"/>
+              <a:rPr sz="1250" b="1">
+                <a:solidFill>
+                  <a:srgbClr val="8B5CF6"/>
                 </a:solidFill>
                 <a:latin typeface="Microsoft YaHei"/>
               </a:rPr>
-              <a:t>100%</a:t>
-            </a:r>
-          </a:p>
-        </p:txBody>
-      </p:sp>
-      <p:sp>
-        <p:nvSpPr>
-          <p:cNvPr id="74" name="TextBox 73"/>
+              <a:t>4</a:t>
+            </a:r>
+          </a:p>
+        </p:txBody>
+      </p:sp>
+      <p:sp>
+        <p:nvSpPr>
+          <p:cNvPr id="94" name="TextBox 93"/>
           <p:cNvSpPr txBox="1"/>
           <p:nvPr/>
         </p:nvSpPr>
         <p:spPr>
           <a:xfrm>
-            <a:off x="4892040" y="7004304"/>
-            <a:ext cx="713232" cy="201168"/>
+            <a:off x="10552176" y="5888736"/>
+            <a:ext cx="694944" cy="182880"/>
           </a:xfrm>
           <a:prstGeom prst="rect">
             <a:avLst/>
@@ -8658,27 +9519,27 @@
               </a:lnSpc>
             </a:pPr>
             <a:r>
-              <a:rPr sz="750" b="0">
+              <a:rPr sz="700" b="0">
                 <a:solidFill>
                   <a:srgbClr val="66707D"/>
                 </a:solidFill>
                 <a:latin typeface="Microsoft YaHei"/>
               </a:rPr>
-              <a:t>事务回滚</a:t>
-            </a:r>
-          </a:p>
-        </p:txBody>
-      </p:sp>
-      <p:sp>
-        <p:nvSpPr>
-          <p:cNvPr id="75" name="Rounded Rectangle 74"/>
+              <a:t>证据层</a:t>
+            </a:r>
+          </a:p>
+        </p:txBody>
+      </p:sp>
+      <p:sp>
+        <p:nvSpPr>
+          <p:cNvPr id="95" name="Rounded Rectangle 94"/>
           <p:cNvSpPr/>
           <p:nvPr/>
         </p:nvSpPr>
         <p:spPr>
           <a:xfrm>
-            <a:off x="978408" y="7370063"/>
-            <a:ext cx="4023360" cy="91440"/>
+            <a:off x="6565392" y="6199632"/>
+            <a:ext cx="4059936" cy="91440"/>
           </a:xfrm>
           <a:prstGeom prst="roundRect">
             <a:avLst>
@@ -8717,14 +9578,14 @@
       </p:sp>
       <p:sp>
         <p:nvSpPr>
-          <p:cNvPr id="76" name="Rounded Rectangle 75"/>
+          <p:cNvPr id="96" name="Rounded Rectangle 95"/>
           <p:cNvSpPr/>
           <p:nvPr/>
         </p:nvSpPr>
         <p:spPr>
           <a:xfrm>
-            <a:off x="978408" y="7370063"/>
-            <a:ext cx="3218688" cy="91440"/>
+            <a:off x="6565392" y="6199632"/>
+            <a:ext cx="2841955" cy="91440"/>
           </a:xfrm>
           <a:prstGeom prst="roundRect">
             <a:avLst>
@@ -8732,7 +9593,7 @@
             </a:avLst>
           </a:prstGeom>
           <a:solidFill>
-            <a:srgbClr val="F97A2E"/>
+            <a:srgbClr val="8B5CF6"/>
           </a:solidFill>
           <a:ln>
             <a:noFill/>
@@ -8763,14 +9624,14 @@
       </p:sp>
       <p:sp>
         <p:nvSpPr>
-          <p:cNvPr id="77" name="TextBox 76"/>
+          <p:cNvPr id="97" name="TextBox 96"/>
           <p:cNvSpPr txBox="1"/>
           <p:nvPr/>
         </p:nvSpPr>
         <p:spPr>
           <a:xfrm>
-            <a:off x="978408" y="7479792"/>
-            <a:ext cx="914400" cy="164592"/>
+            <a:off x="6565392" y="6254496"/>
+            <a:ext cx="914400" cy="146304"/>
           </a:xfrm>
           <a:prstGeom prst="rect">
             <a:avLst/>
@@ -8789,9 +9650,9 @@
               </a:lnSpc>
             </a:pPr>
             <a:r>
-              <a:rPr sz="850" b="1">
-                <a:solidFill>
-                  <a:srgbClr val="F97A2E"/>
+              <a:rPr sz="750" b="1">
+                <a:solidFill>
+                  <a:srgbClr val="8B5CF6"/>
                 </a:solidFill>
                 <a:latin typeface="Microsoft YaHei"/>
               </a:rPr>
@@ -8802,14 +9663,14 @@
       </p:sp>
       <p:sp>
         <p:nvSpPr>
-          <p:cNvPr id="78" name="TextBox 77"/>
+          <p:cNvPr id="98" name="TextBox 97"/>
           <p:cNvSpPr txBox="1"/>
           <p:nvPr/>
         </p:nvSpPr>
         <p:spPr>
           <a:xfrm>
-            <a:off x="1874519" y="7479792"/>
-            <a:ext cx="914400" cy="164592"/>
+            <a:off x="7443216" y="6254496"/>
+            <a:ext cx="914400" cy="146304"/>
           </a:xfrm>
           <a:prstGeom prst="rect">
             <a:avLst/>
@@ -8828,9 +9689,9 @@
               </a:lnSpc>
             </a:pPr>
             <a:r>
-              <a:rPr sz="850" b="1">
-                <a:solidFill>
-                  <a:srgbClr val="F97A2E"/>
+              <a:rPr sz="750" b="1">
+                <a:solidFill>
+                  <a:srgbClr val="8B5CF6"/>
                 </a:solidFill>
                 <a:latin typeface="Microsoft YaHei"/>
               </a:rPr>
@@ -8841,14 +9702,14 @@
       </p:sp>
       <p:sp>
         <p:nvSpPr>
-          <p:cNvPr id="79" name="TextBox 78"/>
+          <p:cNvPr id="99" name="TextBox 98"/>
           <p:cNvSpPr txBox="1"/>
           <p:nvPr/>
         </p:nvSpPr>
         <p:spPr>
           <a:xfrm>
-            <a:off x="2770632" y="7479792"/>
-            <a:ext cx="914400" cy="164592"/>
+            <a:off x="8321040" y="6254496"/>
+            <a:ext cx="914400" cy="146304"/>
           </a:xfrm>
           <a:prstGeom prst="rect">
             <a:avLst/>
@@ -8867,9 +9728,9 @@
               </a:lnSpc>
             </a:pPr>
             <a:r>
-              <a:rPr sz="850" b="1">
-                <a:solidFill>
-                  <a:srgbClr val="F97A2E"/>
+              <a:rPr sz="750" b="1">
+                <a:solidFill>
+                  <a:srgbClr val="8B5CF6"/>
                 </a:solidFill>
                 <a:latin typeface="Microsoft YaHei"/>
               </a:rPr>
@@ -8880,19 +9741,17 @@
       </p:sp>
       <p:sp>
         <p:nvSpPr>
-          <p:cNvPr id="80" name="Rounded Rectangle 79"/>
+          <p:cNvPr id="100" name="Rectangle 99"/>
           <p:cNvSpPr/>
           <p:nvPr/>
         </p:nvSpPr>
         <p:spPr>
           <a:xfrm>
-            <a:off x="6309360" y="5230368"/>
-            <a:ext cx="5212080" cy="2267712"/>
-          </a:xfrm>
-          <a:prstGeom prst="roundRect">
-            <a:avLst>
-              <a:gd name="adj" fmla="val 6000"/>
-            </a:avLst>
+            <a:off x="0" y="6455664"/>
+            <a:ext cx="12191695" cy="402336"/>
+          </a:xfrm>
+          <a:prstGeom prst="rect">
+            <a:avLst/>
           </a:prstGeom>
           <a:solidFill>
             <a:srgbClr val="FFFFFF"/>
@@ -8928,751 +9787,7 @@
       </p:sp>
       <p:sp>
         <p:nvSpPr>
-          <p:cNvPr id="81" name="Rectangle 80"/>
-          <p:cNvSpPr/>
-          <p:nvPr/>
-        </p:nvSpPr>
-        <p:spPr>
-          <a:xfrm>
-            <a:off x="6309360" y="5230368"/>
-            <a:ext cx="82296" cy="2267712"/>
-          </a:xfrm>
-          <a:prstGeom prst="rect">
-            <a:avLst/>
-          </a:prstGeom>
-          <a:solidFill>
-            <a:srgbClr val="8B5CF6"/>
-          </a:solidFill>
-          <a:ln>
-            <a:noFill/>
-          </a:ln>
-          <a:effectLst/>
-        </p:spPr>
-        <p:style>
-          <a:lnRef idx="1">
-            <a:schemeClr val="accent1"/>
-          </a:lnRef>
-          <a:fillRef idx="3">
-            <a:schemeClr val="accent1"/>
-          </a:fillRef>
-          <a:effectRef idx="2">
-            <a:schemeClr val="accent1"/>
-          </a:effectRef>
-          <a:fontRef idx="minor">
-            <a:schemeClr val="lt1"/>
-          </a:fontRef>
-        </p:style>
-        <p:txBody>
-          <a:bodyPr rtlCol="0" anchor="ctr"/>
-          <a:lstStyle/>
-          <a:p>
-            <a:pPr algn="ctr"/>
-          </a:p>
-        </p:txBody>
-      </p:sp>
-      <p:sp>
-        <p:nvSpPr>
-          <p:cNvPr id="82" name="Rounded Rectangle 81"/>
-          <p:cNvSpPr/>
-          <p:nvPr/>
-        </p:nvSpPr>
-        <p:spPr>
-          <a:xfrm>
-            <a:off x="6583680" y="5431536"/>
-            <a:ext cx="566928" cy="566928"/>
-          </a:xfrm>
-          <a:prstGeom prst="roundRect">
-            <a:avLst>
-              <a:gd name="adj" fmla="val 18000"/>
-            </a:avLst>
-          </a:prstGeom>
-          <a:solidFill>
-            <a:srgbClr val="8B5CF6"/>
-          </a:solidFill>
-          <a:ln>
-            <a:noFill/>
-          </a:ln>
-          <a:effectLst/>
-        </p:spPr>
-        <p:style>
-          <a:lnRef idx="1">
-            <a:schemeClr val="accent1"/>
-          </a:lnRef>
-          <a:fillRef idx="3">
-            <a:schemeClr val="accent1"/>
-          </a:fillRef>
-          <a:effectRef idx="2">
-            <a:schemeClr val="accent1"/>
-          </a:effectRef>
-          <a:fontRef idx="minor">
-            <a:schemeClr val="lt1"/>
-          </a:fontRef>
-        </p:style>
-        <p:txBody>
-          <a:bodyPr rtlCol="0" anchor="ctr"/>
-          <a:lstStyle/>
-          <a:p>
-            <a:pPr algn="ctr"/>
-          </a:p>
-        </p:txBody>
-      </p:sp>
-      <p:sp>
-        <p:nvSpPr>
-          <p:cNvPr id="83" name="TextBox 82"/>
-          <p:cNvSpPr txBox="1"/>
-          <p:nvPr/>
-        </p:nvSpPr>
-        <p:spPr>
-          <a:xfrm>
-            <a:off x="6583680" y="5504688"/>
-            <a:ext cx="566928" cy="411480"/>
-          </a:xfrm>
-          <a:prstGeom prst="rect">
-            <a:avLst/>
-          </a:prstGeom>
-          <a:noFill/>
-        </p:spPr>
-        <p:txBody>
-          <a:bodyPr wrap="square" anchor="t">
-            <a:spAutoFit/>
-          </a:bodyPr>
-          <a:lstStyle/>
-          <a:p>
-            <a:pPr algn="ctr">
-              <a:lnSpc>
-                <a:spcPct val="100000"/>
-              </a:lnSpc>
-            </a:pPr>
-            <a:r>
-              <a:rPr sz="1400" b="1">
-                <a:solidFill>
-                  <a:srgbClr val="FFFFFF"/>
-                </a:solidFill>
-                <a:latin typeface="Microsoft YaHei"/>
-              </a:rPr>
-              <a:t>04</a:t>
-            </a:r>
-          </a:p>
-        </p:txBody>
-      </p:sp>
-      <p:sp>
-        <p:nvSpPr>
-          <p:cNvPr id="84" name="TextBox 83"/>
-          <p:cNvSpPr txBox="1"/>
-          <p:nvPr/>
-        </p:nvSpPr>
-        <p:spPr>
-          <a:xfrm>
-            <a:off x="7296912" y="5413248"/>
-            <a:ext cx="2377440" cy="365760"/>
-          </a:xfrm>
-          <a:prstGeom prst="rect">
-            <a:avLst/>
-          </a:prstGeom>
-          <a:noFill/>
-        </p:spPr>
-        <p:txBody>
-          <a:bodyPr wrap="square" anchor="t">
-            <a:spAutoFit/>
-          </a:bodyPr>
-          <a:lstStyle/>
-          <a:p>
-            <a:pPr algn="l">
-              <a:lnSpc>
-                <a:spcPct val="100000"/>
-              </a:lnSpc>
-            </a:pPr>
-            <a:r>
-              <a:rPr sz="1600" b="1">
-                <a:solidFill>
-                  <a:srgbClr val="222A35"/>
-                </a:solidFill>
-                <a:latin typeface="Microsoft YaHei"/>
-              </a:rPr>
-              <a:t>验证 Verify</a:t>
-            </a:r>
-          </a:p>
-        </p:txBody>
-      </p:sp>
-      <p:sp>
-        <p:nvSpPr>
-          <p:cNvPr id="85" name="Rounded Rectangle 84"/>
-          <p:cNvSpPr/>
-          <p:nvPr/>
-        </p:nvSpPr>
-        <p:spPr>
-          <a:xfrm>
-            <a:off x="10149840" y="5486400"/>
-            <a:ext cx="1097280" cy="274320"/>
-          </a:xfrm>
-          <a:prstGeom prst="roundRect">
-            <a:avLst>
-              <a:gd name="adj" fmla="val 50000"/>
-            </a:avLst>
-          </a:prstGeom>
-          <a:solidFill>
-            <a:srgbClr val="F3F5F8"/>
-          </a:solidFill>
-          <a:ln>
-            <a:noFill/>
-          </a:ln>
-          <a:effectLst/>
-        </p:spPr>
-        <p:style>
-          <a:lnRef idx="1">
-            <a:schemeClr val="accent1"/>
-          </a:lnRef>
-          <a:fillRef idx="3">
-            <a:schemeClr val="accent1"/>
-          </a:fillRef>
-          <a:effectRef idx="2">
-            <a:schemeClr val="accent1"/>
-          </a:effectRef>
-          <a:fontRef idx="minor">
-            <a:schemeClr val="lt1"/>
-          </a:fontRef>
-        </p:style>
-        <p:txBody>
-          <a:bodyPr rtlCol="0" anchor="ctr"/>
-          <a:lstStyle/>
-          <a:p>
-            <a:pPr algn="ctr"/>
-          </a:p>
-        </p:txBody>
-      </p:sp>
-      <p:sp>
-        <p:nvSpPr>
-          <p:cNvPr id="86" name="TextBox 85"/>
-          <p:cNvSpPr txBox="1"/>
-          <p:nvPr/>
-        </p:nvSpPr>
-        <p:spPr>
-          <a:xfrm>
-            <a:off x="10149840" y="5522976"/>
-            <a:ext cx="1097280" cy="201168"/>
-          </a:xfrm>
-          <a:prstGeom prst="rect">
-            <a:avLst/>
-          </a:prstGeom>
-          <a:noFill/>
-        </p:spPr>
-        <p:txBody>
-          <a:bodyPr wrap="square" anchor="t">
-            <a:spAutoFit/>
-          </a:bodyPr>
-          <a:lstStyle/>
-          <a:p>
-            <a:pPr algn="ctr">
-              <a:lnSpc>
-                <a:spcPct val="100000"/>
-              </a:lnSpc>
-            </a:pPr>
-            <a:r>
-              <a:rPr sz="850" b="1">
-                <a:solidFill>
-                  <a:srgbClr val="8B5CF6"/>
-                </a:solidFill>
-                <a:latin typeface="Microsoft YaHei"/>
-              </a:rPr>
-              <a:t>VERIFY</a:t>
-            </a:r>
-          </a:p>
-        </p:txBody>
-      </p:sp>
-      <p:sp>
-        <p:nvSpPr>
-          <p:cNvPr id="87" name="TextBox 86"/>
-          <p:cNvSpPr txBox="1"/>
-          <p:nvPr/>
-        </p:nvSpPr>
-        <p:spPr>
-          <a:xfrm>
-            <a:off x="6601968" y="6089904"/>
-            <a:ext cx="4626864" cy="530352"/>
-          </a:xfrm>
-          <a:prstGeom prst="rect">
-            <a:avLst/>
-          </a:prstGeom>
-          <a:noFill/>
-        </p:spPr>
-        <p:txBody>
-          <a:bodyPr wrap="square" anchor="t">
-            <a:spAutoFit/>
-          </a:bodyPr>
-          <a:lstStyle/>
-          <a:p>
-            <a:pPr algn="l">
-              <a:lnSpc>
-                <a:spcPct val="104000"/>
-              </a:lnSpc>
-            </a:pPr>
-            <a:r>
-              <a:rPr sz="1100" b="0">
-                <a:solidFill>
-                  <a:srgbClr val="66707D"/>
-                </a:solidFill>
-                <a:latin typeface="Microsoft YaHei"/>
-              </a:rPr>
-              <a:t>以结构、渲染、视觉与官方评估器四层证据确认交付质量。</a:t>
-            </a:r>
-          </a:p>
-        </p:txBody>
-      </p:sp>
-      <p:sp>
-        <p:nvSpPr>
-          <p:cNvPr id="88" name="TextBox 87"/>
-          <p:cNvSpPr txBox="1"/>
-          <p:nvPr/>
-        </p:nvSpPr>
-        <p:spPr>
-          <a:xfrm>
-            <a:off x="6601968" y="6638544"/>
-            <a:ext cx="4023360" cy="640080"/>
-          </a:xfrm>
-          <a:prstGeom prst="rect">
-            <a:avLst/>
-          </a:prstGeom>
-          <a:noFill/>
-        </p:spPr>
-        <p:txBody>
-          <a:bodyPr wrap="square" anchor="t">
-            <a:spAutoFit/>
-          </a:bodyPr>
-          <a:lstStyle/>
-          <a:p>
-            <a:pPr algn="l">
-              <a:lnSpc>
-                <a:spcPct val="102000"/>
-              </a:lnSpc>
-            </a:pPr>
-            <a:r>
-              <a:rPr sz="1000" b="0">
-                <a:solidFill>
-                  <a:srgbClr val="222A35"/>
-                </a:solidFill>
-                <a:latin typeface="Microsoft YaHei"/>
-              </a:rPr>
-              <a:t>•  反例定位与局部修复</a:t>
-            </a:r>
-          </a:p>
-          <a:p>
-            <a:pPr algn="l">
-              <a:lnSpc>
-                <a:spcPct val="102000"/>
-              </a:lnSpc>
-            </a:pPr>
-            <a:r>
-              <a:rPr sz="1000" b="0">
-                <a:solidFill>
-                  <a:srgbClr val="222A35"/>
-                </a:solidFill>
-                <a:latin typeface="Microsoft YaHei"/>
-              </a:rPr>
-              <a:t>•  证据新鲜度管理</a:t>
-            </a:r>
-          </a:p>
-          <a:p>
-            <a:pPr algn="l">
-              <a:lnSpc>
-                <a:spcPct val="102000"/>
-              </a:lnSpc>
-            </a:pPr>
-            <a:r>
-              <a:rPr sz="1000" b="0">
-                <a:solidFill>
-                  <a:srgbClr val="222A35"/>
-                </a:solidFill>
-                <a:latin typeface="Microsoft YaHei"/>
-              </a:rPr>
-              <a:t>•  交付前强制 gate</a:t>
-            </a:r>
-          </a:p>
-        </p:txBody>
-      </p:sp>
-      <p:sp>
-        <p:nvSpPr>
-          <p:cNvPr id="89" name="Rounded Rectangle 88"/>
-          <p:cNvSpPr/>
-          <p:nvPr/>
-        </p:nvSpPr>
-        <p:spPr>
-          <a:xfrm>
-            <a:off x="10515600" y="6638544"/>
-            <a:ext cx="713232" cy="640080"/>
-          </a:xfrm>
-          <a:prstGeom prst="roundRect">
-            <a:avLst>
-              <a:gd name="adj" fmla="val 10000"/>
-            </a:avLst>
-          </a:prstGeom>
-          <a:solidFill>
-            <a:srgbClr val="F3F5F8"/>
-          </a:solidFill>
-          <a:ln w="9525">
-            <a:solidFill>
-              <a:srgbClr val="DFE5EC"/>
-            </a:solidFill>
-          </a:ln>
-          <a:effectLst/>
-        </p:spPr>
-        <p:style>
-          <a:lnRef idx="1">
-            <a:schemeClr val="accent1"/>
-          </a:lnRef>
-          <a:fillRef idx="3">
-            <a:schemeClr val="accent1"/>
-          </a:fillRef>
-          <a:effectRef idx="2">
-            <a:schemeClr val="accent1"/>
-          </a:effectRef>
-          <a:fontRef idx="minor">
-            <a:schemeClr val="lt1"/>
-          </a:fontRef>
-        </p:style>
-        <p:txBody>
-          <a:bodyPr rtlCol="0" anchor="ctr"/>
-          <a:lstStyle/>
-          <a:p>
-            <a:pPr algn="ctr"/>
-          </a:p>
-        </p:txBody>
-      </p:sp>
-      <p:sp>
-        <p:nvSpPr>
-          <p:cNvPr id="90" name="TextBox 89"/>
-          <p:cNvSpPr txBox="1"/>
-          <p:nvPr/>
-        </p:nvSpPr>
-        <p:spPr>
-          <a:xfrm>
-            <a:off x="10515600" y="6711696"/>
-            <a:ext cx="713232" cy="256032"/>
-          </a:xfrm>
-          <a:prstGeom prst="rect">
-            <a:avLst/>
-          </a:prstGeom>
-          <a:noFill/>
-        </p:spPr>
-        <p:txBody>
-          <a:bodyPr wrap="square" anchor="t">
-            <a:spAutoFit/>
-          </a:bodyPr>
-          <a:lstStyle/>
-          <a:p>
-            <a:pPr algn="ctr">
-              <a:lnSpc>
-                <a:spcPct val="100000"/>
-              </a:lnSpc>
-            </a:pPr>
-            <a:r>
-              <a:rPr sz="1400" b="1">
-                <a:solidFill>
-                  <a:srgbClr val="8B5CF6"/>
-                </a:solidFill>
-                <a:latin typeface="Microsoft YaHei"/>
-              </a:rPr>
-              <a:t>4</a:t>
-            </a:r>
-          </a:p>
-        </p:txBody>
-      </p:sp>
-      <p:sp>
-        <p:nvSpPr>
-          <p:cNvPr id="91" name="TextBox 90"/>
-          <p:cNvSpPr txBox="1"/>
-          <p:nvPr/>
-        </p:nvSpPr>
-        <p:spPr>
-          <a:xfrm>
-            <a:off x="10515600" y="7004304"/>
-            <a:ext cx="713232" cy="201168"/>
-          </a:xfrm>
-          <a:prstGeom prst="rect">
-            <a:avLst/>
-          </a:prstGeom>
-          <a:noFill/>
-        </p:spPr>
-        <p:txBody>
-          <a:bodyPr wrap="square" anchor="t">
-            <a:spAutoFit/>
-          </a:bodyPr>
-          <a:lstStyle/>
-          <a:p>
-            <a:pPr algn="ctr">
-              <a:lnSpc>
-                <a:spcPct val="100000"/>
-              </a:lnSpc>
-            </a:pPr>
-            <a:r>
-              <a:rPr sz="750" b="0">
-                <a:solidFill>
-                  <a:srgbClr val="66707D"/>
-                </a:solidFill>
-                <a:latin typeface="Microsoft YaHei"/>
-              </a:rPr>
-              <a:t>证据层</a:t>
-            </a:r>
-          </a:p>
-        </p:txBody>
-      </p:sp>
-      <p:sp>
-        <p:nvSpPr>
-          <p:cNvPr id="92" name="Rounded Rectangle 91"/>
-          <p:cNvSpPr/>
-          <p:nvPr/>
-        </p:nvSpPr>
-        <p:spPr>
-          <a:xfrm>
-            <a:off x="6601968" y="7370063"/>
-            <a:ext cx="4023360" cy="91440"/>
-          </a:xfrm>
-          <a:prstGeom prst="roundRect">
-            <a:avLst>
-              <a:gd name="adj" fmla="val 50000"/>
-            </a:avLst>
-          </a:prstGeom>
-          <a:solidFill>
-            <a:srgbClr val="2A3D5A"/>
-          </a:solidFill>
-          <a:ln>
-            <a:noFill/>
-          </a:ln>
-          <a:effectLst/>
-        </p:spPr>
-        <p:style>
-          <a:lnRef idx="1">
-            <a:schemeClr val="accent1"/>
-          </a:lnRef>
-          <a:fillRef idx="3">
-            <a:schemeClr val="accent1"/>
-          </a:fillRef>
-          <a:effectRef idx="2">
-            <a:schemeClr val="accent1"/>
-          </a:effectRef>
-          <a:fontRef idx="minor">
-            <a:schemeClr val="lt1"/>
-          </a:fontRef>
-        </p:style>
-        <p:txBody>
-          <a:bodyPr rtlCol="0" anchor="ctr"/>
-          <a:lstStyle/>
-          <a:p>
-            <a:pPr algn="ctr"/>
-          </a:p>
-        </p:txBody>
-      </p:sp>
-      <p:sp>
-        <p:nvSpPr>
-          <p:cNvPr id="93" name="Rounded Rectangle 92"/>
-          <p:cNvSpPr/>
-          <p:nvPr/>
-        </p:nvSpPr>
-        <p:spPr>
-          <a:xfrm>
-            <a:off x="6601968" y="7370063"/>
-            <a:ext cx="2816352" cy="91440"/>
-          </a:xfrm>
-          <a:prstGeom prst="roundRect">
-            <a:avLst>
-              <a:gd name="adj" fmla="val 50000"/>
-            </a:avLst>
-          </a:prstGeom>
-          <a:solidFill>
-            <a:srgbClr val="8B5CF6"/>
-          </a:solidFill>
-          <a:ln>
-            <a:noFill/>
-          </a:ln>
-          <a:effectLst/>
-        </p:spPr>
-        <p:style>
-          <a:lnRef idx="1">
-            <a:schemeClr val="accent1"/>
-          </a:lnRef>
-          <a:fillRef idx="3">
-            <a:schemeClr val="accent1"/>
-          </a:fillRef>
-          <a:effectRef idx="2">
-            <a:schemeClr val="accent1"/>
-          </a:effectRef>
-          <a:fontRef idx="minor">
-            <a:schemeClr val="lt1"/>
-          </a:fontRef>
-        </p:style>
-        <p:txBody>
-          <a:bodyPr rtlCol="0" anchor="ctr"/>
-          <a:lstStyle/>
-          <a:p>
-            <a:pPr algn="ctr"/>
-          </a:p>
-        </p:txBody>
-      </p:sp>
-      <p:sp>
-        <p:nvSpPr>
-          <p:cNvPr id="94" name="TextBox 93"/>
-          <p:cNvSpPr txBox="1"/>
-          <p:nvPr/>
-        </p:nvSpPr>
-        <p:spPr>
-          <a:xfrm>
-            <a:off x="6601968" y="7479792"/>
-            <a:ext cx="914400" cy="164592"/>
-          </a:xfrm>
-          <a:prstGeom prst="rect">
-            <a:avLst/>
-          </a:prstGeom>
-          <a:noFill/>
-        </p:spPr>
-        <p:txBody>
-          <a:bodyPr wrap="square" anchor="t">
-            <a:spAutoFit/>
-          </a:bodyPr>
-          <a:lstStyle/>
-          <a:p>
-            <a:pPr algn="l">
-              <a:lnSpc>
-                <a:spcPct val="100000"/>
-              </a:lnSpc>
-            </a:pPr>
-            <a:r>
-              <a:rPr sz="850" b="1">
-                <a:solidFill>
-                  <a:srgbClr val="8B5CF6"/>
-                </a:solidFill>
-                <a:latin typeface="Microsoft YaHei"/>
-              </a:rPr>
-              <a:t>查看日志</a:t>
-            </a:r>
-          </a:p>
-        </p:txBody>
-      </p:sp>
-      <p:sp>
-        <p:nvSpPr>
-          <p:cNvPr id="95" name="TextBox 94"/>
-          <p:cNvSpPr txBox="1"/>
-          <p:nvPr/>
-        </p:nvSpPr>
-        <p:spPr>
-          <a:xfrm>
-            <a:off x="7498080" y="7479792"/>
-            <a:ext cx="914400" cy="164592"/>
-          </a:xfrm>
-          <a:prstGeom prst="rect">
-            <a:avLst/>
-          </a:prstGeom>
-          <a:noFill/>
-        </p:spPr>
-        <p:txBody>
-          <a:bodyPr wrap="square" anchor="t">
-            <a:spAutoFit/>
-          </a:bodyPr>
-          <a:lstStyle/>
-          <a:p>
-            <a:pPr algn="l">
-              <a:lnSpc>
-                <a:spcPct val="100000"/>
-              </a:lnSpc>
-            </a:pPr>
-            <a:r>
-              <a:rPr sz="850" b="1">
-                <a:solidFill>
-                  <a:srgbClr val="8B5CF6"/>
-                </a:solidFill>
-                <a:latin typeface="Microsoft YaHei"/>
-              </a:rPr>
-              <a:t>查看证据</a:t>
-            </a:r>
-          </a:p>
-        </p:txBody>
-      </p:sp>
-      <p:sp>
-        <p:nvSpPr>
-          <p:cNvPr id="96" name="TextBox 95"/>
-          <p:cNvSpPr txBox="1"/>
-          <p:nvPr/>
-        </p:nvSpPr>
-        <p:spPr>
-          <a:xfrm>
-            <a:off x="8394192" y="7479792"/>
-            <a:ext cx="914400" cy="164592"/>
-          </a:xfrm>
-          <a:prstGeom prst="rect">
-            <a:avLst/>
-          </a:prstGeom>
-          <a:noFill/>
-        </p:spPr>
-        <p:txBody>
-          <a:bodyPr wrap="square" anchor="t">
-            <a:spAutoFit/>
-          </a:bodyPr>
-          <a:lstStyle/>
-          <a:p>
-            <a:pPr algn="l">
-              <a:lnSpc>
-                <a:spcPct val="100000"/>
-              </a:lnSpc>
-            </a:pPr>
-            <a:r>
-              <a:rPr sz="850" b="1">
-                <a:solidFill>
-                  <a:srgbClr val="8B5CF6"/>
-                </a:solidFill>
-                <a:latin typeface="Microsoft YaHei"/>
-              </a:rPr>
-              <a:t>导出</a:t>
-            </a:r>
-          </a:p>
-        </p:txBody>
-      </p:sp>
-      <p:sp>
-        <p:nvSpPr>
-          <p:cNvPr id="97" name="Rectangle 96"/>
-          <p:cNvSpPr/>
-          <p:nvPr/>
-        </p:nvSpPr>
-        <p:spPr>
-          <a:xfrm>
-            <a:off x="0" y="6455664"/>
-            <a:ext cx="12191695" cy="402336"/>
-          </a:xfrm>
-          <a:prstGeom prst="rect">
-            <a:avLst/>
-          </a:prstGeom>
-          <a:solidFill>
-            <a:srgbClr val="FFFFFF"/>
-          </a:solidFill>
-          <a:ln w="9525">
-            <a:solidFill>
-              <a:srgbClr val="DFE5EC"/>
-            </a:solidFill>
-          </a:ln>
-          <a:effectLst/>
-        </p:spPr>
-        <p:style>
-          <a:lnRef idx="1">
-            <a:schemeClr val="accent1"/>
-          </a:lnRef>
-          <a:fillRef idx="3">
-            <a:schemeClr val="accent1"/>
-          </a:fillRef>
-          <a:effectRef idx="2">
-            <a:schemeClr val="accent1"/>
-          </a:effectRef>
-          <a:fontRef idx="minor">
-            <a:schemeClr val="lt1"/>
-          </a:fontRef>
-        </p:style>
-        <p:txBody>
-          <a:bodyPr rtlCol="0" anchor="ctr"/>
-          <a:lstStyle/>
-          <a:p>
-            <a:pPr algn="ctr"/>
-          </a:p>
-        </p:txBody>
-      </p:sp>
-      <p:sp>
-        <p:nvSpPr>
-          <p:cNvPr id="98" name="TextBox 97"/>
+          <p:cNvPr id="101" name="TextBox 100"/>
           <p:cNvSpPr txBox="1"/>
           <p:nvPr/>
         </p:nvSpPr>

</xml_diff>

<commit_message>
AI Agent workflow v6: complete six-stage pipeline on native page
</commit_message>
<xml_diff>
--- a/benchmarks/manual_tasks/ai-agent-workflow/output/ai_agent_workflow.pptx
+++ b/benchmarks/manual_tasks/ai-agent-workflow/output/ai_agent_workflow.pptx
@@ -3471,11 +3471,11 @@
         <p:spPr>
           <a:xfrm>
             <a:off x="658368" y="2788920"/>
-            <a:ext cx="1975104" cy="2615184"/>
+            <a:ext cx="1675333" cy="2615184"/>
           </a:xfrm>
           <a:prstGeom prst="roundRect">
             <a:avLst>
-              <a:gd name="adj" fmla="val 9000"/>
+              <a:gd name="adj" fmla="val 10000"/>
             </a:avLst>
           </a:prstGeom>
           <a:solidFill>
@@ -3518,8 +3518,8 @@
         </p:nvSpPr>
         <p:spPr>
           <a:xfrm>
-            <a:off x="822959" y="2953512"/>
-            <a:ext cx="493776" cy="493776"/>
+            <a:off x="786384" y="2953512"/>
+            <a:ext cx="420624" cy="420624"/>
           </a:xfrm>
           <a:prstGeom prst="roundRect">
             <a:avLst>
@@ -3554,7 +3554,7 @@
           <a:p>
             <a:pPr algn="ctr"/>
             <a:r>
-              <a:rPr sz="1300" b="1">
+              <a:rPr sz="1200" b="1">
                 <a:solidFill>
                   <a:srgbClr val="0F1A2B"/>
                 </a:solidFill>
@@ -3572,8 +3572,8 @@
         </p:nvSpPr>
         <p:spPr>
           <a:xfrm>
-            <a:off x="804672" y="3630168"/>
-            <a:ext cx="1682496" cy="384048"/>
+            <a:off x="768096" y="3575303"/>
+            <a:ext cx="1455877" cy="365760"/>
           </a:xfrm>
           <a:prstGeom prst="rect">
             <a:avLst/>
@@ -3592,7 +3592,7 @@
               </a:lnSpc>
             </a:pPr>
             <a:r>
-              <a:rPr sz="1450" b="1">
+              <a:rPr sz="1250" b="1">
                 <a:solidFill>
                   <a:srgbClr val="FFFFFF"/>
                 </a:solidFill>
@@ -3611,8 +3611,8 @@
         </p:nvSpPr>
         <p:spPr>
           <a:xfrm>
-            <a:off x="804672" y="4050791"/>
-            <a:ext cx="1682496" cy="685800"/>
+            <a:off x="768096" y="3995928"/>
+            <a:ext cx="1455877" cy="658368"/>
           </a:xfrm>
           <a:prstGeom prst="rect">
             <a:avLst/>
@@ -3627,17 +3627,17 @@
           <a:p>
             <a:pPr algn="l">
               <a:lnSpc>
-                <a:spcPct val="104000"/>
+                <a:spcPct val="102000"/>
               </a:lnSpc>
             </a:pPr>
             <a:r>
-              <a:rPr sz="1050" b="0">
+              <a:rPr sz="950" b="0">
                 <a:solidFill>
                   <a:srgbClr val="A8B8CE"/>
                 </a:solidFill>
                 <a:latin typeface="Microsoft YaHei"/>
               </a:rPr>
-              <a:t>接收指令、附件与工作区上下文</a:t>
+              <a:t>指令、附件与上下文</a:t>
             </a:r>
           </a:p>
         </p:txBody>
@@ -3650,8 +3650,8 @@
         </p:nvSpPr>
         <p:spPr>
           <a:xfrm>
-            <a:off x="804672" y="4800600"/>
-            <a:ext cx="1682496" cy="310896"/>
+            <a:off x="768096" y="4727448"/>
+            <a:ext cx="1455877" cy="310896"/>
           </a:xfrm>
           <a:prstGeom prst="roundRect">
             <a:avLst>
@@ -3696,8 +3696,8 @@
         </p:nvSpPr>
         <p:spPr>
           <a:xfrm>
-            <a:off x="877824" y="4855464"/>
-            <a:ext cx="1536192" cy="201168"/>
+            <a:off x="822959" y="4782312"/>
+            <a:ext cx="1346149" cy="201168"/>
           </a:xfrm>
           <a:prstGeom prst="rect">
             <a:avLst/>
@@ -3710,19 +3710,19 @@
           </a:bodyPr>
           <a:lstStyle/>
           <a:p>
-            <a:pPr algn="l">
+            <a:pPr algn="ctr">
               <a:lnSpc>
                 <a:spcPct val="100000"/>
               </a:lnSpc>
             </a:pPr>
             <a:r>
-              <a:rPr sz="850" b="0">
+              <a:rPr sz="800" b="1">
                 <a:solidFill>
                   <a:srgbClr val="F6B544"/>
                 </a:solidFill>
                 <a:latin typeface="Microsoft YaHei"/>
               </a:rPr>
-              <a:t>产出：结构化任务对象</a:t>
+              <a:t>结构化任务</a:t>
             </a:r>
           </a:p>
         </p:txBody>
@@ -3735,8 +3735,8 @@
         </p:nvSpPr>
         <p:spPr>
           <a:xfrm>
-            <a:off x="804672" y="5221224"/>
-            <a:ext cx="1682496" cy="91440"/>
+            <a:off x="768096" y="5148072"/>
+            <a:ext cx="1455877" cy="91440"/>
           </a:xfrm>
           <a:prstGeom prst="roundRect">
             <a:avLst>
@@ -3781,8 +3781,8 @@
         </p:nvSpPr>
         <p:spPr>
           <a:xfrm>
-            <a:off x="804672" y="5221224"/>
-            <a:ext cx="1682496" cy="91440"/>
+            <a:off x="768096" y="5148072"/>
+            <a:ext cx="1455877" cy="91440"/>
           </a:xfrm>
           <a:prstGeom prst="roundRect">
             <a:avLst>
@@ -3827,8 +3827,8 @@
         </p:nvCxnSpPr>
         <p:spPr>
           <a:xfrm>
-            <a:off x="2660903" y="4096511"/>
-            <a:ext cx="146305" cy="0"/>
+            <a:off x="2356561" y="4096511"/>
+            <a:ext cx="118872" cy="0"/>
           </a:xfrm>
           <a:prstGeom prst="line">
             <a:avLst/>
@@ -3863,12 +3863,12 @@
         </p:nvSpPr>
         <p:spPr>
           <a:xfrm>
-            <a:off x="2834640" y="2788920"/>
-            <a:ext cx="1975104" cy="2615184"/>
+            <a:off x="2498293" y="2788920"/>
+            <a:ext cx="1675333" cy="2615184"/>
           </a:xfrm>
           <a:prstGeom prst="roundRect">
             <a:avLst>
-              <a:gd name="adj" fmla="val 9000"/>
+              <a:gd name="adj" fmla="val 10000"/>
             </a:avLst>
           </a:prstGeom>
           <a:solidFill>
@@ -3911,8 +3911,8 @@
         </p:nvSpPr>
         <p:spPr>
           <a:xfrm>
-            <a:off x="2999232" y="2953512"/>
-            <a:ext cx="493776" cy="493776"/>
+            <a:off x="2626309" y="2953512"/>
+            <a:ext cx="420624" cy="420624"/>
           </a:xfrm>
           <a:prstGeom prst="roundRect">
             <a:avLst>
@@ -3947,7 +3947,7 @@
           <a:p>
             <a:pPr algn="ctr"/>
             <a:r>
-              <a:rPr sz="1300" b="1">
+              <a:rPr sz="1200" b="1">
                 <a:solidFill>
                   <a:srgbClr val="0F1A2B"/>
                 </a:solidFill>
@@ -3965,8 +3965,8 @@
         </p:nvSpPr>
         <p:spPr>
           <a:xfrm>
-            <a:off x="2980944" y="3630168"/>
-            <a:ext cx="1682496" cy="384048"/>
+            <a:off x="2608021" y="3575303"/>
+            <a:ext cx="1455877" cy="365760"/>
           </a:xfrm>
           <a:prstGeom prst="rect">
             <a:avLst/>
@@ -3985,7 +3985,7 @@
               </a:lnSpc>
             </a:pPr>
             <a:r>
-              <a:rPr sz="1450" b="1">
+              <a:rPr sz="1250" b="1">
                 <a:solidFill>
                   <a:srgbClr val="FFFFFF"/>
                 </a:solidFill>
@@ -4004,8 +4004,8 @@
         </p:nvSpPr>
         <p:spPr>
           <a:xfrm>
-            <a:off x="2980944" y="4050791"/>
-            <a:ext cx="1682496" cy="685800"/>
+            <a:off x="2608021" y="3995928"/>
+            <a:ext cx="1455877" cy="658368"/>
           </a:xfrm>
           <a:prstGeom prst="rect">
             <a:avLst/>
@@ -4020,17 +4020,17 @@
           <a:p>
             <a:pPr algn="l">
               <a:lnSpc>
-                <a:spcPct val="104000"/>
+                <a:spcPct val="102000"/>
               </a:lnSpc>
             </a:pPr>
             <a:r>
-              <a:rPr sz="1050" b="0">
+              <a:rPr sz="950" b="0">
                 <a:solidFill>
                   <a:srgbClr val="A8B8CE"/>
                 </a:solidFill>
                 <a:latin typeface="Microsoft YaHei"/>
               </a:rPr>
-              <a:t>任务分类、能力匹配与计划生成</a:t>
+              <a:t>分类、能力与计划</a:t>
             </a:r>
           </a:p>
         </p:txBody>
@@ -4043,8 +4043,8 @@
         </p:nvSpPr>
         <p:spPr>
           <a:xfrm>
-            <a:off x="2980944" y="4800600"/>
-            <a:ext cx="1682496" cy="310896"/>
+            <a:off x="2608021" y="4727448"/>
+            <a:ext cx="1455877" cy="310896"/>
           </a:xfrm>
           <a:prstGeom prst="roundRect">
             <a:avLst>
@@ -4089,8 +4089,8 @@
         </p:nvSpPr>
         <p:spPr>
           <a:xfrm>
-            <a:off x="3054096" y="4855464"/>
-            <a:ext cx="1536192" cy="201168"/>
+            <a:off x="2662885" y="4782312"/>
+            <a:ext cx="1346149" cy="201168"/>
           </a:xfrm>
           <a:prstGeom prst="rect">
             <a:avLst/>
@@ -4103,19 +4103,19 @@
           </a:bodyPr>
           <a:lstStyle/>
           <a:p>
-            <a:pPr algn="l">
+            <a:pPr algn="ctr">
               <a:lnSpc>
                 <a:spcPct val="100000"/>
               </a:lnSpc>
             </a:pPr>
             <a:r>
-              <a:rPr sz="850" b="0">
+              <a:rPr sz="800" b="1">
                 <a:solidFill>
                   <a:srgbClr val="3B82F6"/>
                 </a:solidFill>
                 <a:latin typeface="Microsoft YaHei"/>
               </a:rPr>
-              <a:t>产出：执行合同与工具面</a:t>
+              <a:t>执行合同</a:t>
             </a:r>
           </a:p>
         </p:txBody>
@@ -4128,8 +4128,8 @@
         </p:nvSpPr>
         <p:spPr>
           <a:xfrm>
-            <a:off x="2980944" y="5221224"/>
-            <a:ext cx="1682496" cy="91440"/>
+            <a:off x="2608021" y="5148072"/>
+            <a:ext cx="1455877" cy="91440"/>
           </a:xfrm>
           <a:prstGeom prst="roundRect">
             <a:avLst>
@@ -4174,8 +4174,8 @@
         </p:nvSpPr>
         <p:spPr>
           <a:xfrm>
-            <a:off x="2980944" y="5221224"/>
-            <a:ext cx="1682496" cy="91440"/>
+            <a:off x="2608021" y="5148072"/>
+            <a:ext cx="1455877" cy="91440"/>
           </a:xfrm>
           <a:prstGeom prst="roundRect">
             <a:avLst>
@@ -4220,8 +4220,8 @@
         </p:nvCxnSpPr>
         <p:spPr>
           <a:xfrm>
-            <a:off x="4837176" y="4096511"/>
-            <a:ext cx="146304" cy="0"/>
+            <a:off x="4196486" y="4096511"/>
+            <a:ext cx="118872" cy="0"/>
           </a:xfrm>
           <a:prstGeom prst="line">
             <a:avLst/>
@@ -4256,12 +4256,12 @@
         </p:nvSpPr>
         <p:spPr>
           <a:xfrm>
-            <a:off x="5010912" y="2788920"/>
-            <a:ext cx="1975104" cy="2615184"/>
+            <a:off x="4338218" y="2788920"/>
+            <a:ext cx="1675333" cy="2615184"/>
           </a:xfrm>
           <a:prstGeom prst="roundRect">
             <a:avLst>
-              <a:gd name="adj" fmla="val 9000"/>
+              <a:gd name="adj" fmla="val 10000"/>
             </a:avLst>
           </a:prstGeom>
           <a:solidFill>
@@ -4304,8 +4304,8 @@
         </p:nvSpPr>
         <p:spPr>
           <a:xfrm>
-            <a:off x="5175504" y="2953512"/>
-            <a:ext cx="493776" cy="493776"/>
+            <a:off x="4466234" y="2953512"/>
+            <a:ext cx="420624" cy="420624"/>
           </a:xfrm>
           <a:prstGeom prst="roundRect">
             <a:avLst>
@@ -4340,7 +4340,7 @@
           <a:p>
             <a:pPr algn="ctr"/>
             <a:r>
-              <a:rPr sz="1300" b="1">
+              <a:rPr sz="1200" b="1">
                 <a:solidFill>
                   <a:srgbClr val="0F1A2B"/>
                 </a:solidFill>
@@ -4358,8 +4358,8 @@
         </p:nvSpPr>
         <p:spPr>
           <a:xfrm>
-            <a:off x="5157216" y="3630168"/>
-            <a:ext cx="1682496" cy="384048"/>
+            <a:off x="4447946" y="3575303"/>
+            <a:ext cx="1455877" cy="365760"/>
           </a:xfrm>
           <a:prstGeom prst="rect">
             <a:avLst/>
@@ -4378,7 +4378,7 @@
               </a:lnSpc>
             </a:pPr>
             <a:r>
-              <a:rPr sz="1450" b="1">
+              <a:rPr sz="1250" b="1">
                 <a:solidFill>
                   <a:srgbClr val="FFFFFF"/>
                 </a:solidFill>
@@ -4397,8 +4397,8 @@
         </p:nvSpPr>
         <p:spPr>
           <a:xfrm>
-            <a:off x="5157216" y="4050791"/>
-            <a:ext cx="1682496" cy="685800"/>
+            <a:off x="4447946" y="3995928"/>
+            <a:ext cx="1455877" cy="658368"/>
           </a:xfrm>
           <a:prstGeom prst="rect">
             <a:avLst/>
@@ -4413,17 +4413,17 @@
           <a:p>
             <a:pPr algn="l">
               <a:lnSpc>
-                <a:spcPct val="104000"/>
+                <a:spcPct val="102000"/>
               </a:lnSpc>
             </a:pPr>
             <a:r>
-              <a:rPr sz="1050" b="0">
+              <a:rPr sz="950" b="0">
                 <a:solidFill>
                   <a:srgbClr val="A8B8CE"/>
                 </a:solidFill>
                 <a:latin typeface="Microsoft YaHei"/>
               </a:rPr>
-              <a:t>拆解阶段、预检风险与依赖关系</a:t>
+              <a:t>阶段、风险与依赖</a:t>
             </a:r>
           </a:p>
         </p:txBody>
@@ -4436,8 +4436,8 @@
         </p:nvSpPr>
         <p:spPr>
           <a:xfrm>
-            <a:off x="5157216" y="4800600"/>
-            <a:ext cx="1682496" cy="310896"/>
+            <a:off x="4447946" y="4727448"/>
+            <a:ext cx="1455877" cy="310896"/>
           </a:xfrm>
           <a:prstGeom prst="roundRect">
             <a:avLst>
@@ -4482,8 +4482,8 @@
         </p:nvSpPr>
         <p:spPr>
           <a:xfrm>
-            <a:off x="5230368" y="4855464"/>
-            <a:ext cx="1536192" cy="201168"/>
+            <a:off x="4502810" y="4782312"/>
+            <a:ext cx="1346149" cy="201168"/>
           </a:xfrm>
           <a:prstGeom prst="rect">
             <a:avLst/>
@@ -4496,19 +4496,19 @@
           </a:bodyPr>
           <a:lstStyle/>
           <a:p>
-            <a:pPr algn="l">
+            <a:pPr algn="ctr">
               <a:lnSpc>
                 <a:spcPct val="100000"/>
               </a:lnSpc>
             </a:pPr>
             <a:r>
-              <a:rPr sz="850" b="0">
+              <a:rPr sz="800" b="1">
                 <a:solidFill>
                   <a:srgbClr val="06B6D4"/>
                 </a:solidFill>
                 <a:latin typeface="Microsoft YaHei"/>
               </a:rPr>
-              <a:t>产出：执行计划</a:t>
+              <a:t>执行计划</a:t>
             </a:r>
           </a:p>
         </p:txBody>
@@ -4521,8 +4521,8 @@
         </p:nvSpPr>
         <p:spPr>
           <a:xfrm>
-            <a:off x="5157216" y="5221224"/>
-            <a:ext cx="1682496" cy="91440"/>
+            <a:off x="4447946" y="5148072"/>
+            <a:ext cx="1455877" cy="91440"/>
           </a:xfrm>
           <a:prstGeom prst="roundRect">
             <a:avLst>
@@ -4567,8 +4567,8 @@
         </p:nvSpPr>
         <p:spPr>
           <a:xfrm>
-            <a:off x="5157216" y="5221224"/>
-            <a:ext cx="1514246" cy="91440"/>
+            <a:off x="4447946" y="5148072"/>
+            <a:ext cx="1310289" cy="91440"/>
           </a:xfrm>
           <a:prstGeom prst="roundRect">
             <a:avLst>
@@ -4613,8 +4613,8 @@
         </p:nvCxnSpPr>
         <p:spPr>
           <a:xfrm>
-            <a:off x="7013448" y="4096511"/>
-            <a:ext cx="146304" cy="0"/>
+            <a:off x="6036411" y="4096511"/>
+            <a:ext cx="118872" cy="0"/>
           </a:xfrm>
           <a:prstGeom prst="line">
             <a:avLst/>
@@ -4649,12 +4649,12 @@
         </p:nvSpPr>
         <p:spPr>
           <a:xfrm>
-            <a:off x="7187184" y="2788920"/>
-            <a:ext cx="1975104" cy="2615184"/>
+            <a:off x="6178143" y="2788920"/>
+            <a:ext cx="1675333" cy="2615184"/>
           </a:xfrm>
           <a:prstGeom prst="roundRect">
             <a:avLst>
-              <a:gd name="adj" fmla="val 9000"/>
+              <a:gd name="adj" fmla="val 10000"/>
             </a:avLst>
           </a:prstGeom>
           <a:solidFill>
@@ -4697,8 +4697,8 @@
         </p:nvSpPr>
         <p:spPr>
           <a:xfrm>
-            <a:off x="7351776" y="2953512"/>
-            <a:ext cx="493776" cy="493776"/>
+            <a:off x="6306159" y="2953512"/>
+            <a:ext cx="420624" cy="420624"/>
           </a:xfrm>
           <a:prstGeom prst="roundRect">
             <a:avLst>
@@ -4733,7 +4733,7 @@
           <a:p>
             <a:pPr algn="ctr"/>
             <a:r>
-              <a:rPr sz="1300" b="1">
+              <a:rPr sz="1200" b="1">
                 <a:solidFill>
                   <a:srgbClr val="0F1A2B"/>
                 </a:solidFill>
@@ -4751,8 +4751,8 @@
         </p:nvSpPr>
         <p:spPr>
           <a:xfrm>
-            <a:off x="7333488" y="3630168"/>
-            <a:ext cx="1682496" cy="384048"/>
+            <a:off x="6287871" y="3575303"/>
+            <a:ext cx="1455877" cy="365760"/>
           </a:xfrm>
           <a:prstGeom prst="rect">
             <a:avLst/>
@@ -4771,7 +4771,7 @@
               </a:lnSpc>
             </a:pPr>
             <a:r>
-              <a:rPr sz="1450" b="1">
+              <a:rPr sz="1250" b="1">
                 <a:solidFill>
                   <a:srgbClr val="FFFFFF"/>
                 </a:solidFill>
@@ -4790,8 +4790,8 @@
         </p:nvSpPr>
         <p:spPr>
           <a:xfrm>
-            <a:off x="7333488" y="4050791"/>
-            <a:ext cx="1682496" cy="685800"/>
+            <a:off x="6287871" y="3995928"/>
+            <a:ext cx="1455877" cy="658368"/>
           </a:xfrm>
           <a:prstGeom prst="rect">
             <a:avLst/>
@@ -4806,17 +4806,17 @@
           <a:p>
             <a:pPr algn="l">
               <a:lnSpc>
-                <a:spcPct val="104000"/>
+                <a:spcPct val="102000"/>
               </a:lnSpc>
             </a:pPr>
             <a:r>
-              <a:rPr sz="1050" b="0">
+              <a:rPr sz="950" b="0">
                 <a:solidFill>
                   <a:srgbClr val="A8B8CE"/>
                 </a:solidFill>
                 <a:latin typeface="Microsoft YaHei"/>
               </a:rPr>
-              <a:t>工具调用、原子事务与权限审计</a:t>
+              <a:t>调用、事务与审计</a:t>
             </a:r>
           </a:p>
         </p:txBody>
@@ -4829,8 +4829,8 @@
         </p:nvSpPr>
         <p:spPr>
           <a:xfrm>
-            <a:off x="7333488" y="4800600"/>
-            <a:ext cx="1682496" cy="310896"/>
+            <a:off x="6287871" y="4727448"/>
+            <a:ext cx="1455877" cy="310896"/>
           </a:xfrm>
           <a:prstGeom prst="roundRect">
             <a:avLst>
@@ -4875,8 +4875,8 @@
         </p:nvSpPr>
         <p:spPr>
           <a:xfrm>
-            <a:off x="7406640" y="4855464"/>
-            <a:ext cx="1536192" cy="201168"/>
+            <a:off x="6342735" y="4782312"/>
+            <a:ext cx="1346149" cy="201168"/>
           </a:xfrm>
           <a:prstGeom prst="rect">
             <a:avLst/>
@@ -4889,19 +4889,19 @@
           </a:bodyPr>
           <a:lstStyle/>
           <a:p>
-            <a:pPr algn="l">
+            <a:pPr algn="ctr">
               <a:lnSpc>
                 <a:spcPct val="100000"/>
               </a:lnSpc>
             </a:pPr>
             <a:r>
-              <a:rPr sz="850" b="0">
+              <a:rPr sz="800" b="1">
                 <a:solidFill>
                   <a:srgbClr val="F97A2E"/>
                 </a:solidFill>
                 <a:latin typeface="Microsoft YaHei"/>
               </a:rPr>
-              <a:t>产出：候选产物</a:t>
+              <a:t>候选产物</a:t>
             </a:r>
           </a:p>
         </p:txBody>
@@ -4914,8 +4914,8 @@
         </p:nvSpPr>
         <p:spPr>
           <a:xfrm>
-            <a:off x="7333488" y="5221224"/>
-            <a:ext cx="1682496" cy="91440"/>
+            <a:off x="6287871" y="5148072"/>
+            <a:ext cx="1455877" cy="91440"/>
           </a:xfrm>
           <a:prstGeom prst="roundRect">
             <a:avLst>
@@ -4960,8 +4960,8 @@
         </p:nvSpPr>
         <p:spPr>
           <a:xfrm>
-            <a:off x="7333488" y="5221224"/>
-            <a:ext cx="1261872" cy="91440"/>
+            <a:off x="6287871" y="5148072"/>
+            <a:ext cx="1091907" cy="91440"/>
           </a:xfrm>
           <a:prstGeom prst="roundRect">
             <a:avLst>
@@ -5006,8 +5006,8 @@
         </p:nvCxnSpPr>
         <p:spPr>
           <a:xfrm>
-            <a:off x="9189719" y="4096511"/>
-            <a:ext cx="146305" cy="0"/>
+            <a:off x="7876336" y="4096511"/>
+            <a:ext cx="118872" cy="0"/>
           </a:xfrm>
           <a:prstGeom prst="line">
             <a:avLst/>
@@ -5042,12 +5042,12 @@
         </p:nvSpPr>
         <p:spPr>
           <a:xfrm>
-            <a:off x="9363456" y="2788920"/>
-            <a:ext cx="1975104" cy="2615184"/>
+            <a:off x="8018068" y="2788920"/>
+            <a:ext cx="1675333" cy="2615184"/>
           </a:xfrm>
           <a:prstGeom prst="roundRect">
             <a:avLst>
-              <a:gd name="adj" fmla="val 9000"/>
+              <a:gd name="adj" fmla="val 10000"/>
             </a:avLst>
           </a:prstGeom>
           <a:solidFill>
@@ -5090,8 +5090,8 @@
         </p:nvSpPr>
         <p:spPr>
           <a:xfrm>
-            <a:off x="9528048" y="2953512"/>
-            <a:ext cx="493776" cy="493776"/>
+            <a:off x="8146084" y="2953512"/>
+            <a:ext cx="420624" cy="420624"/>
           </a:xfrm>
           <a:prstGeom prst="roundRect">
             <a:avLst>
@@ -5126,7 +5126,7 @@
           <a:p>
             <a:pPr algn="ctr"/>
             <a:r>
-              <a:rPr sz="1300" b="1">
+              <a:rPr sz="1200" b="1">
                 <a:solidFill>
                   <a:srgbClr val="0F1A2B"/>
                 </a:solidFill>
@@ -5144,8 +5144,8 @@
         </p:nvSpPr>
         <p:spPr>
           <a:xfrm>
-            <a:off x="9509760" y="3630168"/>
-            <a:ext cx="1682496" cy="384048"/>
+            <a:off x="8127796" y="3575303"/>
+            <a:ext cx="1455877" cy="365760"/>
           </a:xfrm>
           <a:prstGeom prst="rect">
             <a:avLst/>
@@ -5164,7 +5164,7 @@
               </a:lnSpc>
             </a:pPr>
             <a:r>
-              <a:rPr sz="1450" b="1">
+              <a:rPr sz="1250" b="1">
                 <a:solidFill>
                   <a:srgbClr val="FFFFFF"/>
                 </a:solidFill>
@@ -5183,8 +5183,8 @@
         </p:nvSpPr>
         <p:spPr>
           <a:xfrm>
-            <a:off x="9509760" y="4050791"/>
-            <a:ext cx="1682496" cy="685800"/>
+            <a:off x="8127796" y="3995928"/>
+            <a:ext cx="1455877" cy="658368"/>
           </a:xfrm>
           <a:prstGeom prst="rect">
             <a:avLst/>
@@ -5199,17 +5199,17 @@
           <a:p>
             <a:pPr algn="l">
               <a:lnSpc>
-                <a:spcPct val="104000"/>
+                <a:spcPct val="102000"/>
               </a:lnSpc>
             </a:pPr>
             <a:r>
-              <a:rPr sz="1050" b="0">
+              <a:rPr sz="950" b="0">
                 <a:solidFill>
                   <a:srgbClr val="A8B8CE"/>
                 </a:solidFill>
                 <a:latin typeface="Microsoft YaHei"/>
               </a:rPr>
-              <a:t>结构、渲染、视觉与官方评估器</a:t>
+              <a:t>结构、渲染与评估</a:t>
             </a:r>
           </a:p>
         </p:txBody>
@@ -5222,8 +5222,8 @@
         </p:nvSpPr>
         <p:spPr>
           <a:xfrm>
-            <a:off x="9509760" y="4800600"/>
-            <a:ext cx="1682496" cy="310896"/>
+            <a:off x="8127796" y="4727448"/>
+            <a:ext cx="1455877" cy="310896"/>
           </a:xfrm>
           <a:prstGeom prst="roundRect">
             <a:avLst>
@@ -5268,8 +5268,8 @@
         </p:nvSpPr>
         <p:spPr>
           <a:xfrm>
-            <a:off x="9582912" y="4855464"/>
-            <a:ext cx="1536192" cy="201168"/>
+            <a:off x="8182660" y="4782312"/>
+            <a:ext cx="1346149" cy="201168"/>
           </a:xfrm>
           <a:prstGeom prst="rect">
             <a:avLst/>
@@ -5282,19 +5282,19 @@
           </a:bodyPr>
           <a:lstStyle/>
           <a:p>
-            <a:pPr algn="l">
+            <a:pPr algn="ctr">
               <a:lnSpc>
                 <a:spcPct val="100000"/>
               </a:lnSpc>
             </a:pPr>
             <a:r>
-              <a:rPr sz="850" b="0">
+              <a:rPr sz="800" b="1">
                 <a:solidFill>
                   <a:srgbClr val="10B981"/>
                 </a:solidFill>
                 <a:latin typeface="Microsoft YaHei"/>
               </a:rPr>
-              <a:t>产出：验证证据</a:t>
+              <a:t>验证证据</a:t>
             </a:r>
           </a:p>
         </p:txBody>
@@ -5307,8 +5307,8 @@
         </p:nvSpPr>
         <p:spPr>
           <a:xfrm>
-            <a:off x="9509760" y="5221224"/>
-            <a:ext cx="1682496" cy="91440"/>
+            <a:off x="8127796" y="5148072"/>
+            <a:ext cx="1455877" cy="91440"/>
           </a:xfrm>
           <a:prstGeom prst="roundRect">
             <a:avLst>
@@ -5353,8 +5353,8 @@
         </p:nvSpPr>
         <p:spPr>
           <a:xfrm>
-            <a:off x="9509760" y="5221224"/>
-            <a:ext cx="1009497" cy="91440"/>
+            <a:off x="8127796" y="5148072"/>
+            <a:ext cx="873526" cy="91440"/>
           </a:xfrm>
           <a:prstGeom prst="roundRect">
             <a:avLst>
@@ -5391,20 +5391,56 @@
           </a:p>
         </p:txBody>
       </p:sp>
-      <p:sp>
-        <p:nvSpPr>
-          <p:cNvPr id="55" name="Rounded Rectangle 54"/>
+      <p:cxnSp>
+        <p:nvCxnSpPr>
+          <p:cNvPr id="55" name="Connector 54"/>
+          <p:cNvCxnSpPr/>
+          <p:nvPr/>
+        </p:nvCxnSpPr>
+        <p:spPr>
+          <a:xfrm>
+            <a:off x="9716262" y="4096511"/>
+            <a:ext cx="118872" cy="0"/>
+          </a:xfrm>
+          <a:prstGeom prst="line">
+            <a:avLst/>
+          </a:prstGeom>
+          <a:ln w="25400">
+            <a:solidFill>
+              <a:srgbClr val="F6B544"/>
+            </a:solidFill>
+            <a:headEnd type="arrow" w="med" len="med"/>
+          </a:ln>
+        </p:spPr>
+        <p:style>
+          <a:lnRef idx="2">
+            <a:schemeClr val="accent1"/>
+          </a:lnRef>
+          <a:fillRef idx="0">
+            <a:schemeClr val="accent1"/>
+          </a:fillRef>
+          <a:effectRef idx="1">
+            <a:schemeClr val="accent1"/>
+          </a:effectRef>
+          <a:fontRef idx="minor">
+            <a:schemeClr val="tx1"/>
+          </a:fontRef>
+        </p:style>
+      </p:cxnSp>
+      <p:sp>
+        <p:nvSpPr>
+          <p:cNvPr id="56" name="Rounded Rectangle 55"/>
           <p:cNvSpPr/>
           <p:nvPr/>
         </p:nvSpPr>
         <p:spPr>
           <a:xfrm>
-            <a:off x="658368" y="5742432"/>
-            <a:ext cx="10881360" cy="512064"/>
+            <a:off x="9857994" y="2788920"/>
+            <a:ext cx="1675333" cy="2615184"/>
           </a:xfrm>
           <a:prstGeom prst="roundRect">
             <a:avLst>
-              <a:gd name="adj" fmla="val 50000"/>
+              <a:gd name="adj" fmla="val 10000"/>
             </a:avLst>
           </a:prstGeom>
           <a:solidFill>
@@ -5441,7 +5477,364 @@
       </p:sp>
       <p:sp>
         <p:nvSpPr>
-          <p:cNvPr id="56" name="TextBox 55"/>
+          <p:cNvPr id="57" name="Rounded Rectangle 56"/>
+          <p:cNvSpPr/>
+          <p:nvPr/>
+        </p:nvSpPr>
+        <p:spPr>
+          <a:xfrm>
+            <a:off x="9986010" y="2953512"/>
+            <a:ext cx="420624" cy="420624"/>
+          </a:xfrm>
+          <a:prstGeom prst="roundRect">
+            <a:avLst>
+              <a:gd name="adj" fmla="val 50000"/>
+            </a:avLst>
+          </a:prstGeom>
+          <a:solidFill>
+            <a:srgbClr val="8B5CF6"/>
+          </a:solidFill>
+          <a:ln>
+            <a:noFill/>
+          </a:ln>
+          <a:effectLst/>
+        </p:spPr>
+        <p:style>
+          <a:lnRef idx="1">
+            <a:schemeClr val="accent1"/>
+          </a:lnRef>
+          <a:fillRef idx="3">
+            <a:schemeClr val="accent1"/>
+          </a:fillRef>
+          <a:effectRef idx="2">
+            <a:schemeClr val="accent1"/>
+          </a:effectRef>
+          <a:fontRef idx="minor">
+            <a:schemeClr val="lt1"/>
+          </a:fontRef>
+        </p:style>
+        <p:txBody>
+          <a:bodyPr rtlCol="0" anchor="ctr" wrap="none"/>
+          <a:lstStyle/>
+          <a:p>
+            <a:pPr algn="ctr"/>
+            <a:r>
+              <a:rPr sz="1200" b="1">
+                <a:solidFill>
+                  <a:srgbClr val="0F1A2B"/>
+                </a:solidFill>
+              </a:rPr>
+              <a:t>06</a:t>
+            </a:r>
+          </a:p>
+        </p:txBody>
+      </p:sp>
+      <p:sp>
+        <p:nvSpPr>
+          <p:cNvPr id="58" name="TextBox 57"/>
+          <p:cNvSpPr txBox="1"/>
+          <p:nvPr/>
+        </p:nvSpPr>
+        <p:spPr>
+          <a:xfrm>
+            <a:off x="9967722" y="3575303"/>
+            <a:ext cx="1455877" cy="365760"/>
+          </a:xfrm>
+          <a:prstGeom prst="rect">
+            <a:avLst/>
+          </a:prstGeom>
+          <a:noFill/>
+        </p:spPr>
+        <p:txBody>
+          <a:bodyPr wrap="square" anchor="t">
+            <a:spAutoFit/>
+          </a:bodyPr>
+          <a:lstStyle/>
+          <a:p>
+            <a:pPr algn="l">
+              <a:lnSpc>
+                <a:spcPct val="100000"/>
+              </a:lnSpc>
+            </a:pPr>
+            <a:r>
+              <a:rPr sz="1250" b="1">
+                <a:solidFill>
+                  <a:srgbClr val="FFFFFF"/>
+                </a:solidFill>
+                <a:latin typeface="Microsoft YaHei"/>
+              </a:rPr>
+              <a:t>交付 Deliver</a:t>
+            </a:r>
+          </a:p>
+        </p:txBody>
+      </p:sp>
+      <p:sp>
+        <p:nvSpPr>
+          <p:cNvPr id="59" name="TextBox 58"/>
+          <p:cNvSpPr txBox="1"/>
+          <p:nvPr/>
+        </p:nvSpPr>
+        <p:spPr>
+          <a:xfrm>
+            <a:off x="9967722" y="3995928"/>
+            <a:ext cx="1455877" cy="658368"/>
+          </a:xfrm>
+          <a:prstGeom prst="rect">
+            <a:avLst/>
+          </a:prstGeom>
+          <a:noFill/>
+        </p:spPr>
+        <p:txBody>
+          <a:bodyPr wrap="square" anchor="t">
+            <a:spAutoFit/>
+          </a:bodyPr>
+          <a:lstStyle/>
+          <a:p>
+            <a:pPr algn="l">
+              <a:lnSpc>
+                <a:spcPct val="102000"/>
+              </a:lnSpc>
+            </a:pPr>
+            <a:r>
+              <a:rPr sz="950" b="0">
+                <a:solidFill>
+                  <a:srgbClr val="A8B8CE"/>
+                </a:solidFill>
+                <a:latin typeface="Microsoft YaHei"/>
+              </a:rPr>
+              <a:t>保存、摘要与归档</a:t>
+            </a:r>
+          </a:p>
+        </p:txBody>
+      </p:sp>
+      <p:sp>
+        <p:nvSpPr>
+          <p:cNvPr id="60" name="Rounded Rectangle 59"/>
+          <p:cNvSpPr/>
+          <p:nvPr/>
+        </p:nvSpPr>
+        <p:spPr>
+          <a:xfrm>
+            <a:off x="9967722" y="4727448"/>
+            <a:ext cx="1455877" cy="310896"/>
+          </a:xfrm>
+          <a:prstGeom prst="roundRect">
+            <a:avLst>
+              <a:gd name="adj" fmla="val 50000"/>
+            </a:avLst>
+          </a:prstGeom>
+          <a:solidFill>
+            <a:srgbClr val="213555"/>
+          </a:solidFill>
+          <a:ln>
+            <a:noFill/>
+          </a:ln>
+          <a:effectLst/>
+        </p:spPr>
+        <p:style>
+          <a:lnRef idx="1">
+            <a:schemeClr val="accent1"/>
+          </a:lnRef>
+          <a:fillRef idx="3">
+            <a:schemeClr val="accent1"/>
+          </a:fillRef>
+          <a:effectRef idx="2">
+            <a:schemeClr val="accent1"/>
+          </a:effectRef>
+          <a:fontRef idx="minor">
+            <a:schemeClr val="lt1"/>
+          </a:fontRef>
+        </p:style>
+        <p:txBody>
+          <a:bodyPr rtlCol="0" anchor="ctr"/>
+          <a:lstStyle/>
+          <a:p>
+            <a:pPr algn="ctr"/>
+          </a:p>
+        </p:txBody>
+      </p:sp>
+      <p:sp>
+        <p:nvSpPr>
+          <p:cNvPr id="61" name="TextBox 60"/>
+          <p:cNvSpPr txBox="1"/>
+          <p:nvPr/>
+        </p:nvSpPr>
+        <p:spPr>
+          <a:xfrm>
+            <a:off x="10022586" y="4782312"/>
+            <a:ext cx="1346149" cy="201168"/>
+          </a:xfrm>
+          <a:prstGeom prst="rect">
+            <a:avLst/>
+          </a:prstGeom>
+          <a:noFill/>
+        </p:spPr>
+        <p:txBody>
+          <a:bodyPr wrap="square" anchor="t">
+            <a:spAutoFit/>
+          </a:bodyPr>
+          <a:lstStyle/>
+          <a:p>
+            <a:pPr algn="ctr">
+              <a:lnSpc>
+                <a:spcPct val="100000"/>
+              </a:lnSpc>
+            </a:pPr>
+            <a:r>
+              <a:rPr sz="800" b="1">
+                <a:solidFill>
+                  <a:srgbClr val="8B5CF6"/>
+                </a:solidFill>
+                <a:latin typeface="Microsoft YaHei"/>
+              </a:rPr>
+              <a:t>最终交付物</a:t>
+            </a:r>
+          </a:p>
+        </p:txBody>
+      </p:sp>
+      <p:sp>
+        <p:nvSpPr>
+          <p:cNvPr id="62" name="Rounded Rectangle 61"/>
+          <p:cNvSpPr/>
+          <p:nvPr/>
+        </p:nvSpPr>
+        <p:spPr>
+          <a:xfrm>
+            <a:off x="9967722" y="5148072"/>
+            <a:ext cx="1455877" cy="91440"/>
+          </a:xfrm>
+          <a:prstGeom prst="roundRect">
+            <a:avLst>
+              <a:gd name="adj" fmla="val 50000"/>
+            </a:avLst>
+          </a:prstGeom>
+          <a:solidFill>
+            <a:srgbClr val="2A3D5A"/>
+          </a:solidFill>
+          <a:ln>
+            <a:noFill/>
+          </a:ln>
+          <a:effectLst/>
+        </p:spPr>
+        <p:style>
+          <a:lnRef idx="1">
+            <a:schemeClr val="accent1"/>
+          </a:lnRef>
+          <a:fillRef idx="3">
+            <a:schemeClr val="accent1"/>
+          </a:fillRef>
+          <a:effectRef idx="2">
+            <a:schemeClr val="accent1"/>
+          </a:effectRef>
+          <a:fontRef idx="minor">
+            <a:schemeClr val="lt1"/>
+          </a:fontRef>
+        </p:style>
+        <p:txBody>
+          <a:bodyPr rtlCol="0" anchor="ctr"/>
+          <a:lstStyle/>
+          <a:p>
+            <a:pPr algn="ctr"/>
+          </a:p>
+        </p:txBody>
+      </p:sp>
+      <p:sp>
+        <p:nvSpPr>
+          <p:cNvPr id="63" name="Rounded Rectangle 62"/>
+          <p:cNvSpPr/>
+          <p:nvPr/>
+        </p:nvSpPr>
+        <p:spPr>
+          <a:xfrm>
+            <a:off x="9967722" y="5148072"/>
+            <a:ext cx="73152" cy="91440"/>
+          </a:xfrm>
+          <a:prstGeom prst="roundRect">
+            <a:avLst>
+              <a:gd name="adj" fmla="val 50000"/>
+            </a:avLst>
+          </a:prstGeom>
+          <a:solidFill>
+            <a:srgbClr val="8B5CF6"/>
+          </a:solidFill>
+          <a:ln>
+            <a:noFill/>
+          </a:ln>
+          <a:effectLst/>
+        </p:spPr>
+        <p:style>
+          <a:lnRef idx="1">
+            <a:schemeClr val="accent1"/>
+          </a:lnRef>
+          <a:fillRef idx="3">
+            <a:schemeClr val="accent1"/>
+          </a:fillRef>
+          <a:effectRef idx="2">
+            <a:schemeClr val="accent1"/>
+          </a:effectRef>
+          <a:fontRef idx="minor">
+            <a:schemeClr val="lt1"/>
+          </a:fontRef>
+        </p:style>
+        <p:txBody>
+          <a:bodyPr rtlCol="0" anchor="ctr"/>
+          <a:lstStyle/>
+          <a:p>
+            <a:pPr algn="ctr"/>
+          </a:p>
+        </p:txBody>
+      </p:sp>
+      <p:sp>
+        <p:nvSpPr>
+          <p:cNvPr id="64" name="Rounded Rectangle 63"/>
+          <p:cNvSpPr/>
+          <p:nvPr/>
+        </p:nvSpPr>
+        <p:spPr>
+          <a:xfrm>
+            <a:off x="658368" y="5742432"/>
+            <a:ext cx="10881360" cy="512064"/>
+          </a:xfrm>
+          <a:prstGeom prst="roundRect">
+            <a:avLst>
+              <a:gd name="adj" fmla="val 50000"/>
+            </a:avLst>
+          </a:prstGeom>
+          <a:solidFill>
+            <a:srgbClr val="182B46"/>
+          </a:solidFill>
+          <a:ln w="9525">
+            <a:solidFill>
+              <a:srgbClr val="2E4262"/>
+            </a:solidFill>
+          </a:ln>
+          <a:effectLst/>
+        </p:spPr>
+        <p:style>
+          <a:lnRef idx="1">
+            <a:schemeClr val="accent1"/>
+          </a:lnRef>
+          <a:fillRef idx="3">
+            <a:schemeClr val="accent1"/>
+          </a:fillRef>
+          <a:effectRef idx="2">
+            <a:schemeClr val="accent1"/>
+          </a:effectRef>
+          <a:fontRef idx="minor">
+            <a:schemeClr val="lt1"/>
+          </a:fontRef>
+        </p:style>
+        <p:txBody>
+          <a:bodyPr rtlCol="0" anchor="ctr"/>
+          <a:lstStyle/>
+          <a:p>
+            <a:pPr algn="ctr"/>
+          </a:p>
+        </p:txBody>
+      </p:sp>
+      <p:sp>
+        <p:nvSpPr>
+          <p:cNvPr id="65" name="TextBox 64"/>
           <p:cNvSpPr txBox="1"/>
           <p:nvPr/>
         </p:nvSpPr>

</xml_diff>